<commit_message>
Ground pitch in the real soybean root-hair investigation
</commit_message>
<xml_diff>
--- a/docs/pitchdeck/Celloras-Pitch-Deck.pptx
+++ b/docs/pitchdeck/Celloras-Pitch-Deck.pptx
@@ -2,16 +2,16 @@
 <file path=ppt/presentation.xml><?xml version="1.0" encoding="utf-8"?>
 <p:presentation xmlns:p="http://schemas.openxmlformats.org/presentationml/2006/main">
   <p:sldMasterIdLst>
-    <p:sldMasterId xmlns:r="http://schemas.openxmlformats.org/officeDocument/2006/relationships" id="2147483648" r:id="Rf01c0c7f6c8e465b"/>
+    <p:sldMasterId xmlns:r="http://schemas.openxmlformats.org/officeDocument/2006/relationships" id="2147483648" r:id="Rb53cd896a67d45ad"/>
   </p:sldMasterIdLst>
   <p:notesMasterIdLst>
-    <p:notesMasterId xmlns:r="http://schemas.openxmlformats.org/officeDocument/2006/relationships" r:id="Re7dd0c5dfb6f4cf9"/>
+    <p:notesMasterId xmlns:r="http://schemas.openxmlformats.org/officeDocument/2006/relationships" r:id="Rc6fd9ff9ee6e4ed2"/>
   </p:notesMasterIdLst>
   <p:sldIdLst>
-    <p:sldId xmlns:r="http://schemas.openxmlformats.org/officeDocument/2006/relationships" id="256" r:id="R27762b7e274644a4"/>
-    <p:sldId xmlns:r="http://schemas.openxmlformats.org/officeDocument/2006/relationships" id="257" r:id="R030c148ef8224740"/>
-    <p:sldId xmlns:r="http://schemas.openxmlformats.org/officeDocument/2006/relationships" id="258" r:id="R3c591484595b41f9"/>
-    <p:sldId xmlns:r="http://schemas.openxmlformats.org/officeDocument/2006/relationships" id="259" r:id="R85fc30fc9b8e4283"/>
+    <p:sldId xmlns:r="http://schemas.openxmlformats.org/officeDocument/2006/relationships" id="256" r:id="R8a3c00a47f3f448e"/>
+    <p:sldId xmlns:r="http://schemas.openxmlformats.org/officeDocument/2006/relationships" id="257" r:id="R948b744518e44ace"/>
+    <p:sldId xmlns:r="http://schemas.openxmlformats.org/officeDocument/2006/relationships" id="258" r:id="Rc2854aec1bec4684"/>
+    <p:sldId xmlns:r="http://schemas.openxmlformats.org/officeDocument/2006/relationships" id="259" r:id="R07e0dc3dbe8f4fe9"/>
   </p:sldIdLst>
   <p:sldSz cx="12192000" cy="6858000"/>
   <p:notesSz cx="6858000" cy="9144000"/>
@@ -445,7 +445,7 @@
           <a:lstStyle xmlns:a="http://schemas.openxmlformats.org/drawingml/2006/main"/>
           <a:p xmlns:a="http://schemas.openxmlformats.org/drawingml/2006/main">
             <a:r>
-              <a:t>Celloras is an agent for plant single-cell research, starting with soybean. Ask it to annotate the groups and it runs the tools, returns a visual map and lets you inspect the evidence behind each candidate. The figure is the actual 7,496-nucleus demo. The researcher keeps the final judgment; independent biological validation remains next work.</a:t>
+              <a:t>Root hairs help plants take up water and nutrients. To study them in sequencing data, researchers first need to identify the corresponding cells. Celloras is an annotation agent and research journal. Our real demo reanalyses published soybean data: gene activity measured in 7,496 nuclei, the compartments inside cells. We follow one group of 388 nuclei and ask whether the evidence supports a root-hair identity. The map is the actual Celloras output. This is a reanalysis of a published atlas, not a customer deployment or a nutrient-treatment experiment. We have not measured improvements in crop yield or nutrient uptake.</a:t>
             </a:r>
           </a:p>
           <a:p xmlns:a="http://schemas.openxmlformats.org/drawingml/2006/main">
@@ -460,7 +460,12 @@
           </a:p>
           <a:p xmlns:a="http://schemas.openxmlformats.org/drawingml/2006/main">
             <a:r>
-              <a:t>https://github.com/mpckkk/2026_GenAI/blob/celloras.com/docs/demo.md</a:t>
+              <a:t>https://pubmed.ncbi.nlm.nih.gov/27812010/</a:t>
+            </a:r>
+          </a:p>
+          <a:p xmlns:a="http://schemas.openxmlformats.org/drawingml/2006/main">
+            <a:r>
+              <a:t>https://www.ncbi.nlm.nih.gov/geo/query/acc.cgi?acc=GSE270392</a:t>
             </a:r>
           </a:p>
           <a:p xmlns:a="http://schemas.openxmlformats.org/drawingml/2006/main">
@@ -470,7 +475,7 @@
           </a:p>
           <a:p xmlns:a="http://schemas.openxmlformats.org/drawingml/2006/main">
             <a:r>
-              <a:t>https://github.com/mpckkk/2026_GenAI/blob/celloras.com/docs/annotation-method.md</a:t>
+              <a:t>https://github.com/mpckkk/2026_GenAI/blob/celloras.com/docs/demo.md</a:t>
             </a:r>
           </a:p>
         </p:txBody>
@@ -540,7 +545,7 @@
           <a:lstStyle xmlns:a="http://schemas.openxmlformats.org/drawingml/2006/main"/>
           <a:p xmlns:a="http://schemas.openxmlformats.org/drawingml/2006/main">
             <a:r>
-              <a:t>Without Celloras, the researcher coordinates analysis scripts, reference lookup and their research notes. With Celloras, they ask the agent to run the analysis, inspect the returned evidence and revisit a saved decision in the same conversation. This compares workflow responsibilities, not the capabilities of every competing tool. No measured time-saving or accuracy improvement is claimed.</a:t>
+              <a:t>The task is concrete: assess whether one group in this soybean root dataset represents root-hair cells. Without Celloras, the researcher coordinates scripts, marker-reference lookup and notes. With Celloras, the agent runs the available tools and returns evidence for review in the conversation. The researcher can leave the identity unresolved and record why. We compare workflow responsibilities; no measured time-saving or accuracy improvement is claimed.</a:t>
             </a:r>
           </a:p>
           <a:p xmlns:a="http://schemas.openxmlformats.org/drawingml/2006/main">
@@ -630,7 +635,7 @@
           <a:lstStyle xmlns:a="http://schemas.openxmlformats.org/drawingml/2006/main"/>
           <a:p xmlns:a="http://schemas.openxmlformats.org/drawingml/2006/main">
             <a:r>
-              <a:t>The server-side OpenShell/Codex agent chooses scientific tools in response to the request. Zetaris supplies a checked, versioned marker reference. Numerical tools measure expression; the language model explains their outputs. The official Meterless H-MEM Engine recalls explicit project-owned reviews and their sources when relevant. Next.js and Keycloak provide the interface, with owned state in PostgreSQL. The agent suggests; the researcher reviews.</a:t>
+              <a:t>In the verified workflow, group 6 contains 388 nuclei. The annotation engine suggests Root hair, supported by Glyma.01G224900 and Glyma.17G030700. Markers are genes whose activity helps identify cell types. The OpenShell/Codex agent runs the scientific tools and explains their outputs. Zetaris delivers the checked, versioned marker reference; numerical tools measure expression from the actual matrix. Meterless H-MEM recalls explicit reviews and their sources when asked. These are tool uses across one conversation, not a claim that every prompt calls every tool. The supporting panel comes from the same atlas study, so the candidate needs independent biological review. Next.js/Keycloak provide the interface and authentication; PostgreSQL holds project-owned state.</a:t>
             </a:r>
           </a:p>
           <a:p xmlns:a="http://schemas.openxmlformats.org/drawingml/2006/main">
@@ -645,12 +650,17 @@
           </a:p>
           <a:p xmlns:a="http://schemas.openxmlformats.org/drawingml/2006/main">
             <a:r>
+              <a:t>https://github.com/mpckkk/2026_GenAI/blob/celloras.com/docs/annotation-method.md</a:t>
+            </a:r>
+          </a:p>
+          <a:p xmlns:a="http://schemas.openxmlformats.org/drawingml/2006/main">
+            <a:r>
               <a:t>https://github.com/mpckkk/2026_GenAI/blob/celloras.com/docs/sponsor-explanation.md</a:t>
             </a:r>
           </a:p>
           <a:p xmlns:a="http://schemas.openxmlformats.org/drawingml/2006/main">
             <a:r>
-              <a:t>https://github.com/mpckkk/2026_GenAI/blob/celloras.com/docs/annotation-method.md</a:t>
+              <a:t>https://github.com/mpckkk/2026_GenAI/blob/celloras.com/docs/demo.md</a:t>
             </a:r>
           </a:p>
           <a:p xmlns:a="http://schemas.openxmlformats.org/drawingml/2006/main">
@@ -725,7 +735,7 @@
           <a:lstStyle xmlns:a="http://schemas.openxmlformats.org/drawingml/2006/main"/>
           <a:p xmlns:a="http://schemas.openxmlformats.org/drawingml/2006/main">
             <a:r>
-              <a:t>The slide transcribes the first sentence of the actual agent response after the demonstration review was corrected and links to that reply. It recalls unresolved pending independent evidence and links to the saved review, while the computed Root hair candidate stays unchanged. The same public workflow includes annotation and Zetaris retrieval. The numerical implementation passed 2,952 independent base-R comparisons; this is not an independent biological accuracy benchmark. Try the soybean demo at celloras.com.</a:t>
+              <a:t>The journal makes a concrete difference: it retains the corrected review instead of repeating an older provisional label. This is the first sentence of the actual saved agent reply. The review was explicitly entered for the demonstration, not an external researcher testimonial. It leaves group 6 unresolved pending independent evidence while the computed Root hair candidate stays unchanged. The same verified public workflow includes Zetaris reference retrieval, annotation and measured-marker comparison. Our initial users are plant research labs, starting with soybean and other plants later. For context, MarketsandMarkets forecasts the broader global single-cell sequencing industry at USD 3.46 billion in 2030, versus USD 1.95 billion in 2025 (12.2% reported CAGR). That includes instruments, consumables, software and services; it is not a plant-annotation software market estimate or Celloras revenue forecast. Numerical checks passed 2,952 independent base-R comparisons; independent biological validation and measured user impact remain next work. Try the actual demo at celloras.com.</a:t>
             </a:r>
           </a:p>
           <a:p xmlns:a="http://schemas.openxmlformats.org/drawingml/2006/main">
@@ -751,6 +761,11 @@
           <a:p xmlns:a="http://schemas.openxmlformats.org/drawingml/2006/main">
             <a:r>
               <a:t>https://github.com/mpckkk/2026_GenAI/blob/celloras.com/docs/sponsor-explanation.md</a:t>
+            </a:r>
+          </a:p>
+          <a:p xmlns:a="http://schemas.openxmlformats.org/drawingml/2006/main">
+            <a:r>
+              <a:t>https://www.marketsandmarkets.com/Market-Reports/single-cell-sequencing-market-244864213.html</a:t>
             </a:r>
           </a:p>
           <a:p xmlns:a="http://schemas.openxmlformats.org/drawingml/2006/main">
@@ -802,7 +817,7 @@
           <p:cNvPr id="3" name="Title">
             <a:extLst xmlns:a="http://schemas.openxmlformats.org/drawingml/2006/main">
               <a:ext uri="{FF2B5EF4-FFF2-40B4-BE49-F238E27FC236}">
-                <a16:creationId xmlns:a16="http://schemas.microsoft.com/office/drawing/2014/main" id="{2DAE4D72-EF44-4731-B97B-3FC34AB9513B}"/>
+                <a16:creationId xmlns:a16="http://schemas.microsoft.com/office/drawing/2014/main" id="{3E613E2E-53B0-4909-B1BA-B62CCF6B46D2}"/>
               </a:ext>
             </a:extLst>
           </p:cNvPr>
@@ -1031,7 +1046,7 @@
           <p:cNvPr id="2" name="Subtitle">
             <a:extLst xmlns:a="http://schemas.openxmlformats.org/drawingml/2006/main">
               <a:ext uri="{FF2B5EF4-FFF2-40B4-BE49-F238E27FC236}">
-                <a16:creationId xmlns:a16="http://schemas.microsoft.com/office/drawing/2014/main" id="{EDB53ED1-99B0-41F3-93D4-A9389883B976}"/>
+                <a16:creationId xmlns:a16="http://schemas.microsoft.com/office/drawing/2014/main" id="{32C7D2A5-CD32-4E16-8E6C-9ECEA82D91EA}"/>
               </a:ext>
             </a:extLst>
           </p:cNvPr>
@@ -1277,7 +1292,7 @@
           <p:cNvPr id="2" name="Section title">
             <a:extLst xmlns:a="http://schemas.openxmlformats.org/drawingml/2006/main">
               <a:ext uri="{FF2B5EF4-FFF2-40B4-BE49-F238E27FC236}">
-                <a16:creationId xmlns:a16="http://schemas.microsoft.com/office/drawing/2014/main" id="{AB9E905B-F24D-4715-A84D-FB0F708E4DAF}"/>
+                <a16:creationId xmlns:a16="http://schemas.microsoft.com/office/drawing/2014/main" id="{AA8093D8-F6E0-4381-927A-5ADDF98AC0F6}"/>
               </a:ext>
             </a:extLst>
           </p:cNvPr>
@@ -1523,7 +1538,7 @@
           <p:cNvPr id="3" name="Title">
             <a:extLst xmlns:a="http://schemas.openxmlformats.org/drawingml/2006/main">
               <a:ext uri="{FF2B5EF4-FFF2-40B4-BE49-F238E27FC236}">
-                <a16:creationId xmlns:a16="http://schemas.microsoft.com/office/drawing/2014/main" id="{E81B89D6-CF33-47DD-813D-30CBC67D27A5}"/>
+                <a16:creationId xmlns:a16="http://schemas.microsoft.com/office/drawing/2014/main" id="{398CDD2D-5900-42B2-99C6-E98F4C16599B}"/>
               </a:ext>
             </a:extLst>
           </p:cNvPr>
@@ -1752,7 +1767,7 @@
           <p:cNvPr id="2" name="Body">
             <a:extLst xmlns:a="http://schemas.openxmlformats.org/drawingml/2006/main">
               <a:ext uri="{FF2B5EF4-FFF2-40B4-BE49-F238E27FC236}">
-                <a16:creationId xmlns:a16="http://schemas.microsoft.com/office/drawing/2014/main" id="{2C4DBCA8-C899-4D82-AAC0-6736A200687D}"/>
+                <a16:creationId xmlns:a16="http://schemas.microsoft.com/office/drawing/2014/main" id="{825D11B3-53F4-404F-8282-81A4433005A5}"/>
               </a:ext>
             </a:extLst>
           </p:cNvPr>
@@ -1998,7 +2013,7 @@
           <p:cNvPr id="4" name="Title">
             <a:extLst xmlns:a="http://schemas.openxmlformats.org/drawingml/2006/main">
               <a:ext uri="{FF2B5EF4-FFF2-40B4-BE49-F238E27FC236}">
-                <a16:creationId xmlns:a16="http://schemas.microsoft.com/office/drawing/2014/main" id="{F8FDB0F8-7F2A-41A7-9DB0-3FFED603FB15}"/>
+                <a16:creationId xmlns:a16="http://schemas.microsoft.com/office/drawing/2014/main" id="{8417A935-088B-4B43-875F-48C87122BC6C}"/>
               </a:ext>
             </a:extLst>
           </p:cNvPr>
@@ -2227,7 +2242,7 @@
           <p:cNvPr id="2" name="Left column">
             <a:extLst xmlns:a="http://schemas.openxmlformats.org/drawingml/2006/main">
               <a:ext uri="{FF2B5EF4-FFF2-40B4-BE49-F238E27FC236}">
-                <a16:creationId xmlns:a16="http://schemas.microsoft.com/office/drawing/2014/main" id="{7351A9A7-6F74-45E3-9D52-48F4D1EB85D1}"/>
+                <a16:creationId xmlns:a16="http://schemas.microsoft.com/office/drawing/2014/main" id="{8AD6B605-5498-408A-93E1-AC733C11B5E2}"/>
               </a:ext>
             </a:extLst>
           </p:cNvPr>
@@ -2456,7 +2471,7 @@
           <p:cNvPr id="3" name="Right column">
             <a:extLst xmlns:a="http://schemas.openxmlformats.org/drawingml/2006/main">
               <a:ext uri="{FF2B5EF4-FFF2-40B4-BE49-F238E27FC236}">
-                <a16:creationId xmlns:a16="http://schemas.microsoft.com/office/drawing/2014/main" id="{ECAFF073-3A46-495F-AC35-BF8E73CA9FB1}"/>
+                <a16:creationId xmlns:a16="http://schemas.microsoft.com/office/drawing/2014/main" id="{171C6D87-B8D2-412F-A8FD-53F8E7910B1E}"/>
               </a:ext>
             </a:extLst>
           </p:cNvPr>
@@ -2702,7 +2717,7 @@
           <p:cNvPr id="3" name="Title">
             <a:extLst xmlns:a="http://schemas.openxmlformats.org/drawingml/2006/main">
               <a:ext uri="{FF2B5EF4-FFF2-40B4-BE49-F238E27FC236}">
-                <a16:creationId xmlns:a16="http://schemas.microsoft.com/office/drawing/2014/main" id="{2477923A-FA80-4433-9E28-7B7EA773F02B}"/>
+                <a16:creationId xmlns:a16="http://schemas.microsoft.com/office/drawing/2014/main" id="{B312F9F3-1733-49FD-8955-3A39CCF16FE4}"/>
               </a:ext>
             </a:extLst>
           </p:cNvPr>
@@ -2931,7 +2946,7 @@
           <p:cNvPr id="2" name="Left column">
             <a:extLst xmlns:a="http://schemas.openxmlformats.org/drawingml/2006/main">
               <a:ext uri="{FF2B5EF4-FFF2-40B4-BE49-F238E27FC236}">
-                <a16:creationId xmlns:a16="http://schemas.microsoft.com/office/drawing/2014/main" id="{EE95067B-90C7-4B54-AC19-FA7E89BC5AAA}"/>
+                <a16:creationId xmlns:a16="http://schemas.microsoft.com/office/drawing/2014/main" id="{604BB4E9-41D7-420D-82C0-A128EB23A1D3}"/>
               </a:ext>
             </a:extLst>
           </p:cNvPr>
@@ -3198,12 +3213,12 @@
   </p:cSld>
   <p:clrMap bg1="lt1" tx1="dk1" bg2="lt2" tx2="dk2" accent1="accent1" accent2="accent2" accent3="accent3" accent4="accent4" accent5="accent5" accent6="accent6" hlink="hlink" folHlink="folHlink"/>
   <p:sldLayoutIdLst>
-    <p:sldLayoutId xmlns:r="http://schemas.openxmlformats.org/officeDocument/2006/relationships" id="2147483649" r:id="R0812fa30cc854044"/>
-    <p:sldLayoutId xmlns:r="http://schemas.openxmlformats.org/officeDocument/2006/relationships" id="2147483650" r:id="R746a05c2710d420a"/>
-    <p:sldLayoutId xmlns:r="http://schemas.openxmlformats.org/officeDocument/2006/relationships" id="2147483651" r:id="Rbce4f0254afd4cc5"/>
-    <p:sldLayoutId xmlns:r="http://schemas.openxmlformats.org/officeDocument/2006/relationships" id="2147483652" r:id="Rcba66cff563b48bf"/>
-    <p:sldLayoutId xmlns:r="http://schemas.openxmlformats.org/officeDocument/2006/relationships" id="2147483653" r:id="R80a323677048472c"/>
-    <p:sldLayoutId xmlns:r="http://schemas.openxmlformats.org/officeDocument/2006/relationships" id="2147483654" r:id="R6b11bad04f254895"/>
+    <p:sldLayoutId xmlns:r="http://schemas.openxmlformats.org/officeDocument/2006/relationships" id="2147483649" r:id="R0a0b566774334e90"/>
+    <p:sldLayoutId xmlns:r="http://schemas.openxmlformats.org/officeDocument/2006/relationships" id="2147483650" r:id="R3fa4130d98ea47ae"/>
+    <p:sldLayoutId xmlns:r="http://schemas.openxmlformats.org/officeDocument/2006/relationships" id="2147483651" r:id="Rf4c2a506f1f04d49"/>
+    <p:sldLayoutId xmlns:r="http://schemas.openxmlformats.org/officeDocument/2006/relationships" id="2147483652" r:id="R278209b2e8c34b7e"/>
+    <p:sldLayoutId xmlns:r="http://schemas.openxmlformats.org/officeDocument/2006/relationships" id="2147483653" r:id="R27a0b0ace4314ecc"/>
+    <p:sldLayoutId xmlns:r="http://schemas.openxmlformats.org/officeDocument/2006/relationships" id="2147483654" r:id="R3ade6f14cc234e24"/>
   </p:sldLayoutIdLst>
   <p:txStyles>
     <p:titleStyle>
@@ -3754,7 +3769,7 @@
           <p:cNvPr id="7" name="">
             <a:extLst xmlns:a="http://schemas.openxmlformats.org/drawingml/2006/main">
               <a:ext uri="{FF2B5EF4-FFF2-40B4-BE49-F238E27FC236}">
-                <a16:creationId xmlns:a16="http://schemas.microsoft.com/office/drawing/2014/main" id="{092F30EF-C8EC-45AC-B500-C42783DF5073}"/>
+                <a16:creationId xmlns:a16="http://schemas.microsoft.com/office/drawing/2014/main" id="{C832B7B0-F74D-4FE4-B8E6-01606BBD0508}"/>
               </a:ext>
             </a:extLst>
           </p:cNvPr>
@@ -3764,7 +3779,7 @@
           <p:nvPr/>
         </p:nvPicPr>
         <p:blipFill>
-          <a:blip xmlns:r="http://schemas.openxmlformats.org/officeDocument/2006/relationships" xmlns:a="http://schemas.openxmlformats.org/drawingml/2006/main" r:embed="R2ce9d418df2442eb"/>
+          <a:blip xmlns:r="http://schemas.openxmlformats.org/officeDocument/2006/relationships" xmlns:a="http://schemas.openxmlformats.org/drawingml/2006/main" r:embed="R0cfa776bc2454ecc"/>
           <a:srcRect xmlns:a="http://schemas.openxmlformats.org/drawingml/2006/main" l="10800" t="30500" r="5500" b="33000"/>
           <a:stretch xmlns:a="http://schemas.openxmlformats.org/drawingml/2006/main"/>
         </p:blipFill>
@@ -3783,7 +3798,7 @@
           <p:cNvPr id="2" name="copy-1">
             <a:extLst xmlns:a="http://schemas.openxmlformats.org/drawingml/2006/main">
               <a:ext uri="{FF2B5EF4-FFF2-40B4-BE49-F238E27FC236}">
-                <a16:creationId xmlns:a16="http://schemas.microsoft.com/office/drawing/2014/main" id="{B1D3EEB9-F985-48B3-A48B-FDD55370B6AC}"/>
+                <a16:creationId xmlns:a16="http://schemas.microsoft.com/office/drawing/2014/main" id="{D9183BD6-7F0E-46D5-A701-79728BA8993B}"/>
               </a:ext>
             </a:extLst>
           </p:cNvPr>
@@ -3794,7 +3809,7 @@
         </p:nvSpPr>
         <p:spPr>
           <a:xfrm xmlns:a="http://schemas.openxmlformats.org/drawingml/2006/main">
-            <a:off x="514350" y="1562100"/>
+            <a:off x="514350" y="1495425"/>
             <a:ext cx="5810250" cy="1457325"/>
           </a:xfrm>
           <a:prstGeom xmlns:a="http://schemas.openxmlformats.org/drawingml/2006/main" prst="rect">
@@ -3811,7 +3826,7 @@
           </a:bodyPr>
           <a:lstStyle xmlns:a="http://schemas.openxmlformats.org/drawingml/2006/main">
             <a:defPPr>
-              <a:defRPr sz="4050" b="1">
+              <a:defRPr sz="3825" b="1">
                 <a:solidFill>
                   <a:srgbClr val="111111"/>
                 </a:solidFill>
@@ -3821,7 +3836,7 @@
               </a:defRPr>
             </a:defPPr>
             <a:lvl1pPr>
-              <a:defRPr sz="4050" b="1">
+              <a:defRPr sz="3825" b="1">
                 <a:solidFill>
                   <a:srgbClr val="111111"/>
                 </a:solidFill>
@@ -3831,7 +3846,7 @@
               </a:defRPr>
             </a:lvl1pPr>
             <a:lvl2pPr>
-              <a:defRPr sz="4050" b="1">
+              <a:defRPr sz="3825" b="1">
                 <a:solidFill>
                   <a:srgbClr val="111111"/>
                 </a:solidFill>
@@ -3841,7 +3856,7 @@
               </a:defRPr>
             </a:lvl2pPr>
             <a:lvl3pPr>
-              <a:defRPr sz="4050" b="1">
+              <a:defRPr sz="3825" b="1">
                 <a:solidFill>
                   <a:srgbClr val="111111"/>
                 </a:solidFill>
@@ -3851,7 +3866,7 @@
               </a:defRPr>
             </a:lvl3pPr>
             <a:lvl4pPr>
-              <a:defRPr sz="4050" b="1">
+              <a:defRPr sz="3825" b="1">
                 <a:solidFill>
                   <a:srgbClr val="111111"/>
                 </a:solidFill>
@@ -3861,7 +3876,7 @@
               </a:defRPr>
             </a:lvl4pPr>
             <a:lvl5pPr>
-              <a:defRPr sz="4050" b="1">
+              <a:defRPr sz="3825" b="1">
                 <a:solidFill>
                   <a:srgbClr val="111111"/>
                 </a:solidFill>
@@ -3871,7 +3886,7 @@
               </a:defRPr>
             </a:lvl5pPr>
             <a:lvl6pPr>
-              <a:defRPr sz="4050" b="1">
+              <a:defRPr sz="3825" b="1">
                 <a:solidFill>
                   <a:srgbClr val="111111"/>
                 </a:solidFill>
@@ -3881,7 +3896,7 @@
               </a:defRPr>
             </a:lvl6pPr>
             <a:lvl7pPr>
-              <a:defRPr sz="4050" b="1">
+              <a:defRPr sz="3825" b="1">
                 <a:solidFill>
                   <a:srgbClr val="111111"/>
                 </a:solidFill>
@@ -3891,7 +3906,7 @@
               </a:defRPr>
             </a:lvl7pPr>
             <a:lvl8pPr>
-              <a:defRPr sz="4050" b="1">
+              <a:defRPr sz="3825" b="1">
                 <a:solidFill>
                   <a:srgbClr val="111111"/>
                 </a:solidFill>
@@ -3901,7 +3916,7 @@
               </a:defRPr>
             </a:lvl8pPr>
             <a:lvl9pPr>
-              <a:defRPr sz="4050" b="1">
+              <a:defRPr sz="3825" b="1">
                 <a:solidFill>
                   <a:srgbClr val="111111"/>
                 </a:solidFill>
@@ -3913,7 +3928,7 @@
           </a:lstStyle>
           <a:p xmlns:a="http://schemas.openxmlformats.org/drawingml/2006/main">
             <a:pPr>
-              <a:defRPr sz="4050" b="1">
+              <a:defRPr sz="3825" b="1">
                 <a:solidFill>
                   <a:srgbClr val="111111"/>
                 </a:solidFill>
@@ -3923,7 +3938,7 @@
               </a:defRPr>
             </a:pPr>
             <a:r>
-              <a:rPr sz="4050" b="1">
+              <a:rPr sz="3825" b="1">
                 <a:solidFill>
                   <a:srgbClr val="111111"/>
                 </a:solidFill>
@@ -3931,12 +3946,12 @@
                 <a:ea typeface="Inter"/>
                 <a:cs typeface="Inter"/>
               </a:rPr>
-              <a:t>An agent for</a:t>
+              <a:t>Which soybean cells</a:t>
             </a:r>
           </a:p>
           <a:p xmlns:a="http://schemas.openxmlformats.org/drawingml/2006/main">
             <a:pPr>
-              <a:defRPr sz="4050" b="1">
+              <a:defRPr sz="3825" b="1">
                 <a:solidFill>
                   <a:srgbClr val="111111"/>
                 </a:solidFill>
@@ -3946,7 +3961,7 @@
               </a:defRPr>
             </a:pPr>
             <a:r>
-              <a:rPr sz="4050" b="1">
+              <a:rPr sz="3825" b="1">
                 <a:solidFill>
                   <a:srgbClr val="111111"/>
                 </a:solidFill>
@@ -3954,7 +3969,7 @@
                 <a:ea typeface="Inter"/>
                 <a:cs typeface="Inter"/>
               </a:rPr>
-              <a:t>plant cell annotation.</a:t>
+              <a:t>help absorb nutrients?</a:t>
             </a:r>
           </a:p>
         </p:txBody>
@@ -3964,7 +3979,7 @@
           <p:cNvPr id="3" name="copy-2">
             <a:extLst xmlns:a="http://schemas.openxmlformats.org/drawingml/2006/main">
               <a:ext uri="{FF2B5EF4-FFF2-40B4-BE49-F238E27FC236}">
-                <a16:creationId xmlns:a16="http://schemas.microsoft.com/office/drawing/2014/main" id="{2FA4018D-A03B-4F0D-AB64-EDFABBD4D57B}"/>
+                <a16:creationId xmlns:a16="http://schemas.microsoft.com/office/drawing/2014/main" id="{753F0731-D619-4356-BF5D-A7AD9E1B4B4B}"/>
               </a:ext>
             </a:extLst>
           </p:cNvPr>
@@ -3975,8 +3990,8 @@
         </p:nvSpPr>
         <p:spPr>
           <a:xfrm xmlns:a="http://schemas.openxmlformats.org/drawingml/2006/main">
-            <a:off x="552450" y="3419475"/>
-            <a:ext cx="5381625" cy="904875"/>
+            <a:off x="552450" y="3257550"/>
+            <a:ext cx="5429250" cy="1143000"/>
           </a:xfrm>
           <a:prstGeom xmlns:a="http://schemas.openxmlformats.org/drawingml/2006/main" prst="rect">
             <a:avLst/>
@@ -3992,7 +4007,7 @@
           </a:bodyPr>
           <a:lstStyle xmlns:a="http://schemas.openxmlformats.org/drawingml/2006/main">
             <a:defPPr>
-              <a:defRPr sz="2025" b="0">
+              <a:defRPr sz="1875" b="0">
                 <a:solidFill>
                   <a:srgbClr val="666666"/>
                 </a:solidFill>
@@ -4002,7 +4017,7 @@
               </a:defRPr>
             </a:defPPr>
             <a:lvl1pPr>
-              <a:defRPr sz="2025" b="0">
+              <a:defRPr sz="1875" b="0">
                 <a:solidFill>
                   <a:srgbClr val="666666"/>
                 </a:solidFill>
@@ -4012,7 +4027,7 @@
               </a:defRPr>
             </a:lvl1pPr>
             <a:lvl2pPr>
-              <a:defRPr sz="2025" b="0">
+              <a:defRPr sz="1875" b="0">
                 <a:solidFill>
                   <a:srgbClr val="666666"/>
                 </a:solidFill>
@@ -4022,7 +4037,7 @@
               </a:defRPr>
             </a:lvl2pPr>
             <a:lvl3pPr>
-              <a:defRPr sz="2025" b="0">
+              <a:defRPr sz="1875" b="0">
                 <a:solidFill>
                   <a:srgbClr val="666666"/>
                 </a:solidFill>
@@ -4032,7 +4047,7 @@
               </a:defRPr>
             </a:lvl3pPr>
             <a:lvl4pPr>
-              <a:defRPr sz="2025" b="0">
+              <a:defRPr sz="1875" b="0">
                 <a:solidFill>
                   <a:srgbClr val="666666"/>
                 </a:solidFill>
@@ -4042,7 +4057,7 @@
               </a:defRPr>
             </a:lvl4pPr>
             <a:lvl5pPr>
-              <a:defRPr sz="2025" b="0">
+              <a:defRPr sz="1875" b="0">
                 <a:solidFill>
                   <a:srgbClr val="666666"/>
                 </a:solidFill>
@@ -4052,7 +4067,7 @@
               </a:defRPr>
             </a:lvl5pPr>
             <a:lvl6pPr>
-              <a:defRPr sz="2025" b="0">
+              <a:defRPr sz="1875" b="0">
                 <a:solidFill>
                   <a:srgbClr val="666666"/>
                 </a:solidFill>
@@ -4062,7 +4077,7 @@
               </a:defRPr>
             </a:lvl6pPr>
             <a:lvl7pPr>
-              <a:defRPr sz="2025" b="0">
+              <a:defRPr sz="1875" b="0">
                 <a:solidFill>
                   <a:srgbClr val="666666"/>
                 </a:solidFill>
@@ -4072,7 +4087,7 @@
               </a:defRPr>
             </a:lvl7pPr>
             <a:lvl8pPr>
-              <a:defRPr sz="2025" b="0">
+              <a:defRPr sz="1875" b="0">
                 <a:solidFill>
                   <a:srgbClr val="666666"/>
                 </a:solidFill>
@@ -4082,7 +4097,7 @@
               </a:defRPr>
             </a:lvl8pPr>
             <a:lvl9pPr>
-              <a:defRPr sz="2025" b="0">
+              <a:defRPr sz="1875" b="0">
                 <a:solidFill>
                   <a:srgbClr val="666666"/>
                 </a:solidFill>
@@ -4094,7 +4109,7 @@
           </a:lstStyle>
           <a:p xmlns:a="http://schemas.openxmlformats.org/drawingml/2006/main">
             <a:pPr>
-              <a:defRPr sz="2025" b="0">
+              <a:defRPr sz="1875" b="0">
                 <a:solidFill>
                   <a:srgbClr val="666666"/>
                 </a:solidFill>
@@ -4104,7 +4119,7 @@
               </a:defRPr>
             </a:pPr>
             <a:r>
-              <a:rPr sz="2025" b="0">
+              <a:rPr sz="1875" b="0">
                 <a:solidFill>
                   <a:srgbClr val="666666"/>
                 </a:solidFill>
@@ -4112,12 +4127,12 @@
                 <a:ea typeface="Inter"/>
                 <a:cs typeface="Inter"/>
               </a:rPr>
-              <a:t>From gene expression to candidate</a:t>
+              <a:t>Root-hair cells absorb water and nutrients.</a:t>
             </a:r>
           </a:p>
           <a:p xmlns:a="http://schemas.openxmlformats.org/drawingml/2006/main">
             <a:pPr>
-              <a:defRPr sz="2025" b="0">
+              <a:defRPr sz="1875" b="0">
                 <a:solidFill>
                   <a:srgbClr val="666666"/>
                 </a:solidFill>
@@ -4127,7 +4142,7 @@
               </a:defRPr>
             </a:pPr>
             <a:r>
-              <a:rPr sz="2025" b="0">
+              <a:rPr sz="1875" b="0">
                 <a:solidFill>
                   <a:srgbClr val="666666"/>
                 </a:solidFill>
@@ -4135,7 +4150,30 @@
                 <a:ea typeface="Inter"/>
                 <a:cs typeface="Inter"/>
               </a:rPr>
-              <a:t>cell types, with the supporting evidence.</a:t>
+              <a:t>Researchers first need to find them</a:t>
+            </a:r>
+          </a:p>
+          <a:p xmlns:a="http://schemas.openxmlformats.org/drawingml/2006/main">
+            <a:pPr>
+              <a:defRPr sz="1875" b="0">
+                <a:solidFill>
+                  <a:srgbClr val="666666"/>
+                </a:solidFill>
+                <a:latin typeface="Inter"/>
+                <a:ea typeface="Inter"/>
+                <a:cs typeface="Inter"/>
+              </a:defRPr>
+            </a:pPr>
+            <a:r>
+              <a:rPr sz="1875" b="0">
+                <a:solidFill>
+                  <a:srgbClr val="666666"/>
+                </a:solidFill>
+                <a:latin typeface="Inter"/>
+                <a:ea typeface="Inter"/>
+                <a:cs typeface="Inter"/>
+              </a:rPr>
+              <a:t>in their sequencing data.</a:t>
             </a:r>
           </a:p>
         </p:txBody>
@@ -4145,7 +4183,7 @@
           <p:cNvPr id="4" name="copy-3">
             <a:extLst xmlns:a="http://schemas.openxmlformats.org/drawingml/2006/main">
               <a:ext uri="{FF2B5EF4-FFF2-40B4-BE49-F238E27FC236}">
-                <a16:creationId xmlns:a16="http://schemas.microsoft.com/office/drawing/2014/main" id="{29CEDBC9-16CB-4E5D-81F1-E83FF64C913E}"/>
+                <a16:creationId xmlns:a16="http://schemas.microsoft.com/office/drawing/2014/main" id="{EC361824-816F-45BD-9AA8-6C0273AAAF35}"/>
               </a:ext>
             </a:extLst>
           </p:cNvPr>
@@ -4156,8 +4194,8 @@
         </p:nvSpPr>
         <p:spPr>
           <a:xfrm xmlns:a="http://schemas.openxmlformats.org/drawingml/2006/main">
-            <a:off x="552450" y="4667250"/>
-            <a:ext cx="5381625" cy="904875"/>
+            <a:off x="552450" y="4695825"/>
+            <a:ext cx="5429250" cy="828675"/>
           </a:xfrm>
           <a:prstGeom xmlns:a="http://schemas.openxmlformats.org/drawingml/2006/main" prst="rect">
             <a:avLst/>
@@ -4173,7 +4211,7 @@
           </a:bodyPr>
           <a:lstStyle xmlns:a="http://schemas.openxmlformats.org/drawingml/2006/main">
             <a:defPPr>
-              <a:defRPr sz="2100" b="1">
+              <a:defRPr sz="1950" b="1">
                 <a:solidFill>
                   <a:srgbClr val="1B5E20"/>
                 </a:solidFill>
@@ -4183,7 +4221,7 @@
               </a:defRPr>
             </a:defPPr>
             <a:lvl1pPr>
-              <a:defRPr sz="2100" b="1">
+              <a:defRPr sz="1950" b="1">
                 <a:solidFill>
                   <a:srgbClr val="1B5E20"/>
                 </a:solidFill>
@@ -4193,7 +4231,7 @@
               </a:defRPr>
             </a:lvl1pPr>
             <a:lvl2pPr>
-              <a:defRPr sz="2100" b="1">
+              <a:defRPr sz="1950" b="1">
                 <a:solidFill>
                   <a:srgbClr val="1B5E20"/>
                 </a:solidFill>
@@ -4203,7 +4241,7 @@
               </a:defRPr>
             </a:lvl2pPr>
             <a:lvl3pPr>
-              <a:defRPr sz="2100" b="1">
+              <a:defRPr sz="1950" b="1">
                 <a:solidFill>
                   <a:srgbClr val="1B5E20"/>
                 </a:solidFill>
@@ -4213,7 +4251,7 @@
               </a:defRPr>
             </a:lvl3pPr>
             <a:lvl4pPr>
-              <a:defRPr sz="2100" b="1">
+              <a:defRPr sz="1950" b="1">
                 <a:solidFill>
                   <a:srgbClr val="1B5E20"/>
                 </a:solidFill>
@@ -4223,7 +4261,7 @@
               </a:defRPr>
             </a:lvl4pPr>
             <a:lvl5pPr>
-              <a:defRPr sz="2100" b="1">
+              <a:defRPr sz="1950" b="1">
                 <a:solidFill>
                   <a:srgbClr val="1B5E20"/>
                 </a:solidFill>
@@ -4233,7 +4271,7 @@
               </a:defRPr>
             </a:lvl5pPr>
             <a:lvl6pPr>
-              <a:defRPr sz="2100" b="1">
+              <a:defRPr sz="1950" b="1">
                 <a:solidFill>
                   <a:srgbClr val="1B5E20"/>
                 </a:solidFill>
@@ -4243,7 +4281,7 @@
               </a:defRPr>
             </a:lvl6pPr>
             <a:lvl7pPr>
-              <a:defRPr sz="2100" b="1">
+              <a:defRPr sz="1950" b="1">
                 <a:solidFill>
                   <a:srgbClr val="1B5E20"/>
                 </a:solidFill>
@@ -4253,7 +4291,7 @@
               </a:defRPr>
             </a:lvl7pPr>
             <a:lvl8pPr>
-              <a:defRPr sz="2100" b="1">
+              <a:defRPr sz="1950" b="1">
                 <a:solidFill>
                   <a:srgbClr val="1B5E20"/>
                 </a:solidFill>
@@ -4263,7 +4301,7 @@
               </a:defRPr>
             </a:lvl8pPr>
             <a:lvl9pPr>
-              <a:defRPr sz="2100" b="1">
+              <a:defRPr sz="1950" b="1">
                 <a:solidFill>
                   <a:srgbClr val="1B5E20"/>
                 </a:solidFill>
@@ -4275,7 +4313,7 @@
           </a:lstStyle>
           <a:p xmlns:a="http://schemas.openxmlformats.org/drawingml/2006/main">
             <a:pPr>
-              <a:defRPr sz="2100" b="1">
+              <a:defRPr sz="1950" b="1">
                 <a:solidFill>
                   <a:srgbClr val="1B5E20"/>
                 </a:solidFill>
@@ -4285,7 +4323,7 @@
               </a:defRPr>
             </a:pPr>
             <a:r>
-              <a:rPr sz="2100" b="1">
+              <a:rPr sz="1950" b="1">
                 <a:solidFill>
                   <a:srgbClr val="1B5E20"/>
                 </a:solidFill>
@@ -4293,12 +4331,12 @@
                 <a:ea typeface="Inter"/>
                 <a:cs typeface="Inter"/>
               </a:rPr>
-              <a:t>Ask a question. Get a cell map,</a:t>
+              <a:t>Celloras investigates 7,496 soybean nuclei</a:t>
             </a:r>
           </a:p>
           <a:p xmlns:a="http://schemas.openxmlformats.org/drawingml/2006/main">
             <a:pPr>
-              <a:defRPr sz="2100" b="1">
+              <a:defRPr sz="1950" b="1">
                 <a:solidFill>
                   <a:srgbClr val="1B5E20"/>
                 </a:solidFill>
@@ -4308,7 +4346,7 @@
               </a:defRPr>
             </a:pPr>
             <a:r>
-              <a:rPr sz="2100" b="1">
+              <a:rPr sz="1950" b="1">
                 <a:solidFill>
                   <a:srgbClr val="1B5E20"/>
                 </a:solidFill>
@@ -4316,7 +4354,7 @@
                 <a:ea typeface="Inter"/>
                 <a:cs typeface="Inter"/>
               </a:rPr>
-              <a:t>marker evidence and source links.</a:t>
+              <a:t>and explains a root-hair candidate.</a:t>
             </a:r>
           </a:p>
         </p:txBody>
@@ -4326,7 +4364,7 @@
           <p:cNvPr id="5" name="">
             <a:extLst xmlns:a="http://schemas.openxmlformats.org/drawingml/2006/main">
               <a:ext uri="{FF2B5EF4-FFF2-40B4-BE49-F238E27FC236}">
-                <a16:creationId xmlns:a16="http://schemas.microsoft.com/office/drawing/2014/main" id="{C3BD8244-1780-4051-B8B2-8DF7CD03DB24}"/>
+                <a16:creationId xmlns:a16="http://schemas.microsoft.com/office/drawing/2014/main" id="{56C3C0A1-19ED-4E4E-A19B-D935602DD81D}"/>
               </a:ext>
             </a:extLst>
           </p:cNvPr>
@@ -4336,7 +4374,7 @@
           <p:nvPr/>
         </p:nvPicPr>
         <p:blipFill>
-          <a:blip xmlns:r="http://schemas.openxmlformats.org/officeDocument/2006/relationships" xmlns:a="http://schemas.openxmlformats.org/drawingml/2006/main" r:embed="R83f27ba48a7543cb"/>
+          <a:blip xmlns:r="http://schemas.openxmlformats.org/officeDocument/2006/relationships" xmlns:a="http://schemas.openxmlformats.org/drawingml/2006/main" r:embed="Rc9b2ad86570f461e"/>
           <a:stretch xmlns:a="http://schemas.openxmlformats.org/drawingml/2006/main"/>
         </p:blipFill>
         <p:spPr>
@@ -4354,7 +4392,7 @@
           <p:cNvPr id="6" name="copy-4">
             <a:extLst xmlns:a="http://schemas.openxmlformats.org/drawingml/2006/main">
               <a:ext uri="{FF2B5EF4-FFF2-40B4-BE49-F238E27FC236}">
-                <a16:creationId xmlns:a16="http://schemas.microsoft.com/office/drawing/2014/main" id="{AF882377-1657-4AD4-B56E-AE2FCE3251DC}"/>
+                <a16:creationId xmlns:a16="http://schemas.microsoft.com/office/drawing/2014/main" id="{670173D5-37CC-4203-958F-A6C499B6E65A}"/>
               </a:ext>
             </a:extLst>
           </p:cNvPr>
@@ -4502,7 +4540,7 @@
                 <a:ea typeface="Inter"/>
                 <a:cs typeface="Inter"/>
               </a:rPr>
-              <a:t>Starting with soybean. More plants next.</a:t>
+              <a:t>Real demo: published soybean root data (GSE270392).</a:t>
             </a:r>
           </a:p>
         </p:txBody>
@@ -4510,7 +4548,7 @@
     </p:spTree>
     <p:extLst>
       <p:ext uri="{BB962C8B-B14F-4D97-AF65-F5344CB8AC3E}">
-        <p14:creationId xmlns:p14="http://schemas.microsoft.com/office/powerpoint/2010/main" val="183982470"/>
+        <p14:creationId xmlns:p14="http://schemas.microsoft.com/office/powerpoint/2010/main" val="1547641445"/>
       </p:ext>
     </p:extLst>
   </p:cSld>
@@ -4538,10 +4576,10 @@
       </p:grpSpPr>
       <p:sp>
         <p:nvSpPr>
-          <p:cNvPr id="15" name="copy-5">
+          <p:cNvPr id="16" name="copy-5">
             <a:extLst xmlns:a="http://schemas.openxmlformats.org/drawingml/2006/main">
               <a:ext uri="{FF2B5EF4-FFF2-40B4-BE49-F238E27FC236}">
-                <a16:creationId xmlns:a16="http://schemas.microsoft.com/office/drawing/2014/main" id="{43081E3E-C828-4D47-B8F1-0BC65D249233}"/>
+                <a16:creationId xmlns:a16="http://schemas.microsoft.com/office/drawing/2014/main" id="{D5172FB8-CF7B-44EF-88CD-FD28082C79AF}"/>
               </a:ext>
             </a:extLst>
           </p:cNvPr>
@@ -4689,17 +4727,17 @@
                 <a:ea typeface="Inter"/>
                 <a:cs typeface="Inter"/>
               </a:rPr>
-              <a:t>What changes with Celloras?</a:t>
+              <a:t>Finding root-hair cells</a:t>
             </a:r>
           </a:p>
         </p:txBody>
       </p:sp>
       <p:sp>
         <p:nvSpPr>
-          <p:cNvPr id="2" name="block-6">
+          <p:cNvPr id="2" name="copy-6">
             <a:extLst xmlns:a="http://schemas.openxmlformats.org/drawingml/2006/main">
               <a:ext uri="{FF2B5EF4-FFF2-40B4-BE49-F238E27FC236}">
-                <a16:creationId xmlns:a16="http://schemas.microsoft.com/office/drawing/2014/main" id="{B2EFCFB6-C220-4A63-885E-A87398A740F5}"/>
+                <a16:creationId xmlns:a16="http://schemas.microsoft.com/office/drawing/2014/main" id="{80D7BA7B-4152-431F-9094-8BAC0184DC21}"/>
               </a:ext>
             </a:extLst>
           </p:cNvPr>
@@ -4710,8 +4748,166 @@
         </p:nvSpPr>
         <p:spPr>
           <a:xfrm xmlns:a="http://schemas.openxmlformats.org/drawingml/2006/main">
-            <a:off x="6334125" y="1847850"/>
-            <a:ext cx="5362575" cy="3971925"/>
+            <a:off x="552450" y="1495425"/>
+            <a:ext cx="11087100" cy="409575"/>
+          </a:xfrm>
+          <a:prstGeom xmlns:a="http://schemas.openxmlformats.org/drawingml/2006/main" prst="rect">
+            <a:avLst/>
+          </a:prstGeom>
+          <a:noFill xmlns:a="http://schemas.openxmlformats.org/drawingml/2006/main"/>
+          <a:ln xmlns:a="http://schemas.openxmlformats.org/drawingml/2006/main" w="0">
+            <a:noFill/>
+          </a:ln>
+        </p:spPr>
+        <p:txBody>
+          <a:bodyPr xmlns:a="http://schemas.openxmlformats.org/drawingml/2006/main" wrap="square" lIns="0" tIns="0" rIns="0" bIns="0">
+            <a:noAutofit/>
+          </a:bodyPr>
+          <a:lstStyle xmlns:a="http://schemas.openxmlformats.org/drawingml/2006/main">
+            <a:defPPr>
+              <a:defRPr sz="2025" b="0">
+                <a:solidFill>
+                  <a:srgbClr val="666666"/>
+                </a:solidFill>
+                <a:latin typeface="Inter"/>
+                <a:ea typeface="Inter"/>
+                <a:cs typeface="Inter"/>
+              </a:defRPr>
+            </a:defPPr>
+            <a:lvl1pPr>
+              <a:defRPr sz="2025" b="0">
+                <a:solidFill>
+                  <a:srgbClr val="666666"/>
+                </a:solidFill>
+                <a:latin typeface="Inter"/>
+                <a:ea typeface="Inter"/>
+                <a:cs typeface="Inter"/>
+              </a:defRPr>
+            </a:lvl1pPr>
+            <a:lvl2pPr>
+              <a:defRPr sz="2025" b="0">
+                <a:solidFill>
+                  <a:srgbClr val="666666"/>
+                </a:solidFill>
+                <a:latin typeface="Inter"/>
+                <a:ea typeface="Inter"/>
+                <a:cs typeface="Inter"/>
+              </a:defRPr>
+            </a:lvl2pPr>
+            <a:lvl3pPr>
+              <a:defRPr sz="2025" b="0">
+                <a:solidFill>
+                  <a:srgbClr val="666666"/>
+                </a:solidFill>
+                <a:latin typeface="Inter"/>
+                <a:ea typeface="Inter"/>
+                <a:cs typeface="Inter"/>
+              </a:defRPr>
+            </a:lvl3pPr>
+            <a:lvl4pPr>
+              <a:defRPr sz="2025" b="0">
+                <a:solidFill>
+                  <a:srgbClr val="666666"/>
+                </a:solidFill>
+                <a:latin typeface="Inter"/>
+                <a:ea typeface="Inter"/>
+                <a:cs typeface="Inter"/>
+              </a:defRPr>
+            </a:lvl4pPr>
+            <a:lvl5pPr>
+              <a:defRPr sz="2025" b="0">
+                <a:solidFill>
+                  <a:srgbClr val="666666"/>
+                </a:solidFill>
+                <a:latin typeface="Inter"/>
+                <a:ea typeface="Inter"/>
+                <a:cs typeface="Inter"/>
+              </a:defRPr>
+            </a:lvl5pPr>
+            <a:lvl6pPr>
+              <a:defRPr sz="2025" b="0">
+                <a:solidFill>
+                  <a:srgbClr val="666666"/>
+                </a:solidFill>
+                <a:latin typeface="Inter"/>
+                <a:ea typeface="Inter"/>
+                <a:cs typeface="Inter"/>
+              </a:defRPr>
+            </a:lvl6pPr>
+            <a:lvl7pPr>
+              <a:defRPr sz="2025" b="0">
+                <a:solidFill>
+                  <a:srgbClr val="666666"/>
+                </a:solidFill>
+                <a:latin typeface="Inter"/>
+                <a:ea typeface="Inter"/>
+                <a:cs typeface="Inter"/>
+              </a:defRPr>
+            </a:lvl7pPr>
+            <a:lvl8pPr>
+              <a:defRPr sz="2025" b="0">
+                <a:solidFill>
+                  <a:srgbClr val="666666"/>
+                </a:solidFill>
+                <a:latin typeface="Inter"/>
+                <a:ea typeface="Inter"/>
+                <a:cs typeface="Inter"/>
+              </a:defRPr>
+            </a:lvl8pPr>
+            <a:lvl9pPr>
+              <a:defRPr sz="2025" b="0">
+                <a:solidFill>
+                  <a:srgbClr val="666666"/>
+                </a:solidFill>
+                <a:latin typeface="Inter"/>
+                <a:ea typeface="Inter"/>
+                <a:cs typeface="Inter"/>
+              </a:defRPr>
+            </a:lvl9pPr>
+          </a:lstStyle>
+          <a:p xmlns:a="http://schemas.openxmlformats.org/drawingml/2006/main">
+            <a:pPr>
+              <a:defRPr sz="2025" b="0">
+                <a:solidFill>
+                  <a:srgbClr val="666666"/>
+                </a:solidFill>
+                <a:latin typeface="Inter"/>
+                <a:ea typeface="Inter"/>
+                <a:cs typeface="Inter"/>
+              </a:defRPr>
+            </a:pPr>
+            <a:r>
+              <a:rPr sz="2025" b="0">
+                <a:solidFill>
+                  <a:srgbClr val="666666"/>
+                </a:solidFill>
+                <a:latin typeface="Inter"/>
+                <a:ea typeface="Inter"/>
+                <a:cs typeface="Inter"/>
+              </a:rPr>
+              <a:t>The same research question, with less manual coordination.</a:t>
+            </a:r>
+          </a:p>
+        </p:txBody>
+      </p:sp>
+      <p:sp>
+        <p:nvSpPr>
+          <p:cNvPr id="3" name="block-7">
+            <a:extLst xmlns:a="http://schemas.openxmlformats.org/drawingml/2006/main">
+              <a:ext uri="{FF2B5EF4-FFF2-40B4-BE49-F238E27FC236}">
+                <a16:creationId xmlns:a16="http://schemas.microsoft.com/office/drawing/2014/main" id="{00CFF2E7-2A82-49D9-A932-073D8315A874}"/>
+              </a:ext>
+            </a:extLst>
+          </p:cNvPr>
+          <p:cNvSpPr>
+            <a:spLocks xmlns:a="http://schemas.openxmlformats.org/drawingml/2006/main" noGrp="1"/>
+          </p:cNvSpPr>
+          <p:nvPr/>
+        </p:nvSpPr>
+        <p:spPr>
+          <a:xfrm xmlns:a="http://schemas.openxmlformats.org/drawingml/2006/main">
+            <a:off x="6334125" y="2143125"/>
+            <a:ext cx="5362575" cy="3676650"/>
           </a:xfrm>
           <a:prstGeom xmlns:a="http://schemas.openxmlformats.org/drawingml/2006/main" prst="rect">
             <a:avLst/>
@@ -4726,10 +4922,10 @@
       </p:sp>
       <p:sp>
         <p:nvSpPr>
-          <p:cNvPr id="3" name="copy-7">
+          <p:cNvPr id="4" name="copy-8">
             <a:extLst xmlns:a="http://schemas.openxmlformats.org/drawingml/2006/main">
               <a:ext uri="{FF2B5EF4-FFF2-40B4-BE49-F238E27FC236}">
-                <a16:creationId xmlns:a16="http://schemas.microsoft.com/office/drawing/2014/main" id="{64739AF2-975F-44CA-B6B9-D5FE10CAA122}"/>
+                <a16:creationId xmlns:a16="http://schemas.microsoft.com/office/drawing/2014/main" id="{4C5C29E6-0DF3-4966-9903-5537D1D469D1}"/>
               </a:ext>
             </a:extLst>
           </p:cNvPr>
@@ -4740,7 +4936,7 @@
         </p:nvSpPr>
         <p:spPr>
           <a:xfrm xmlns:a="http://schemas.openxmlformats.org/drawingml/2006/main">
-            <a:off x="552450" y="2076450"/>
+            <a:off x="552450" y="2333625"/>
             <a:ext cx="5048250" cy="581025"/>
           </a:xfrm>
           <a:prstGeom xmlns:a="http://schemas.openxmlformats.org/drawingml/2006/main" prst="rect">
@@ -4884,10 +5080,10 @@
       </p:sp>
       <p:sp>
         <p:nvSpPr>
-          <p:cNvPr id="4" name="copy-8">
+          <p:cNvPr id="5" name="copy-9">
             <a:extLst xmlns:a="http://schemas.openxmlformats.org/drawingml/2006/main">
               <a:ext uri="{FF2B5EF4-FFF2-40B4-BE49-F238E27FC236}">
-                <a16:creationId xmlns:a16="http://schemas.microsoft.com/office/drawing/2014/main" id="{2E0ABB6F-5947-4DCD-82E8-0F591079A85E}"/>
+                <a16:creationId xmlns:a16="http://schemas.microsoft.com/office/drawing/2014/main" id="{2B14828D-C1BE-44BE-AA01-7362452C3D76}"/>
               </a:ext>
             </a:extLst>
           </p:cNvPr>
@@ -4898,7 +5094,7 @@
         </p:nvSpPr>
         <p:spPr>
           <a:xfrm xmlns:a="http://schemas.openxmlformats.org/drawingml/2006/main">
-            <a:off x="6667500" y="2076450"/>
+            <a:off x="6667500" y="2333625"/>
             <a:ext cx="4667250" cy="581025"/>
           </a:xfrm>
           <a:prstGeom xmlns:a="http://schemas.openxmlformats.org/drawingml/2006/main" prst="rect">
@@ -5042,10 +5238,10 @@
       </p:sp>
       <p:sp>
         <p:nvSpPr>
-          <p:cNvPr id="5" name="copy-9">
+          <p:cNvPr id="6" name="copy-10">
             <a:extLst xmlns:a="http://schemas.openxmlformats.org/drawingml/2006/main">
               <a:ext uri="{FF2B5EF4-FFF2-40B4-BE49-F238E27FC236}">
-                <a16:creationId xmlns:a16="http://schemas.microsoft.com/office/drawing/2014/main" id="{EF387A8D-02E0-410E-99EE-96EDD35AD89A}"/>
+                <a16:creationId xmlns:a16="http://schemas.microsoft.com/office/drawing/2014/main" id="{240EE40C-A4CD-4A2E-9124-75D5E877203B}"/>
               </a:ext>
             </a:extLst>
           </p:cNvPr>
@@ -5056,8 +5252,8 @@
         </p:nvSpPr>
         <p:spPr>
           <a:xfrm xmlns:a="http://schemas.openxmlformats.org/drawingml/2006/main">
-            <a:off x="552450" y="3124200"/>
-            <a:ext cx="4953000" cy="628650"/>
+            <a:off x="552450" y="3228975"/>
+            <a:ext cx="4953000" cy="704850"/>
           </a:xfrm>
           <a:prstGeom xmlns:a="http://schemas.openxmlformats.org/drawingml/2006/main" prst="rect">
             <a:avLst/>
@@ -5073,7 +5269,7 @@
           </a:bodyPr>
           <a:lstStyle xmlns:a="http://schemas.openxmlformats.org/drawingml/2006/main">
             <a:defPPr>
-              <a:defRPr sz="2100" b="0">
+              <a:defRPr sz="2025" b="0">
                 <a:solidFill>
                   <a:srgbClr val="666666"/>
                 </a:solidFill>
@@ -5083,7 +5279,7 @@
               </a:defRPr>
             </a:defPPr>
             <a:lvl1pPr>
-              <a:defRPr sz="2100" b="0">
+              <a:defRPr sz="2025" b="0">
                 <a:solidFill>
                   <a:srgbClr val="666666"/>
                 </a:solidFill>
@@ -5093,7 +5289,7 @@
               </a:defRPr>
             </a:lvl1pPr>
             <a:lvl2pPr>
-              <a:defRPr sz="2100" b="0">
+              <a:defRPr sz="2025" b="0">
                 <a:solidFill>
                   <a:srgbClr val="666666"/>
                 </a:solidFill>
@@ -5103,7 +5299,7 @@
               </a:defRPr>
             </a:lvl2pPr>
             <a:lvl3pPr>
-              <a:defRPr sz="2100" b="0">
+              <a:defRPr sz="2025" b="0">
                 <a:solidFill>
                   <a:srgbClr val="666666"/>
                 </a:solidFill>
@@ -5113,7 +5309,7 @@
               </a:defRPr>
             </a:lvl3pPr>
             <a:lvl4pPr>
-              <a:defRPr sz="2100" b="0">
+              <a:defRPr sz="2025" b="0">
                 <a:solidFill>
                   <a:srgbClr val="666666"/>
                 </a:solidFill>
@@ -5123,7 +5319,7 @@
               </a:defRPr>
             </a:lvl4pPr>
             <a:lvl5pPr>
-              <a:defRPr sz="2100" b="0">
+              <a:defRPr sz="2025" b="0">
                 <a:solidFill>
                   <a:srgbClr val="666666"/>
                 </a:solidFill>
@@ -5133,7 +5329,7 @@
               </a:defRPr>
             </a:lvl5pPr>
             <a:lvl6pPr>
-              <a:defRPr sz="2100" b="0">
+              <a:defRPr sz="2025" b="0">
                 <a:solidFill>
                   <a:srgbClr val="666666"/>
                 </a:solidFill>
@@ -5143,7 +5339,7 @@
               </a:defRPr>
             </a:lvl6pPr>
             <a:lvl7pPr>
-              <a:defRPr sz="2100" b="0">
+              <a:defRPr sz="2025" b="0">
                 <a:solidFill>
                   <a:srgbClr val="666666"/>
                 </a:solidFill>
@@ -5153,7 +5349,7 @@
               </a:defRPr>
             </a:lvl7pPr>
             <a:lvl8pPr>
-              <a:defRPr sz="2100" b="0">
+              <a:defRPr sz="2025" b="0">
                 <a:solidFill>
                   <a:srgbClr val="666666"/>
                 </a:solidFill>
@@ -5163,7 +5359,7 @@
               </a:defRPr>
             </a:lvl8pPr>
             <a:lvl9pPr>
-              <a:defRPr sz="2100" b="0">
+              <a:defRPr sz="2025" b="0">
                 <a:solidFill>
                   <a:srgbClr val="666666"/>
                 </a:solidFill>
@@ -5175,7 +5371,7 @@
           </a:lstStyle>
           <a:p xmlns:a="http://schemas.openxmlformats.org/drawingml/2006/main">
             <a:pPr>
-              <a:defRPr sz="2100" b="0">
+              <a:defRPr sz="2025" b="0">
                 <a:solidFill>
                   <a:srgbClr val="666666"/>
                 </a:solidFill>
@@ -5185,7 +5381,7 @@
               </a:defRPr>
             </a:pPr>
             <a:r>
-              <a:rPr sz="2100" b="0">
+              <a:rPr sz="2025" b="0">
                 <a:solidFill>
                   <a:srgbClr val="666666"/>
                 </a:solidFill>
@@ -5193,17 +5389,17 @@
                 <a:ea typeface="Inter"/>
                 <a:cs typeface="Inter"/>
               </a:rPr>
-              <a:t>Run analysis scripts</a:t>
+              <a:t>Run scripts to inspect the group</a:t>
             </a:r>
           </a:p>
         </p:txBody>
       </p:sp>
       <p:sp>
         <p:nvSpPr>
-          <p:cNvPr id="6" name="arrow-10">
+          <p:cNvPr id="7" name="arrow-11">
             <a:extLst xmlns:a="http://schemas.openxmlformats.org/drawingml/2006/main">
               <a:ext uri="{FF2B5EF4-FFF2-40B4-BE49-F238E27FC236}">
-                <a16:creationId xmlns:a16="http://schemas.microsoft.com/office/drawing/2014/main" id="{332E2F28-8D2D-44D9-81EF-7F8B5A925026}"/>
+                <a16:creationId xmlns:a16="http://schemas.microsoft.com/office/drawing/2014/main" id="{073C5262-488C-45C4-B790-11B7FD0A8914}"/>
               </a:ext>
             </a:extLst>
           </p:cNvPr>
@@ -5214,7 +5410,7 @@
         </p:nvSpPr>
         <p:spPr>
           <a:xfrm xmlns:a="http://schemas.openxmlformats.org/drawingml/2006/main">
-            <a:off x="5781675" y="3228975"/>
+            <a:off x="5781675" y="3333750"/>
             <a:ext cx="304800" cy="152400"/>
           </a:xfrm>
           <a:prstGeom xmlns:a="http://schemas.openxmlformats.org/drawingml/2006/main" prst="rightArrow">
@@ -5230,10 +5426,10 @@
       </p:sp>
       <p:sp>
         <p:nvSpPr>
-          <p:cNvPr id="7" name="copy-11">
+          <p:cNvPr id="8" name="copy-12">
             <a:extLst xmlns:a="http://schemas.openxmlformats.org/drawingml/2006/main">
               <a:ext uri="{FF2B5EF4-FFF2-40B4-BE49-F238E27FC236}">
-                <a16:creationId xmlns:a16="http://schemas.microsoft.com/office/drawing/2014/main" id="{AA9E3AEE-7E3E-40E8-A452-3E06D68F31BC}"/>
+                <a16:creationId xmlns:a16="http://schemas.microsoft.com/office/drawing/2014/main" id="{53E0009D-2053-47E9-AE2A-CD243BE10C2D}"/>
               </a:ext>
             </a:extLst>
           </p:cNvPr>
@@ -5244,8 +5440,8 @@
         </p:nvSpPr>
         <p:spPr>
           <a:xfrm xmlns:a="http://schemas.openxmlformats.org/drawingml/2006/main">
-            <a:off x="6667500" y="3124200"/>
-            <a:ext cx="4695825" cy="685800"/>
+            <a:off x="6667500" y="3228975"/>
+            <a:ext cx="4695825" cy="704850"/>
           </a:xfrm>
           <a:prstGeom xmlns:a="http://schemas.openxmlformats.org/drawingml/2006/main" prst="rect">
             <a:avLst/>
@@ -5261,7 +5457,7 @@
           </a:bodyPr>
           <a:lstStyle xmlns:a="http://schemas.openxmlformats.org/drawingml/2006/main">
             <a:defPPr>
-              <a:defRPr sz="2100" b="1">
+              <a:defRPr sz="2025" b="1">
                 <a:solidFill>
                   <a:srgbClr val="1B5E20"/>
                 </a:solidFill>
@@ -5271,7 +5467,7 @@
               </a:defRPr>
             </a:defPPr>
             <a:lvl1pPr>
-              <a:defRPr sz="2100" b="1">
+              <a:defRPr sz="2025" b="1">
                 <a:solidFill>
                   <a:srgbClr val="1B5E20"/>
                 </a:solidFill>
@@ -5281,7 +5477,7 @@
               </a:defRPr>
             </a:lvl1pPr>
             <a:lvl2pPr>
-              <a:defRPr sz="2100" b="1">
+              <a:defRPr sz="2025" b="1">
                 <a:solidFill>
                   <a:srgbClr val="1B5E20"/>
                 </a:solidFill>
@@ -5291,7 +5487,7 @@
               </a:defRPr>
             </a:lvl2pPr>
             <a:lvl3pPr>
-              <a:defRPr sz="2100" b="1">
+              <a:defRPr sz="2025" b="1">
                 <a:solidFill>
                   <a:srgbClr val="1B5E20"/>
                 </a:solidFill>
@@ -5301,7 +5497,7 @@
               </a:defRPr>
             </a:lvl3pPr>
             <a:lvl4pPr>
-              <a:defRPr sz="2100" b="1">
+              <a:defRPr sz="2025" b="1">
                 <a:solidFill>
                   <a:srgbClr val="1B5E20"/>
                 </a:solidFill>
@@ -5311,7 +5507,7 @@
               </a:defRPr>
             </a:lvl4pPr>
             <a:lvl5pPr>
-              <a:defRPr sz="2100" b="1">
+              <a:defRPr sz="2025" b="1">
                 <a:solidFill>
                   <a:srgbClr val="1B5E20"/>
                 </a:solidFill>
@@ -5321,7 +5517,7 @@
               </a:defRPr>
             </a:lvl5pPr>
             <a:lvl6pPr>
-              <a:defRPr sz="2100" b="1">
+              <a:defRPr sz="2025" b="1">
                 <a:solidFill>
                   <a:srgbClr val="1B5E20"/>
                 </a:solidFill>
@@ -5331,7 +5527,7 @@
               </a:defRPr>
             </a:lvl6pPr>
             <a:lvl7pPr>
-              <a:defRPr sz="2100" b="1">
+              <a:defRPr sz="2025" b="1">
                 <a:solidFill>
                   <a:srgbClr val="1B5E20"/>
                 </a:solidFill>
@@ -5341,7 +5537,7 @@
               </a:defRPr>
             </a:lvl7pPr>
             <a:lvl8pPr>
-              <a:defRPr sz="2100" b="1">
+              <a:defRPr sz="2025" b="1">
                 <a:solidFill>
                   <a:srgbClr val="1B5E20"/>
                 </a:solidFill>
@@ -5351,7 +5547,7 @@
               </a:defRPr>
             </a:lvl8pPr>
             <a:lvl9pPr>
-              <a:defRPr sz="2100" b="1">
+              <a:defRPr sz="2025" b="1">
                 <a:solidFill>
                   <a:srgbClr val="1B5E20"/>
                 </a:solidFill>
@@ -5363,7 +5559,7 @@
           </a:lstStyle>
           <a:p xmlns:a="http://schemas.openxmlformats.org/drawingml/2006/main">
             <a:pPr>
-              <a:defRPr sz="2100" b="1">
+              <a:defRPr sz="2025" b="1">
                 <a:solidFill>
                   <a:srgbClr val="1B5E20"/>
                 </a:solidFill>
@@ -5373,7 +5569,7 @@
               </a:defRPr>
             </a:pPr>
             <a:r>
-              <a:rPr sz="2100" b="1">
+              <a:rPr sz="2025" b="1">
                 <a:solidFill>
                   <a:srgbClr val="1B5E20"/>
                 </a:solidFill>
@@ -5381,17 +5577,17 @@
                 <a:ea typeface="Inter"/>
                 <a:cs typeface="Inter"/>
               </a:rPr>
-              <a:t>Ask the agent to run the analysis</a:t>
+              <a:t>Ask the agent to investigate it</a:t>
             </a:r>
           </a:p>
         </p:txBody>
       </p:sp>
       <p:sp>
         <p:nvSpPr>
-          <p:cNvPr id="8" name="copy-12">
+          <p:cNvPr id="9" name="copy-13">
             <a:extLst xmlns:a="http://schemas.openxmlformats.org/drawingml/2006/main">
               <a:ext uri="{FF2B5EF4-FFF2-40B4-BE49-F238E27FC236}">
-                <a16:creationId xmlns:a16="http://schemas.microsoft.com/office/drawing/2014/main" id="{024FD050-9023-4C98-BC9D-AE8AF93014D3}"/>
+                <a16:creationId xmlns:a16="http://schemas.microsoft.com/office/drawing/2014/main" id="{158B34CD-419D-4D91-90A1-C35C862CDA96}"/>
               </a:ext>
             </a:extLst>
           </p:cNvPr>
@@ -5402,8 +5598,8 @@
         </p:nvSpPr>
         <p:spPr>
           <a:xfrm xmlns:a="http://schemas.openxmlformats.org/drawingml/2006/main">
-            <a:off x="552450" y="4152900"/>
-            <a:ext cx="4953000" cy="628650"/>
+            <a:off x="552450" y="4105275"/>
+            <a:ext cx="4953000" cy="704850"/>
           </a:xfrm>
           <a:prstGeom xmlns:a="http://schemas.openxmlformats.org/drawingml/2006/main" prst="rect">
             <a:avLst/>
@@ -5419,7 +5615,7 @@
           </a:bodyPr>
           <a:lstStyle xmlns:a="http://schemas.openxmlformats.org/drawingml/2006/main">
             <a:defPPr>
-              <a:defRPr sz="2100" b="0">
+              <a:defRPr sz="2025" b="0">
                 <a:solidFill>
                   <a:srgbClr val="666666"/>
                 </a:solidFill>
@@ -5429,7 +5625,7 @@
               </a:defRPr>
             </a:defPPr>
             <a:lvl1pPr>
-              <a:defRPr sz="2100" b="0">
+              <a:defRPr sz="2025" b="0">
                 <a:solidFill>
                   <a:srgbClr val="666666"/>
                 </a:solidFill>
@@ -5439,7 +5635,7 @@
               </a:defRPr>
             </a:lvl1pPr>
             <a:lvl2pPr>
-              <a:defRPr sz="2100" b="0">
+              <a:defRPr sz="2025" b="0">
                 <a:solidFill>
                   <a:srgbClr val="666666"/>
                 </a:solidFill>
@@ -5449,7 +5645,7 @@
               </a:defRPr>
             </a:lvl2pPr>
             <a:lvl3pPr>
-              <a:defRPr sz="2100" b="0">
+              <a:defRPr sz="2025" b="0">
                 <a:solidFill>
                   <a:srgbClr val="666666"/>
                 </a:solidFill>
@@ -5459,7 +5655,7 @@
               </a:defRPr>
             </a:lvl3pPr>
             <a:lvl4pPr>
-              <a:defRPr sz="2100" b="0">
+              <a:defRPr sz="2025" b="0">
                 <a:solidFill>
                   <a:srgbClr val="666666"/>
                 </a:solidFill>
@@ -5469,7 +5665,7 @@
               </a:defRPr>
             </a:lvl4pPr>
             <a:lvl5pPr>
-              <a:defRPr sz="2100" b="0">
+              <a:defRPr sz="2025" b="0">
                 <a:solidFill>
                   <a:srgbClr val="666666"/>
                 </a:solidFill>
@@ -5479,7 +5675,7 @@
               </a:defRPr>
             </a:lvl5pPr>
             <a:lvl6pPr>
-              <a:defRPr sz="2100" b="0">
+              <a:defRPr sz="2025" b="0">
                 <a:solidFill>
                   <a:srgbClr val="666666"/>
                 </a:solidFill>
@@ -5489,7 +5685,7 @@
               </a:defRPr>
             </a:lvl6pPr>
             <a:lvl7pPr>
-              <a:defRPr sz="2100" b="0">
+              <a:defRPr sz="2025" b="0">
                 <a:solidFill>
                   <a:srgbClr val="666666"/>
                 </a:solidFill>
@@ -5499,7 +5695,7 @@
               </a:defRPr>
             </a:lvl7pPr>
             <a:lvl8pPr>
-              <a:defRPr sz="2100" b="0">
+              <a:defRPr sz="2025" b="0">
                 <a:solidFill>
                   <a:srgbClr val="666666"/>
                 </a:solidFill>
@@ -5509,7 +5705,7 @@
               </a:defRPr>
             </a:lvl8pPr>
             <a:lvl9pPr>
-              <a:defRPr sz="2100" b="0">
+              <a:defRPr sz="2025" b="0">
                 <a:solidFill>
                   <a:srgbClr val="666666"/>
                 </a:solidFill>
@@ -5521,7 +5717,7 @@
           </a:lstStyle>
           <a:p xmlns:a="http://schemas.openxmlformats.org/drawingml/2006/main">
             <a:pPr>
-              <a:defRPr sz="2100" b="0">
+              <a:defRPr sz="2025" b="0">
                 <a:solidFill>
                   <a:srgbClr val="666666"/>
                 </a:solidFill>
@@ -5531,7 +5727,7 @@
               </a:defRPr>
             </a:pPr>
             <a:r>
-              <a:rPr sz="2100" b="0">
+              <a:rPr sz="2025" b="0">
                 <a:solidFill>
                   <a:srgbClr val="666666"/>
                 </a:solidFill>
@@ -5539,17 +5735,17 @@
                 <a:ea typeface="Inter"/>
                 <a:cs typeface="Inter"/>
               </a:rPr>
-              <a:t>Look up marker references</a:t>
+              <a:t>Find and compare marker references</a:t>
             </a:r>
           </a:p>
         </p:txBody>
       </p:sp>
       <p:sp>
         <p:nvSpPr>
-          <p:cNvPr id="9" name="arrow-13">
+          <p:cNvPr id="10" name="arrow-14">
             <a:extLst xmlns:a="http://schemas.openxmlformats.org/drawingml/2006/main">
               <a:ext uri="{FF2B5EF4-FFF2-40B4-BE49-F238E27FC236}">
-                <a16:creationId xmlns:a16="http://schemas.microsoft.com/office/drawing/2014/main" id="{72562C67-A842-441F-8385-D049189E4FFE}"/>
+                <a16:creationId xmlns:a16="http://schemas.microsoft.com/office/drawing/2014/main" id="{1DF1541E-C258-4012-9CAE-5A71ED75BE80}"/>
               </a:ext>
             </a:extLst>
           </p:cNvPr>
@@ -5560,7 +5756,7 @@
         </p:nvSpPr>
         <p:spPr>
           <a:xfrm xmlns:a="http://schemas.openxmlformats.org/drawingml/2006/main">
-            <a:off x="5781675" y="4257675"/>
+            <a:off x="5781675" y="4210050"/>
             <a:ext cx="304800" cy="152400"/>
           </a:xfrm>
           <a:prstGeom xmlns:a="http://schemas.openxmlformats.org/drawingml/2006/main" prst="rightArrow">
@@ -5576,10 +5772,10 @@
       </p:sp>
       <p:sp>
         <p:nvSpPr>
-          <p:cNvPr id="10" name="copy-14">
+          <p:cNvPr id="11" name="copy-15">
             <a:extLst xmlns:a="http://schemas.openxmlformats.org/drawingml/2006/main">
               <a:ext uri="{FF2B5EF4-FFF2-40B4-BE49-F238E27FC236}">
-                <a16:creationId xmlns:a16="http://schemas.microsoft.com/office/drawing/2014/main" id="{8DCBF99D-013F-4F36-B0D8-C966E62DE0F8}"/>
+                <a16:creationId xmlns:a16="http://schemas.microsoft.com/office/drawing/2014/main" id="{6D6E1312-0B63-4425-869C-6A3663899DC5}"/>
               </a:ext>
             </a:extLst>
           </p:cNvPr>
@@ -5590,8 +5786,8 @@
         </p:nvSpPr>
         <p:spPr>
           <a:xfrm xmlns:a="http://schemas.openxmlformats.org/drawingml/2006/main">
-            <a:off x="6667500" y="4152900"/>
-            <a:ext cx="4695825" cy="685800"/>
+            <a:off x="6667500" y="4105275"/>
+            <a:ext cx="4695825" cy="704850"/>
           </a:xfrm>
           <a:prstGeom xmlns:a="http://schemas.openxmlformats.org/drawingml/2006/main" prst="rect">
             <a:avLst/>
@@ -5607,7 +5803,7 @@
           </a:bodyPr>
           <a:lstStyle xmlns:a="http://schemas.openxmlformats.org/drawingml/2006/main">
             <a:defPPr>
-              <a:defRPr sz="2100" b="1">
+              <a:defRPr sz="2025" b="1">
                 <a:solidFill>
                   <a:srgbClr val="1B5E20"/>
                 </a:solidFill>
@@ -5617,7 +5813,7 @@
               </a:defRPr>
             </a:defPPr>
             <a:lvl1pPr>
-              <a:defRPr sz="2100" b="1">
+              <a:defRPr sz="2025" b="1">
                 <a:solidFill>
                   <a:srgbClr val="1B5E20"/>
                 </a:solidFill>
@@ -5627,7 +5823,7 @@
               </a:defRPr>
             </a:lvl1pPr>
             <a:lvl2pPr>
-              <a:defRPr sz="2100" b="1">
+              <a:defRPr sz="2025" b="1">
                 <a:solidFill>
                   <a:srgbClr val="1B5E20"/>
                 </a:solidFill>
@@ -5637,7 +5833,7 @@
               </a:defRPr>
             </a:lvl2pPr>
             <a:lvl3pPr>
-              <a:defRPr sz="2100" b="1">
+              <a:defRPr sz="2025" b="1">
                 <a:solidFill>
                   <a:srgbClr val="1B5E20"/>
                 </a:solidFill>
@@ -5647,7 +5843,7 @@
               </a:defRPr>
             </a:lvl3pPr>
             <a:lvl4pPr>
-              <a:defRPr sz="2100" b="1">
+              <a:defRPr sz="2025" b="1">
                 <a:solidFill>
                   <a:srgbClr val="1B5E20"/>
                 </a:solidFill>
@@ -5657,7 +5853,7 @@
               </a:defRPr>
             </a:lvl4pPr>
             <a:lvl5pPr>
-              <a:defRPr sz="2100" b="1">
+              <a:defRPr sz="2025" b="1">
                 <a:solidFill>
                   <a:srgbClr val="1B5E20"/>
                 </a:solidFill>
@@ -5667,7 +5863,7 @@
               </a:defRPr>
             </a:lvl5pPr>
             <a:lvl6pPr>
-              <a:defRPr sz="2100" b="1">
+              <a:defRPr sz="2025" b="1">
                 <a:solidFill>
                   <a:srgbClr val="1B5E20"/>
                 </a:solidFill>
@@ -5677,7 +5873,7 @@
               </a:defRPr>
             </a:lvl6pPr>
             <a:lvl7pPr>
-              <a:defRPr sz="2100" b="1">
+              <a:defRPr sz="2025" b="1">
                 <a:solidFill>
                   <a:srgbClr val="1B5E20"/>
                 </a:solidFill>
@@ -5687,7 +5883,7 @@
               </a:defRPr>
             </a:lvl7pPr>
             <a:lvl8pPr>
-              <a:defRPr sz="2100" b="1">
+              <a:defRPr sz="2025" b="1">
                 <a:solidFill>
                   <a:srgbClr val="1B5E20"/>
                 </a:solidFill>
@@ -5697,7 +5893,7 @@
               </a:defRPr>
             </a:lvl8pPr>
             <a:lvl9pPr>
-              <a:defRPr sz="2100" b="1">
+              <a:defRPr sz="2025" b="1">
                 <a:solidFill>
                   <a:srgbClr val="1B5E20"/>
                 </a:solidFill>
@@ -5709,7 +5905,7 @@
           </a:lstStyle>
           <a:p xmlns:a="http://schemas.openxmlformats.org/drawingml/2006/main">
             <a:pPr>
-              <a:defRPr sz="2100" b="1">
+              <a:defRPr sz="2025" b="1">
                 <a:solidFill>
                   <a:srgbClr val="1B5E20"/>
                 </a:solidFill>
@@ -5719,7 +5915,7 @@
               </a:defRPr>
             </a:pPr>
             <a:r>
-              <a:rPr sz="2100" b="1">
+              <a:rPr sz="2025" b="1">
                 <a:solidFill>
                   <a:srgbClr val="1B5E20"/>
                 </a:solidFill>
@@ -5727,17 +5923,17 @@
                 <a:ea typeface="Inter"/>
                 <a:cs typeface="Inter"/>
               </a:rPr>
-              <a:t>Review genes and source links</a:t>
+              <a:t>Review measured genes and sources</a:t>
             </a:r>
           </a:p>
         </p:txBody>
       </p:sp>
       <p:sp>
         <p:nvSpPr>
-          <p:cNvPr id="11" name="copy-15">
+          <p:cNvPr id="12" name="copy-16">
             <a:extLst xmlns:a="http://schemas.openxmlformats.org/drawingml/2006/main">
               <a:ext uri="{FF2B5EF4-FFF2-40B4-BE49-F238E27FC236}">
-                <a16:creationId xmlns:a16="http://schemas.microsoft.com/office/drawing/2014/main" id="{A6D79F35-18E0-4A61-B354-8D4902DAD702}"/>
+                <a16:creationId xmlns:a16="http://schemas.microsoft.com/office/drawing/2014/main" id="{2CBB3269-618F-48D1-B416-9915F337219B}"/>
               </a:ext>
             </a:extLst>
           </p:cNvPr>
@@ -5748,8 +5944,8 @@
         </p:nvSpPr>
         <p:spPr>
           <a:xfrm xmlns:a="http://schemas.openxmlformats.org/drawingml/2006/main">
-            <a:off x="552450" y="5181600"/>
-            <a:ext cx="4953000" cy="628650"/>
+            <a:off x="552450" y="4981575"/>
+            <a:ext cx="4953000" cy="704850"/>
           </a:xfrm>
           <a:prstGeom xmlns:a="http://schemas.openxmlformats.org/drawingml/2006/main" prst="rect">
             <a:avLst/>
@@ -5765,7 +5961,7 @@
           </a:bodyPr>
           <a:lstStyle xmlns:a="http://schemas.openxmlformats.org/drawingml/2006/main">
             <a:defPPr>
-              <a:defRPr sz="2100" b="0">
+              <a:defRPr sz="2025" b="0">
                 <a:solidFill>
                   <a:srgbClr val="666666"/>
                 </a:solidFill>
@@ -5775,7 +5971,7 @@
               </a:defRPr>
             </a:defPPr>
             <a:lvl1pPr>
-              <a:defRPr sz="2100" b="0">
+              <a:defRPr sz="2025" b="0">
                 <a:solidFill>
                   <a:srgbClr val="666666"/>
                 </a:solidFill>
@@ -5785,7 +5981,7 @@
               </a:defRPr>
             </a:lvl1pPr>
             <a:lvl2pPr>
-              <a:defRPr sz="2100" b="0">
+              <a:defRPr sz="2025" b="0">
                 <a:solidFill>
                   <a:srgbClr val="666666"/>
                 </a:solidFill>
@@ -5795,7 +5991,7 @@
               </a:defRPr>
             </a:lvl2pPr>
             <a:lvl3pPr>
-              <a:defRPr sz="2100" b="0">
+              <a:defRPr sz="2025" b="0">
                 <a:solidFill>
                   <a:srgbClr val="666666"/>
                 </a:solidFill>
@@ -5805,7 +6001,7 @@
               </a:defRPr>
             </a:lvl3pPr>
             <a:lvl4pPr>
-              <a:defRPr sz="2100" b="0">
+              <a:defRPr sz="2025" b="0">
                 <a:solidFill>
                   <a:srgbClr val="666666"/>
                 </a:solidFill>
@@ -5815,7 +6011,7 @@
               </a:defRPr>
             </a:lvl4pPr>
             <a:lvl5pPr>
-              <a:defRPr sz="2100" b="0">
+              <a:defRPr sz="2025" b="0">
                 <a:solidFill>
                   <a:srgbClr val="666666"/>
                 </a:solidFill>
@@ -5825,7 +6021,7 @@
               </a:defRPr>
             </a:lvl5pPr>
             <a:lvl6pPr>
-              <a:defRPr sz="2100" b="0">
+              <a:defRPr sz="2025" b="0">
                 <a:solidFill>
                   <a:srgbClr val="666666"/>
                 </a:solidFill>
@@ -5835,7 +6031,7 @@
               </a:defRPr>
             </a:lvl6pPr>
             <a:lvl7pPr>
-              <a:defRPr sz="2100" b="0">
+              <a:defRPr sz="2025" b="0">
                 <a:solidFill>
                   <a:srgbClr val="666666"/>
                 </a:solidFill>
@@ -5845,7 +6041,7 @@
               </a:defRPr>
             </a:lvl7pPr>
             <a:lvl8pPr>
-              <a:defRPr sz="2100" b="0">
+              <a:defRPr sz="2025" b="0">
                 <a:solidFill>
                   <a:srgbClr val="666666"/>
                 </a:solidFill>
@@ -5855,7 +6051,7 @@
               </a:defRPr>
             </a:lvl8pPr>
             <a:lvl9pPr>
-              <a:defRPr sz="2100" b="0">
+              <a:defRPr sz="2025" b="0">
                 <a:solidFill>
                   <a:srgbClr val="666666"/>
                 </a:solidFill>
@@ -5867,7 +6063,7 @@
           </a:lstStyle>
           <a:p xmlns:a="http://schemas.openxmlformats.org/drawingml/2006/main">
             <a:pPr>
-              <a:defRPr sz="2100" b="0">
+              <a:defRPr sz="2025" b="0">
                 <a:solidFill>
                   <a:srgbClr val="666666"/>
                 </a:solidFill>
@@ -5877,7 +6073,7 @@
               </a:defRPr>
             </a:pPr>
             <a:r>
-              <a:rPr sz="2100" b="0">
+              <a:rPr sz="2025" b="0">
                 <a:solidFill>
                   <a:srgbClr val="666666"/>
                 </a:solidFill>
@@ -5885,17 +6081,17 @@
                 <a:ea typeface="Inter"/>
                 <a:cs typeface="Inter"/>
               </a:rPr>
-              <a:t>Reconstruct past decisions</a:t>
+              <a:t>Keep decisions in separate notes</a:t>
             </a:r>
           </a:p>
         </p:txBody>
       </p:sp>
       <p:sp>
         <p:nvSpPr>
-          <p:cNvPr id="12" name="arrow-16">
+          <p:cNvPr id="13" name="arrow-17">
             <a:extLst xmlns:a="http://schemas.openxmlformats.org/drawingml/2006/main">
               <a:ext uri="{FF2B5EF4-FFF2-40B4-BE49-F238E27FC236}">
-                <a16:creationId xmlns:a16="http://schemas.microsoft.com/office/drawing/2014/main" id="{8668A13A-777A-48DB-809C-4DA85F2E4C54}"/>
+                <a16:creationId xmlns:a16="http://schemas.microsoft.com/office/drawing/2014/main" id="{FA5ACD28-7E5F-4A81-837E-BF4A9851B139}"/>
               </a:ext>
             </a:extLst>
           </p:cNvPr>
@@ -5906,7 +6102,7 @@
         </p:nvSpPr>
         <p:spPr>
           <a:xfrm xmlns:a="http://schemas.openxmlformats.org/drawingml/2006/main">
-            <a:off x="5781675" y="5286375"/>
+            <a:off x="5781675" y="5086350"/>
             <a:ext cx="304800" cy="152400"/>
           </a:xfrm>
           <a:prstGeom xmlns:a="http://schemas.openxmlformats.org/drawingml/2006/main" prst="rightArrow">
@@ -5922,10 +6118,10 @@
       </p:sp>
       <p:sp>
         <p:nvSpPr>
-          <p:cNvPr id="13" name="copy-17">
+          <p:cNvPr id="14" name="copy-18">
             <a:extLst xmlns:a="http://schemas.openxmlformats.org/drawingml/2006/main">
               <a:ext uri="{FF2B5EF4-FFF2-40B4-BE49-F238E27FC236}">
-                <a16:creationId xmlns:a16="http://schemas.microsoft.com/office/drawing/2014/main" id="{D91EEAAC-18D6-4762-B6CE-D5CF361FEA53}"/>
+                <a16:creationId xmlns:a16="http://schemas.microsoft.com/office/drawing/2014/main" id="{333A4147-236C-47EA-9921-142F78CEC4FF}"/>
               </a:ext>
             </a:extLst>
           </p:cNvPr>
@@ -5936,8 +6132,8 @@
         </p:nvSpPr>
         <p:spPr>
           <a:xfrm xmlns:a="http://schemas.openxmlformats.org/drawingml/2006/main">
-            <a:off x="6667500" y="5181600"/>
-            <a:ext cx="4695825" cy="685800"/>
+            <a:off x="6667500" y="4981575"/>
+            <a:ext cx="4695825" cy="704850"/>
           </a:xfrm>
           <a:prstGeom xmlns:a="http://schemas.openxmlformats.org/drawingml/2006/main" prst="rect">
             <a:avLst/>
@@ -5953,7 +6149,7 @@
           </a:bodyPr>
           <a:lstStyle xmlns:a="http://schemas.openxmlformats.org/drawingml/2006/main">
             <a:defPPr>
-              <a:defRPr sz="2100" b="1">
+              <a:defRPr sz="2025" b="1">
                 <a:solidFill>
                   <a:srgbClr val="1B5E20"/>
                 </a:solidFill>
@@ -5963,7 +6159,7 @@
               </a:defRPr>
             </a:defPPr>
             <a:lvl1pPr>
-              <a:defRPr sz="2100" b="1">
+              <a:defRPr sz="2025" b="1">
                 <a:solidFill>
                   <a:srgbClr val="1B5E20"/>
                 </a:solidFill>
@@ -5973,7 +6169,7 @@
               </a:defRPr>
             </a:lvl1pPr>
             <a:lvl2pPr>
-              <a:defRPr sz="2100" b="1">
+              <a:defRPr sz="2025" b="1">
                 <a:solidFill>
                   <a:srgbClr val="1B5E20"/>
                 </a:solidFill>
@@ -5983,7 +6179,7 @@
               </a:defRPr>
             </a:lvl2pPr>
             <a:lvl3pPr>
-              <a:defRPr sz="2100" b="1">
+              <a:defRPr sz="2025" b="1">
                 <a:solidFill>
                   <a:srgbClr val="1B5E20"/>
                 </a:solidFill>
@@ -5993,7 +6189,7 @@
               </a:defRPr>
             </a:lvl3pPr>
             <a:lvl4pPr>
-              <a:defRPr sz="2100" b="1">
+              <a:defRPr sz="2025" b="1">
                 <a:solidFill>
                   <a:srgbClr val="1B5E20"/>
                 </a:solidFill>
@@ -6003,7 +6199,7 @@
               </a:defRPr>
             </a:lvl4pPr>
             <a:lvl5pPr>
-              <a:defRPr sz="2100" b="1">
+              <a:defRPr sz="2025" b="1">
                 <a:solidFill>
                   <a:srgbClr val="1B5E20"/>
                 </a:solidFill>
@@ -6013,7 +6209,7 @@
               </a:defRPr>
             </a:lvl5pPr>
             <a:lvl6pPr>
-              <a:defRPr sz="2100" b="1">
+              <a:defRPr sz="2025" b="1">
                 <a:solidFill>
                   <a:srgbClr val="1B5E20"/>
                 </a:solidFill>
@@ -6023,7 +6219,7 @@
               </a:defRPr>
             </a:lvl6pPr>
             <a:lvl7pPr>
-              <a:defRPr sz="2100" b="1">
+              <a:defRPr sz="2025" b="1">
                 <a:solidFill>
                   <a:srgbClr val="1B5E20"/>
                 </a:solidFill>
@@ -6033,7 +6229,7 @@
               </a:defRPr>
             </a:lvl7pPr>
             <a:lvl8pPr>
-              <a:defRPr sz="2100" b="1">
+              <a:defRPr sz="2025" b="1">
                 <a:solidFill>
                   <a:srgbClr val="1B5E20"/>
                 </a:solidFill>
@@ -6043,7 +6239,7 @@
               </a:defRPr>
             </a:lvl8pPr>
             <a:lvl9pPr>
-              <a:defRPr sz="2100" b="1">
+              <a:defRPr sz="2025" b="1">
                 <a:solidFill>
                   <a:srgbClr val="1B5E20"/>
                 </a:solidFill>
@@ -6055,7 +6251,7 @@
           </a:lstStyle>
           <a:p xmlns:a="http://schemas.openxmlformats.org/drawingml/2006/main">
             <a:pPr>
-              <a:defRPr sz="2100" b="1">
+              <a:defRPr sz="2025" b="1">
                 <a:solidFill>
                   <a:srgbClr val="1B5E20"/>
                 </a:solidFill>
@@ -6065,7 +6261,7 @@
               </a:defRPr>
             </a:pPr>
             <a:r>
-              <a:rPr sz="2100" b="1">
+              <a:rPr sz="2025" b="1">
                 <a:solidFill>
                   <a:srgbClr val="1B5E20"/>
                 </a:solidFill>
@@ -6073,17 +6269,17 @@
                 <a:ea typeface="Inter"/>
                 <a:cs typeface="Inter"/>
               </a:rPr>
-              <a:t>Ask what you decided and why</a:t>
+              <a:t>Save and revisit the decision in chat</a:t>
             </a:r>
           </a:p>
         </p:txBody>
       </p:sp>
       <p:sp>
         <p:nvSpPr>
-          <p:cNvPr id="14" name="copy-18">
+          <p:cNvPr id="15" name="copy-19">
             <a:extLst xmlns:a="http://schemas.openxmlformats.org/drawingml/2006/main">
               <a:ext uri="{FF2B5EF4-FFF2-40B4-BE49-F238E27FC236}">
-                <a16:creationId xmlns:a16="http://schemas.microsoft.com/office/drawing/2014/main" id="{71C0EE02-649F-4D01-916D-45798F4FD40D}"/>
+                <a16:creationId xmlns:a16="http://schemas.microsoft.com/office/drawing/2014/main" id="{D8BBD288-DFA6-4C43-A745-C15BC8D14278}"/>
               </a:ext>
             </a:extLst>
           </p:cNvPr>
@@ -6111,7 +6307,7 @@
           </a:bodyPr>
           <a:lstStyle xmlns:a="http://schemas.openxmlformats.org/drawingml/2006/main">
             <a:defPPr>
-              <a:defRPr sz="1950" b="0">
+              <a:defRPr sz="2100" b="0">
                 <a:solidFill>
                   <a:srgbClr val="111111"/>
                 </a:solidFill>
@@ -6121,7 +6317,7 @@
               </a:defRPr>
             </a:defPPr>
             <a:lvl1pPr>
-              <a:defRPr sz="1950" b="0">
+              <a:defRPr sz="2100" b="0">
                 <a:solidFill>
                   <a:srgbClr val="111111"/>
                 </a:solidFill>
@@ -6131,7 +6327,7 @@
               </a:defRPr>
             </a:lvl1pPr>
             <a:lvl2pPr>
-              <a:defRPr sz="1950" b="0">
+              <a:defRPr sz="2100" b="0">
                 <a:solidFill>
                   <a:srgbClr val="111111"/>
                 </a:solidFill>
@@ -6141,7 +6337,7 @@
               </a:defRPr>
             </a:lvl2pPr>
             <a:lvl3pPr>
-              <a:defRPr sz="1950" b="0">
+              <a:defRPr sz="2100" b="0">
                 <a:solidFill>
                   <a:srgbClr val="111111"/>
                 </a:solidFill>
@@ -6151,7 +6347,7 @@
               </a:defRPr>
             </a:lvl3pPr>
             <a:lvl4pPr>
-              <a:defRPr sz="1950" b="0">
+              <a:defRPr sz="2100" b="0">
                 <a:solidFill>
                   <a:srgbClr val="111111"/>
                 </a:solidFill>
@@ -6161,7 +6357,7 @@
               </a:defRPr>
             </a:lvl4pPr>
             <a:lvl5pPr>
-              <a:defRPr sz="1950" b="0">
+              <a:defRPr sz="2100" b="0">
                 <a:solidFill>
                   <a:srgbClr val="111111"/>
                 </a:solidFill>
@@ -6171,7 +6367,7 @@
               </a:defRPr>
             </a:lvl5pPr>
             <a:lvl6pPr>
-              <a:defRPr sz="1950" b="0">
+              <a:defRPr sz="2100" b="0">
                 <a:solidFill>
                   <a:srgbClr val="111111"/>
                 </a:solidFill>
@@ -6181,7 +6377,7 @@
               </a:defRPr>
             </a:lvl6pPr>
             <a:lvl7pPr>
-              <a:defRPr sz="1950" b="0">
+              <a:defRPr sz="2100" b="0">
                 <a:solidFill>
                   <a:srgbClr val="111111"/>
                 </a:solidFill>
@@ -6191,7 +6387,7 @@
               </a:defRPr>
             </a:lvl7pPr>
             <a:lvl8pPr>
-              <a:defRPr sz="1950" b="0">
+              <a:defRPr sz="2100" b="0">
                 <a:solidFill>
                   <a:srgbClr val="111111"/>
                 </a:solidFill>
@@ -6201,7 +6397,7 @@
               </a:defRPr>
             </a:lvl8pPr>
             <a:lvl9pPr>
-              <a:defRPr sz="1950" b="0">
+              <a:defRPr sz="2100" b="0">
                 <a:solidFill>
                   <a:srgbClr val="111111"/>
                 </a:solidFill>
@@ -6213,7 +6409,7 @@
           </a:lstStyle>
           <a:p xmlns:a="http://schemas.openxmlformats.org/drawingml/2006/main">
             <a:pPr>
-              <a:defRPr sz="1950" b="0">
+              <a:defRPr sz="2100" b="0">
                 <a:solidFill>
                   <a:srgbClr val="111111"/>
                 </a:solidFill>
@@ -6223,7 +6419,7 @@
               </a:defRPr>
             </a:pPr>
             <a:r>
-              <a:rPr sz="1950" b="0">
+              <a:rPr sz="2100" b="0">
                 <a:solidFill>
                   <a:srgbClr val="111111"/>
                 </a:solidFill>
@@ -6231,7 +6427,7 @@
                 <a:ea typeface="Inter"/>
                 <a:cs typeface="Inter"/>
               </a:rPr>
-              <a:t>You keep the scientific judgment. The agent coordinates the work.</a:t>
+              <a:t>The researcher decides whether the evidence is enough.</a:t>
             </a:r>
           </a:p>
         </p:txBody>
@@ -6239,7 +6435,7 @@
     </p:spTree>
     <p:extLst>
       <p:ext uri="{BB962C8B-B14F-4D97-AF65-F5344CB8AC3E}">
-        <p14:creationId xmlns:p14="http://schemas.microsoft.com/office/powerpoint/2010/main" val="1469401544"/>
+        <p14:creationId xmlns:p14="http://schemas.microsoft.com/office/powerpoint/2010/main" val="2138293464"/>
       </p:ext>
     </p:extLst>
   </p:cSld>
@@ -6267,10 +6463,10 @@
       </p:grpSpPr>
       <p:sp>
         <p:nvSpPr>
-          <p:cNvPr id="17" name="copy-19">
+          <p:cNvPr id="18" name="copy-20">
             <a:extLst xmlns:a="http://schemas.openxmlformats.org/drawingml/2006/main">
               <a:ext uri="{FF2B5EF4-FFF2-40B4-BE49-F238E27FC236}">
-                <a16:creationId xmlns:a16="http://schemas.microsoft.com/office/drawing/2014/main" id="{B374BC4E-BA18-4630-8329-4AE94CB95A3B}"/>
+                <a16:creationId xmlns:a16="http://schemas.microsoft.com/office/drawing/2014/main" id="{BFBEAA76-542D-4A9C-AF47-5E855FE9F609}"/>
               </a:ext>
             </a:extLst>
           </p:cNvPr>
@@ -6298,7 +6494,7 @@
           </a:bodyPr>
           <a:lstStyle xmlns:a="http://schemas.openxmlformats.org/drawingml/2006/main">
             <a:defPPr>
-              <a:defRPr sz="4275" b="1">
+              <a:defRPr sz="3825" b="1">
                 <a:solidFill>
                   <a:srgbClr val="111111"/>
                 </a:solidFill>
@@ -6308,7 +6504,7 @@
               </a:defRPr>
             </a:defPPr>
             <a:lvl1pPr>
-              <a:defRPr sz="4275" b="1">
+              <a:defRPr sz="3825" b="1">
                 <a:solidFill>
                   <a:srgbClr val="111111"/>
                 </a:solidFill>
@@ -6318,7 +6514,7 @@
               </a:defRPr>
             </a:lvl1pPr>
             <a:lvl2pPr>
-              <a:defRPr sz="4275" b="1">
+              <a:defRPr sz="3825" b="1">
                 <a:solidFill>
                   <a:srgbClr val="111111"/>
                 </a:solidFill>
@@ -6328,7 +6524,7 @@
               </a:defRPr>
             </a:lvl2pPr>
             <a:lvl3pPr>
-              <a:defRPr sz="4275" b="1">
+              <a:defRPr sz="3825" b="1">
                 <a:solidFill>
                   <a:srgbClr val="111111"/>
                 </a:solidFill>
@@ -6338,7 +6534,7 @@
               </a:defRPr>
             </a:lvl3pPr>
             <a:lvl4pPr>
-              <a:defRPr sz="4275" b="1">
+              <a:defRPr sz="3825" b="1">
                 <a:solidFill>
                   <a:srgbClr val="111111"/>
                 </a:solidFill>
@@ -6348,7 +6544,7 @@
               </a:defRPr>
             </a:lvl4pPr>
             <a:lvl5pPr>
-              <a:defRPr sz="4275" b="1">
+              <a:defRPr sz="3825" b="1">
                 <a:solidFill>
                   <a:srgbClr val="111111"/>
                 </a:solidFill>
@@ -6358,7 +6554,7 @@
               </a:defRPr>
             </a:lvl5pPr>
             <a:lvl6pPr>
-              <a:defRPr sz="4275" b="1">
+              <a:defRPr sz="3825" b="1">
                 <a:solidFill>
                   <a:srgbClr val="111111"/>
                 </a:solidFill>
@@ -6368,7 +6564,7 @@
               </a:defRPr>
             </a:lvl6pPr>
             <a:lvl7pPr>
-              <a:defRPr sz="4275" b="1">
+              <a:defRPr sz="3825" b="1">
                 <a:solidFill>
                   <a:srgbClr val="111111"/>
                 </a:solidFill>
@@ -6378,7 +6574,7 @@
               </a:defRPr>
             </a:lvl7pPr>
             <a:lvl8pPr>
-              <a:defRPr sz="4275" b="1">
+              <a:defRPr sz="3825" b="1">
                 <a:solidFill>
                   <a:srgbClr val="111111"/>
                 </a:solidFill>
@@ -6388,7 +6584,7 @@
               </a:defRPr>
             </a:lvl8pPr>
             <a:lvl9pPr>
-              <a:defRPr sz="4275" b="1">
+              <a:defRPr sz="3825" b="1">
                 <a:solidFill>
                   <a:srgbClr val="111111"/>
                 </a:solidFill>
@@ -6400,7 +6596,7 @@
           </a:lstStyle>
           <a:p xmlns:a="http://schemas.openxmlformats.org/drawingml/2006/main">
             <a:pPr>
-              <a:defRPr sz="4275" b="1">
+              <a:defRPr sz="3825" b="1">
                 <a:solidFill>
                   <a:srgbClr val="111111"/>
                 </a:solidFill>
@@ -6410,7 +6606,7 @@
               </a:defRPr>
             </a:pPr>
             <a:r>
-              <a:rPr sz="4275" b="1">
+              <a:rPr sz="3825" b="1">
                 <a:solidFill>
                   <a:srgbClr val="111111"/>
                 </a:solidFill>
@@ -6418,17 +6614,17 @@
                 <a:ea typeface="Inter"/>
                 <a:cs typeface="Inter"/>
               </a:rPr>
-              <a:t>What the agent actually does</a:t>
+              <a:t>The agent investigates one cell group</a:t>
             </a:r>
           </a:p>
         </p:txBody>
       </p:sp>
       <p:sp>
         <p:nvSpPr>
-          <p:cNvPr id="2" name="copy-20">
+          <p:cNvPr id="2" name="copy-21">
             <a:extLst xmlns:a="http://schemas.openxmlformats.org/drawingml/2006/main">
               <a:ext uri="{FF2B5EF4-FFF2-40B4-BE49-F238E27FC236}">
-                <a16:creationId xmlns:a16="http://schemas.microsoft.com/office/drawing/2014/main" id="{DFCC718C-3D16-4DFD-840B-960AA8E7D8F9}"/>
+                <a16:creationId xmlns:a16="http://schemas.microsoft.com/office/drawing/2014/main" id="{FFA10BB3-2BDE-4E94-A70E-531774834FE9}"/>
               </a:ext>
             </a:extLst>
           </p:cNvPr>
@@ -6439,7 +6635,165 @@
         </p:nvSpPr>
         <p:spPr>
           <a:xfrm xmlns:a="http://schemas.openxmlformats.org/drawingml/2006/main">
-            <a:off x="552450" y="2428875"/>
+            <a:off x="552450" y="1504950"/>
+            <a:ext cx="11087100" cy="466725"/>
+          </a:xfrm>
+          <a:prstGeom xmlns:a="http://schemas.openxmlformats.org/drawingml/2006/main" prst="rect">
+            <a:avLst/>
+          </a:prstGeom>
+          <a:noFill xmlns:a="http://schemas.openxmlformats.org/drawingml/2006/main"/>
+          <a:ln xmlns:a="http://schemas.openxmlformats.org/drawingml/2006/main" w="0">
+            <a:noFill/>
+          </a:ln>
+        </p:spPr>
+        <p:txBody>
+          <a:bodyPr xmlns:a="http://schemas.openxmlformats.org/drawingml/2006/main" wrap="square" lIns="0" tIns="0" rIns="0" bIns="0">
+            <a:noAutofit/>
+          </a:bodyPr>
+          <a:lstStyle xmlns:a="http://schemas.openxmlformats.org/drawingml/2006/main">
+            <a:defPPr>
+              <a:defRPr sz="1950" b="0">
+                <a:solidFill>
+                  <a:srgbClr val="666666"/>
+                </a:solidFill>
+                <a:latin typeface="Inter"/>
+                <a:ea typeface="Inter"/>
+                <a:cs typeface="Inter"/>
+              </a:defRPr>
+            </a:defPPr>
+            <a:lvl1pPr>
+              <a:defRPr sz="1950" b="0">
+                <a:solidFill>
+                  <a:srgbClr val="666666"/>
+                </a:solidFill>
+                <a:latin typeface="Inter"/>
+                <a:ea typeface="Inter"/>
+                <a:cs typeface="Inter"/>
+              </a:defRPr>
+            </a:lvl1pPr>
+            <a:lvl2pPr>
+              <a:defRPr sz="1950" b="0">
+                <a:solidFill>
+                  <a:srgbClr val="666666"/>
+                </a:solidFill>
+                <a:latin typeface="Inter"/>
+                <a:ea typeface="Inter"/>
+                <a:cs typeface="Inter"/>
+              </a:defRPr>
+            </a:lvl2pPr>
+            <a:lvl3pPr>
+              <a:defRPr sz="1950" b="0">
+                <a:solidFill>
+                  <a:srgbClr val="666666"/>
+                </a:solidFill>
+                <a:latin typeface="Inter"/>
+                <a:ea typeface="Inter"/>
+                <a:cs typeface="Inter"/>
+              </a:defRPr>
+            </a:lvl3pPr>
+            <a:lvl4pPr>
+              <a:defRPr sz="1950" b="0">
+                <a:solidFill>
+                  <a:srgbClr val="666666"/>
+                </a:solidFill>
+                <a:latin typeface="Inter"/>
+                <a:ea typeface="Inter"/>
+                <a:cs typeface="Inter"/>
+              </a:defRPr>
+            </a:lvl4pPr>
+            <a:lvl5pPr>
+              <a:defRPr sz="1950" b="0">
+                <a:solidFill>
+                  <a:srgbClr val="666666"/>
+                </a:solidFill>
+                <a:latin typeface="Inter"/>
+                <a:ea typeface="Inter"/>
+                <a:cs typeface="Inter"/>
+              </a:defRPr>
+            </a:lvl5pPr>
+            <a:lvl6pPr>
+              <a:defRPr sz="1950" b="0">
+                <a:solidFill>
+                  <a:srgbClr val="666666"/>
+                </a:solidFill>
+                <a:latin typeface="Inter"/>
+                <a:ea typeface="Inter"/>
+                <a:cs typeface="Inter"/>
+              </a:defRPr>
+            </a:lvl6pPr>
+            <a:lvl7pPr>
+              <a:defRPr sz="1950" b="0">
+                <a:solidFill>
+                  <a:srgbClr val="666666"/>
+                </a:solidFill>
+                <a:latin typeface="Inter"/>
+                <a:ea typeface="Inter"/>
+                <a:cs typeface="Inter"/>
+              </a:defRPr>
+            </a:lvl7pPr>
+            <a:lvl8pPr>
+              <a:defRPr sz="1950" b="0">
+                <a:solidFill>
+                  <a:srgbClr val="666666"/>
+                </a:solidFill>
+                <a:latin typeface="Inter"/>
+                <a:ea typeface="Inter"/>
+                <a:cs typeface="Inter"/>
+              </a:defRPr>
+            </a:lvl8pPr>
+            <a:lvl9pPr>
+              <a:defRPr sz="1950" b="0">
+                <a:solidFill>
+                  <a:srgbClr val="666666"/>
+                </a:solidFill>
+                <a:latin typeface="Inter"/>
+                <a:ea typeface="Inter"/>
+                <a:cs typeface="Inter"/>
+              </a:defRPr>
+            </a:lvl9pPr>
+          </a:lstStyle>
+          <a:p xmlns:a="http://schemas.openxmlformats.org/drawingml/2006/main">
+            <a:pPr>
+              <a:defRPr sz="1950" b="0">
+                <a:solidFill>
+                  <a:srgbClr val="666666"/>
+                </a:solidFill>
+                <a:latin typeface="Inter"/>
+                <a:ea typeface="Inter"/>
+                <a:cs typeface="Inter"/>
+              </a:defRPr>
+            </a:pPr>
+            <a:r>
+              <a:rPr sz="1950" b="0">
+                <a:solidFill>
+                  <a:srgbClr val="666666"/>
+                </a:solidFill>
+                <a:latin typeface="Inter"/>
+                <a:ea typeface="Inter"/>
+                <a:cs typeface="Inter"/>
+              </a:rPr>
+              <a:t>Actual demo: 388 nuclei in group 6; two genes support a Root hair candidate.</a:t>
+            </a:r>
+          </a:p>
+        </p:txBody>
+      </p:sp>
+      <p:sp>
+        <p:nvSpPr>
+          <p:cNvPr id="3" name="copy-22">
+            <a:extLst xmlns:a="http://schemas.openxmlformats.org/drawingml/2006/main">
+              <a:ext uri="{FF2B5EF4-FFF2-40B4-BE49-F238E27FC236}">
+                <a16:creationId xmlns:a16="http://schemas.microsoft.com/office/drawing/2014/main" id="{77221447-B2F7-4219-A414-1985C53EB959}"/>
+              </a:ext>
+            </a:extLst>
+          </p:cNvPr>
+          <p:cNvSpPr>
+            <a:spLocks xmlns:a="http://schemas.openxmlformats.org/drawingml/2006/main" noGrp="1"/>
+          </p:cNvSpPr>
+          <p:nvPr/>
+        </p:nvSpPr>
+        <p:spPr>
+          <a:xfrm xmlns:a="http://schemas.openxmlformats.org/drawingml/2006/main">
+            <a:off x="552450" y="2628900"/>
             <a:ext cx="2714625" cy="428625"/>
           </a:xfrm>
           <a:prstGeom xmlns:a="http://schemas.openxmlformats.org/drawingml/2006/main" prst="rect">
@@ -6583,10 +6937,10 @@
       </p:sp>
       <p:sp>
         <p:nvSpPr>
-          <p:cNvPr id="3" name="copy-21">
+          <p:cNvPr id="4" name="copy-23">
             <a:extLst xmlns:a="http://schemas.openxmlformats.org/drawingml/2006/main">
               <a:ext uri="{FF2B5EF4-FFF2-40B4-BE49-F238E27FC236}">
-                <a16:creationId xmlns:a16="http://schemas.microsoft.com/office/drawing/2014/main" id="{149793C8-AD60-4543-BBA7-6376D46BCE21}"/>
+                <a16:creationId xmlns:a16="http://schemas.microsoft.com/office/drawing/2014/main" id="{28C885E3-D376-49CB-A534-9C48391FF729}"/>
               </a:ext>
             </a:extLst>
           </p:cNvPr>
@@ -6597,7 +6951,7 @@
         </p:nvSpPr>
         <p:spPr>
           <a:xfrm xmlns:a="http://schemas.openxmlformats.org/drawingml/2006/main">
-            <a:off x="552450" y="3095625"/>
+            <a:off x="552450" y="3286125"/>
             <a:ext cx="2714625" cy="1047750"/>
           </a:xfrm>
           <a:prstGeom xmlns:a="http://schemas.openxmlformats.org/drawingml/2006/main" prst="rect">
@@ -6614,7 +6968,7 @@
           </a:bodyPr>
           <a:lstStyle xmlns:a="http://schemas.openxmlformats.org/drawingml/2006/main">
             <a:defPPr>
-              <a:defRPr sz="2550" b="1">
+              <a:defRPr sz="2400" b="1">
                 <a:solidFill>
                   <a:srgbClr val="111111"/>
                 </a:solidFill>
@@ -6624,7 +6978,7 @@
               </a:defRPr>
             </a:defPPr>
             <a:lvl1pPr>
-              <a:defRPr sz="2550" b="1">
+              <a:defRPr sz="2400" b="1">
                 <a:solidFill>
                   <a:srgbClr val="111111"/>
                 </a:solidFill>
@@ -6634,7 +6988,7 @@
               </a:defRPr>
             </a:lvl1pPr>
             <a:lvl2pPr>
-              <a:defRPr sz="2550" b="1">
+              <a:defRPr sz="2400" b="1">
                 <a:solidFill>
                   <a:srgbClr val="111111"/>
                 </a:solidFill>
@@ -6644,7 +6998,7 @@
               </a:defRPr>
             </a:lvl2pPr>
             <a:lvl3pPr>
-              <a:defRPr sz="2550" b="1">
+              <a:defRPr sz="2400" b="1">
                 <a:solidFill>
                   <a:srgbClr val="111111"/>
                 </a:solidFill>
@@ -6654,7 +7008,7 @@
               </a:defRPr>
             </a:lvl3pPr>
             <a:lvl4pPr>
-              <a:defRPr sz="2550" b="1">
+              <a:defRPr sz="2400" b="1">
                 <a:solidFill>
                   <a:srgbClr val="111111"/>
                 </a:solidFill>
@@ -6664,7 +7018,7 @@
               </a:defRPr>
             </a:lvl4pPr>
             <a:lvl5pPr>
-              <a:defRPr sz="2550" b="1">
+              <a:defRPr sz="2400" b="1">
                 <a:solidFill>
                   <a:srgbClr val="111111"/>
                 </a:solidFill>
@@ -6674,7 +7028,7 @@
               </a:defRPr>
             </a:lvl5pPr>
             <a:lvl6pPr>
-              <a:defRPr sz="2550" b="1">
+              <a:defRPr sz="2400" b="1">
                 <a:solidFill>
                   <a:srgbClr val="111111"/>
                 </a:solidFill>
@@ -6684,7 +7038,7 @@
               </a:defRPr>
             </a:lvl6pPr>
             <a:lvl7pPr>
-              <a:defRPr sz="2550" b="1">
+              <a:defRPr sz="2400" b="1">
                 <a:solidFill>
                   <a:srgbClr val="111111"/>
                 </a:solidFill>
@@ -6694,7 +7048,7 @@
               </a:defRPr>
             </a:lvl7pPr>
             <a:lvl8pPr>
-              <a:defRPr sz="2550" b="1">
+              <a:defRPr sz="2400" b="1">
                 <a:solidFill>
                   <a:srgbClr val="111111"/>
                 </a:solidFill>
@@ -6704,7 +7058,7 @@
               </a:defRPr>
             </a:lvl8pPr>
             <a:lvl9pPr>
-              <a:defRPr sz="2550" b="1">
+              <a:defRPr sz="2400" b="1">
                 <a:solidFill>
                   <a:srgbClr val="111111"/>
                 </a:solidFill>
@@ -6716,7 +7070,7 @@
           </a:lstStyle>
           <a:p xmlns:a="http://schemas.openxmlformats.org/drawingml/2006/main">
             <a:pPr>
-              <a:defRPr sz="2550" b="1">
+              <a:defRPr sz="2400" b="1">
                 <a:solidFill>
                   <a:srgbClr val="111111"/>
                 </a:solidFill>
@@ -6726,7 +7080,7 @@
               </a:defRPr>
             </a:pPr>
             <a:r>
-              <a:rPr sz="2550" b="1">
+              <a:rPr sz="2400" b="1">
                 <a:solidFill>
                   <a:srgbClr val="111111"/>
                 </a:solidFill>
@@ -6734,12 +7088,12 @@
                 <a:ea typeface="Inter"/>
                 <a:cs typeface="Inter"/>
               </a:rPr>
-              <a:t>“Which cells</a:t>
+              <a:t>“Could these be</a:t>
             </a:r>
           </a:p>
           <a:p xmlns:a="http://schemas.openxmlformats.org/drawingml/2006/main">
             <a:pPr>
-              <a:defRPr sz="2550" b="1">
+              <a:defRPr sz="2400" b="1">
                 <a:solidFill>
                   <a:srgbClr val="111111"/>
                 </a:solidFill>
@@ -6749,7 +7103,7 @@
               </a:defRPr>
             </a:pPr>
             <a:r>
-              <a:rPr sz="2550" b="1">
+              <a:rPr sz="2400" b="1">
                 <a:solidFill>
                   <a:srgbClr val="111111"/>
                 </a:solidFill>
@@ -6757,17 +7111,17 @@
                 <a:ea typeface="Inter"/>
                 <a:cs typeface="Inter"/>
               </a:rPr>
-              <a:t>are these?”</a:t>
+              <a:t>root-hair cells?”</a:t>
             </a:r>
           </a:p>
         </p:txBody>
       </p:sp>
       <p:sp>
         <p:nvSpPr>
-          <p:cNvPr id="4" name="arrow-22">
+          <p:cNvPr id="5" name="arrow-24">
             <a:extLst xmlns:a="http://schemas.openxmlformats.org/drawingml/2006/main">
               <a:ext uri="{FF2B5EF4-FFF2-40B4-BE49-F238E27FC236}">
-                <a16:creationId xmlns:a16="http://schemas.microsoft.com/office/drawing/2014/main" id="{DD93AF22-BF1E-4ECB-8ACF-B94553A539AC}"/>
+                <a16:creationId xmlns:a16="http://schemas.microsoft.com/office/drawing/2014/main" id="{0CE8535E-E2C5-4510-9E28-7D7C630F2015}"/>
               </a:ext>
             </a:extLst>
           </p:cNvPr>
@@ -6778,7 +7132,7 @@
         </p:nvSpPr>
         <p:spPr>
           <a:xfrm xmlns:a="http://schemas.openxmlformats.org/drawingml/2006/main">
-            <a:off x="3057525" y="3705225"/>
+            <a:off x="3057525" y="3895725"/>
             <a:ext cx="361950" cy="152400"/>
           </a:xfrm>
           <a:prstGeom xmlns:a="http://schemas.openxmlformats.org/drawingml/2006/main" prst="rightArrow">
@@ -6794,10 +7148,10 @@
       </p:sp>
       <p:sp>
         <p:nvSpPr>
-          <p:cNvPr id="5" name="block-23">
+          <p:cNvPr id="6" name="block-25">
             <a:extLst xmlns:a="http://schemas.openxmlformats.org/drawingml/2006/main">
               <a:ext uri="{FF2B5EF4-FFF2-40B4-BE49-F238E27FC236}">
-                <a16:creationId xmlns:a16="http://schemas.microsoft.com/office/drawing/2014/main" id="{C6453E33-9D11-417E-A683-4682ED99F972}"/>
+                <a16:creationId xmlns:a16="http://schemas.microsoft.com/office/drawing/2014/main" id="{B3934760-426C-4887-BCAD-9C2AE14F6999}"/>
               </a:ext>
             </a:extLst>
           </p:cNvPr>
@@ -6808,7 +7162,7 @@
         </p:nvSpPr>
         <p:spPr>
           <a:xfrm xmlns:a="http://schemas.openxmlformats.org/drawingml/2006/main">
-            <a:off x="3714750" y="2133600"/>
+            <a:off x="3714750" y="2324100"/>
             <a:ext cx="4762500" cy="3476625"/>
           </a:xfrm>
           <a:prstGeom xmlns:a="http://schemas.openxmlformats.org/drawingml/2006/main" prst="rect">
@@ -6824,10 +7178,10 @@
       </p:sp>
       <p:sp>
         <p:nvSpPr>
-          <p:cNvPr id="6" name="copy-24">
+          <p:cNvPr id="7" name="copy-26">
             <a:extLst xmlns:a="http://schemas.openxmlformats.org/drawingml/2006/main">
               <a:ext uri="{FF2B5EF4-FFF2-40B4-BE49-F238E27FC236}">
-                <a16:creationId xmlns:a16="http://schemas.microsoft.com/office/drawing/2014/main" id="{FE7CA30B-2B73-4F84-925C-53823FA3C756}"/>
+                <a16:creationId xmlns:a16="http://schemas.microsoft.com/office/drawing/2014/main" id="{BCA520AA-4DF4-4381-B8D8-F8E0EEE84D4E}"/>
               </a:ext>
             </a:extLst>
           </p:cNvPr>
@@ -6838,7 +7192,7 @@
         </p:nvSpPr>
         <p:spPr>
           <a:xfrm xmlns:a="http://schemas.openxmlformats.org/drawingml/2006/main">
-            <a:off x="4000500" y="2362200"/>
+            <a:off x="4000500" y="2552700"/>
             <a:ext cx="4191000" cy="523875"/>
           </a:xfrm>
           <a:prstGeom xmlns:a="http://schemas.openxmlformats.org/drawingml/2006/main" prst="rect">
@@ -6982,10 +7336,10 @@
       </p:sp>
       <p:sp>
         <p:nvSpPr>
-          <p:cNvPr id="7" name="copy-25">
+          <p:cNvPr id="8" name="copy-27">
             <a:extLst xmlns:a="http://schemas.openxmlformats.org/drawingml/2006/main">
               <a:ext uri="{FF2B5EF4-FFF2-40B4-BE49-F238E27FC236}">
-                <a16:creationId xmlns:a16="http://schemas.microsoft.com/office/drawing/2014/main" id="{666F5245-859C-42FE-B619-2159436BCD59}"/>
+                <a16:creationId xmlns:a16="http://schemas.microsoft.com/office/drawing/2014/main" id="{A6D9B3FE-6455-4384-86A5-6E464A346A6D}"/>
               </a:ext>
             </a:extLst>
           </p:cNvPr>
@@ -6996,7 +7350,7 @@
         </p:nvSpPr>
         <p:spPr>
           <a:xfrm xmlns:a="http://schemas.openxmlformats.org/drawingml/2006/main">
-            <a:off x="4000500" y="3152775"/>
+            <a:off x="4000500" y="3343275"/>
             <a:ext cx="4191000" cy="352425"/>
           </a:xfrm>
           <a:prstGeom xmlns:a="http://schemas.openxmlformats.org/drawingml/2006/main" prst="rect">
@@ -7013,7 +7367,7 @@
           </a:bodyPr>
           <a:lstStyle xmlns:a="http://schemas.openxmlformats.org/drawingml/2006/main">
             <a:defPPr>
-              <a:defRPr sz="1875" b="1">
+              <a:defRPr sz="1800" b="1">
                 <a:solidFill>
                   <a:srgbClr val="FFFFFF"/>
                 </a:solidFill>
@@ -7023,7 +7377,7 @@
               </a:defRPr>
             </a:defPPr>
             <a:lvl1pPr>
-              <a:defRPr sz="1875" b="1">
+              <a:defRPr sz="1800" b="1">
                 <a:solidFill>
                   <a:srgbClr val="FFFFFF"/>
                 </a:solidFill>
@@ -7033,7 +7387,7 @@
               </a:defRPr>
             </a:lvl1pPr>
             <a:lvl2pPr>
-              <a:defRPr sz="1875" b="1">
+              <a:defRPr sz="1800" b="1">
                 <a:solidFill>
                   <a:srgbClr val="FFFFFF"/>
                 </a:solidFill>
@@ -7043,7 +7397,7 @@
               </a:defRPr>
             </a:lvl2pPr>
             <a:lvl3pPr>
-              <a:defRPr sz="1875" b="1">
+              <a:defRPr sz="1800" b="1">
                 <a:solidFill>
                   <a:srgbClr val="FFFFFF"/>
                 </a:solidFill>
@@ -7053,7 +7407,7 @@
               </a:defRPr>
             </a:lvl3pPr>
             <a:lvl4pPr>
-              <a:defRPr sz="1875" b="1">
+              <a:defRPr sz="1800" b="1">
                 <a:solidFill>
                   <a:srgbClr val="FFFFFF"/>
                 </a:solidFill>
@@ -7063,7 +7417,7 @@
               </a:defRPr>
             </a:lvl4pPr>
             <a:lvl5pPr>
-              <a:defRPr sz="1875" b="1">
+              <a:defRPr sz="1800" b="1">
                 <a:solidFill>
                   <a:srgbClr val="FFFFFF"/>
                 </a:solidFill>
@@ -7073,7 +7427,7 @@
               </a:defRPr>
             </a:lvl5pPr>
             <a:lvl6pPr>
-              <a:defRPr sz="1875" b="1">
+              <a:defRPr sz="1800" b="1">
                 <a:solidFill>
                   <a:srgbClr val="FFFFFF"/>
                 </a:solidFill>
@@ -7083,7 +7437,7 @@
               </a:defRPr>
             </a:lvl6pPr>
             <a:lvl7pPr>
-              <a:defRPr sz="1875" b="1">
+              <a:defRPr sz="1800" b="1">
                 <a:solidFill>
                   <a:srgbClr val="FFFFFF"/>
                 </a:solidFill>
@@ -7093,7 +7447,7 @@
               </a:defRPr>
             </a:lvl7pPr>
             <a:lvl8pPr>
-              <a:defRPr sz="1875" b="1">
+              <a:defRPr sz="1800" b="1">
                 <a:solidFill>
                   <a:srgbClr val="FFFFFF"/>
                 </a:solidFill>
@@ -7103,7 +7457,7 @@
               </a:defRPr>
             </a:lvl8pPr>
             <a:lvl9pPr>
-              <a:defRPr sz="1875" b="1">
+              <a:defRPr sz="1800" b="1">
                 <a:solidFill>
                   <a:srgbClr val="FFFFFF"/>
                 </a:solidFill>
@@ -7115,7 +7469,7 @@
           </a:lstStyle>
           <a:p xmlns:a="http://schemas.openxmlformats.org/drawingml/2006/main">
             <a:pPr>
-              <a:defRPr sz="1875" b="1">
+              <a:defRPr sz="1800" b="1">
                 <a:solidFill>
                   <a:srgbClr val="FFFFFF"/>
                 </a:solidFill>
@@ -7125,7 +7479,7 @@
               </a:defRPr>
             </a:pPr>
             <a:r>
-              <a:rPr sz="1875" b="1">
+              <a:rPr sz="1800" b="1">
                 <a:solidFill>
                   <a:srgbClr val="FFFFFF"/>
                 </a:solidFill>
@@ -7133,17 +7487,17 @@
                 <a:ea typeface="Inter"/>
                 <a:cs typeface="Inter"/>
               </a:rPr>
-              <a:t>Checks published markers</a:t>
+              <a:t>Checks published marker genes</a:t>
             </a:r>
           </a:p>
         </p:txBody>
       </p:sp>
       <p:sp>
         <p:nvSpPr>
-          <p:cNvPr id="8" name="copy-26">
+          <p:cNvPr id="9" name="copy-28">
             <a:extLst xmlns:a="http://schemas.openxmlformats.org/drawingml/2006/main">
               <a:ext uri="{FF2B5EF4-FFF2-40B4-BE49-F238E27FC236}">
-                <a16:creationId xmlns:a16="http://schemas.microsoft.com/office/drawing/2014/main" id="{0C0B7B26-3B4B-450E-BBBD-A782513622BD}"/>
+                <a16:creationId xmlns:a16="http://schemas.microsoft.com/office/drawing/2014/main" id="{2712A84A-4191-4C0C-B04B-C74AFA9BFC86}"/>
               </a:ext>
             </a:extLst>
           </p:cNvPr>
@@ -7154,7 +7508,7 @@
         </p:nvSpPr>
         <p:spPr>
           <a:xfrm xmlns:a="http://schemas.openxmlformats.org/drawingml/2006/main">
-            <a:off x="4000500" y="3514725"/>
+            <a:off x="4000500" y="3705225"/>
             <a:ext cx="4191000" cy="266700"/>
           </a:xfrm>
           <a:prstGeom xmlns:a="http://schemas.openxmlformats.org/drawingml/2006/main" prst="rect">
@@ -7291,17 +7645,17 @@
                 <a:ea typeface="Inter"/>
                 <a:cs typeface="Inter"/>
               </a:rPr>
-              <a:t>Zetaris</a:t>
+              <a:t>Zetaris reference retrieval</a:t>
             </a:r>
           </a:p>
         </p:txBody>
       </p:sp>
       <p:sp>
         <p:nvSpPr>
-          <p:cNvPr id="9" name="copy-27">
+          <p:cNvPr id="10" name="copy-29">
             <a:extLst xmlns:a="http://schemas.openxmlformats.org/drawingml/2006/main">
               <a:ext uri="{FF2B5EF4-FFF2-40B4-BE49-F238E27FC236}">
-                <a16:creationId xmlns:a16="http://schemas.microsoft.com/office/drawing/2014/main" id="{CED8882E-8BA3-46A6-AF3D-E00F637376F7}"/>
+                <a16:creationId xmlns:a16="http://schemas.microsoft.com/office/drawing/2014/main" id="{62681BC6-E941-49E8-9170-FC986A105CCA}"/>
               </a:ext>
             </a:extLst>
           </p:cNvPr>
@@ -7312,7 +7666,7 @@
         </p:nvSpPr>
         <p:spPr>
           <a:xfrm xmlns:a="http://schemas.openxmlformats.org/drawingml/2006/main">
-            <a:off x="4000500" y="3914775"/>
+            <a:off x="4000500" y="4105275"/>
             <a:ext cx="4191000" cy="352425"/>
           </a:xfrm>
           <a:prstGeom xmlns:a="http://schemas.openxmlformats.org/drawingml/2006/main" prst="rect">
@@ -7329,7 +7683,7 @@
           </a:bodyPr>
           <a:lstStyle xmlns:a="http://schemas.openxmlformats.org/drawingml/2006/main">
             <a:defPPr>
-              <a:defRPr sz="1875" b="1">
+              <a:defRPr sz="1800" b="1">
                 <a:solidFill>
                   <a:srgbClr val="FFFFFF"/>
                 </a:solidFill>
@@ -7339,7 +7693,7 @@
               </a:defRPr>
             </a:defPPr>
             <a:lvl1pPr>
-              <a:defRPr sz="1875" b="1">
+              <a:defRPr sz="1800" b="1">
                 <a:solidFill>
                   <a:srgbClr val="FFFFFF"/>
                 </a:solidFill>
@@ -7349,7 +7703,7 @@
               </a:defRPr>
             </a:lvl1pPr>
             <a:lvl2pPr>
-              <a:defRPr sz="1875" b="1">
+              <a:defRPr sz="1800" b="1">
                 <a:solidFill>
                   <a:srgbClr val="FFFFFF"/>
                 </a:solidFill>
@@ -7359,7 +7713,7 @@
               </a:defRPr>
             </a:lvl2pPr>
             <a:lvl3pPr>
-              <a:defRPr sz="1875" b="1">
+              <a:defRPr sz="1800" b="1">
                 <a:solidFill>
                   <a:srgbClr val="FFFFFF"/>
                 </a:solidFill>
@@ -7369,7 +7723,7 @@
               </a:defRPr>
             </a:lvl3pPr>
             <a:lvl4pPr>
-              <a:defRPr sz="1875" b="1">
+              <a:defRPr sz="1800" b="1">
                 <a:solidFill>
                   <a:srgbClr val="FFFFFF"/>
                 </a:solidFill>
@@ -7379,7 +7733,7 @@
               </a:defRPr>
             </a:lvl4pPr>
             <a:lvl5pPr>
-              <a:defRPr sz="1875" b="1">
+              <a:defRPr sz="1800" b="1">
                 <a:solidFill>
                   <a:srgbClr val="FFFFFF"/>
                 </a:solidFill>
@@ -7389,7 +7743,7 @@
               </a:defRPr>
             </a:lvl5pPr>
             <a:lvl6pPr>
-              <a:defRPr sz="1875" b="1">
+              <a:defRPr sz="1800" b="1">
                 <a:solidFill>
                   <a:srgbClr val="FFFFFF"/>
                 </a:solidFill>
@@ -7399,7 +7753,7 @@
               </a:defRPr>
             </a:lvl6pPr>
             <a:lvl7pPr>
-              <a:defRPr sz="1875" b="1">
+              <a:defRPr sz="1800" b="1">
                 <a:solidFill>
                   <a:srgbClr val="FFFFFF"/>
                 </a:solidFill>
@@ -7409,7 +7763,7 @@
               </a:defRPr>
             </a:lvl7pPr>
             <a:lvl8pPr>
-              <a:defRPr sz="1875" b="1">
+              <a:defRPr sz="1800" b="1">
                 <a:solidFill>
                   <a:srgbClr val="FFFFFF"/>
                 </a:solidFill>
@@ -7419,7 +7773,7 @@
               </a:defRPr>
             </a:lvl8pPr>
             <a:lvl9pPr>
-              <a:defRPr sz="1875" b="1">
+              <a:defRPr sz="1800" b="1">
                 <a:solidFill>
                   <a:srgbClr val="FFFFFF"/>
                 </a:solidFill>
@@ -7431,7 +7785,7 @@
           </a:lstStyle>
           <a:p xmlns:a="http://schemas.openxmlformats.org/drawingml/2006/main">
             <a:pPr>
-              <a:defRPr sz="1875" b="1">
+              <a:defRPr sz="1800" b="1">
                 <a:solidFill>
                   <a:srgbClr val="FFFFFF"/>
                 </a:solidFill>
@@ -7441,7 +7795,7 @@
               </a:defRPr>
             </a:pPr>
             <a:r>
-              <a:rPr sz="1875" b="1">
+              <a:rPr sz="1800" b="1">
                 <a:solidFill>
                   <a:srgbClr val="FFFFFF"/>
                 </a:solidFill>
@@ -7449,17 +7803,17 @@
                 <a:ea typeface="Inter"/>
                 <a:cs typeface="Inter"/>
               </a:rPr>
-              <a:t>Measures gene expression</a:t>
+              <a:t>Measures activity of those genes</a:t>
             </a:r>
           </a:p>
         </p:txBody>
       </p:sp>
       <p:sp>
         <p:nvSpPr>
-          <p:cNvPr id="10" name="copy-28">
+          <p:cNvPr id="11" name="copy-30">
             <a:extLst xmlns:a="http://schemas.openxmlformats.org/drawingml/2006/main">
               <a:ext uri="{FF2B5EF4-FFF2-40B4-BE49-F238E27FC236}">
-                <a16:creationId xmlns:a16="http://schemas.microsoft.com/office/drawing/2014/main" id="{6488416E-FB4F-43F9-AE42-CF4695E7FAF9}"/>
+                <a16:creationId xmlns:a16="http://schemas.microsoft.com/office/drawing/2014/main" id="{5C398793-78F7-4028-AB8D-05A9541AA2B6}"/>
               </a:ext>
             </a:extLst>
           </p:cNvPr>
@@ -7470,7 +7824,7 @@
         </p:nvSpPr>
         <p:spPr>
           <a:xfrm xmlns:a="http://schemas.openxmlformats.org/drawingml/2006/main">
-            <a:off x="4000500" y="4276725"/>
+            <a:off x="4000500" y="4467225"/>
             <a:ext cx="4191000" cy="266700"/>
           </a:xfrm>
           <a:prstGeom xmlns:a="http://schemas.openxmlformats.org/drawingml/2006/main" prst="rect">
@@ -7614,10 +7968,10 @@
       </p:sp>
       <p:sp>
         <p:nvSpPr>
-          <p:cNvPr id="11" name="copy-29">
+          <p:cNvPr id="12" name="copy-31">
             <a:extLst xmlns:a="http://schemas.openxmlformats.org/drawingml/2006/main">
               <a:ext uri="{FF2B5EF4-FFF2-40B4-BE49-F238E27FC236}">
-                <a16:creationId xmlns:a16="http://schemas.microsoft.com/office/drawing/2014/main" id="{94430AA9-54F6-425A-9535-EB0A2F31DFB5}"/>
+                <a16:creationId xmlns:a16="http://schemas.microsoft.com/office/drawing/2014/main" id="{C0AC56A2-87FE-4426-88AC-890A4C74E001}"/>
               </a:ext>
             </a:extLst>
           </p:cNvPr>
@@ -7628,7 +7982,7 @@
         </p:nvSpPr>
         <p:spPr>
           <a:xfrm xmlns:a="http://schemas.openxmlformats.org/drawingml/2006/main">
-            <a:off x="4000500" y="4676775"/>
+            <a:off x="4000500" y="4867275"/>
             <a:ext cx="4191000" cy="352425"/>
           </a:xfrm>
           <a:prstGeom xmlns:a="http://schemas.openxmlformats.org/drawingml/2006/main" prst="rect">
@@ -7645,7 +7999,7 @@
           </a:bodyPr>
           <a:lstStyle xmlns:a="http://schemas.openxmlformats.org/drawingml/2006/main">
             <a:defPPr>
-              <a:defRPr sz="1875" b="1">
+              <a:defRPr sz="1800" b="1">
                 <a:solidFill>
                   <a:srgbClr val="FFFFFF"/>
                 </a:solidFill>
@@ -7655,7 +8009,7 @@
               </a:defRPr>
             </a:defPPr>
             <a:lvl1pPr>
-              <a:defRPr sz="1875" b="1">
+              <a:defRPr sz="1800" b="1">
                 <a:solidFill>
                   <a:srgbClr val="FFFFFF"/>
                 </a:solidFill>
@@ -7665,7 +8019,7 @@
               </a:defRPr>
             </a:lvl1pPr>
             <a:lvl2pPr>
-              <a:defRPr sz="1875" b="1">
+              <a:defRPr sz="1800" b="1">
                 <a:solidFill>
                   <a:srgbClr val="FFFFFF"/>
                 </a:solidFill>
@@ -7675,7 +8029,7 @@
               </a:defRPr>
             </a:lvl2pPr>
             <a:lvl3pPr>
-              <a:defRPr sz="1875" b="1">
+              <a:defRPr sz="1800" b="1">
                 <a:solidFill>
                   <a:srgbClr val="FFFFFF"/>
                 </a:solidFill>
@@ -7685,7 +8039,7 @@
               </a:defRPr>
             </a:lvl3pPr>
             <a:lvl4pPr>
-              <a:defRPr sz="1875" b="1">
+              <a:defRPr sz="1800" b="1">
                 <a:solidFill>
                   <a:srgbClr val="FFFFFF"/>
                 </a:solidFill>
@@ -7695,7 +8049,7 @@
               </a:defRPr>
             </a:lvl4pPr>
             <a:lvl5pPr>
-              <a:defRPr sz="1875" b="1">
+              <a:defRPr sz="1800" b="1">
                 <a:solidFill>
                   <a:srgbClr val="FFFFFF"/>
                 </a:solidFill>
@@ -7705,7 +8059,7 @@
               </a:defRPr>
             </a:lvl5pPr>
             <a:lvl6pPr>
-              <a:defRPr sz="1875" b="1">
+              <a:defRPr sz="1800" b="1">
                 <a:solidFill>
                   <a:srgbClr val="FFFFFF"/>
                 </a:solidFill>
@@ -7715,7 +8069,7 @@
               </a:defRPr>
             </a:lvl6pPr>
             <a:lvl7pPr>
-              <a:defRPr sz="1875" b="1">
+              <a:defRPr sz="1800" b="1">
                 <a:solidFill>
                   <a:srgbClr val="FFFFFF"/>
                 </a:solidFill>
@@ -7725,7 +8079,7 @@
               </a:defRPr>
             </a:lvl7pPr>
             <a:lvl8pPr>
-              <a:defRPr sz="1875" b="1">
+              <a:defRPr sz="1800" b="1">
                 <a:solidFill>
                   <a:srgbClr val="FFFFFF"/>
                 </a:solidFill>
@@ -7735,7 +8089,7 @@
               </a:defRPr>
             </a:lvl8pPr>
             <a:lvl9pPr>
-              <a:defRPr sz="1875" b="1">
+              <a:defRPr sz="1800" b="1">
                 <a:solidFill>
                   <a:srgbClr val="FFFFFF"/>
                 </a:solidFill>
@@ -7747,7 +8101,7 @@
           </a:lstStyle>
           <a:p xmlns:a="http://schemas.openxmlformats.org/drawingml/2006/main">
             <a:pPr>
-              <a:defRPr sz="1875" b="1">
+              <a:defRPr sz="1800" b="1">
                 <a:solidFill>
                   <a:srgbClr val="FFFFFF"/>
                 </a:solidFill>
@@ -7757,7 +8111,7 @@
               </a:defRPr>
             </a:pPr>
             <a:r>
-              <a:rPr sz="1875" b="1">
+              <a:rPr sz="1800" b="1">
                 <a:solidFill>
                   <a:srgbClr val="FFFFFF"/>
                 </a:solidFill>
@@ -7765,17 +8119,17 @@
                 <a:ea typeface="Inter"/>
                 <a:cs typeface="Inter"/>
               </a:rPr>
-              <a:t>Recalls your reviewed decisions</a:t>
+              <a:t>Recalls the saved review and why</a:t>
             </a:r>
           </a:p>
         </p:txBody>
       </p:sp>
       <p:sp>
         <p:nvSpPr>
-          <p:cNvPr id="12" name="copy-30">
+          <p:cNvPr id="13" name="copy-32">
             <a:extLst xmlns:a="http://schemas.openxmlformats.org/drawingml/2006/main">
               <a:ext uri="{FF2B5EF4-FFF2-40B4-BE49-F238E27FC236}">
-                <a16:creationId xmlns:a16="http://schemas.microsoft.com/office/drawing/2014/main" id="{9CAC7BDB-0147-4BD3-96A6-4449412F0320}"/>
+                <a16:creationId xmlns:a16="http://schemas.microsoft.com/office/drawing/2014/main" id="{BC661AF2-9BE6-40F3-AE42-F12BFBCDD8C7}"/>
               </a:ext>
             </a:extLst>
           </p:cNvPr>
@@ -7786,7 +8140,7 @@
         </p:nvSpPr>
         <p:spPr>
           <a:xfrm xmlns:a="http://schemas.openxmlformats.org/drawingml/2006/main">
-            <a:off x="4000500" y="5038725"/>
+            <a:off x="4000500" y="5229225"/>
             <a:ext cx="4191000" cy="266700"/>
           </a:xfrm>
           <a:prstGeom xmlns:a="http://schemas.openxmlformats.org/drawingml/2006/main" prst="rect">
@@ -7930,10 +8284,10 @@
       </p:sp>
       <p:sp>
         <p:nvSpPr>
-          <p:cNvPr id="13" name="arrow-31">
+          <p:cNvPr id="14" name="arrow-33">
             <a:extLst xmlns:a="http://schemas.openxmlformats.org/drawingml/2006/main">
               <a:ext uri="{FF2B5EF4-FFF2-40B4-BE49-F238E27FC236}">
-                <a16:creationId xmlns:a16="http://schemas.microsoft.com/office/drawing/2014/main" id="{A446DA27-0513-444B-BD85-03C652A8959C}"/>
+                <a16:creationId xmlns:a16="http://schemas.microsoft.com/office/drawing/2014/main" id="{345E5CEE-935B-41F2-A7C4-5DBBE91766CB}"/>
               </a:ext>
             </a:extLst>
           </p:cNvPr>
@@ -7944,7 +8298,7 @@
         </p:nvSpPr>
         <p:spPr>
           <a:xfrm xmlns:a="http://schemas.openxmlformats.org/drawingml/2006/main">
-            <a:off x="8724900" y="3705225"/>
+            <a:off x="8724900" y="3895725"/>
             <a:ext cx="361950" cy="152400"/>
           </a:xfrm>
           <a:prstGeom xmlns:a="http://schemas.openxmlformats.org/drawingml/2006/main" prst="rightArrow">
@@ -7960,10 +8314,10 @@
       </p:sp>
       <p:sp>
         <p:nvSpPr>
-          <p:cNvPr id="14" name="copy-32">
+          <p:cNvPr id="15" name="copy-34">
             <a:extLst xmlns:a="http://schemas.openxmlformats.org/drawingml/2006/main">
               <a:ext uri="{FF2B5EF4-FFF2-40B4-BE49-F238E27FC236}">
-                <a16:creationId xmlns:a16="http://schemas.microsoft.com/office/drawing/2014/main" id="{7A8EA216-7165-44E3-80C8-CC98AD033E1F}"/>
+                <a16:creationId xmlns:a16="http://schemas.microsoft.com/office/drawing/2014/main" id="{1D7F0C62-DBAA-47B8-BE1C-C361BE76A845}"/>
               </a:ext>
             </a:extLst>
           </p:cNvPr>
@@ -7974,7 +8328,7 @@
         </p:nvSpPr>
         <p:spPr>
           <a:xfrm xmlns:a="http://schemas.openxmlformats.org/drawingml/2006/main">
-            <a:off x="9372600" y="2428875"/>
+            <a:off x="9372600" y="2628900"/>
             <a:ext cx="2381250" cy="428625"/>
           </a:xfrm>
           <a:prstGeom xmlns:a="http://schemas.openxmlformats.org/drawingml/2006/main" prst="rect">
@@ -8111,17 +8465,17 @@
                 <a:ea typeface="Inter"/>
                 <a:cs typeface="Inter"/>
               </a:rPr>
-              <a:t>You receive</a:t>
+              <a:t>You see</a:t>
             </a:r>
           </a:p>
         </p:txBody>
       </p:sp>
       <p:sp>
         <p:nvSpPr>
-          <p:cNvPr id="15" name="copy-33">
+          <p:cNvPr id="16" name="copy-35">
             <a:extLst xmlns:a="http://schemas.openxmlformats.org/drawingml/2006/main">
               <a:ext uri="{FF2B5EF4-FFF2-40B4-BE49-F238E27FC236}">
-                <a16:creationId xmlns:a16="http://schemas.microsoft.com/office/drawing/2014/main" id="{C110C285-2917-4A64-84DA-C450DC72E081}"/>
+                <a16:creationId xmlns:a16="http://schemas.microsoft.com/office/drawing/2014/main" id="{2F47BDCF-BC8C-4798-82C4-581688653804}"/>
               </a:ext>
             </a:extLst>
           </p:cNvPr>
@@ -8132,7 +8486,7 @@
         </p:nvSpPr>
         <p:spPr>
           <a:xfrm xmlns:a="http://schemas.openxmlformats.org/drawingml/2006/main">
-            <a:off x="9372600" y="3095625"/>
+            <a:off x="9372600" y="3286125"/>
             <a:ext cx="2381250" cy="1381125"/>
           </a:xfrm>
           <a:prstGeom xmlns:a="http://schemas.openxmlformats.org/drawingml/2006/main" prst="rect">
@@ -8149,7 +8503,7 @@
           </a:bodyPr>
           <a:lstStyle xmlns:a="http://schemas.openxmlformats.org/drawingml/2006/main">
             <a:defPPr>
-              <a:defRPr sz="2025" b="0">
+              <a:defRPr sz="1875" b="0">
                 <a:solidFill>
                   <a:srgbClr val="111111"/>
                 </a:solidFill>
@@ -8159,7 +8513,7 @@
               </a:defRPr>
             </a:defPPr>
             <a:lvl1pPr>
-              <a:defRPr sz="2025" b="0">
+              <a:defRPr sz="1875" b="0">
                 <a:solidFill>
                   <a:srgbClr val="111111"/>
                 </a:solidFill>
@@ -8169,7 +8523,7 @@
               </a:defRPr>
             </a:lvl1pPr>
             <a:lvl2pPr>
-              <a:defRPr sz="2025" b="0">
+              <a:defRPr sz="1875" b="0">
                 <a:solidFill>
                   <a:srgbClr val="111111"/>
                 </a:solidFill>
@@ -8179,7 +8533,7 @@
               </a:defRPr>
             </a:lvl2pPr>
             <a:lvl3pPr>
-              <a:defRPr sz="2025" b="0">
+              <a:defRPr sz="1875" b="0">
                 <a:solidFill>
                   <a:srgbClr val="111111"/>
                 </a:solidFill>
@@ -8189,7 +8543,7 @@
               </a:defRPr>
             </a:lvl3pPr>
             <a:lvl4pPr>
-              <a:defRPr sz="2025" b="0">
+              <a:defRPr sz="1875" b="0">
                 <a:solidFill>
                   <a:srgbClr val="111111"/>
                 </a:solidFill>
@@ -8199,7 +8553,7 @@
               </a:defRPr>
             </a:lvl4pPr>
             <a:lvl5pPr>
-              <a:defRPr sz="2025" b="0">
+              <a:defRPr sz="1875" b="0">
                 <a:solidFill>
                   <a:srgbClr val="111111"/>
                 </a:solidFill>
@@ -8209,7 +8563,7 @@
               </a:defRPr>
             </a:lvl5pPr>
             <a:lvl6pPr>
-              <a:defRPr sz="2025" b="0">
+              <a:defRPr sz="1875" b="0">
                 <a:solidFill>
                   <a:srgbClr val="111111"/>
                 </a:solidFill>
@@ -8219,7 +8573,7 @@
               </a:defRPr>
             </a:lvl6pPr>
             <a:lvl7pPr>
-              <a:defRPr sz="2025" b="0">
+              <a:defRPr sz="1875" b="0">
                 <a:solidFill>
                   <a:srgbClr val="111111"/>
                 </a:solidFill>
@@ -8229,7 +8583,7 @@
               </a:defRPr>
             </a:lvl7pPr>
             <a:lvl8pPr>
-              <a:defRPr sz="2025" b="0">
+              <a:defRPr sz="1875" b="0">
                 <a:solidFill>
                   <a:srgbClr val="111111"/>
                 </a:solidFill>
@@ -8239,7 +8593,7 @@
               </a:defRPr>
             </a:lvl8pPr>
             <a:lvl9pPr>
-              <a:defRPr sz="2025" b="0">
+              <a:defRPr sz="1875" b="0">
                 <a:solidFill>
                   <a:srgbClr val="111111"/>
                 </a:solidFill>
@@ -8251,7 +8605,7 @@
           </a:lstStyle>
           <a:p xmlns:a="http://schemas.openxmlformats.org/drawingml/2006/main">
             <a:pPr>
-              <a:defRPr sz="2025" b="0">
+              <a:defRPr sz="1875" b="0">
                 <a:solidFill>
                   <a:srgbClr val="111111"/>
                 </a:solidFill>
@@ -8261,7 +8615,7 @@
               </a:defRPr>
             </a:pPr>
             <a:r>
-              <a:rPr sz="2025" b="0">
+              <a:rPr sz="1875" b="0">
                 <a:solidFill>
                   <a:srgbClr val="111111"/>
                 </a:solidFill>
@@ -8269,12 +8623,12 @@
                 <a:ea typeface="Inter"/>
                 <a:cs typeface="Inter"/>
               </a:rPr>
-              <a:t>Cell map</a:t>
+              <a:t>Root hair candidate</a:t>
             </a:r>
           </a:p>
           <a:p xmlns:a="http://schemas.openxmlformats.org/drawingml/2006/main">
             <a:pPr>
-              <a:defRPr sz="2025" b="0">
+              <a:defRPr sz="1875" b="0">
                 <a:solidFill>
                   <a:srgbClr val="111111"/>
                 </a:solidFill>
@@ -8284,7 +8638,7 @@
               </a:defRPr>
             </a:pPr>
             <a:r>
-              <a:rPr sz="2025" b="0">
+              <a:rPr sz="1875" b="0">
                 <a:solidFill>
                   <a:srgbClr val="111111"/>
                 </a:solidFill>
@@ -8292,12 +8646,12 @@
                 <a:ea typeface="Inter"/>
                 <a:cs typeface="Inter"/>
               </a:rPr>
-              <a:t>Supporting genes</a:t>
+              <a:t>2 supporting genes</a:t>
             </a:r>
           </a:p>
           <a:p xmlns:a="http://schemas.openxmlformats.org/drawingml/2006/main">
             <a:pPr>
-              <a:defRPr sz="2025" b="0">
+              <a:defRPr sz="1875" b="0">
                 <a:solidFill>
                   <a:srgbClr val="111111"/>
                 </a:solidFill>
@@ -8307,7 +8661,7 @@
               </a:defRPr>
             </a:pPr>
             <a:r>
-              <a:rPr sz="2025" b="0">
+              <a:rPr sz="1875" b="0">
                 <a:solidFill>
                   <a:srgbClr val="111111"/>
                 </a:solidFill>
@@ -8315,17 +8669,17 @@
                 <a:ea typeface="Inter"/>
                 <a:cs typeface="Inter"/>
               </a:rPr>
-              <a:t>Source links</a:t>
+              <a:t>Links to the evidence</a:t>
             </a:r>
           </a:p>
         </p:txBody>
       </p:sp>
       <p:sp>
         <p:nvSpPr>
-          <p:cNvPr id="16" name="copy-34">
+          <p:cNvPr id="17" name="copy-36">
             <a:extLst xmlns:a="http://schemas.openxmlformats.org/drawingml/2006/main">
               <a:ext uri="{FF2B5EF4-FFF2-40B4-BE49-F238E27FC236}">
-                <a16:creationId xmlns:a16="http://schemas.microsoft.com/office/drawing/2014/main" id="{C302DCCD-D9EF-4D59-9B71-7A8CC8BA2BB4}"/>
+                <a16:creationId xmlns:a16="http://schemas.microsoft.com/office/drawing/2014/main" id="{6652F4D3-E1ED-49CF-AE12-E9F5EEC731C4}"/>
               </a:ext>
             </a:extLst>
           </p:cNvPr>
@@ -8336,7 +8690,7 @@
         </p:nvSpPr>
         <p:spPr>
           <a:xfrm xmlns:a="http://schemas.openxmlformats.org/drawingml/2006/main">
-            <a:off x="552450" y="6172200"/>
+            <a:off x="552450" y="6238875"/>
             <a:ext cx="11087100" cy="409575"/>
           </a:xfrm>
           <a:prstGeom xmlns:a="http://schemas.openxmlformats.org/drawingml/2006/main" prst="rect">
@@ -8353,7 +8707,7 @@
           </a:bodyPr>
           <a:lstStyle xmlns:a="http://schemas.openxmlformats.org/drawingml/2006/main">
             <a:defPPr>
-              <a:defRPr sz="2100" b="0">
+              <a:defRPr sz="1950" b="0">
                 <a:solidFill>
                   <a:srgbClr val="111111"/>
                 </a:solidFill>
@@ -8363,7 +8717,7 @@
               </a:defRPr>
             </a:defPPr>
             <a:lvl1pPr>
-              <a:defRPr sz="2100" b="0">
+              <a:defRPr sz="1950" b="0">
                 <a:solidFill>
                   <a:srgbClr val="111111"/>
                 </a:solidFill>
@@ -8373,7 +8727,7 @@
               </a:defRPr>
             </a:lvl1pPr>
             <a:lvl2pPr>
-              <a:defRPr sz="2100" b="0">
+              <a:defRPr sz="1950" b="0">
                 <a:solidFill>
                   <a:srgbClr val="111111"/>
                 </a:solidFill>
@@ -8383,7 +8737,7 @@
               </a:defRPr>
             </a:lvl2pPr>
             <a:lvl3pPr>
-              <a:defRPr sz="2100" b="0">
+              <a:defRPr sz="1950" b="0">
                 <a:solidFill>
                   <a:srgbClr val="111111"/>
                 </a:solidFill>
@@ -8393,7 +8747,7 @@
               </a:defRPr>
             </a:lvl3pPr>
             <a:lvl4pPr>
-              <a:defRPr sz="2100" b="0">
+              <a:defRPr sz="1950" b="0">
                 <a:solidFill>
                   <a:srgbClr val="111111"/>
                 </a:solidFill>
@@ -8403,7 +8757,7 @@
               </a:defRPr>
             </a:lvl4pPr>
             <a:lvl5pPr>
-              <a:defRPr sz="2100" b="0">
+              <a:defRPr sz="1950" b="0">
                 <a:solidFill>
                   <a:srgbClr val="111111"/>
                 </a:solidFill>
@@ -8413,7 +8767,7 @@
               </a:defRPr>
             </a:lvl5pPr>
             <a:lvl6pPr>
-              <a:defRPr sz="2100" b="0">
+              <a:defRPr sz="1950" b="0">
                 <a:solidFill>
                   <a:srgbClr val="111111"/>
                 </a:solidFill>
@@ -8423,7 +8777,7 @@
               </a:defRPr>
             </a:lvl6pPr>
             <a:lvl7pPr>
-              <a:defRPr sz="2100" b="0">
+              <a:defRPr sz="1950" b="0">
                 <a:solidFill>
                   <a:srgbClr val="111111"/>
                 </a:solidFill>
@@ -8433,7 +8787,7 @@
               </a:defRPr>
             </a:lvl7pPr>
             <a:lvl8pPr>
-              <a:defRPr sz="2100" b="0">
+              <a:defRPr sz="1950" b="0">
                 <a:solidFill>
                   <a:srgbClr val="111111"/>
                 </a:solidFill>
@@ -8443,7 +8797,7 @@
               </a:defRPr>
             </a:lvl8pPr>
             <a:lvl9pPr>
-              <a:defRPr sz="2100" b="0">
+              <a:defRPr sz="1950" b="0">
                 <a:solidFill>
                   <a:srgbClr val="111111"/>
                 </a:solidFill>
@@ -8455,7 +8809,7 @@
           </a:lstStyle>
           <a:p xmlns:a="http://schemas.openxmlformats.org/drawingml/2006/main">
             <a:pPr>
-              <a:defRPr sz="2100" b="0">
+              <a:defRPr sz="1950" b="0">
                 <a:solidFill>
                   <a:srgbClr val="111111"/>
                 </a:solidFill>
@@ -8465,7 +8819,7 @@
               </a:defRPr>
             </a:pPr>
             <a:r>
-              <a:rPr sz="2100" b="0">
+              <a:rPr sz="1950" b="0">
                 <a:solidFill>
                   <a:srgbClr val="111111"/>
                 </a:solidFill>
@@ -8473,7 +8827,7 @@
                 <a:ea typeface="Inter"/>
                 <a:cs typeface="Inter"/>
               </a:rPr>
-              <a:t>You review the evidence and save your decision.</a:t>
+              <a:t>Annotation suggests the identity. The journal keeps your judgment.</a:t>
             </a:r>
           </a:p>
         </p:txBody>
@@ -8481,7 +8835,7 @@
     </p:spTree>
     <p:extLst>
       <p:ext uri="{BB962C8B-B14F-4D97-AF65-F5344CB8AC3E}">
-        <p14:creationId xmlns:p14="http://schemas.microsoft.com/office/powerpoint/2010/main" val="1020874434"/>
+        <p14:creationId xmlns:p14="http://schemas.microsoft.com/office/powerpoint/2010/main" val="1611020421"/>
       </p:ext>
     </p:extLst>
   </p:cSld>
@@ -8509,10 +8863,10 @@
       </p:grpSpPr>
       <p:sp>
         <p:nvSpPr>
-          <p:cNvPr id="12" name="copy-35">
+          <p:cNvPr id="14" name="copy-37">
             <a:extLst xmlns:a="http://schemas.openxmlformats.org/drawingml/2006/main">
               <a:ext uri="{FF2B5EF4-FFF2-40B4-BE49-F238E27FC236}">
-                <a16:creationId xmlns:a16="http://schemas.microsoft.com/office/drawing/2014/main" id="{94F7065F-F657-4019-92CB-22EF801D5FBB}"/>
+                <a16:creationId xmlns:a16="http://schemas.microsoft.com/office/drawing/2014/main" id="{59BC21FD-FC09-486B-B91E-C6F60C4D5902}"/>
               </a:ext>
             </a:extLst>
           </p:cNvPr>
@@ -8667,10 +9021,10 @@
       </p:sp>
       <p:sp>
         <p:nvSpPr>
-          <p:cNvPr id="2" name="copy-36">
+          <p:cNvPr id="2" name="copy-38">
             <a:extLst xmlns:a="http://schemas.openxmlformats.org/drawingml/2006/main">
               <a:ext uri="{FF2B5EF4-FFF2-40B4-BE49-F238E27FC236}">
-                <a16:creationId xmlns:a16="http://schemas.microsoft.com/office/drawing/2014/main" id="{598F4407-745E-448E-9E6C-1C6EAB9E527E}"/>
+                <a16:creationId xmlns:a16="http://schemas.microsoft.com/office/drawing/2014/main" id="{9A4B30CA-426F-4192-8595-4939804FB638}"/>
               </a:ext>
             </a:extLst>
           </p:cNvPr>
@@ -8818,17 +9172,17 @@
                 <a:ea typeface="Inter"/>
                 <a:cs typeface="Inter"/>
               </a:rPr>
-              <a:t>The agent recalls your latest decision and links to its source.</a:t>
+              <a:t>The research journal keeps the decision attached to its evidence.</a:t>
             </a:r>
           </a:p>
         </p:txBody>
       </p:sp>
       <p:sp>
         <p:nvSpPr>
-          <p:cNvPr id="3" name="copy-37">
+          <p:cNvPr id="3" name="copy-39">
             <a:extLst xmlns:a="http://schemas.openxmlformats.org/drawingml/2006/main">
               <a:ext uri="{FF2B5EF4-FFF2-40B4-BE49-F238E27FC236}">
-                <a16:creationId xmlns:a16="http://schemas.microsoft.com/office/drawing/2014/main" id="{160B9BA7-06BF-4AF7-8FFB-BED151A722AF}"/>
+                <a16:creationId xmlns:a16="http://schemas.microsoft.com/office/drawing/2014/main" id="{356CC0B6-54FC-427D-B643-83F5BE140E4C}"/>
               </a:ext>
             </a:extLst>
           </p:cNvPr>
@@ -8839,7 +9193,7 @@
         </p:nvSpPr>
         <p:spPr>
           <a:xfrm xmlns:a="http://schemas.openxmlformats.org/drawingml/2006/main">
-            <a:off x="552450" y="2286000"/>
+            <a:off x="552450" y="2228850"/>
             <a:ext cx="11087100" cy="314325"/>
           </a:xfrm>
           <a:prstGeom xmlns:a="http://schemas.openxmlformats.org/drawingml/2006/main" prst="rect">
@@ -8976,17 +9330,17 @@
                 <a:ea typeface="Inter"/>
                 <a:cs typeface="Inter"/>
               </a:rPr>
-              <a:t>Actual agent reply</a:t>
+              <a:t>Actual agent reply after a demo review</a:t>
             </a:r>
           </a:p>
         </p:txBody>
       </p:sp>
       <p:sp>
         <p:nvSpPr>
-          <p:cNvPr id="4" name="copy-38">
+          <p:cNvPr id="4" name="copy-40">
             <a:extLst xmlns:a="http://schemas.openxmlformats.org/drawingml/2006/main">
               <a:ext uri="{FF2B5EF4-FFF2-40B4-BE49-F238E27FC236}">
-                <a16:creationId xmlns:a16="http://schemas.microsoft.com/office/drawing/2014/main" id="{87E76C6C-DBA0-436A-BB0D-0048DA1D766C}"/>
+                <a16:creationId xmlns:a16="http://schemas.microsoft.com/office/drawing/2014/main" id="{C09246AB-0122-4E1F-B058-930022F718DB}"/>
               </a:ext>
             </a:extLst>
           </p:cNvPr>
@@ -8997,8 +9351,8 @@
         </p:nvSpPr>
         <p:spPr>
           <a:xfrm xmlns:a="http://schemas.openxmlformats.org/drawingml/2006/main">
-            <a:off x="552450" y="2800350"/>
-            <a:ext cx="11087100" cy="1152525"/>
+            <a:off x="552450" y="2667000"/>
+            <a:ext cx="11087100" cy="1028700"/>
           </a:xfrm>
           <a:prstGeom xmlns:a="http://schemas.openxmlformats.org/drawingml/2006/main" prst="rect">
             <a:avLst/>
@@ -9014,7 +9368,7 @@
           </a:bodyPr>
           <a:lstStyle xmlns:a="http://schemas.openxmlformats.org/drawingml/2006/main">
             <a:defPPr>
-              <a:defRPr sz="2175" b="0">
+              <a:defRPr sz="2100" b="0">
                 <a:solidFill>
                   <a:srgbClr val="111111"/>
                 </a:solidFill>
@@ -9024,7 +9378,7 @@
               </a:defRPr>
             </a:defPPr>
             <a:lvl1pPr>
-              <a:defRPr sz="2175" b="0">
+              <a:defRPr sz="2100" b="0">
                 <a:solidFill>
                   <a:srgbClr val="111111"/>
                 </a:solidFill>
@@ -9034,7 +9388,7 @@
               </a:defRPr>
             </a:lvl1pPr>
             <a:lvl2pPr>
-              <a:defRPr sz="2175" b="0">
+              <a:defRPr sz="2100" b="0">
                 <a:solidFill>
                   <a:srgbClr val="111111"/>
                 </a:solidFill>
@@ -9044,7 +9398,7 @@
               </a:defRPr>
             </a:lvl2pPr>
             <a:lvl3pPr>
-              <a:defRPr sz="2175" b="0">
+              <a:defRPr sz="2100" b="0">
                 <a:solidFill>
                   <a:srgbClr val="111111"/>
                 </a:solidFill>
@@ -9054,7 +9408,7 @@
               </a:defRPr>
             </a:lvl3pPr>
             <a:lvl4pPr>
-              <a:defRPr sz="2175" b="0">
+              <a:defRPr sz="2100" b="0">
                 <a:solidFill>
                   <a:srgbClr val="111111"/>
                 </a:solidFill>
@@ -9064,7 +9418,7 @@
               </a:defRPr>
             </a:lvl4pPr>
             <a:lvl5pPr>
-              <a:defRPr sz="2175" b="0">
+              <a:defRPr sz="2100" b="0">
                 <a:solidFill>
                   <a:srgbClr val="111111"/>
                 </a:solidFill>
@@ -9074,7 +9428,7 @@
               </a:defRPr>
             </a:lvl5pPr>
             <a:lvl6pPr>
-              <a:defRPr sz="2175" b="0">
+              <a:defRPr sz="2100" b="0">
                 <a:solidFill>
                   <a:srgbClr val="111111"/>
                 </a:solidFill>
@@ -9084,7 +9438,7 @@
               </a:defRPr>
             </a:lvl6pPr>
             <a:lvl7pPr>
-              <a:defRPr sz="2175" b="0">
+              <a:defRPr sz="2100" b="0">
                 <a:solidFill>
                   <a:srgbClr val="111111"/>
                 </a:solidFill>
@@ -9094,7 +9448,7 @@
               </a:defRPr>
             </a:lvl7pPr>
             <a:lvl8pPr>
-              <a:defRPr sz="2175" b="0">
+              <a:defRPr sz="2100" b="0">
                 <a:solidFill>
                   <a:srgbClr val="111111"/>
                 </a:solidFill>
@@ -9104,7 +9458,7 @@
               </a:defRPr>
             </a:lvl8pPr>
             <a:lvl9pPr>
-              <a:defRPr sz="2175" b="0">
+              <a:defRPr sz="2100" b="0">
                 <a:solidFill>
                   <a:srgbClr val="111111"/>
                 </a:solidFill>
@@ -9116,7 +9470,7 @@
           </a:lstStyle>
           <a:p xmlns:a="http://schemas.openxmlformats.org/drawingml/2006/main">
             <a:pPr>
-              <a:defRPr sz="2175" b="0">
+              <a:defRPr sz="2100" b="0">
                 <a:solidFill>
                   <a:srgbClr val="111111"/>
                 </a:solidFill>
@@ -9126,7 +9480,7 @@
               </a:defRPr>
             </a:pPr>
             <a:r>
-              <a:rPr sz="2175" b="0">
+              <a:rPr sz="2100" b="0">
                 <a:solidFill>
                   <a:srgbClr val="111111"/>
                 </a:solidFill>
@@ -9141,10 +9495,10 @@
       </p:sp>
       <p:sp>
         <p:nvSpPr>
-          <p:cNvPr id="5" name="copy-39">
+          <p:cNvPr id="5" name="copy-41">
             <a:extLst xmlns:a="http://schemas.openxmlformats.org/drawingml/2006/main">
               <a:ext uri="{FF2B5EF4-FFF2-40B4-BE49-F238E27FC236}">
-                <a16:creationId xmlns:a16="http://schemas.microsoft.com/office/drawing/2014/main" id="{5B53936B-BABA-400B-8123-42992C7EDA8F}"/>
+                <a16:creationId xmlns:a16="http://schemas.microsoft.com/office/drawing/2014/main" id="{BBEFB007-4E66-46FA-9A0B-852FD98C7D51}"/>
               </a:ext>
             </a:extLst>
           </p:cNvPr>
@@ -9155,7 +9509,7 @@
         </p:nvSpPr>
         <p:spPr>
           <a:xfrm xmlns:a="http://schemas.openxmlformats.org/drawingml/2006/main">
-            <a:off x="552450" y="3981450"/>
+            <a:off x="552450" y="3667125"/>
             <a:ext cx="11087100" cy="352425"/>
           </a:xfrm>
           <a:prstGeom xmlns:a="http://schemas.openxmlformats.org/drawingml/2006/main" prst="rect">
@@ -9291,7 +9645,7 @@
                 <a:latin typeface="Inter"/>
                 <a:ea typeface="Inter"/>
                 <a:cs typeface="Inter"/>
-                <a:hlinkClick xmlns:r="http://schemas.openxmlformats.org/officeDocument/2006/relationships" r:id="Rfa0665f5669b49ba"/>
+                <a:hlinkClick xmlns:r="http://schemas.openxmlformats.org/officeDocument/2006/relationships" r:id="Rf1e771b4b3ce47ea"/>
               </a:rPr>
               <a:t>Open the reply and its saved-review source</a:t>
             </a:r>
@@ -9300,10 +9654,10 @@
       </p:sp>
       <p:sp>
         <p:nvSpPr>
-          <p:cNvPr id="6" name="copy-40">
+          <p:cNvPr id="6" name="copy-42">
             <a:extLst xmlns:a="http://schemas.openxmlformats.org/drawingml/2006/main">
               <a:ext uri="{FF2B5EF4-FFF2-40B4-BE49-F238E27FC236}">
-                <a16:creationId xmlns:a16="http://schemas.microsoft.com/office/drawing/2014/main" id="{27DF9C1C-EE4C-4ECE-94E6-72193D9666D0}"/>
+                <a16:creationId xmlns:a16="http://schemas.microsoft.com/office/drawing/2014/main" id="{B36CECFB-8100-4EA5-86D5-C16744B9BA47}"/>
               </a:ext>
             </a:extLst>
           </p:cNvPr>
@@ -9314,7 +9668,7 @@
         </p:nvSpPr>
         <p:spPr>
           <a:xfrm xmlns:a="http://schemas.openxmlformats.org/drawingml/2006/main">
-            <a:off x="552450" y="4533900"/>
+            <a:off x="552450" y="4295775"/>
             <a:ext cx="4953000" cy="361950"/>
           </a:xfrm>
           <a:prstGeom xmlns:a="http://schemas.openxmlformats.org/drawingml/2006/main" prst="rect">
@@ -9458,10 +9812,10 @@
       </p:sp>
       <p:sp>
         <p:nvSpPr>
-          <p:cNvPr id="7" name="copy-41">
+          <p:cNvPr id="7" name="copy-43">
             <a:extLst xmlns:a="http://schemas.openxmlformats.org/drawingml/2006/main">
               <a:ext uri="{FF2B5EF4-FFF2-40B4-BE49-F238E27FC236}">
-                <a16:creationId xmlns:a16="http://schemas.microsoft.com/office/drawing/2014/main" id="{CDE0BCC8-35B1-4360-80CA-53FA194DC67E}"/>
+                <a16:creationId xmlns:a16="http://schemas.microsoft.com/office/drawing/2014/main" id="{F846373C-D9B5-4F3D-B363-54E355A9CC65}"/>
               </a:ext>
             </a:extLst>
           </p:cNvPr>
@@ -9472,8 +9826,8 @@
         </p:nvSpPr>
         <p:spPr>
           <a:xfrm xmlns:a="http://schemas.openxmlformats.org/drawingml/2006/main">
-            <a:off x="552450" y="5010150"/>
-            <a:ext cx="4953000" cy="704850"/>
+            <a:off x="552450" y="4705350"/>
+            <a:ext cx="4953000" cy="666750"/>
           </a:xfrm>
           <a:prstGeom xmlns:a="http://schemas.openxmlformats.org/drawingml/2006/main" prst="rect">
             <a:avLst/>
@@ -9489,7 +9843,7 @@
           </a:bodyPr>
           <a:lstStyle xmlns:a="http://schemas.openxmlformats.org/drawingml/2006/main">
             <a:defPPr>
-              <a:defRPr sz="3825" b="1">
+              <a:defRPr sz="3600" b="1">
                 <a:solidFill>
                   <a:srgbClr val="111111"/>
                 </a:solidFill>
@@ -9499,7 +9853,7 @@
               </a:defRPr>
             </a:defPPr>
             <a:lvl1pPr>
-              <a:defRPr sz="3825" b="1">
+              <a:defRPr sz="3600" b="1">
                 <a:solidFill>
                   <a:srgbClr val="111111"/>
                 </a:solidFill>
@@ -9509,7 +9863,7 @@
               </a:defRPr>
             </a:lvl1pPr>
             <a:lvl2pPr>
-              <a:defRPr sz="3825" b="1">
+              <a:defRPr sz="3600" b="1">
                 <a:solidFill>
                   <a:srgbClr val="111111"/>
                 </a:solidFill>
@@ -9519,7 +9873,7 @@
               </a:defRPr>
             </a:lvl2pPr>
             <a:lvl3pPr>
-              <a:defRPr sz="3825" b="1">
+              <a:defRPr sz="3600" b="1">
                 <a:solidFill>
                   <a:srgbClr val="111111"/>
                 </a:solidFill>
@@ -9529,7 +9883,7 @@
               </a:defRPr>
             </a:lvl3pPr>
             <a:lvl4pPr>
-              <a:defRPr sz="3825" b="1">
+              <a:defRPr sz="3600" b="1">
                 <a:solidFill>
                   <a:srgbClr val="111111"/>
                 </a:solidFill>
@@ -9539,7 +9893,7 @@
               </a:defRPr>
             </a:lvl4pPr>
             <a:lvl5pPr>
-              <a:defRPr sz="3825" b="1">
+              <a:defRPr sz="3600" b="1">
                 <a:solidFill>
                   <a:srgbClr val="111111"/>
                 </a:solidFill>
@@ -9549,7 +9903,7 @@
               </a:defRPr>
             </a:lvl5pPr>
             <a:lvl6pPr>
-              <a:defRPr sz="3825" b="1">
+              <a:defRPr sz="3600" b="1">
                 <a:solidFill>
                   <a:srgbClr val="111111"/>
                 </a:solidFill>
@@ -9559,7 +9913,7 @@
               </a:defRPr>
             </a:lvl6pPr>
             <a:lvl7pPr>
-              <a:defRPr sz="3825" b="1">
+              <a:defRPr sz="3600" b="1">
                 <a:solidFill>
                   <a:srgbClr val="111111"/>
                 </a:solidFill>
@@ -9569,7 +9923,7 @@
               </a:defRPr>
             </a:lvl7pPr>
             <a:lvl8pPr>
-              <a:defRPr sz="3825" b="1">
+              <a:defRPr sz="3600" b="1">
                 <a:solidFill>
                   <a:srgbClr val="111111"/>
                 </a:solidFill>
@@ -9579,7 +9933,7 @@
               </a:defRPr>
             </a:lvl8pPr>
             <a:lvl9pPr>
-              <a:defRPr sz="3825" b="1">
+              <a:defRPr sz="3600" b="1">
                 <a:solidFill>
                   <a:srgbClr val="111111"/>
                 </a:solidFill>
@@ -9591,7 +9945,7 @@
           </a:lstStyle>
           <a:p xmlns:a="http://schemas.openxmlformats.org/drawingml/2006/main">
             <a:pPr>
-              <a:defRPr sz="3825" b="1">
+              <a:defRPr sz="3600" b="1">
                 <a:solidFill>
                   <a:srgbClr val="111111"/>
                 </a:solidFill>
@@ -9601,7 +9955,7 @@
               </a:defRPr>
             </a:pPr>
             <a:r>
-              <a:rPr sz="3825" b="1">
+              <a:rPr sz="3600" b="1">
                 <a:solidFill>
                   <a:srgbClr val="111111"/>
                 </a:solidFill>
@@ -9616,10 +9970,10 @@
       </p:sp>
       <p:sp>
         <p:nvSpPr>
-          <p:cNvPr id="8" name="copy-42">
+          <p:cNvPr id="8" name="copy-44">
             <a:extLst xmlns:a="http://schemas.openxmlformats.org/drawingml/2006/main">
               <a:ext uri="{FF2B5EF4-FFF2-40B4-BE49-F238E27FC236}">
-                <a16:creationId xmlns:a16="http://schemas.microsoft.com/office/drawing/2014/main" id="{B41745BD-65FF-4650-961A-5DBBD7BA1586}"/>
+                <a16:creationId xmlns:a16="http://schemas.microsoft.com/office/drawing/2014/main" id="{2B3F87F0-8E1A-4A85-BA93-279E1B702CDD}"/>
               </a:ext>
             </a:extLst>
           </p:cNvPr>
@@ -9630,7 +9984,7 @@
         </p:nvSpPr>
         <p:spPr>
           <a:xfrm xmlns:a="http://schemas.openxmlformats.org/drawingml/2006/main">
-            <a:off x="6686550" y="4533900"/>
+            <a:off x="6686550" y="4295775"/>
             <a:ext cx="4953000" cy="361950"/>
           </a:xfrm>
           <a:prstGeom xmlns:a="http://schemas.openxmlformats.org/drawingml/2006/main" prst="rect">
@@ -9774,10 +10128,10 @@
       </p:sp>
       <p:sp>
         <p:nvSpPr>
-          <p:cNvPr id="9" name="copy-43">
+          <p:cNvPr id="9" name="copy-45">
             <a:extLst xmlns:a="http://schemas.openxmlformats.org/drawingml/2006/main">
               <a:ext uri="{FF2B5EF4-FFF2-40B4-BE49-F238E27FC236}">
-                <a16:creationId xmlns:a16="http://schemas.microsoft.com/office/drawing/2014/main" id="{A2CCE58B-76BD-4677-8A44-4FA49F17B209}"/>
+                <a16:creationId xmlns:a16="http://schemas.microsoft.com/office/drawing/2014/main" id="{F18924CB-ACD7-44D2-9DE1-07754BFBD1A1}"/>
               </a:ext>
             </a:extLst>
           </p:cNvPr>
@@ -9788,8 +10142,8 @@
         </p:nvSpPr>
         <p:spPr>
           <a:xfrm xmlns:a="http://schemas.openxmlformats.org/drawingml/2006/main">
-            <a:off x="6686550" y="5010150"/>
-            <a:ext cx="4953000" cy="704850"/>
+            <a:off x="6686550" y="4705350"/>
+            <a:ext cx="4953000" cy="666750"/>
           </a:xfrm>
           <a:prstGeom xmlns:a="http://schemas.openxmlformats.org/drawingml/2006/main" prst="rect">
             <a:avLst/>
@@ -9805,7 +10159,7 @@
           </a:bodyPr>
           <a:lstStyle xmlns:a="http://schemas.openxmlformats.org/drawingml/2006/main">
             <a:defPPr>
-              <a:defRPr sz="3825" b="1">
+              <a:defRPr sz="3600" b="1">
                 <a:solidFill>
                   <a:srgbClr val="1B5E20"/>
                 </a:solidFill>
@@ -9815,7 +10169,7 @@
               </a:defRPr>
             </a:defPPr>
             <a:lvl1pPr>
-              <a:defRPr sz="3825" b="1">
+              <a:defRPr sz="3600" b="1">
                 <a:solidFill>
                   <a:srgbClr val="1B5E20"/>
                 </a:solidFill>
@@ -9825,7 +10179,7 @@
               </a:defRPr>
             </a:lvl1pPr>
             <a:lvl2pPr>
-              <a:defRPr sz="3825" b="1">
+              <a:defRPr sz="3600" b="1">
                 <a:solidFill>
                   <a:srgbClr val="1B5E20"/>
                 </a:solidFill>
@@ -9835,7 +10189,7 @@
               </a:defRPr>
             </a:lvl2pPr>
             <a:lvl3pPr>
-              <a:defRPr sz="3825" b="1">
+              <a:defRPr sz="3600" b="1">
                 <a:solidFill>
                   <a:srgbClr val="1B5E20"/>
                 </a:solidFill>
@@ -9845,7 +10199,7 @@
               </a:defRPr>
             </a:lvl3pPr>
             <a:lvl4pPr>
-              <a:defRPr sz="3825" b="1">
+              <a:defRPr sz="3600" b="1">
                 <a:solidFill>
                   <a:srgbClr val="1B5E20"/>
                 </a:solidFill>
@@ -9855,7 +10209,7 @@
               </a:defRPr>
             </a:lvl4pPr>
             <a:lvl5pPr>
-              <a:defRPr sz="3825" b="1">
+              <a:defRPr sz="3600" b="1">
                 <a:solidFill>
                   <a:srgbClr val="1B5E20"/>
                 </a:solidFill>
@@ -9865,7 +10219,7 @@
               </a:defRPr>
             </a:lvl5pPr>
             <a:lvl6pPr>
-              <a:defRPr sz="3825" b="1">
+              <a:defRPr sz="3600" b="1">
                 <a:solidFill>
                   <a:srgbClr val="1B5E20"/>
                 </a:solidFill>
@@ -9875,7 +10229,7 @@
               </a:defRPr>
             </a:lvl6pPr>
             <a:lvl7pPr>
-              <a:defRPr sz="3825" b="1">
+              <a:defRPr sz="3600" b="1">
                 <a:solidFill>
                   <a:srgbClr val="1B5E20"/>
                 </a:solidFill>
@@ -9885,7 +10239,7 @@
               </a:defRPr>
             </a:lvl7pPr>
             <a:lvl8pPr>
-              <a:defRPr sz="3825" b="1">
+              <a:defRPr sz="3600" b="1">
                 <a:solidFill>
                   <a:srgbClr val="1B5E20"/>
                 </a:solidFill>
@@ -9895,7 +10249,7 @@
               </a:defRPr>
             </a:lvl8pPr>
             <a:lvl9pPr>
-              <a:defRPr sz="3825" b="1">
+              <a:defRPr sz="3600" b="1">
                 <a:solidFill>
                   <a:srgbClr val="1B5E20"/>
                 </a:solidFill>
@@ -9907,7 +10261,7 @@
           </a:lstStyle>
           <a:p xmlns:a="http://schemas.openxmlformats.org/drawingml/2006/main">
             <a:pPr>
-              <a:defRPr sz="3825" b="1">
+              <a:defRPr sz="3600" b="1">
                 <a:solidFill>
                   <a:srgbClr val="1B5E20"/>
                 </a:solidFill>
@@ -9917,7 +10271,7 @@
               </a:defRPr>
             </a:pPr>
             <a:r>
-              <a:rPr sz="3825" b="1">
+              <a:rPr sz="3600" b="1">
                 <a:solidFill>
                   <a:srgbClr val="1B5E20"/>
                 </a:solidFill>
@@ -9932,10 +10286,10 @@
       </p:sp>
       <p:sp>
         <p:nvSpPr>
-          <p:cNvPr id="10" name="copy-44">
+          <p:cNvPr id="10" name="copy-46">
             <a:extLst xmlns:a="http://schemas.openxmlformats.org/drawingml/2006/main">
               <a:ext uri="{FF2B5EF4-FFF2-40B4-BE49-F238E27FC236}">
-                <a16:creationId xmlns:a16="http://schemas.microsoft.com/office/drawing/2014/main" id="{1279840C-05BF-4C01-A80C-800150690D77}"/>
+                <a16:creationId xmlns:a16="http://schemas.microsoft.com/office/drawing/2014/main" id="{35C8FD8B-860F-4403-9048-EFEE4B90AAF1}"/>
               </a:ext>
             </a:extLst>
           </p:cNvPr>
@@ -9946,166 +10300,8 @@
         </p:nvSpPr>
         <p:spPr>
           <a:xfrm xmlns:a="http://schemas.openxmlformats.org/drawingml/2006/main">
-            <a:off x="552450" y="6210300"/>
-            <a:ext cx="5905500" cy="447675"/>
-          </a:xfrm>
-          <a:prstGeom xmlns:a="http://schemas.openxmlformats.org/drawingml/2006/main" prst="rect">
-            <a:avLst/>
-          </a:prstGeom>
-          <a:noFill xmlns:a="http://schemas.openxmlformats.org/drawingml/2006/main"/>
-          <a:ln xmlns:a="http://schemas.openxmlformats.org/drawingml/2006/main" w="0">
-            <a:noFill/>
-          </a:ln>
-        </p:spPr>
-        <p:txBody>
-          <a:bodyPr xmlns:a="http://schemas.openxmlformats.org/drawingml/2006/main" wrap="square" lIns="0" tIns="0" rIns="0" bIns="0">
-            <a:noAutofit/>
-          </a:bodyPr>
-          <a:lstStyle xmlns:a="http://schemas.openxmlformats.org/drawingml/2006/main">
-            <a:defPPr>
-              <a:defRPr sz="2400" b="1">
-                <a:solidFill>
-                  <a:srgbClr val="1B5E20"/>
-                </a:solidFill>
-                <a:latin typeface="Inter"/>
-                <a:ea typeface="Inter"/>
-                <a:cs typeface="Inter"/>
-              </a:defRPr>
-            </a:defPPr>
-            <a:lvl1pPr>
-              <a:defRPr sz="2400" b="1">
-                <a:solidFill>
-                  <a:srgbClr val="1B5E20"/>
-                </a:solidFill>
-                <a:latin typeface="Inter"/>
-                <a:ea typeface="Inter"/>
-                <a:cs typeface="Inter"/>
-              </a:defRPr>
-            </a:lvl1pPr>
-            <a:lvl2pPr>
-              <a:defRPr sz="2400" b="1">
-                <a:solidFill>
-                  <a:srgbClr val="1B5E20"/>
-                </a:solidFill>
-                <a:latin typeface="Inter"/>
-                <a:ea typeface="Inter"/>
-                <a:cs typeface="Inter"/>
-              </a:defRPr>
-            </a:lvl2pPr>
-            <a:lvl3pPr>
-              <a:defRPr sz="2400" b="1">
-                <a:solidFill>
-                  <a:srgbClr val="1B5E20"/>
-                </a:solidFill>
-                <a:latin typeface="Inter"/>
-                <a:ea typeface="Inter"/>
-                <a:cs typeface="Inter"/>
-              </a:defRPr>
-            </a:lvl3pPr>
-            <a:lvl4pPr>
-              <a:defRPr sz="2400" b="1">
-                <a:solidFill>
-                  <a:srgbClr val="1B5E20"/>
-                </a:solidFill>
-                <a:latin typeface="Inter"/>
-                <a:ea typeface="Inter"/>
-                <a:cs typeface="Inter"/>
-              </a:defRPr>
-            </a:lvl4pPr>
-            <a:lvl5pPr>
-              <a:defRPr sz="2400" b="1">
-                <a:solidFill>
-                  <a:srgbClr val="1B5E20"/>
-                </a:solidFill>
-                <a:latin typeface="Inter"/>
-                <a:ea typeface="Inter"/>
-                <a:cs typeface="Inter"/>
-              </a:defRPr>
-            </a:lvl5pPr>
-            <a:lvl6pPr>
-              <a:defRPr sz="2400" b="1">
-                <a:solidFill>
-                  <a:srgbClr val="1B5E20"/>
-                </a:solidFill>
-                <a:latin typeface="Inter"/>
-                <a:ea typeface="Inter"/>
-                <a:cs typeface="Inter"/>
-              </a:defRPr>
-            </a:lvl6pPr>
-            <a:lvl7pPr>
-              <a:defRPr sz="2400" b="1">
-                <a:solidFill>
-                  <a:srgbClr val="1B5E20"/>
-                </a:solidFill>
-                <a:latin typeface="Inter"/>
-                <a:ea typeface="Inter"/>
-                <a:cs typeface="Inter"/>
-              </a:defRPr>
-            </a:lvl7pPr>
-            <a:lvl8pPr>
-              <a:defRPr sz="2400" b="1">
-                <a:solidFill>
-                  <a:srgbClr val="1B5E20"/>
-                </a:solidFill>
-                <a:latin typeface="Inter"/>
-                <a:ea typeface="Inter"/>
-                <a:cs typeface="Inter"/>
-              </a:defRPr>
-            </a:lvl8pPr>
-            <a:lvl9pPr>
-              <a:defRPr sz="2400" b="1">
-                <a:solidFill>
-                  <a:srgbClr val="1B5E20"/>
-                </a:solidFill>
-                <a:latin typeface="Inter"/>
-                <a:ea typeface="Inter"/>
-                <a:cs typeface="Inter"/>
-              </a:defRPr>
-            </a:lvl9pPr>
-          </a:lstStyle>
-          <a:p xmlns:a="http://schemas.openxmlformats.org/drawingml/2006/main">
-            <a:pPr>
-              <a:defRPr sz="2400" b="1">
-                <a:solidFill>
-                  <a:srgbClr val="1B5E20"/>
-                </a:solidFill>
-                <a:latin typeface="Inter"/>
-                <a:ea typeface="Inter"/>
-                <a:cs typeface="Inter"/>
-              </a:defRPr>
-            </a:pPr>
-            <a:r>
-              <a:rPr sz="2400" b="1">
-                <a:solidFill>
-                  <a:srgbClr val="1B5E20"/>
-                </a:solidFill>
-                <a:latin typeface="Inter"/>
-                <a:ea typeface="Inter"/>
-                <a:cs typeface="Inter"/>
-              </a:rPr>
-              <a:t>celloras.com</a:t>
-            </a:r>
-          </a:p>
-        </p:txBody>
-      </p:sp>
-      <p:sp>
-        <p:nvSpPr>
-          <p:cNvPr id="11" name="copy-45">
-            <a:extLst xmlns:a="http://schemas.openxmlformats.org/drawingml/2006/main">
-              <a:ext uri="{FF2B5EF4-FFF2-40B4-BE49-F238E27FC236}">
-                <a16:creationId xmlns:a16="http://schemas.microsoft.com/office/drawing/2014/main" id="{4DAF4A1B-3F59-4C08-9524-78564A9980F0}"/>
-              </a:ext>
-            </a:extLst>
-          </p:cNvPr>
-          <p:cNvSpPr>
-            <a:spLocks xmlns:a="http://schemas.openxmlformats.org/drawingml/2006/main" noGrp="1"/>
-          </p:cNvSpPr>
-          <p:nvPr/>
-        </p:nvSpPr>
-        <p:spPr>
-          <a:xfrm xmlns:a="http://schemas.openxmlformats.org/drawingml/2006/main">
-            <a:off x="8410575" y="6248400"/>
-            <a:ext cx="3267075" cy="361950"/>
+            <a:off x="552450" y="5619750"/>
+            <a:ext cx="11087100" cy="342900"/>
           </a:xfrm>
           <a:prstGeom xmlns:a="http://schemas.openxmlformats.org/drawingml/2006/main" prst="rect">
             <a:avLst/>
@@ -10123,7 +10319,7 @@
             <a:defPPr>
               <a:defRPr sz="1725" b="0">
                 <a:solidFill>
-                  <a:srgbClr val="1B5E20"/>
+                  <a:srgbClr val="666666"/>
                 </a:solidFill>
                 <a:latin typeface="Inter"/>
                 <a:ea typeface="Inter"/>
@@ -10133,7 +10329,7 @@
             <a:lvl1pPr>
               <a:defRPr sz="1725" b="0">
                 <a:solidFill>
-                  <a:srgbClr val="1B5E20"/>
+                  <a:srgbClr val="666666"/>
                 </a:solidFill>
                 <a:latin typeface="Inter"/>
                 <a:ea typeface="Inter"/>
@@ -10143,7 +10339,7 @@
             <a:lvl2pPr>
               <a:defRPr sz="1725" b="0">
                 <a:solidFill>
-                  <a:srgbClr val="1B5E20"/>
+                  <a:srgbClr val="666666"/>
                 </a:solidFill>
                 <a:latin typeface="Inter"/>
                 <a:ea typeface="Inter"/>
@@ -10153,7 +10349,7 @@
             <a:lvl3pPr>
               <a:defRPr sz="1725" b="0">
                 <a:solidFill>
-                  <a:srgbClr val="1B5E20"/>
+                  <a:srgbClr val="666666"/>
                 </a:solidFill>
                 <a:latin typeface="Inter"/>
                 <a:ea typeface="Inter"/>
@@ -10163,7 +10359,7 @@
             <a:lvl4pPr>
               <a:defRPr sz="1725" b="0">
                 <a:solidFill>
-                  <a:srgbClr val="1B5E20"/>
+                  <a:srgbClr val="666666"/>
                 </a:solidFill>
                 <a:latin typeface="Inter"/>
                 <a:ea typeface="Inter"/>
@@ -10173,7 +10369,7 @@
             <a:lvl5pPr>
               <a:defRPr sz="1725" b="0">
                 <a:solidFill>
-                  <a:srgbClr val="1B5E20"/>
+                  <a:srgbClr val="666666"/>
                 </a:solidFill>
                 <a:latin typeface="Inter"/>
                 <a:ea typeface="Inter"/>
@@ -10183,7 +10379,7 @@
             <a:lvl6pPr>
               <a:defRPr sz="1725" b="0">
                 <a:solidFill>
-                  <a:srgbClr val="1B5E20"/>
+                  <a:srgbClr val="666666"/>
                 </a:solidFill>
                 <a:latin typeface="Inter"/>
                 <a:ea typeface="Inter"/>
@@ -10193,7 +10389,7 @@
             <a:lvl7pPr>
               <a:defRPr sz="1725" b="0">
                 <a:solidFill>
-                  <a:srgbClr val="1B5E20"/>
+                  <a:srgbClr val="666666"/>
                 </a:solidFill>
                 <a:latin typeface="Inter"/>
                 <a:ea typeface="Inter"/>
@@ -10203,7 +10399,7 @@
             <a:lvl8pPr>
               <a:defRPr sz="1725" b="0">
                 <a:solidFill>
-                  <a:srgbClr val="1B5E20"/>
+                  <a:srgbClr val="666666"/>
                 </a:solidFill>
                 <a:latin typeface="Inter"/>
                 <a:ea typeface="Inter"/>
@@ -10213,7 +10409,7 @@
             <a:lvl9pPr>
               <a:defRPr sz="1725" b="0">
                 <a:solidFill>
-                  <a:srgbClr val="1B5E20"/>
+                  <a:srgbClr val="666666"/>
                 </a:solidFill>
                 <a:latin typeface="Inter"/>
                 <a:ea typeface="Inter"/>
@@ -10225,7 +10421,7 @@
             <a:pPr>
               <a:defRPr sz="1725" b="0">
                 <a:solidFill>
-                  <a:srgbClr val="1B5E20"/>
+                  <a:srgbClr val="666666"/>
                 </a:solidFill>
                 <a:latin typeface="Inter"/>
                 <a:ea typeface="Inter"/>
@@ -10235,12 +10431,487 @@
             <a:r>
               <a:rPr sz="1725" b="0">
                 <a:solidFill>
-                  <a:srgbClr val="1B5E20"/>
-                </a:solidFill>
-                <a:latin typeface="Inter"/>
-                <a:ea typeface="Inter"/>
-                <a:cs typeface="Inter"/>
-                <a:hlinkClick xmlns:r="http://schemas.openxmlformats.org/officeDocument/2006/relationships" r:id="R1756bb5969b54154"/>
+                  <a:srgbClr val="666666"/>
+                </a:solidFill>
+                <a:latin typeface="Inter"/>
+                <a:ea typeface="Inter"/>
+                <a:cs typeface="Inter"/>
+              </a:rPr>
+              <a:t>Global single-cell sequencing: $3.46B forecast for 2030.</a:t>
+            </a:r>
+          </a:p>
+        </p:txBody>
+      </p:sp>
+      <p:sp>
+        <p:nvSpPr>
+          <p:cNvPr id="11" name="copy-47">
+            <a:extLst xmlns:a="http://schemas.openxmlformats.org/drawingml/2006/main">
+              <a:ext uri="{FF2B5EF4-FFF2-40B4-BE49-F238E27FC236}">
+                <a16:creationId xmlns:a16="http://schemas.microsoft.com/office/drawing/2014/main" id="{D71282D1-8748-4BBC-89A6-C9795DD63CC8}"/>
+              </a:ext>
+            </a:extLst>
+          </p:cNvPr>
+          <p:cNvSpPr>
+            <a:spLocks xmlns:a="http://schemas.openxmlformats.org/drawingml/2006/main" noGrp="1"/>
+          </p:cNvSpPr>
+          <p:nvPr/>
+        </p:nvSpPr>
+        <p:spPr>
+          <a:xfrm xmlns:a="http://schemas.openxmlformats.org/drawingml/2006/main">
+            <a:off x="552450" y="5981700"/>
+            <a:ext cx="11087100" cy="285750"/>
+          </a:xfrm>
+          <a:prstGeom xmlns:a="http://schemas.openxmlformats.org/drawingml/2006/main" prst="rect">
+            <a:avLst/>
+          </a:prstGeom>
+          <a:noFill xmlns:a="http://schemas.openxmlformats.org/drawingml/2006/main"/>
+          <a:ln xmlns:a="http://schemas.openxmlformats.org/drawingml/2006/main" w="0">
+            <a:noFill/>
+          </a:ln>
+        </p:spPr>
+        <p:txBody>
+          <a:bodyPr xmlns:a="http://schemas.openxmlformats.org/drawingml/2006/main" wrap="square" lIns="0" tIns="0" rIns="0" bIns="0">
+            <a:noAutofit/>
+          </a:bodyPr>
+          <a:lstStyle xmlns:a="http://schemas.openxmlformats.org/drawingml/2006/main">
+            <a:defPPr>
+              <a:defRPr sz="1350" b="0">
+                <a:solidFill>
+                  <a:srgbClr val="666666"/>
+                </a:solidFill>
+                <a:latin typeface="Inter"/>
+                <a:ea typeface="Inter"/>
+                <a:cs typeface="Inter"/>
+              </a:defRPr>
+            </a:defPPr>
+            <a:lvl1pPr>
+              <a:defRPr sz="1350" b="0">
+                <a:solidFill>
+                  <a:srgbClr val="666666"/>
+                </a:solidFill>
+                <a:latin typeface="Inter"/>
+                <a:ea typeface="Inter"/>
+                <a:cs typeface="Inter"/>
+              </a:defRPr>
+            </a:lvl1pPr>
+            <a:lvl2pPr>
+              <a:defRPr sz="1350" b="0">
+                <a:solidFill>
+                  <a:srgbClr val="666666"/>
+                </a:solidFill>
+                <a:latin typeface="Inter"/>
+                <a:ea typeface="Inter"/>
+                <a:cs typeface="Inter"/>
+              </a:defRPr>
+            </a:lvl2pPr>
+            <a:lvl3pPr>
+              <a:defRPr sz="1350" b="0">
+                <a:solidFill>
+                  <a:srgbClr val="666666"/>
+                </a:solidFill>
+                <a:latin typeface="Inter"/>
+                <a:ea typeface="Inter"/>
+                <a:cs typeface="Inter"/>
+              </a:defRPr>
+            </a:lvl3pPr>
+            <a:lvl4pPr>
+              <a:defRPr sz="1350" b="0">
+                <a:solidFill>
+                  <a:srgbClr val="666666"/>
+                </a:solidFill>
+                <a:latin typeface="Inter"/>
+                <a:ea typeface="Inter"/>
+                <a:cs typeface="Inter"/>
+              </a:defRPr>
+            </a:lvl4pPr>
+            <a:lvl5pPr>
+              <a:defRPr sz="1350" b="0">
+                <a:solidFill>
+                  <a:srgbClr val="666666"/>
+                </a:solidFill>
+                <a:latin typeface="Inter"/>
+                <a:ea typeface="Inter"/>
+                <a:cs typeface="Inter"/>
+              </a:defRPr>
+            </a:lvl5pPr>
+            <a:lvl6pPr>
+              <a:defRPr sz="1350" b="0">
+                <a:solidFill>
+                  <a:srgbClr val="666666"/>
+                </a:solidFill>
+                <a:latin typeface="Inter"/>
+                <a:ea typeface="Inter"/>
+                <a:cs typeface="Inter"/>
+              </a:defRPr>
+            </a:lvl6pPr>
+            <a:lvl7pPr>
+              <a:defRPr sz="1350" b="0">
+                <a:solidFill>
+                  <a:srgbClr val="666666"/>
+                </a:solidFill>
+                <a:latin typeface="Inter"/>
+                <a:ea typeface="Inter"/>
+                <a:cs typeface="Inter"/>
+              </a:defRPr>
+            </a:lvl7pPr>
+            <a:lvl8pPr>
+              <a:defRPr sz="1350" b="0">
+                <a:solidFill>
+                  <a:srgbClr val="666666"/>
+                </a:solidFill>
+                <a:latin typeface="Inter"/>
+                <a:ea typeface="Inter"/>
+                <a:cs typeface="Inter"/>
+              </a:defRPr>
+            </a:lvl8pPr>
+            <a:lvl9pPr>
+              <a:defRPr sz="1350" b="0">
+                <a:solidFill>
+                  <a:srgbClr val="666666"/>
+                </a:solidFill>
+                <a:latin typeface="Inter"/>
+                <a:ea typeface="Inter"/>
+                <a:cs typeface="Inter"/>
+              </a:defRPr>
+            </a:lvl9pPr>
+          </a:lstStyle>
+          <a:p xmlns:a="http://schemas.openxmlformats.org/drawingml/2006/main">
+            <a:pPr>
+              <a:defRPr sz="1350" b="0">
+                <a:solidFill>
+                  <a:srgbClr val="666666"/>
+                </a:solidFill>
+                <a:latin typeface="Inter"/>
+                <a:ea typeface="Inter"/>
+                <a:cs typeface="Inter"/>
+              </a:defRPr>
+            </a:pPr>
+            <a:r>
+              <a:rPr sz="1350" b="0">
+                <a:solidFill>
+                  <a:srgbClr val="666666"/>
+                </a:solidFill>
+                <a:latin typeface="Inter"/>
+                <a:ea typeface="Inter"/>
+                <a:cs typeface="Inter"/>
+                <a:hlinkClick xmlns:r="http://schemas.openxmlformats.org/officeDocument/2006/relationships" r:id="R11dc5293d2a74003"/>
+              </a:rPr>
+              <a:t>MarketsandMarkets (2025); includes equipment, consumables and services.</a:t>
+            </a:r>
+          </a:p>
+        </p:txBody>
+      </p:sp>
+      <p:sp>
+        <p:nvSpPr>
+          <p:cNvPr id="12" name="copy-48">
+            <a:extLst xmlns:a="http://schemas.openxmlformats.org/drawingml/2006/main">
+              <a:ext uri="{FF2B5EF4-FFF2-40B4-BE49-F238E27FC236}">
+                <a16:creationId xmlns:a16="http://schemas.microsoft.com/office/drawing/2014/main" id="{62202090-525C-4B96-8843-CF1D7D8E9AD3}"/>
+              </a:ext>
+            </a:extLst>
+          </p:cNvPr>
+          <p:cNvSpPr>
+            <a:spLocks xmlns:a="http://schemas.openxmlformats.org/drawingml/2006/main" noGrp="1"/>
+          </p:cNvSpPr>
+          <p:nvPr/>
+        </p:nvSpPr>
+        <p:spPr>
+          <a:xfrm xmlns:a="http://schemas.openxmlformats.org/drawingml/2006/main">
+            <a:off x="552450" y="6372225"/>
+            <a:ext cx="5905500" cy="381000"/>
+          </a:xfrm>
+          <a:prstGeom xmlns:a="http://schemas.openxmlformats.org/drawingml/2006/main" prst="rect">
+            <a:avLst/>
+          </a:prstGeom>
+          <a:noFill xmlns:a="http://schemas.openxmlformats.org/drawingml/2006/main"/>
+          <a:ln xmlns:a="http://schemas.openxmlformats.org/drawingml/2006/main" w="0">
+            <a:noFill/>
+          </a:ln>
+        </p:spPr>
+        <p:txBody>
+          <a:bodyPr xmlns:a="http://schemas.openxmlformats.org/drawingml/2006/main" wrap="square" lIns="0" tIns="0" rIns="0" bIns="0">
+            <a:noAutofit/>
+          </a:bodyPr>
+          <a:lstStyle xmlns:a="http://schemas.openxmlformats.org/drawingml/2006/main">
+            <a:defPPr>
+              <a:defRPr sz="2025" b="1">
+                <a:solidFill>
+                  <a:srgbClr val="1B5E20"/>
+                </a:solidFill>
+                <a:latin typeface="Inter"/>
+                <a:ea typeface="Inter"/>
+                <a:cs typeface="Inter"/>
+              </a:defRPr>
+            </a:defPPr>
+            <a:lvl1pPr>
+              <a:defRPr sz="2025" b="1">
+                <a:solidFill>
+                  <a:srgbClr val="1B5E20"/>
+                </a:solidFill>
+                <a:latin typeface="Inter"/>
+                <a:ea typeface="Inter"/>
+                <a:cs typeface="Inter"/>
+              </a:defRPr>
+            </a:lvl1pPr>
+            <a:lvl2pPr>
+              <a:defRPr sz="2025" b="1">
+                <a:solidFill>
+                  <a:srgbClr val="1B5E20"/>
+                </a:solidFill>
+                <a:latin typeface="Inter"/>
+                <a:ea typeface="Inter"/>
+                <a:cs typeface="Inter"/>
+              </a:defRPr>
+            </a:lvl2pPr>
+            <a:lvl3pPr>
+              <a:defRPr sz="2025" b="1">
+                <a:solidFill>
+                  <a:srgbClr val="1B5E20"/>
+                </a:solidFill>
+                <a:latin typeface="Inter"/>
+                <a:ea typeface="Inter"/>
+                <a:cs typeface="Inter"/>
+              </a:defRPr>
+            </a:lvl3pPr>
+            <a:lvl4pPr>
+              <a:defRPr sz="2025" b="1">
+                <a:solidFill>
+                  <a:srgbClr val="1B5E20"/>
+                </a:solidFill>
+                <a:latin typeface="Inter"/>
+                <a:ea typeface="Inter"/>
+                <a:cs typeface="Inter"/>
+              </a:defRPr>
+            </a:lvl4pPr>
+            <a:lvl5pPr>
+              <a:defRPr sz="2025" b="1">
+                <a:solidFill>
+                  <a:srgbClr val="1B5E20"/>
+                </a:solidFill>
+                <a:latin typeface="Inter"/>
+                <a:ea typeface="Inter"/>
+                <a:cs typeface="Inter"/>
+              </a:defRPr>
+            </a:lvl5pPr>
+            <a:lvl6pPr>
+              <a:defRPr sz="2025" b="1">
+                <a:solidFill>
+                  <a:srgbClr val="1B5E20"/>
+                </a:solidFill>
+                <a:latin typeface="Inter"/>
+                <a:ea typeface="Inter"/>
+                <a:cs typeface="Inter"/>
+              </a:defRPr>
+            </a:lvl6pPr>
+            <a:lvl7pPr>
+              <a:defRPr sz="2025" b="1">
+                <a:solidFill>
+                  <a:srgbClr val="1B5E20"/>
+                </a:solidFill>
+                <a:latin typeface="Inter"/>
+                <a:ea typeface="Inter"/>
+                <a:cs typeface="Inter"/>
+              </a:defRPr>
+            </a:lvl7pPr>
+            <a:lvl8pPr>
+              <a:defRPr sz="2025" b="1">
+                <a:solidFill>
+                  <a:srgbClr val="1B5E20"/>
+                </a:solidFill>
+                <a:latin typeface="Inter"/>
+                <a:ea typeface="Inter"/>
+                <a:cs typeface="Inter"/>
+              </a:defRPr>
+            </a:lvl8pPr>
+            <a:lvl9pPr>
+              <a:defRPr sz="2025" b="1">
+                <a:solidFill>
+                  <a:srgbClr val="1B5E20"/>
+                </a:solidFill>
+                <a:latin typeface="Inter"/>
+                <a:ea typeface="Inter"/>
+                <a:cs typeface="Inter"/>
+              </a:defRPr>
+            </a:lvl9pPr>
+          </a:lstStyle>
+          <a:p xmlns:a="http://schemas.openxmlformats.org/drawingml/2006/main">
+            <a:pPr>
+              <a:defRPr sz="2025" b="1">
+                <a:solidFill>
+                  <a:srgbClr val="1B5E20"/>
+                </a:solidFill>
+                <a:latin typeface="Inter"/>
+                <a:ea typeface="Inter"/>
+                <a:cs typeface="Inter"/>
+              </a:defRPr>
+            </a:pPr>
+            <a:r>
+              <a:rPr sz="2025" b="1">
+                <a:solidFill>
+                  <a:srgbClr val="1B5E20"/>
+                </a:solidFill>
+                <a:latin typeface="Inter"/>
+                <a:ea typeface="Inter"/>
+                <a:cs typeface="Inter"/>
+              </a:rPr>
+              <a:t>celloras.com</a:t>
+            </a:r>
+          </a:p>
+        </p:txBody>
+      </p:sp>
+      <p:sp>
+        <p:nvSpPr>
+          <p:cNvPr id="13" name="copy-49">
+            <a:extLst xmlns:a="http://schemas.openxmlformats.org/drawingml/2006/main">
+              <a:ext uri="{FF2B5EF4-FFF2-40B4-BE49-F238E27FC236}">
+                <a16:creationId xmlns:a16="http://schemas.microsoft.com/office/drawing/2014/main" id="{086091EC-ACCD-4DDA-A92E-0F5F058D5F14}"/>
+              </a:ext>
+            </a:extLst>
+          </p:cNvPr>
+          <p:cNvSpPr>
+            <a:spLocks xmlns:a="http://schemas.openxmlformats.org/drawingml/2006/main" noGrp="1"/>
+          </p:cNvSpPr>
+          <p:nvPr/>
+        </p:nvSpPr>
+        <p:spPr>
+          <a:xfrm xmlns:a="http://schemas.openxmlformats.org/drawingml/2006/main">
+            <a:off x="8410575" y="6391275"/>
+            <a:ext cx="3267075" cy="304800"/>
+          </a:xfrm>
+          <a:prstGeom xmlns:a="http://schemas.openxmlformats.org/drawingml/2006/main" prst="rect">
+            <a:avLst/>
+          </a:prstGeom>
+          <a:noFill xmlns:a="http://schemas.openxmlformats.org/drawingml/2006/main"/>
+          <a:ln xmlns:a="http://schemas.openxmlformats.org/drawingml/2006/main" w="0">
+            <a:noFill/>
+          </a:ln>
+        </p:spPr>
+        <p:txBody>
+          <a:bodyPr xmlns:a="http://schemas.openxmlformats.org/drawingml/2006/main" wrap="square" lIns="0" tIns="0" rIns="0" bIns="0">
+            <a:noAutofit/>
+          </a:bodyPr>
+          <a:lstStyle xmlns:a="http://schemas.openxmlformats.org/drawingml/2006/main">
+            <a:defPPr>
+              <a:defRPr sz="1650" b="0">
+                <a:solidFill>
+                  <a:srgbClr val="1B5E20"/>
+                </a:solidFill>
+                <a:latin typeface="Inter"/>
+                <a:ea typeface="Inter"/>
+                <a:cs typeface="Inter"/>
+              </a:defRPr>
+            </a:defPPr>
+            <a:lvl1pPr>
+              <a:defRPr sz="1650" b="0">
+                <a:solidFill>
+                  <a:srgbClr val="1B5E20"/>
+                </a:solidFill>
+                <a:latin typeface="Inter"/>
+                <a:ea typeface="Inter"/>
+                <a:cs typeface="Inter"/>
+              </a:defRPr>
+            </a:lvl1pPr>
+            <a:lvl2pPr>
+              <a:defRPr sz="1650" b="0">
+                <a:solidFill>
+                  <a:srgbClr val="1B5E20"/>
+                </a:solidFill>
+                <a:latin typeface="Inter"/>
+                <a:ea typeface="Inter"/>
+                <a:cs typeface="Inter"/>
+              </a:defRPr>
+            </a:lvl2pPr>
+            <a:lvl3pPr>
+              <a:defRPr sz="1650" b="0">
+                <a:solidFill>
+                  <a:srgbClr val="1B5E20"/>
+                </a:solidFill>
+                <a:latin typeface="Inter"/>
+                <a:ea typeface="Inter"/>
+                <a:cs typeface="Inter"/>
+              </a:defRPr>
+            </a:lvl3pPr>
+            <a:lvl4pPr>
+              <a:defRPr sz="1650" b="0">
+                <a:solidFill>
+                  <a:srgbClr val="1B5E20"/>
+                </a:solidFill>
+                <a:latin typeface="Inter"/>
+                <a:ea typeface="Inter"/>
+                <a:cs typeface="Inter"/>
+              </a:defRPr>
+            </a:lvl4pPr>
+            <a:lvl5pPr>
+              <a:defRPr sz="1650" b="0">
+                <a:solidFill>
+                  <a:srgbClr val="1B5E20"/>
+                </a:solidFill>
+                <a:latin typeface="Inter"/>
+                <a:ea typeface="Inter"/>
+                <a:cs typeface="Inter"/>
+              </a:defRPr>
+            </a:lvl5pPr>
+            <a:lvl6pPr>
+              <a:defRPr sz="1650" b="0">
+                <a:solidFill>
+                  <a:srgbClr val="1B5E20"/>
+                </a:solidFill>
+                <a:latin typeface="Inter"/>
+                <a:ea typeface="Inter"/>
+                <a:cs typeface="Inter"/>
+              </a:defRPr>
+            </a:lvl6pPr>
+            <a:lvl7pPr>
+              <a:defRPr sz="1650" b="0">
+                <a:solidFill>
+                  <a:srgbClr val="1B5E20"/>
+                </a:solidFill>
+                <a:latin typeface="Inter"/>
+                <a:ea typeface="Inter"/>
+                <a:cs typeface="Inter"/>
+              </a:defRPr>
+            </a:lvl7pPr>
+            <a:lvl8pPr>
+              <a:defRPr sz="1650" b="0">
+                <a:solidFill>
+                  <a:srgbClr val="1B5E20"/>
+                </a:solidFill>
+                <a:latin typeface="Inter"/>
+                <a:ea typeface="Inter"/>
+                <a:cs typeface="Inter"/>
+              </a:defRPr>
+            </a:lvl8pPr>
+            <a:lvl9pPr>
+              <a:defRPr sz="1650" b="0">
+                <a:solidFill>
+                  <a:srgbClr val="1B5E20"/>
+                </a:solidFill>
+                <a:latin typeface="Inter"/>
+                <a:ea typeface="Inter"/>
+                <a:cs typeface="Inter"/>
+              </a:defRPr>
+            </a:lvl9pPr>
+          </a:lstStyle>
+          <a:p xmlns:a="http://schemas.openxmlformats.org/drawingml/2006/main">
+            <a:pPr>
+              <a:defRPr sz="1650" b="0">
+                <a:solidFill>
+                  <a:srgbClr val="1B5E20"/>
+                </a:solidFill>
+                <a:latin typeface="Inter"/>
+                <a:ea typeface="Inter"/>
+                <a:cs typeface="Inter"/>
+              </a:defRPr>
+            </a:pPr>
+            <a:r>
+              <a:rPr sz="1650" b="0">
+                <a:solidFill>
+                  <a:srgbClr val="1B5E20"/>
+                </a:solidFill>
+                <a:latin typeface="Inter"/>
+                <a:ea typeface="Inter"/>
+                <a:cs typeface="Inter"/>
+                <a:hlinkClick xmlns:r="http://schemas.openxmlformats.org/officeDocument/2006/relationships" r:id="Rd7964e1745644503"/>
               </a:rPr>
               <a:t>Public code and demo</a:t>
             </a:r>
@@ -10250,7 +10921,7 @@
     </p:spTree>
     <p:extLst>
       <p:ext uri="{BB962C8B-B14F-4D97-AF65-F5344CB8AC3E}">
-        <p14:creationId xmlns:p14="http://schemas.microsoft.com/office/powerpoint/2010/main" val="517376490"/>
+        <p14:creationId xmlns:p14="http://schemas.microsoft.com/office/powerpoint/2010/main" val="1580949889"/>
       </p:ext>
     </p:extLst>
   </p:cSld>

</xml_diff>

<commit_message>
Restore the preferred four-slide pitch
</commit_message>
<xml_diff>
--- a/docs/pitchdeck/Celloras-Pitch-Deck.pptx
+++ b/docs/pitchdeck/Celloras-Pitch-Deck.pptx
@@ -2,16 +2,16 @@
 <file path=ppt/presentation.xml><?xml version="1.0" encoding="utf-8"?>
 <p:presentation xmlns:p="http://schemas.openxmlformats.org/presentationml/2006/main">
   <p:sldMasterIdLst>
-    <p:sldMasterId xmlns:r="http://schemas.openxmlformats.org/officeDocument/2006/relationships" id="2147483648" r:id="Rb53cd896a67d45ad"/>
+    <p:sldMasterId xmlns:r="http://schemas.openxmlformats.org/officeDocument/2006/relationships" id="2147483648" r:id="Rf01c0c7f6c8e465b"/>
   </p:sldMasterIdLst>
   <p:notesMasterIdLst>
-    <p:notesMasterId xmlns:r="http://schemas.openxmlformats.org/officeDocument/2006/relationships" r:id="Rc6fd9ff9ee6e4ed2"/>
+    <p:notesMasterId xmlns:r="http://schemas.openxmlformats.org/officeDocument/2006/relationships" r:id="Re7dd0c5dfb6f4cf9"/>
   </p:notesMasterIdLst>
   <p:sldIdLst>
-    <p:sldId xmlns:r="http://schemas.openxmlformats.org/officeDocument/2006/relationships" id="256" r:id="R8a3c00a47f3f448e"/>
-    <p:sldId xmlns:r="http://schemas.openxmlformats.org/officeDocument/2006/relationships" id="257" r:id="R948b744518e44ace"/>
-    <p:sldId xmlns:r="http://schemas.openxmlformats.org/officeDocument/2006/relationships" id="258" r:id="Rc2854aec1bec4684"/>
-    <p:sldId xmlns:r="http://schemas.openxmlformats.org/officeDocument/2006/relationships" id="259" r:id="R07e0dc3dbe8f4fe9"/>
+    <p:sldId xmlns:r="http://schemas.openxmlformats.org/officeDocument/2006/relationships" id="256" r:id="R27762b7e274644a4"/>
+    <p:sldId xmlns:r="http://schemas.openxmlformats.org/officeDocument/2006/relationships" id="257" r:id="R030c148ef8224740"/>
+    <p:sldId xmlns:r="http://schemas.openxmlformats.org/officeDocument/2006/relationships" id="258" r:id="R3c591484595b41f9"/>
+    <p:sldId xmlns:r="http://schemas.openxmlformats.org/officeDocument/2006/relationships" id="259" r:id="R85fc30fc9b8e4283"/>
   </p:sldIdLst>
   <p:sldSz cx="12192000" cy="6858000"/>
   <p:notesSz cx="6858000" cy="9144000"/>
@@ -445,7 +445,7 @@
           <a:lstStyle xmlns:a="http://schemas.openxmlformats.org/drawingml/2006/main"/>
           <a:p xmlns:a="http://schemas.openxmlformats.org/drawingml/2006/main">
             <a:r>
-              <a:t>Root hairs help plants take up water and nutrients. To study them in sequencing data, researchers first need to identify the corresponding cells. Celloras is an annotation agent and research journal. Our real demo reanalyses published soybean data: gene activity measured in 7,496 nuclei, the compartments inside cells. We follow one group of 388 nuclei and ask whether the evidence supports a root-hair identity. The map is the actual Celloras output. This is a reanalysis of a published atlas, not a customer deployment or a nutrient-treatment experiment. We have not measured improvements in crop yield or nutrient uptake.</a:t>
+              <a:t>Celloras is an agent for plant single-cell research, starting with soybean. Ask it to annotate the groups and it runs the tools, returns a visual map and lets you inspect the evidence behind each candidate. The figure is the actual 7,496-nucleus demo. The researcher keeps the final judgment; independent biological validation remains next work.</a:t>
             </a:r>
           </a:p>
           <a:p xmlns:a="http://schemas.openxmlformats.org/drawingml/2006/main">
@@ -460,12 +460,7 @@
           </a:p>
           <a:p xmlns:a="http://schemas.openxmlformats.org/drawingml/2006/main">
             <a:r>
-              <a:t>https://pubmed.ncbi.nlm.nih.gov/27812010/</a:t>
-            </a:r>
-          </a:p>
-          <a:p xmlns:a="http://schemas.openxmlformats.org/drawingml/2006/main">
-            <a:r>
-              <a:t>https://www.ncbi.nlm.nih.gov/geo/query/acc.cgi?acc=GSE270392</a:t>
+              <a:t>https://github.com/mpckkk/2026_GenAI/blob/celloras.com/docs/demo.md</a:t>
             </a:r>
           </a:p>
           <a:p xmlns:a="http://schemas.openxmlformats.org/drawingml/2006/main">
@@ -475,7 +470,7 @@
           </a:p>
           <a:p xmlns:a="http://schemas.openxmlformats.org/drawingml/2006/main">
             <a:r>
-              <a:t>https://github.com/mpckkk/2026_GenAI/blob/celloras.com/docs/demo.md</a:t>
+              <a:t>https://github.com/mpckkk/2026_GenAI/blob/celloras.com/docs/annotation-method.md</a:t>
             </a:r>
           </a:p>
         </p:txBody>
@@ -545,7 +540,7 @@
           <a:lstStyle xmlns:a="http://schemas.openxmlformats.org/drawingml/2006/main"/>
           <a:p xmlns:a="http://schemas.openxmlformats.org/drawingml/2006/main">
             <a:r>
-              <a:t>The task is concrete: assess whether one group in this soybean root dataset represents root-hair cells. Without Celloras, the researcher coordinates scripts, marker-reference lookup and notes. With Celloras, the agent runs the available tools and returns evidence for review in the conversation. The researcher can leave the identity unresolved and record why. We compare workflow responsibilities; no measured time-saving or accuracy improvement is claimed.</a:t>
+              <a:t>Without Celloras, the researcher coordinates analysis scripts, reference lookup and their research notes. With Celloras, they ask the agent to run the analysis, inspect the returned evidence and revisit a saved decision in the same conversation. This compares workflow responsibilities, not the capabilities of every competing tool. No measured time-saving or accuracy improvement is claimed.</a:t>
             </a:r>
           </a:p>
           <a:p xmlns:a="http://schemas.openxmlformats.org/drawingml/2006/main">
@@ -635,7 +630,7 @@
           <a:lstStyle xmlns:a="http://schemas.openxmlformats.org/drawingml/2006/main"/>
           <a:p xmlns:a="http://schemas.openxmlformats.org/drawingml/2006/main">
             <a:r>
-              <a:t>In the verified workflow, group 6 contains 388 nuclei. The annotation engine suggests Root hair, supported by Glyma.01G224900 and Glyma.17G030700. Markers are genes whose activity helps identify cell types. The OpenShell/Codex agent runs the scientific tools and explains their outputs. Zetaris delivers the checked, versioned marker reference; numerical tools measure expression from the actual matrix. Meterless H-MEM recalls explicit reviews and their sources when asked. These are tool uses across one conversation, not a claim that every prompt calls every tool. The supporting panel comes from the same atlas study, so the candidate needs independent biological review. Next.js/Keycloak provide the interface and authentication; PostgreSQL holds project-owned state.</a:t>
+              <a:t>The server-side OpenShell/Codex agent chooses scientific tools in response to the request. Zetaris supplies a checked, versioned marker reference. Numerical tools measure expression; the language model explains their outputs. The official Meterless H-MEM Engine recalls explicit project-owned reviews and their sources when relevant. Next.js and Keycloak provide the interface, with owned state in PostgreSQL. The agent suggests; the researcher reviews.</a:t>
             </a:r>
           </a:p>
           <a:p xmlns:a="http://schemas.openxmlformats.org/drawingml/2006/main">
@@ -650,17 +645,12 @@
           </a:p>
           <a:p xmlns:a="http://schemas.openxmlformats.org/drawingml/2006/main">
             <a:r>
-              <a:t>https://github.com/mpckkk/2026_GenAI/blob/celloras.com/docs/annotation-method.md</a:t>
-            </a:r>
-          </a:p>
-          <a:p xmlns:a="http://schemas.openxmlformats.org/drawingml/2006/main">
-            <a:r>
               <a:t>https://github.com/mpckkk/2026_GenAI/blob/celloras.com/docs/sponsor-explanation.md</a:t>
             </a:r>
           </a:p>
           <a:p xmlns:a="http://schemas.openxmlformats.org/drawingml/2006/main">
             <a:r>
-              <a:t>https://github.com/mpckkk/2026_GenAI/blob/celloras.com/docs/demo.md</a:t>
+              <a:t>https://github.com/mpckkk/2026_GenAI/blob/celloras.com/docs/annotation-method.md</a:t>
             </a:r>
           </a:p>
           <a:p xmlns:a="http://schemas.openxmlformats.org/drawingml/2006/main">
@@ -735,7 +725,7 @@
           <a:lstStyle xmlns:a="http://schemas.openxmlformats.org/drawingml/2006/main"/>
           <a:p xmlns:a="http://schemas.openxmlformats.org/drawingml/2006/main">
             <a:r>
-              <a:t>The journal makes a concrete difference: it retains the corrected review instead of repeating an older provisional label. This is the first sentence of the actual saved agent reply. The review was explicitly entered for the demonstration, not an external researcher testimonial. It leaves group 6 unresolved pending independent evidence while the computed Root hair candidate stays unchanged. The same verified public workflow includes Zetaris reference retrieval, annotation and measured-marker comparison. Our initial users are plant research labs, starting with soybean and other plants later. For context, MarketsandMarkets forecasts the broader global single-cell sequencing industry at USD 3.46 billion in 2030, versus USD 1.95 billion in 2025 (12.2% reported CAGR). That includes instruments, consumables, software and services; it is not a plant-annotation software market estimate or Celloras revenue forecast. Numerical checks passed 2,952 independent base-R comparisons; independent biological validation and measured user impact remain next work. Try the actual demo at celloras.com.</a:t>
+              <a:t>The slide transcribes the first sentence of the actual agent response after the demonstration review was corrected and links to that reply. It recalls unresolved pending independent evidence and links to the saved review, while the computed Root hair candidate stays unchanged. The same public workflow includes annotation and Zetaris retrieval. The numerical implementation passed 2,952 independent base-R comparisons; this is not an independent biological accuracy benchmark. Try the soybean demo at celloras.com.</a:t>
             </a:r>
           </a:p>
           <a:p xmlns:a="http://schemas.openxmlformats.org/drawingml/2006/main">
@@ -761,11 +751,6 @@
           <a:p xmlns:a="http://schemas.openxmlformats.org/drawingml/2006/main">
             <a:r>
               <a:t>https://github.com/mpckkk/2026_GenAI/blob/celloras.com/docs/sponsor-explanation.md</a:t>
-            </a:r>
-          </a:p>
-          <a:p xmlns:a="http://schemas.openxmlformats.org/drawingml/2006/main">
-            <a:r>
-              <a:t>https://www.marketsandmarkets.com/Market-Reports/single-cell-sequencing-market-244864213.html</a:t>
             </a:r>
           </a:p>
           <a:p xmlns:a="http://schemas.openxmlformats.org/drawingml/2006/main">
@@ -817,7 +802,7 @@
           <p:cNvPr id="3" name="Title">
             <a:extLst xmlns:a="http://schemas.openxmlformats.org/drawingml/2006/main">
               <a:ext uri="{FF2B5EF4-FFF2-40B4-BE49-F238E27FC236}">
-                <a16:creationId xmlns:a16="http://schemas.microsoft.com/office/drawing/2014/main" id="{3E613E2E-53B0-4909-B1BA-B62CCF6B46D2}"/>
+                <a16:creationId xmlns:a16="http://schemas.microsoft.com/office/drawing/2014/main" id="{2DAE4D72-EF44-4731-B97B-3FC34AB9513B}"/>
               </a:ext>
             </a:extLst>
           </p:cNvPr>
@@ -1046,7 +1031,7 @@
           <p:cNvPr id="2" name="Subtitle">
             <a:extLst xmlns:a="http://schemas.openxmlformats.org/drawingml/2006/main">
               <a:ext uri="{FF2B5EF4-FFF2-40B4-BE49-F238E27FC236}">
-                <a16:creationId xmlns:a16="http://schemas.microsoft.com/office/drawing/2014/main" id="{32C7D2A5-CD32-4E16-8E6C-9ECEA82D91EA}"/>
+                <a16:creationId xmlns:a16="http://schemas.microsoft.com/office/drawing/2014/main" id="{EDB53ED1-99B0-41F3-93D4-A9389883B976}"/>
               </a:ext>
             </a:extLst>
           </p:cNvPr>
@@ -1292,7 +1277,7 @@
           <p:cNvPr id="2" name="Section title">
             <a:extLst xmlns:a="http://schemas.openxmlformats.org/drawingml/2006/main">
               <a:ext uri="{FF2B5EF4-FFF2-40B4-BE49-F238E27FC236}">
-                <a16:creationId xmlns:a16="http://schemas.microsoft.com/office/drawing/2014/main" id="{AA8093D8-F6E0-4381-927A-5ADDF98AC0F6}"/>
+                <a16:creationId xmlns:a16="http://schemas.microsoft.com/office/drawing/2014/main" id="{AB9E905B-F24D-4715-A84D-FB0F708E4DAF}"/>
               </a:ext>
             </a:extLst>
           </p:cNvPr>
@@ -1538,7 +1523,7 @@
           <p:cNvPr id="3" name="Title">
             <a:extLst xmlns:a="http://schemas.openxmlformats.org/drawingml/2006/main">
               <a:ext uri="{FF2B5EF4-FFF2-40B4-BE49-F238E27FC236}">
-                <a16:creationId xmlns:a16="http://schemas.microsoft.com/office/drawing/2014/main" id="{398CDD2D-5900-42B2-99C6-E98F4C16599B}"/>
+                <a16:creationId xmlns:a16="http://schemas.microsoft.com/office/drawing/2014/main" id="{E81B89D6-CF33-47DD-813D-30CBC67D27A5}"/>
               </a:ext>
             </a:extLst>
           </p:cNvPr>
@@ -1767,7 +1752,7 @@
           <p:cNvPr id="2" name="Body">
             <a:extLst xmlns:a="http://schemas.openxmlformats.org/drawingml/2006/main">
               <a:ext uri="{FF2B5EF4-FFF2-40B4-BE49-F238E27FC236}">
-                <a16:creationId xmlns:a16="http://schemas.microsoft.com/office/drawing/2014/main" id="{825D11B3-53F4-404F-8282-81A4433005A5}"/>
+                <a16:creationId xmlns:a16="http://schemas.microsoft.com/office/drawing/2014/main" id="{2C4DBCA8-C899-4D82-AAC0-6736A200687D}"/>
               </a:ext>
             </a:extLst>
           </p:cNvPr>
@@ -2013,7 +1998,7 @@
           <p:cNvPr id="4" name="Title">
             <a:extLst xmlns:a="http://schemas.openxmlformats.org/drawingml/2006/main">
               <a:ext uri="{FF2B5EF4-FFF2-40B4-BE49-F238E27FC236}">
-                <a16:creationId xmlns:a16="http://schemas.microsoft.com/office/drawing/2014/main" id="{8417A935-088B-4B43-875F-48C87122BC6C}"/>
+                <a16:creationId xmlns:a16="http://schemas.microsoft.com/office/drawing/2014/main" id="{F8FDB0F8-7F2A-41A7-9DB0-3FFED603FB15}"/>
               </a:ext>
             </a:extLst>
           </p:cNvPr>
@@ -2242,7 +2227,7 @@
           <p:cNvPr id="2" name="Left column">
             <a:extLst xmlns:a="http://schemas.openxmlformats.org/drawingml/2006/main">
               <a:ext uri="{FF2B5EF4-FFF2-40B4-BE49-F238E27FC236}">
-                <a16:creationId xmlns:a16="http://schemas.microsoft.com/office/drawing/2014/main" id="{8AD6B605-5498-408A-93E1-AC733C11B5E2}"/>
+                <a16:creationId xmlns:a16="http://schemas.microsoft.com/office/drawing/2014/main" id="{7351A9A7-6F74-45E3-9D52-48F4D1EB85D1}"/>
               </a:ext>
             </a:extLst>
           </p:cNvPr>
@@ -2471,7 +2456,7 @@
           <p:cNvPr id="3" name="Right column">
             <a:extLst xmlns:a="http://schemas.openxmlformats.org/drawingml/2006/main">
               <a:ext uri="{FF2B5EF4-FFF2-40B4-BE49-F238E27FC236}">
-                <a16:creationId xmlns:a16="http://schemas.microsoft.com/office/drawing/2014/main" id="{171C6D87-B8D2-412F-A8FD-53F8E7910B1E}"/>
+                <a16:creationId xmlns:a16="http://schemas.microsoft.com/office/drawing/2014/main" id="{ECAFF073-3A46-495F-AC35-BF8E73CA9FB1}"/>
               </a:ext>
             </a:extLst>
           </p:cNvPr>
@@ -2717,7 +2702,7 @@
           <p:cNvPr id="3" name="Title">
             <a:extLst xmlns:a="http://schemas.openxmlformats.org/drawingml/2006/main">
               <a:ext uri="{FF2B5EF4-FFF2-40B4-BE49-F238E27FC236}">
-                <a16:creationId xmlns:a16="http://schemas.microsoft.com/office/drawing/2014/main" id="{B312F9F3-1733-49FD-8955-3A39CCF16FE4}"/>
+                <a16:creationId xmlns:a16="http://schemas.microsoft.com/office/drawing/2014/main" id="{2477923A-FA80-4433-9E28-7B7EA773F02B}"/>
               </a:ext>
             </a:extLst>
           </p:cNvPr>
@@ -2946,7 +2931,7 @@
           <p:cNvPr id="2" name="Left column">
             <a:extLst xmlns:a="http://schemas.openxmlformats.org/drawingml/2006/main">
               <a:ext uri="{FF2B5EF4-FFF2-40B4-BE49-F238E27FC236}">
-                <a16:creationId xmlns:a16="http://schemas.microsoft.com/office/drawing/2014/main" id="{604BB4E9-41D7-420D-82C0-A128EB23A1D3}"/>
+                <a16:creationId xmlns:a16="http://schemas.microsoft.com/office/drawing/2014/main" id="{EE95067B-90C7-4B54-AC19-FA7E89BC5AAA}"/>
               </a:ext>
             </a:extLst>
           </p:cNvPr>
@@ -3213,12 +3198,12 @@
   </p:cSld>
   <p:clrMap bg1="lt1" tx1="dk1" bg2="lt2" tx2="dk2" accent1="accent1" accent2="accent2" accent3="accent3" accent4="accent4" accent5="accent5" accent6="accent6" hlink="hlink" folHlink="folHlink"/>
   <p:sldLayoutIdLst>
-    <p:sldLayoutId xmlns:r="http://schemas.openxmlformats.org/officeDocument/2006/relationships" id="2147483649" r:id="R0a0b566774334e90"/>
-    <p:sldLayoutId xmlns:r="http://schemas.openxmlformats.org/officeDocument/2006/relationships" id="2147483650" r:id="R3fa4130d98ea47ae"/>
-    <p:sldLayoutId xmlns:r="http://schemas.openxmlformats.org/officeDocument/2006/relationships" id="2147483651" r:id="Rf4c2a506f1f04d49"/>
-    <p:sldLayoutId xmlns:r="http://schemas.openxmlformats.org/officeDocument/2006/relationships" id="2147483652" r:id="R278209b2e8c34b7e"/>
-    <p:sldLayoutId xmlns:r="http://schemas.openxmlformats.org/officeDocument/2006/relationships" id="2147483653" r:id="R27a0b0ace4314ecc"/>
-    <p:sldLayoutId xmlns:r="http://schemas.openxmlformats.org/officeDocument/2006/relationships" id="2147483654" r:id="R3ade6f14cc234e24"/>
+    <p:sldLayoutId xmlns:r="http://schemas.openxmlformats.org/officeDocument/2006/relationships" id="2147483649" r:id="R0812fa30cc854044"/>
+    <p:sldLayoutId xmlns:r="http://schemas.openxmlformats.org/officeDocument/2006/relationships" id="2147483650" r:id="R746a05c2710d420a"/>
+    <p:sldLayoutId xmlns:r="http://schemas.openxmlformats.org/officeDocument/2006/relationships" id="2147483651" r:id="Rbce4f0254afd4cc5"/>
+    <p:sldLayoutId xmlns:r="http://schemas.openxmlformats.org/officeDocument/2006/relationships" id="2147483652" r:id="Rcba66cff563b48bf"/>
+    <p:sldLayoutId xmlns:r="http://schemas.openxmlformats.org/officeDocument/2006/relationships" id="2147483653" r:id="R80a323677048472c"/>
+    <p:sldLayoutId xmlns:r="http://schemas.openxmlformats.org/officeDocument/2006/relationships" id="2147483654" r:id="R6b11bad04f254895"/>
   </p:sldLayoutIdLst>
   <p:txStyles>
     <p:titleStyle>
@@ -3769,7 +3754,7 @@
           <p:cNvPr id="7" name="">
             <a:extLst xmlns:a="http://schemas.openxmlformats.org/drawingml/2006/main">
               <a:ext uri="{FF2B5EF4-FFF2-40B4-BE49-F238E27FC236}">
-                <a16:creationId xmlns:a16="http://schemas.microsoft.com/office/drawing/2014/main" id="{C832B7B0-F74D-4FE4-B8E6-01606BBD0508}"/>
+                <a16:creationId xmlns:a16="http://schemas.microsoft.com/office/drawing/2014/main" id="{092F30EF-C8EC-45AC-B500-C42783DF5073}"/>
               </a:ext>
             </a:extLst>
           </p:cNvPr>
@@ -3779,7 +3764,7 @@
           <p:nvPr/>
         </p:nvPicPr>
         <p:blipFill>
-          <a:blip xmlns:r="http://schemas.openxmlformats.org/officeDocument/2006/relationships" xmlns:a="http://schemas.openxmlformats.org/drawingml/2006/main" r:embed="R0cfa776bc2454ecc"/>
+          <a:blip xmlns:r="http://schemas.openxmlformats.org/officeDocument/2006/relationships" xmlns:a="http://schemas.openxmlformats.org/drawingml/2006/main" r:embed="R2ce9d418df2442eb"/>
           <a:srcRect xmlns:a="http://schemas.openxmlformats.org/drawingml/2006/main" l="10800" t="30500" r="5500" b="33000"/>
           <a:stretch xmlns:a="http://schemas.openxmlformats.org/drawingml/2006/main"/>
         </p:blipFill>
@@ -3798,7 +3783,7 @@
           <p:cNvPr id="2" name="copy-1">
             <a:extLst xmlns:a="http://schemas.openxmlformats.org/drawingml/2006/main">
               <a:ext uri="{FF2B5EF4-FFF2-40B4-BE49-F238E27FC236}">
-                <a16:creationId xmlns:a16="http://schemas.microsoft.com/office/drawing/2014/main" id="{D9183BD6-7F0E-46D5-A701-79728BA8993B}"/>
+                <a16:creationId xmlns:a16="http://schemas.microsoft.com/office/drawing/2014/main" id="{B1D3EEB9-F985-48B3-A48B-FDD55370B6AC}"/>
               </a:ext>
             </a:extLst>
           </p:cNvPr>
@@ -3809,7 +3794,7 @@
         </p:nvSpPr>
         <p:spPr>
           <a:xfrm xmlns:a="http://schemas.openxmlformats.org/drawingml/2006/main">
-            <a:off x="514350" y="1495425"/>
+            <a:off x="514350" y="1562100"/>
             <a:ext cx="5810250" cy="1457325"/>
           </a:xfrm>
           <a:prstGeom xmlns:a="http://schemas.openxmlformats.org/drawingml/2006/main" prst="rect">
@@ -3826,7 +3811,7 @@
           </a:bodyPr>
           <a:lstStyle xmlns:a="http://schemas.openxmlformats.org/drawingml/2006/main">
             <a:defPPr>
-              <a:defRPr sz="3825" b="1">
+              <a:defRPr sz="4050" b="1">
                 <a:solidFill>
                   <a:srgbClr val="111111"/>
                 </a:solidFill>
@@ -3836,7 +3821,7 @@
               </a:defRPr>
             </a:defPPr>
             <a:lvl1pPr>
-              <a:defRPr sz="3825" b="1">
+              <a:defRPr sz="4050" b="1">
                 <a:solidFill>
                   <a:srgbClr val="111111"/>
                 </a:solidFill>
@@ -3846,7 +3831,7 @@
               </a:defRPr>
             </a:lvl1pPr>
             <a:lvl2pPr>
-              <a:defRPr sz="3825" b="1">
+              <a:defRPr sz="4050" b="1">
                 <a:solidFill>
                   <a:srgbClr val="111111"/>
                 </a:solidFill>
@@ -3856,7 +3841,7 @@
               </a:defRPr>
             </a:lvl2pPr>
             <a:lvl3pPr>
-              <a:defRPr sz="3825" b="1">
+              <a:defRPr sz="4050" b="1">
                 <a:solidFill>
                   <a:srgbClr val="111111"/>
                 </a:solidFill>
@@ -3866,7 +3851,7 @@
               </a:defRPr>
             </a:lvl3pPr>
             <a:lvl4pPr>
-              <a:defRPr sz="3825" b="1">
+              <a:defRPr sz="4050" b="1">
                 <a:solidFill>
                   <a:srgbClr val="111111"/>
                 </a:solidFill>
@@ -3876,7 +3861,7 @@
               </a:defRPr>
             </a:lvl4pPr>
             <a:lvl5pPr>
-              <a:defRPr sz="3825" b="1">
+              <a:defRPr sz="4050" b="1">
                 <a:solidFill>
                   <a:srgbClr val="111111"/>
                 </a:solidFill>
@@ -3886,7 +3871,7 @@
               </a:defRPr>
             </a:lvl5pPr>
             <a:lvl6pPr>
-              <a:defRPr sz="3825" b="1">
+              <a:defRPr sz="4050" b="1">
                 <a:solidFill>
                   <a:srgbClr val="111111"/>
                 </a:solidFill>
@@ -3896,7 +3881,7 @@
               </a:defRPr>
             </a:lvl6pPr>
             <a:lvl7pPr>
-              <a:defRPr sz="3825" b="1">
+              <a:defRPr sz="4050" b="1">
                 <a:solidFill>
                   <a:srgbClr val="111111"/>
                 </a:solidFill>
@@ -3906,7 +3891,7 @@
               </a:defRPr>
             </a:lvl7pPr>
             <a:lvl8pPr>
-              <a:defRPr sz="3825" b="1">
+              <a:defRPr sz="4050" b="1">
                 <a:solidFill>
                   <a:srgbClr val="111111"/>
                 </a:solidFill>
@@ -3916,7 +3901,7 @@
               </a:defRPr>
             </a:lvl8pPr>
             <a:lvl9pPr>
-              <a:defRPr sz="3825" b="1">
+              <a:defRPr sz="4050" b="1">
                 <a:solidFill>
                   <a:srgbClr val="111111"/>
                 </a:solidFill>
@@ -3928,7 +3913,7 @@
           </a:lstStyle>
           <a:p xmlns:a="http://schemas.openxmlformats.org/drawingml/2006/main">
             <a:pPr>
-              <a:defRPr sz="3825" b="1">
+              <a:defRPr sz="4050" b="1">
                 <a:solidFill>
                   <a:srgbClr val="111111"/>
                 </a:solidFill>
@@ -3938,7 +3923,7 @@
               </a:defRPr>
             </a:pPr>
             <a:r>
-              <a:rPr sz="3825" b="1">
+              <a:rPr sz="4050" b="1">
                 <a:solidFill>
                   <a:srgbClr val="111111"/>
                 </a:solidFill>
@@ -3946,12 +3931,12 @@
                 <a:ea typeface="Inter"/>
                 <a:cs typeface="Inter"/>
               </a:rPr>
-              <a:t>Which soybean cells</a:t>
+              <a:t>An agent for</a:t>
             </a:r>
           </a:p>
           <a:p xmlns:a="http://schemas.openxmlformats.org/drawingml/2006/main">
             <a:pPr>
-              <a:defRPr sz="3825" b="1">
+              <a:defRPr sz="4050" b="1">
                 <a:solidFill>
                   <a:srgbClr val="111111"/>
                 </a:solidFill>
@@ -3961,7 +3946,7 @@
               </a:defRPr>
             </a:pPr>
             <a:r>
-              <a:rPr sz="3825" b="1">
+              <a:rPr sz="4050" b="1">
                 <a:solidFill>
                   <a:srgbClr val="111111"/>
                 </a:solidFill>
@@ -3969,7 +3954,7 @@
                 <a:ea typeface="Inter"/>
                 <a:cs typeface="Inter"/>
               </a:rPr>
-              <a:t>help absorb nutrients?</a:t>
+              <a:t>plant cell annotation.</a:t>
             </a:r>
           </a:p>
         </p:txBody>
@@ -3979,7 +3964,7 @@
           <p:cNvPr id="3" name="copy-2">
             <a:extLst xmlns:a="http://schemas.openxmlformats.org/drawingml/2006/main">
               <a:ext uri="{FF2B5EF4-FFF2-40B4-BE49-F238E27FC236}">
-                <a16:creationId xmlns:a16="http://schemas.microsoft.com/office/drawing/2014/main" id="{753F0731-D619-4356-BF5D-A7AD9E1B4B4B}"/>
+                <a16:creationId xmlns:a16="http://schemas.microsoft.com/office/drawing/2014/main" id="{2FA4018D-A03B-4F0D-AB64-EDFABBD4D57B}"/>
               </a:ext>
             </a:extLst>
           </p:cNvPr>
@@ -3990,8 +3975,8 @@
         </p:nvSpPr>
         <p:spPr>
           <a:xfrm xmlns:a="http://schemas.openxmlformats.org/drawingml/2006/main">
-            <a:off x="552450" y="3257550"/>
-            <a:ext cx="5429250" cy="1143000"/>
+            <a:off x="552450" y="3419475"/>
+            <a:ext cx="5381625" cy="904875"/>
           </a:xfrm>
           <a:prstGeom xmlns:a="http://schemas.openxmlformats.org/drawingml/2006/main" prst="rect">
             <a:avLst/>
@@ -4007,7 +3992,7 @@
           </a:bodyPr>
           <a:lstStyle xmlns:a="http://schemas.openxmlformats.org/drawingml/2006/main">
             <a:defPPr>
-              <a:defRPr sz="1875" b="0">
+              <a:defRPr sz="2025" b="0">
                 <a:solidFill>
                   <a:srgbClr val="666666"/>
                 </a:solidFill>
@@ -4017,7 +4002,7 @@
               </a:defRPr>
             </a:defPPr>
             <a:lvl1pPr>
-              <a:defRPr sz="1875" b="0">
+              <a:defRPr sz="2025" b="0">
                 <a:solidFill>
                   <a:srgbClr val="666666"/>
                 </a:solidFill>
@@ -4027,7 +4012,7 @@
               </a:defRPr>
             </a:lvl1pPr>
             <a:lvl2pPr>
-              <a:defRPr sz="1875" b="0">
+              <a:defRPr sz="2025" b="0">
                 <a:solidFill>
                   <a:srgbClr val="666666"/>
                 </a:solidFill>
@@ -4037,7 +4022,7 @@
               </a:defRPr>
             </a:lvl2pPr>
             <a:lvl3pPr>
-              <a:defRPr sz="1875" b="0">
+              <a:defRPr sz="2025" b="0">
                 <a:solidFill>
                   <a:srgbClr val="666666"/>
                 </a:solidFill>
@@ -4047,7 +4032,7 @@
               </a:defRPr>
             </a:lvl3pPr>
             <a:lvl4pPr>
-              <a:defRPr sz="1875" b="0">
+              <a:defRPr sz="2025" b="0">
                 <a:solidFill>
                   <a:srgbClr val="666666"/>
                 </a:solidFill>
@@ -4057,7 +4042,7 @@
               </a:defRPr>
             </a:lvl4pPr>
             <a:lvl5pPr>
-              <a:defRPr sz="1875" b="0">
+              <a:defRPr sz="2025" b="0">
                 <a:solidFill>
                   <a:srgbClr val="666666"/>
                 </a:solidFill>
@@ -4067,7 +4052,7 @@
               </a:defRPr>
             </a:lvl5pPr>
             <a:lvl6pPr>
-              <a:defRPr sz="1875" b="0">
+              <a:defRPr sz="2025" b="0">
                 <a:solidFill>
                   <a:srgbClr val="666666"/>
                 </a:solidFill>
@@ -4077,7 +4062,7 @@
               </a:defRPr>
             </a:lvl6pPr>
             <a:lvl7pPr>
-              <a:defRPr sz="1875" b="0">
+              <a:defRPr sz="2025" b="0">
                 <a:solidFill>
                   <a:srgbClr val="666666"/>
                 </a:solidFill>
@@ -4087,7 +4072,7 @@
               </a:defRPr>
             </a:lvl7pPr>
             <a:lvl8pPr>
-              <a:defRPr sz="1875" b="0">
+              <a:defRPr sz="2025" b="0">
                 <a:solidFill>
                   <a:srgbClr val="666666"/>
                 </a:solidFill>
@@ -4097,7 +4082,7 @@
               </a:defRPr>
             </a:lvl8pPr>
             <a:lvl9pPr>
-              <a:defRPr sz="1875" b="0">
+              <a:defRPr sz="2025" b="0">
                 <a:solidFill>
                   <a:srgbClr val="666666"/>
                 </a:solidFill>
@@ -4109,7 +4094,7 @@
           </a:lstStyle>
           <a:p xmlns:a="http://schemas.openxmlformats.org/drawingml/2006/main">
             <a:pPr>
-              <a:defRPr sz="1875" b="0">
+              <a:defRPr sz="2025" b="0">
                 <a:solidFill>
                   <a:srgbClr val="666666"/>
                 </a:solidFill>
@@ -4119,7 +4104,7 @@
               </a:defRPr>
             </a:pPr>
             <a:r>
-              <a:rPr sz="1875" b="0">
+              <a:rPr sz="2025" b="0">
                 <a:solidFill>
                   <a:srgbClr val="666666"/>
                 </a:solidFill>
@@ -4127,12 +4112,12 @@
                 <a:ea typeface="Inter"/>
                 <a:cs typeface="Inter"/>
               </a:rPr>
-              <a:t>Root-hair cells absorb water and nutrients.</a:t>
+              <a:t>From gene expression to candidate</a:t>
             </a:r>
           </a:p>
           <a:p xmlns:a="http://schemas.openxmlformats.org/drawingml/2006/main">
             <a:pPr>
-              <a:defRPr sz="1875" b="0">
+              <a:defRPr sz="2025" b="0">
                 <a:solidFill>
                   <a:srgbClr val="666666"/>
                 </a:solidFill>
@@ -4142,7 +4127,7 @@
               </a:defRPr>
             </a:pPr>
             <a:r>
-              <a:rPr sz="1875" b="0">
+              <a:rPr sz="2025" b="0">
                 <a:solidFill>
                   <a:srgbClr val="666666"/>
                 </a:solidFill>
@@ -4150,30 +4135,7 @@
                 <a:ea typeface="Inter"/>
                 <a:cs typeface="Inter"/>
               </a:rPr>
-              <a:t>Researchers first need to find them</a:t>
-            </a:r>
-          </a:p>
-          <a:p xmlns:a="http://schemas.openxmlformats.org/drawingml/2006/main">
-            <a:pPr>
-              <a:defRPr sz="1875" b="0">
-                <a:solidFill>
-                  <a:srgbClr val="666666"/>
-                </a:solidFill>
-                <a:latin typeface="Inter"/>
-                <a:ea typeface="Inter"/>
-                <a:cs typeface="Inter"/>
-              </a:defRPr>
-            </a:pPr>
-            <a:r>
-              <a:rPr sz="1875" b="0">
-                <a:solidFill>
-                  <a:srgbClr val="666666"/>
-                </a:solidFill>
-                <a:latin typeface="Inter"/>
-                <a:ea typeface="Inter"/>
-                <a:cs typeface="Inter"/>
-              </a:rPr>
-              <a:t>in their sequencing data.</a:t>
+              <a:t>cell types, with the supporting evidence.</a:t>
             </a:r>
           </a:p>
         </p:txBody>
@@ -4183,7 +4145,7 @@
           <p:cNvPr id="4" name="copy-3">
             <a:extLst xmlns:a="http://schemas.openxmlformats.org/drawingml/2006/main">
               <a:ext uri="{FF2B5EF4-FFF2-40B4-BE49-F238E27FC236}">
-                <a16:creationId xmlns:a16="http://schemas.microsoft.com/office/drawing/2014/main" id="{EC361824-816F-45BD-9AA8-6C0273AAAF35}"/>
+                <a16:creationId xmlns:a16="http://schemas.microsoft.com/office/drawing/2014/main" id="{29CEDBC9-16CB-4E5D-81F1-E83FF64C913E}"/>
               </a:ext>
             </a:extLst>
           </p:cNvPr>
@@ -4194,8 +4156,8 @@
         </p:nvSpPr>
         <p:spPr>
           <a:xfrm xmlns:a="http://schemas.openxmlformats.org/drawingml/2006/main">
-            <a:off x="552450" y="4695825"/>
-            <a:ext cx="5429250" cy="828675"/>
+            <a:off x="552450" y="4667250"/>
+            <a:ext cx="5381625" cy="904875"/>
           </a:xfrm>
           <a:prstGeom xmlns:a="http://schemas.openxmlformats.org/drawingml/2006/main" prst="rect">
             <a:avLst/>
@@ -4211,7 +4173,7 @@
           </a:bodyPr>
           <a:lstStyle xmlns:a="http://schemas.openxmlformats.org/drawingml/2006/main">
             <a:defPPr>
-              <a:defRPr sz="1950" b="1">
+              <a:defRPr sz="2100" b="1">
                 <a:solidFill>
                   <a:srgbClr val="1B5E20"/>
                 </a:solidFill>
@@ -4221,7 +4183,7 @@
               </a:defRPr>
             </a:defPPr>
             <a:lvl1pPr>
-              <a:defRPr sz="1950" b="1">
+              <a:defRPr sz="2100" b="1">
                 <a:solidFill>
                   <a:srgbClr val="1B5E20"/>
                 </a:solidFill>
@@ -4231,7 +4193,7 @@
               </a:defRPr>
             </a:lvl1pPr>
             <a:lvl2pPr>
-              <a:defRPr sz="1950" b="1">
+              <a:defRPr sz="2100" b="1">
                 <a:solidFill>
                   <a:srgbClr val="1B5E20"/>
                 </a:solidFill>
@@ -4241,7 +4203,7 @@
               </a:defRPr>
             </a:lvl2pPr>
             <a:lvl3pPr>
-              <a:defRPr sz="1950" b="1">
+              <a:defRPr sz="2100" b="1">
                 <a:solidFill>
                   <a:srgbClr val="1B5E20"/>
                 </a:solidFill>
@@ -4251,7 +4213,7 @@
               </a:defRPr>
             </a:lvl3pPr>
             <a:lvl4pPr>
-              <a:defRPr sz="1950" b="1">
+              <a:defRPr sz="2100" b="1">
                 <a:solidFill>
                   <a:srgbClr val="1B5E20"/>
                 </a:solidFill>
@@ -4261,7 +4223,7 @@
               </a:defRPr>
             </a:lvl4pPr>
             <a:lvl5pPr>
-              <a:defRPr sz="1950" b="1">
+              <a:defRPr sz="2100" b="1">
                 <a:solidFill>
                   <a:srgbClr val="1B5E20"/>
                 </a:solidFill>
@@ -4271,7 +4233,7 @@
               </a:defRPr>
             </a:lvl5pPr>
             <a:lvl6pPr>
-              <a:defRPr sz="1950" b="1">
+              <a:defRPr sz="2100" b="1">
                 <a:solidFill>
                   <a:srgbClr val="1B5E20"/>
                 </a:solidFill>
@@ -4281,7 +4243,7 @@
               </a:defRPr>
             </a:lvl6pPr>
             <a:lvl7pPr>
-              <a:defRPr sz="1950" b="1">
+              <a:defRPr sz="2100" b="1">
                 <a:solidFill>
                   <a:srgbClr val="1B5E20"/>
                 </a:solidFill>
@@ -4291,7 +4253,7 @@
               </a:defRPr>
             </a:lvl7pPr>
             <a:lvl8pPr>
-              <a:defRPr sz="1950" b="1">
+              <a:defRPr sz="2100" b="1">
                 <a:solidFill>
                   <a:srgbClr val="1B5E20"/>
                 </a:solidFill>
@@ -4301,7 +4263,7 @@
               </a:defRPr>
             </a:lvl8pPr>
             <a:lvl9pPr>
-              <a:defRPr sz="1950" b="1">
+              <a:defRPr sz="2100" b="1">
                 <a:solidFill>
                   <a:srgbClr val="1B5E20"/>
                 </a:solidFill>
@@ -4313,7 +4275,7 @@
           </a:lstStyle>
           <a:p xmlns:a="http://schemas.openxmlformats.org/drawingml/2006/main">
             <a:pPr>
-              <a:defRPr sz="1950" b="1">
+              <a:defRPr sz="2100" b="1">
                 <a:solidFill>
                   <a:srgbClr val="1B5E20"/>
                 </a:solidFill>
@@ -4323,7 +4285,7 @@
               </a:defRPr>
             </a:pPr>
             <a:r>
-              <a:rPr sz="1950" b="1">
+              <a:rPr sz="2100" b="1">
                 <a:solidFill>
                   <a:srgbClr val="1B5E20"/>
                 </a:solidFill>
@@ -4331,12 +4293,12 @@
                 <a:ea typeface="Inter"/>
                 <a:cs typeface="Inter"/>
               </a:rPr>
-              <a:t>Celloras investigates 7,496 soybean nuclei</a:t>
+              <a:t>Ask a question. Get a cell map,</a:t>
             </a:r>
           </a:p>
           <a:p xmlns:a="http://schemas.openxmlformats.org/drawingml/2006/main">
             <a:pPr>
-              <a:defRPr sz="1950" b="1">
+              <a:defRPr sz="2100" b="1">
                 <a:solidFill>
                   <a:srgbClr val="1B5E20"/>
                 </a:solidFill>
@@ -4346,7 +4308,7 @@
               </a:defRPr>
             </a:pPr>
             <a:r>
-              <a:rPr sz="1950" b="1">
+              <a:rPr sz="2100" b="1">
                 <a:solidFill>
                   <a:srgbClr val="1B5E20"/>
                 </a:solidFill>
@@ -4354,7 +4316,7 @@
                 <a:ea typeface="Inter"/>
                 <a:cs typeface="Inter"/>
               </a:rPr>
-              <a:t>and explains a root-hair candidate.</a:t>
+              <a:t>marker evidence and source links.</a:t>
             </a:r>
           </a:p>
         </p:txBody>
@@ -4364,7 +4326,7 @@
           <p:cNvPr id="5" name="">
             <a:extLst xmlns:a="http://schemas.openxmlformats.org/drawingml/2006/main">
               <a:ext uri="{FF2B5EF4-FFF2-40B4-BE49-F238E27FC236}">
-                <a16:creationId xmlns:a16="http://schemas.microsoft.com/office/drawing/2014/main" id="{56C3C0A1-19ED-4E4E-A19B-D935602DD81D}"/>
+                <a16:creationId xmlns:a16="http://schemas.microsoft.com/office/drawing/2014/main" id="{C3BD8244-1780-4051-B8B2-8DF7CD03DB24}"/>
               </a:ext>
             </a:extLst>
           </p:cNvPr>
@@ -4374,7 +4336,7 @@
           <p:nvPr/>
         </p:nvPicPr>
         <p:blipFill>
-          <a:blip xmlns:r="http://schemas.openxmlformats.org/officeDocument/2006/relationships" xmlns:a="http://schemas.openxmlformats.org/drawingml/2006/main" r:embed="Rc9b2ad86570f461e"/>
+          <a:blip xmlns:r="http://schemas.openxmlformats.org/officeDocument/2006/relationships" xmlns:a="http://schemas.openxmlformats.org/drawingml/2006/main" r:embed="R83f27ba48a7543cb"/>
           <a:stretch xmlns:a="http://schemas.openxmlformats.org/drawingml/2006/main"/>
         </p:blipFill>
         <p:spPr>
@@ -4392,7 +4354,7 @@
           <p:cNvPr id="6" name="copy-4">
             <a:extLst xmlns:a="http://schemas.openxmlformats.org/drawingml/2006/main">
               <a:ext uri="{FF2B5EF4-FFF2-40B4-BE49-F238E27FC236}">
-                <a16:creationId xmlns:a16="http://schemas.microsoft.com/office/drawing/2014/main" id="{670173D5-37CC-4203-958F-A6C499B6E65A}"/>
+                <a16:creationId xmlns:a16="http://schemas.microsoft.com/office/drawing/2014/main" id="{AF882377-1657-4AD4-B56E-AE2FCE3251DC}"/>
               </a:ext>
             </a:extLst>
           </p:cNvPr>
@@ -4540,7 +4502,7 @@
                 <a:ea typeface="Inter"/>
                 <a:cs typeface="Inter"/>
               </a:rPr>
-              <a:t>Real demo: published soybean root data (GSE270392).</a:t>
+              <a:t>Starting with soybean. More plants next.</a:t>
             </a:r>
           </a:p>
         </p:txBody>
@@ -4548,7 +4510,7 @@
     </p:spTree>
     <p:extLst>
       <p:ext uri="{BB962C8B-B14F-4D97-AF65-F5344CB8AC3E}">
-        <p14:creationId xmlns:p14="http://schemas.microsoft.com/office/powerpoint/2010/main" val="1547641445"/>
+        <p14:creationId xmlns:p14="http://schemas.microsoft.com/office/powerpoint/2010/main" val="183982470"/>
       </p:ext>
     </p:extLst>
   </p:cSld>
@@ -4576,10 +4538,10 @@
       </p:grpSpPr>
       <p:sp>
         <p:nvSpPr>
-          <p:cNvPr id="16" name="copy-5">
+          <p:cNvPr id="15" name="copy-5">
             <a:extLst xmlns:a="http://schemas.openxmlformats.org/drawingml/2006/main">
               <a:ext uri="{FF2B5EF4-FFF2-40B4-BE49-F238E27FC236}">
-                <a16:creationId xmlns:a16="http://schemas.microsoft.com/office/drawing/2014/main" id="{D5172FB8-CF7B-44EF-88CD-FD28082C79AF}"/>
+                <a16:creationId xmlns:a16="http://schemas.microsoft.com/office/drawing/2014/main" id="{43081E3E-C828-4D47-B8F1-0BC65D249233}"/>
               </a:ext>
             </a:extLst>
           </p:cNvPr>
@@ -4727,17 +4689,17 @@
                 <a:ea typeface="Inter"/>
                 <a:cs typeface="Inter"/>
               </a:rPr>
-              <a:t>Finding root-hair cells</a:t>
+              <a:t>What changes with Celloras?</a:t>
             </a:r>
           </a:p>
         </p:txBody>
       </p:sp>
       <p:sp>
         <p:nvSpPr>
-          <p:cNvPr id="2" name="copy-6">
+          <p:cNvPr id="2" name="block-6">
             <a:extLst xmlns:a="http://schemas.openxmlformats.org/drawingml/2006/main">
               <a:ext uri="{FF2B5EF4-FFF2-40B4-BE49-F238E27FC236}">
-                <a16:creationId xmlns:a16="http://schemas.microsoft.com/office/drawing/2014/main" id="{80D7BA7B-4152-431F-9094-8BAC0184DC21}"/>
+                <a16:creationId xmlns:a16="http://schemas.microsoft.com/office/drawing/2014/main" id="{B2EFCFB6-C220-4A63-885E-A87398A740F5}"/>
               </a:ext>
             </a:extLst>
           </p:cNvPr>
@@ -4748,166 +4710,8 @@
         </p:nvSpPr>
         <p:spPr>
           <a:xfrm xmlns:a="http://schemas.openxmlformats.org/drawingml/2006/main">
-            <a:off x="552450" y="1495425"/>
-            <a:ext cx="11087100" cy="409575"/>
-          </a:xfrm>
-          <a:prstGeom xmlns:a="http://schemas.openxmlformats.org/drawingml/2006/main" prst="rect">
-            <a:avLst/>
-          </a:prstGeom>
-          <a:noFill xmlns:a="http://schemas.openxmlformats.org/drawingml/2006/main"/>
-          <a:ln xmlns:a="http://schemas.openxmlformats.org/drawingml/2006/main" w="0">
-            <a:noFill/>
-          </a:ln>
-        </p:spPr>
-        <p:txBody>
-          <a:bodyPr xmlns:a="http://schemas.openxmlformats.org/drawingml/2006/main" wrap="square" lIns="0" tIns="0" rIns="0" bIns="0">
-            <a:noAutofit/>
-          </a:bodyPr>
-          <a:lstStyle xmlns:a="http://schemas.openxmlformats.org/drawingml/2006/main">
-            <a:defPPr>
-              <a:defRPr sz="2025" b="0">
-                <a:solidFill>
-                  <a:srgbClr val="666666"/>
-                </a:solidFill>
-                <a:latin typeface="Inter"/>
-                <a:ea typeface="Inter"/>
-                <a:cs typeface="Inter"/>
-              </a:defRPr>
-            </a:defPPr>
-            <a:lvl1pPr>
-              <a:defRPr sz="2025" b="0">
-                <a:solidFill>
-                  <a:srgbClr val="666666"/>
-                </a:solidFill>
-                <a:latin typeface="Inter"/>
-                <a:ea typeface="Inter"/>
-                <a:cs typeface="Inter"/>
-              </a:defRPr>
-            </a:lvl1pPr>
-            <a:lvl2pPr>
-              <a:defRPr sz="2025" b="0">
-                <a:solidFill>
-                  <a:srgbClr val="666666"/>
-                </a:solidFill>
-                <a:latin typeface="Inter"/>
-                <a:ea typeface="Inter"/>
-                <a:cs typeface="Inter"/>
-              </a:defRPr>
-            </a:lvl2pPr>
-            <a:lvl3pPr>
-              <a:defRPr sz="2025" b="0">
-                <a:solidFill>
-                  <a:srgbClr val="666666"/>
-                </a:solidFill>
-                <a:latin typeface="Inter"/>
-                <a:ea typeface="Inter"/>
-                <a:cs typeface="Inter"/>
-              </a:defRPr>
-            </a:lvl3pPr>
-            <a:lvl4pPr>
-              <a:defRPr sz="2025" b="0">
-                <a:solidFill>
-                  <a:srgbClr val="666666"/>
-                </a:solidFill>
-                <a:latin typeface="Inter"/>
-                <a:ea typeface="Inter"/>
-                <a:cs typeface="Inter"/>
-              </a:defRPr>
-            </a:lvl4pPr>
-            <a:lvl5pPr>
-              <a:defRPr sz="2025" b="0">
-                <a:solidFill>
-                  <a:srgbClr val="666666"/>
-                </a:solidFill>
-                <a:latin typeface="Inter"/>
-                <a:ea typeface="Inter"/>
-                <a:cs typeface="Inter"/>
-              </a:defRPr>
-            </a:lvl5pPr>
-            <a:lvl6pPr>
-              <a:defRPr sz="2025" b="0">
-                <a:solidFill>
-                  <a:srgbClr val="666666"/>
-                </a:solidFill>
-                <a:latin typeface="Inter"/>
-                <a:ea typeface="Inter"/>
-                <a:cs typeface="Inter"/>
-              </a:defRPr>
-            </a:lvl6pPr>
-            <a:lvl7pPr>
-              <a:defRPr sz="2025" b="0">
-                <a:solidFill>
-                  <a:srgbClr val="666666"/>
-                </a:solidFill>
-                <a:latin typeface="Inter"/>
-                <a:ea typeface="Inter"/>
-                <a:cs typeface="Inter"/>
-              </a:defRPr>
-            </a:lvl7pPr>
-            <a:lvl8pPr>
-              <a:defRPr sz="2025" b="0">
-                <a:solidFill>
-                  <a:srgbClr val="666666"/>
-                </a:solidFill>
-                <a:latin typeface="Inter"/>
-                <a:ea typeface="Inter"/>
-                <a:cs typeface="Inter"/>
-              </a:defRPr>
-            </a:lvl8pPr>
-            <a:lvl9pPr>
-              <a:defRPr sz="2025" b="0">
-                <a:solidFill>
-                  <a:srgbClr val="666666"/>
-                </a:solidFill>
-                <a:latin typeface="Inter"/>
-                <a:ea typeface="Inter"/>
-                <a:cs typeface="Inter"/>
-              </a:defRPr>
-            </a:lvl9pPr>
-          </a:lstStyle>
-          <a:p xmlns:a="http://schemas.openxmlformats.org/drawingml/2006/main">
-            <a:pPr>
-              <a:defRPr sz="2025" b="0">
-                <a:solidFill>
-                  <a:srgbClr val="666666"/>
-                </a:solidFill>
-                <a:latin typeface="Inter"/>
-                <a:ea typeface="Inter"/>
-                <a:cs typeface="Inter"/>
-              </a:defRPr>
-            </a:pPr>
-            <a:r>
-              <a:rPr sz="2025" b="0">
-                <a:solidFill>
-                  <a:srgbClr val="666666"/>
-                </a:solidFill>
-                <a:latin typeface="Inter"/>
-                <a:ea typeface="Inter"/>
-                <a:cs typeface="Inter"/>
-              </a:rPr>
-              <a:t>The same research question, with less manual coordination.</a:t>
-            </a:r>
-          </a:p>
-        </p:txBody>
-      </p:sp>
-      <p:sp>
-        <p:nvSpPr>
-          <p:cNvPr id="3" name="block-7">
-            <a:extLst xmlns:a="http://schemas.openxmlformats.org/drawingml/2006/main">
-              <a:ext uri="{FF2B5EF4-FFF2-40B4-BE49-F238E27FC236}">
-                <a16:creationId xmlns:a16="http://schemas.microsoft.com/office/drawing/2014/main" id="{00CFF2E7-2A82-49D9-A932-073D8315A874}"/>
-              </a:ext>
-            </a:extLst>
-          </p:cNvPr>
-          <p:cNvSpPr>
-            <a:spLocks xmlns:a="http://schemas.openxmlformats.org/drawingml/2006/main" noGrp="1"/>
-          </p:cNvSpPr>
-          <p:nvPr/>
-        </p:nvSpPr>
-        <p:spPr>
-          <a:xfrm xmlns:a="http://schemas.openxmlformats.org/drawingml/2006/main">
-            <a:off x="6334125" y="2143125"/>
-            <a:ext cx="5362575" cy="3676650"/>
+            <a:off x="6334125" y="1847850"/>
+            <a:ext cx="5362575" cy="3971925"/>
           </a:xfrm>
           <a:prstGeom xmlns:a="http://schemas.openxmlformats.org/drawingml/2006/main" prst="rect">
             <a:avLst/>
@@ -4922,10 +4726,10 @@
       </p:sp>
       <p:sp>
         <p:nvSpPr>
-          <p:cNvPr id="4" name="copy-8">
+          <p:cNvPr id="3" name="copy-7">
             <a:extLst xmlns:a="http://schemas.openxmlformats.org/drawingml/2006/main">
               <a:ext uri="{FF2B5EF4-FFF2-40B4-BE49-F238E27FC236}">
-                <a16:creationId xmlns:a16="http://schemas.microsoft.com/office/drawing/2014/main" id="{4C5C29E6-0DF3-4966-9903-5537D1D469D1}"/>
+                <a16:creationId xmlns:a16="http://schemas.microsoft.com/office/drawing/2014/main" id="{64739AF2-975F-44CA-B6B9-D5FE10CAA122}"/>
               </a:ext>
             </a:extLst>
           </p:cNvPr>
@@ -4936,7 +4740,7 @@
         </p:nvSpPr>
         <p:spPr>
           <a:xfrm xmlns:a="http://schemas.openxmlformats.org/drawingml/2006/main">
-            <a:off x="552450" y="2333625"/>
+            <a:off x="552450" y="2076450"/>
             <a:ext cx="5048250" cy="581025"/>
           </a:xfrm>
           <a:prstGeom xmlns:a="http://schemas.openxmlformats.org/drawingml/2006/main" prst="rect">
@@ -5080,10 +4884,10 @@
       </p:sp>
       <p:sp>
         <p:nvSpPr>
-          <p:cNvPr id="5" name="copy-9">
+          <p:cNvPr id="4" name="copy-8">
             <a:extLst xmlns:a="http://schemas.openxmlformats.org/drawingml/2006/main">
               <a:ext uri="{FF2B5EF4-FFF2-40B4-BE49-F238E27FC236}">
-                <a16:creationId xmlns:a16="http://schemas.microsoft.com/office/drawing/2014/main" id="{2B14828D-C1BE-44BE-AA01-7362452C3D76}"/>
+                <a16:creationId xmlns:a16="http://schemas.microsoft.com/office/drawing/2014/main" id="{2E0ABB6F-5947-4DCD-82E8-0F591079A85E}"/>
               </a:ext>
             </a:extLst>
           </p:cNvPr>
@@ -5094,7 +4898,7 @@
         </p:nvSpPr>
         <p:spPr>
           <a:xfrm xmlns:a="http://schemas.openxmlformats.org/drawingml/2006/main">
-            <a:off x="6667500" y="2333625"/>
+            <a:off x="6667500" y="2076450"/>
             <a:ext cx="4667250" cy="581025"/>
           </a:xfrm>
           <a:prstGeom xmlns:a="http://schemas.openxmlformats.org/drawingml/2006/main" prst="rect">
@@ -5238,10 +5042,10 @@
       </p:sp>
       <p:sp>
         <p:nvSpPr>
-          <p:cNvPr id="6" name="copy-10">
+          <p:cNvPr id="5" name="copy-9">
             <a:extLst xmlns:a="http://schemas.openxmlformats.org/drawingml/2006/main">
               <a:ext uri="{FF2B5EF4-FFF2-40B4-BE49-F238E27FC236}">
-                <a16:creationId xmlns:a16="http://schemas.microsoft.com/office/drawing/2014/main" id="{240EE40C-A4CD-4A2E-9124-75D5E877203B}"/>
+                <a16:creationId xmlns:a16="http://schemas.microsoft.com/office/drawing/2014/main" id="{EF387A8D-02E0-410E-99EE-96EDD35AD89A}"/>
               </a:ext>
             </a:extLst>
           </p:cNvPr>
@@ -5252,8 +5056,8 @@
         </p:nvSpPr>
         <p:spPr>
           <a:xfrm xmlns:a="http://schemas.openxmlformats.org/drawingml/2006/main">
-            <a:off x="552450" y="3228975"/>
-            <a:ext cx="4953000" cy="704850"/>
+            <a:off x="552450" y="3124200"/>
+            <a:ext cx="4953000" cy="628650"/>
           </a:xfrm>
           <a:prstGeom xmlns:a="http://schemas.openxmlformats.org/drawingml/2006/main" prst="rect">
             <a:avLst/>
@@ -5269,7 +5073,7 @@
           </a:bodyPr>
           <a:lstStyle xmlns:a="http://schemas.openxmlformats.org/drawingml/2006/main">
             <a:defPPr>
-              <a:defRPr sz="2025" b="0">
+              <a:defRPr sz="2100" b="0">
                 <a:solidFill>
                   <a:srgbClr val="666666"/>
                 </a:solidFill>
@@ -5279,7 +5083,7 @@
               </a:defRPr>
             </a:defPPr>
             <a:lvl1pPr>
-              <a:defRPr sz="2025" b="0">
+              <a:defRPr sz="2100" b="0">
                 <a:solidFill>
                   <a:srgbClr val="666666"/>
                 </a:solidFill>
@@ -5289,7 +5093,7 @@
               </a:defRPr>
             </a:lvl1pPr>
             <a:lvl2pPr>
-              <a:defRPr sz="2025" b="0">
+              <a:defRPr sz="2100" b="0">
                 <a:solidFill>
                   <a:srgbClr val="666666"/>
                 </a:solidFill>
@@ -5299,7 +5103,7 @@
               </a:defRPr>
             </a:lvl2pPr>
             <a:lvl3pPr>
-              <a:defRPr sz="2025" b="0">
+              <a:defRPr sz="2100" b="0">
                 <a:solidFill>
                   <a:srgbClr val="666666"/>
                 </a:solidFill>
@@ -5309,7 +5113,7 @@
               </a:defRPr>
             </a:lvl3pPr>
             <a:lvl4pPr>
-              <a:defRPr sz="2025" b="0">
+              <a:defRPr sz="2100" b="0">
                 <a:solidFill>
                   <a:srgbClr val="666666"/>
                 </a:solidFill>
@@ -5319,7 +5123,7 @@
               </a:defRPr>
             </a:lvl4pPr>
             <a:lvl5pPr>
-              <a:defRPr sz="2025" b="0">
+              <a:defRPr sz="2100" b="0">
                 <a:solidFill>
                   <a:srgbClr val="666666"/>
                 </a:solidFill>
@@ -5329,7 +5133,7 @@
               </a:defRPr>
             </a:lvl5pPr>
             <a:lvl6pPr>
-              <a:defRPr sz="2025" b="0">
+              <a:defRPr sz="2100" b="0">
                 <a:solidFill>
                   <a:srgbClr val="666666"/>
                 </a:solidFill>
@@ -5339,7 +5143,7 @@
               </a:defRPr>
             </a:lvl6pPr>
             <a:lvl7pPr>
-              <a:defRPr sz="2025" b="0">
+              <a:defRPr sz="2100" b="0">
                 <a:solidFill>
                   <a:srgbClr val="666666"/>
                 </a:solidFill>
@@ -5349,7 +5153,7 @@
               </a:defRPr>
             </a:lvl7pPr>
             <a:lvl8pPr>
-              <a:defRPr sz="2025" b="0">
+              <a:defRPr sz="2100" b="0">
                 <a:solidFill>
                   <a:srgbClr val="666666"/>
                 </a:solidFill>
@@ -5359,7 +5163,7 @@
               </a:defRPr>
             </a:lvl8pPr>
             <a:lvl9pPr>
-              <a:defRPr sz="2025" b="0">
+              <a:defRPr sz="2100" b="0">
                 <a:solidFill>
                   <a:srgbClr val="666666"/>
                 </a:solidFill>
@@ -5371,7 +5175,7 @@
           </a:lstStyle>
           <a:p xmlns:a="http://schemas.openxmlformats.org/drawingml/2006/main">
             <a:pPr>
-              <a:defRPr sz="2025" b="0">
+              <a:defRPr sz="2100" b="0">
                 <a:solidFill>
                   <a:srgbClr val="666666"/>
                 </a:solidFill>
@@ -5381,7 +5185,7 @@
               </a:defRPr>
             </a:pPr>
             <a:r>
-              <a:rPr sz="2025" b="0">
+              <a:rPr sz="2100" b="0">
                 <a:solidFill>
                   <a:srgbClr val="666666"/>
                 </a:solidFill>
@@ -5389,17 +5193,17 @@
                 <a:ea typeface="Inter"/>
                 <a:cs typeface="Inter"/>
               </a:rPr>
-              <a:t>Run scripts to inspect the group</a:t>
+              <a:t>Run analysis scripts</a:t>
             </a:r>
           </a:p>
         </p:txBody>
       </p:sp>
       <p:sp>
         <p:nvSpPr>
-          <p:cNvPr id="7" name="arrow-11">
+          <p:cNvPr id="6" name="arrow-10">
             <a:extLst xmlns:a="http://schemas.openxmlformats.org/drawingml/2006/main">
               <a:ext uri="{FF2B5EF4-FFF2-40B4-BE49-F238E27FC236}">
-                <a16:creationId xmlns:a16="http://schemas.microsoft.com/office/drawing/2014/main" id="{073C5262-488C-45C4-B790-11B7FD0A8914}"/>
+                <a16:creationId xmlns:a16="http://schemas.microsoft.com/office/drawing/2014/main" id="{332E2F28-8D2D-44D9-81EF-7F8B5A925026}"/>
               </a:ext>
             </a:extLst>
           </p:cNvPr>
@@ -5410,7 +5214,7 @@
         </p:nvSpPr>
         <p:spPr>
           <a:xfrm xmlns:a="http://schemas.openxmlformats.org/drawingml/2006/main">
-            <a:off x="5781675" y="3333750"/>
+            <a:off x="5781675" y="3228975"/>
             <a:ext cx="304800" cy="152400"/>
           </a:xfrm>
           <a:prstGeom xmlns:a="http://schemas.openxmlformats.org/drawingml/2006/main" prst="rightArrow">
@@ -5426,10 +5230,10 @@
       </p:sp>
       <p:sp>
         <p:nvSpPr>
-          <p:cNvPr id="8" name="copy-12">
+          <p:cNvPr id="7" name="copy-11">
             <a:extLst xmlns:a="http://schemas.openxmlformats.org/drawingml/2006/main">
               <a:ext uri="{FF2B5EF4-FFF2-40B4-BE49-F238E27FC236}">
-                <a16:creationId xmlns:a16="http://schemas.microsoft.com/office/drawing/2014/main" id="{53E0009D-2053-47E9-AE2A-CD243BE10C2D}"/>
+                <a16:creationId xmlns:a16="http://schemas.microsoft.com/office/drawing/2014/main" id="{AA9E3AEE-7E3E-40E8-A452-3E06D68F31BC}"/>
               </a:ext>
             </a:extLst>
           </p:cNvPr>
@@ -5440,8 +5244,8 @@
         </p:nvSpPr>
         <p:spPr>
           <a:xfrm xmlns:a="http://schemas.openxmlformats.org/drawingml/2006/main">
-            <a:off x="6667500" y="3228975"/>
-            <a:ext cx="4695825" cy="704850"/>
+            <a:off x="6667500" y="3124200"/>
+            <a:ext cx="4695825" cy="685800"/>
           </a:xfrm>
           <a:prstGeom xmlns:a="http://schemas.openxmlformats.org/drawingml/2006/main" prst="rect">
             <a:avLst/>
@@ -5457,7 +5261,7 @@
           </a:bodyPr>
           <a:lstStyle xmlns:a="http://schemas.openxmlformats.org/drawingml/2006/main">
             <a:defPPr>
-              <a:defRPr sz="2025" b="1">
+              <a:defRPr sz="2100" b="1">
                 <a:solidFill>
                   <a:srgbClr val="1B5E20"/>
                 </a:solidFill>
@@ -5467,7 +5271,7 @@
               </a:defRPr>
             </a:defPPr>
             <a:lvl1pPr>
-              <a:defRPr sz="2025" b="1">
+              <a:defRPr sz="2100" b="1">
                 <a:solidFill>
                   <a:srgbClr val="1B5E20"/>
                 </a:solidFill>
@@ -5477,7 +5281,7 @@
               </a:defRPr>
             </a:lvl1pPr>
             <a:lvl2pPr>
-              <a:defRPr sz="2025" b="1">
+              <a:defRPr sz="2100" b="1">
                 <a:solidFill>
                   <a:srgbClr val="1B5E20"/>
                 </a:solidFill>
@@ -5487,7 +5291,7 @@
               </a:defRPr>
             </a:lvl2pPr>
             <a:lvl3pPr>
-              <a:defRPr sz="2025" b="1">
+              <a:defRPr sz="2100" b="1">
                 <a:solidFill>
                   <a:srgbClr val="1B5E20"/>
                 </a:solidFill>
@@ -5497,7 +5301,7 @@
               </a:defRPr>
             </a:lvl3pPr>
             <a:lvl4pPr>
-              <a:defRPr sz="2025" b="1">
+              <a:defRPr sz="2100" b="1">
                 <a:solidFill>
                   <a:srgbClr val="1B5E20"/>
                 </a:solidFill>
@@ -5507,7 +5311,7 @@
               </a:defRPr>
             </a:lvl4pPr>
             <a:lvl5pPr>
-              <a:defRPr sz="2025" b="1">
+              <a:defRPr sz="2100" b="1">
                 <a:solidFill>
                   <a:srgbClr val="1B5E20"/>
                 </a:solidFill>
@@ -5517,7 +5321,7 @@
               </a:defRPr>
             </a:lvl5pPr>
             <a:lvl6pPr>
-              <a:defRPr sz="2025" b="1">
+              <a:defRPr sz="2100" b="1">
                 <a:solidFill>
                   <a:srgbClr val="1B5E20"/>
                 </a:solidFill>
@@ -5527,7 +5331,7 @@
               </a:defRPr>
             </a:lvl6pPr>
             <a:lvl7pPr>
-              <a:defRPr sz="2025" b="1">
+              <a:defRPr sz="2100" b="1">
                 <a:solidFill>
                   <a:srgbClr val="1B5E20"/>
                 </a:solidFill>
@@ -5537,7 +5341,7 @@
               </a:defRPr>
             </a:lvl7pPr>
             <a:lvl8pPr>
-              <a:defRPr sz="2025" b="1">
+              <a:defRPr sz="2100" b="1">
                 <a:solidFill>
                   <a:srgbClr val="1B5E20"/>
                 </a:solidFill>
@@ -5547,7 +5351,7 @@
               </a:defRPr>
             </a:lvl8pPr>
             <a:lvl9pPr>
-              <a:defRPr sz="2025" b="1">
+              <a:defRPr sz="2100" b="1">
                 <a:solidFill>
                   <a:srgbClr val="1B5E20"/>
                 </a:solidFill>
@@ -5559,7 +5363,7 @@
           </a:lstStyle>
           <a:p xmlns:a="http://schemas.openxmlformats.org/drawingml/2006/main">
             <a:pPr>
-              <a:defRPr sz="2025" b="1">
+              <a:defRPr sz="2100" b="1">
                 <a:solidFill>
                   <a:srgbClr val="1B5E20"/>
                 </a:solidFill>
@@ -5569,7 +5373,7 @@
               </a:defRPr>
             </a:pPr>
             <a:r>
-              <a:rPr sz="2025" b="1">
+              <a:rPr sz="2100" b="1">
                 <a:solidFill>
                   <a:srgbClr val="1B5E20"/>
                 </a:solidFill>
@@ -5577,17 +5381,17 @@
                 <a:ea typeface="Inter"/>
                 <a:cs typeface="Inter"/>
               </a:rPr>
-              <a:t>Ask the agent to investigate it</a:t>
+              <a:t>Ask the agent to run the analysis</a:t>
             </a:r>
           </a:p>
         </p:txBody>
       </p:sp>
       <p:sp>
         <p:nvSpPr>
-          <p:cNvPr id="9" name="copy-13">
+          <p:cNvPr id="8" name="copy-12">
             <a:extLst xmlns:a="http://schemas.openxmlformats.org/drawingml/2006/main">
               <a:ext uri="{FF2B5EF4-FFF2-40B4-BE49-F238E27FC236}">
-                <a16:creationId xmlns:a16="http://schemas.microsoft.com/office/drawing/2014/main" id="{158B34CD-419D-4D91-90A1-C35C862CDA96}"/>
+                <a16:creationId xmlns:a16="http://schemas.microsoft.com/office/drawing/2014/main" id="{024FD050-9023-4C98-BC9D-AE8AF93014D3}"/>
               </a:ext>
             </a:extLst>
           </p:cNvPr>
@@ -5598,8 +5402,8 @@
         </p:nvSpPr>
         <p:spPr>
           <a:xfrm xmlns:a="http://schemas.openxmlformats.org/drawingml/2006/main">
-            <a:off x="552450" y="4105275"/>
-            <a:ext cx="4953000" cy="704850"/>
+            <a:off x="552450" y="4152900"/>
+            <a:ext cx="4953000" cy="628650"/>
           </a:xfrm>
           <a:prstGeom xmlns:a="http://schemas.openxmlformats.org/drawingml/2006/main" prst="rect">
             <a:avLst/>
@@ -5615,7 +5419,7 @@
           </a:bodyPr>
           <a:lstStyle xmlns:a="http://schemas.openxmlformats.org/drawingml/2006/main">
             <a:defPPr>
-              <a:defRPr sz="2025" b="0">
+              <a:defRPr sz="2100" b="0">
                 <a:solidFill>
                   <a:srgbClr val="666666"/>
                 </a:solidFill>
@@ -5625,7 +5429,7 @@
               </a:defRPr>
             </a:defPPr>
             <a:lvl1pPr>
-              <a:defRPr sz="2025" b="0">
+              <a:defRPr sz="2100" b="0">
                 <a:solidFill>
                   <a:srgbClr val="666666"/>
                 </a:solidFill>
@@ -5635,7 +5439,7 @@
               </a:defRPr>
             </a:lvl1pPr>
             <a:lvl2pPr>
-              <a:defRPr sz="2025" b="0">
+              <a:defRPr sz="2100" b="0">
                 <a:solidFill>
                   <a:srgbClr val="666666"/>
                 </a:solidFill>
@@ -5645,7 +5449,7 @@
               </a:defRPr>
             </a:lvl2pPr>
             <a:lvl3pPr>
-              <a:defRPr sz="2025" b="0">
+              <a:defRPr sz="2100" b="0">
                 <a:solidFill>
                   <a:srgbClr val="666666"/>
                 </a:solidFill>
@@ -5655,7 +5459,7 @@
               </a:defRPr>
             </a:lvl3pPr>
             <a:lvl4pPr>
-              <a:defRPr sz="2025" b="0">
+              <a:defRPr sz="2100" b="0">
                 <a:solidFill>
                   <a:srgbClr val="666666"/>
                 </a:solidFill>
@@ -5665,7 +5469,7 @@
               </a:defRPr>
             </a:lvl4pPr>
             <a:lvl5pPr>
-              <a:defRPr sz="2025" b="0">
+              <a:defRPr sz="2100" b="0">
                 <a:solidFill>
                   <a:srgbClr val="666666"/>
                 </a:solidFill>
@@ -5675,7 +5479,7 @@
               </a:defRPr>
             </a:lvl5pPr>
             <a:lvl6pPr>
-              <a:defRPr sz="2025" b="0">
+              <a:defRPr sz="2100" b="0">
                 <a:solidFill>
                   <a:srgbClr val="666666"/>
                 </a:solidFill>
@@ -5685,7 +5489,7 @@
               </a:defRPr>
             </a:lvl6pPr>
             <a:lvl7pPr>
-              <a:defRPr sz="2025" b="0">
+              <a:defRPr sz="2100" b="0">
                 <a:solidFill>
                   <a:srgbClr val="666666"/>
                 </a:solidFill>
@@ -5695,7 +5499,7 @@
               </a:defRPr>
             </a:lvl7pPr>
             <a:lvl8pPr>
-              <a:defRPr sz="2025" b="0">
+              <a:defRPr sz="2100" b="0">
                 <a:solidFill>
                   <a:srgbClr val="666666"/>
                 </a:solidFill>
@@ -5705,7 +5509,7 @@
               </a:defRPr>
             </a:lvl8pPr>
             <a:lvl9pPr>
-              <a:defRPr sz="2025" b="0">
+              <a:defRPr sz="2100" b="0">
                 <a:solidFill>
                   <a:srgbClr val="666666"/>
                 </a:solidFill>
@@ -5717,7 +5521,7 @@
           </a:lstStyle>
           <a:p xmlns:a="http://schemas.openxmlformats.org/drawingml/2006/main">
             <a:pPr>
-              <a:defRPr sz="2025" b="0">
+              <a:defRPr sz="2100" b="0">
                 <a:solidFill>
                   <a:srgbClr val="666666"/>
                 </a:solidFill>
@@ -5727,7 +5531,7 @@
               </a:defRPr>
             </a:pPr>
             <a:r>
-              <a:rPr sz="2025" b="0">
+              <a:rPr sz="2100" b="0">
                 <a:solidFill>
                   <a:srgbClr val="666666"/>
                 </a:solidFill>
@@ -5735,17 +5539,17 @@
                 <a:ea typeface="Inter"/>
                 <a:cs typeface="Inter"/>
               </a:rPr>
-              <a:t>Find and compare marker references</a:t>
+              <a:t>Look up marker references</a:t>
             </a:r>
           </a:p>
         </p:txBody>
       </p:sp>
       <p:sp>
         <p:nvSpPr>
-          <p:cNvPr id="10" name="arrow-14">
+          <p:cNvPr id="9" name="arrow-13">
             <a:extLst xmlns:a="http://schemas.openxmlformats.org/drawingml/2006/main">
               <a:ext uri="{FF2B5EF4-FFF2-40B4-BE49-F238E27FC236}">
-                <a16:creationId xmlns:a16="http://schemas.microsoft.com/office/drawing/2014/main" id="{1DF1541E-C258-4012-9CAE-5A71ED75BE80}"/>
+                <a16:creationId xmlns:a16="http://schemas.microsoft.com/office/drawing/2014/main" id="{72562C67-A842-441F-8385-D049189E4FFE}"/>
               </a:ext>
             </a:extLst>
           </p:cNvPr>
@@ -5756,7 +5560,7 @@
         </p:nvSpPr>
         <p:spPr>
           <a:xfrm xmlns:a="http://schemas.openxmlformats.org/drawingml/2006/main">
-            <a:off x="5781675" y="4210050"/>
+            <a:off x="5781675" y="4257675"/>
             <a:ext cx="304800" cy="152400"/>
           </a:xfrm>
           <a:prstGeom xmlns:a="http://schemas.openxmlformats.org/drawingml/2006/main" prst="rightArrow">
@@ -5772,10 +5576,10 @@
       </p:sp>
       <p:sp>
         <p:nvSpPr>
-          <p:cNvPr id="11" name="copy-15">
+          <p:cNvPr id="10" name="copy-14">
             <a:extLst xmlns:a="http://schemas.openxmlformats.org/drawingml/2006/main">
               <a:ext uri="{FF2B5EF4-FFF2-40B4-BE49-F238E27FC236}">
-                <a16:creationId xmlns:a16="http://schemas.microsoft.com/office/drawing/2014/main" id="{6D6E1312-0B63-4425-869C-6A3663899DC5}"/>
+                <a16:creationId xmlns:a16="http://schemas.microsoft.com/office/drawing/2014/main" id="{8DCBF99D-013F-4F36-B0D8-C966E62DE0F8}"/>
               </a:ext>
             </a:extLst>
           </p:cNvPr>
@@ -5786,8 +5590,8 @@
         </p:nvSpPr>
         <p:spPr>
           <a:xfrm xmlns:a="http://schemas.openxmlformats.org/drawingml/2006/main">
-            <a:off x="6667500" y="4105275"/>
-            <a:ext cx="4695825" cy="704850"/>
+            <a:off x="6667500" y="4152900"/>
+            <a:ext cx="4695825" cy="685800"/>
           </a:xfrm>
           <a:prstGeom xmlns:a="http://schemas.openxmlformats.org/drawingml/2006/main" prst="rect">
             <a:avLst/>
@@ -5803,7 +5607,7 @@
           </a:bodyPr>
           <a:lstStyle xmlns:a="http://schemas.openxmlformats.org/drawingml/2006/main">
             <a:defPPr>
-              <a:defRPr sz="2025" b="1">
+              <a:defRPr sz="2100" b="1">
                 <a:solidFill>
                   <a:srgbClr val="1B5E20"/>
                 </a:solidFill>
@@ -5813,7 +5617,7 @@
               </a:defRPr>
             </a:defPPr>
             <a:lvl1pPr>
-              <a:defRPr sz="2025" b="1">
+              <a:defRPr sz="2100" b="1">
                 <a:solidFill>
                   <a:srgbClr val="1B5E20"/>
                 </a:solidFill>
@@ -5823,7 +5627,7 @@
               </a:defRPr>
             </a:lvl1pPr>
             <a:lvl2pPr>
-              <a:defRPr sz="2025" b="1">
+              <a:defRPr sz="2100" b="1">
                 <a:solidFill>
                   <a:srgbClr val="1B5E20"/>
                 </a:solidFill>
@@ -5833,7 +5637,7 @@
               </a:defRPr>
             </a:lvl2pPr>
             <a:lvl3pPr>
-              <a:defRPr sz="2025" b="1">
+              <a:defRPr sz="2100" b="1">
                 <a:solidFill>
                   <a:srgbClr val="1B5E20"/>
                 </a:solidFill>
@@ -5843,7 +5647,7 @@
               </a:defRPr>
             </a:lvl3pPr>
             <a:lvl4pPr>
-              <a:defRPr sz="2025" b="1">
+              <a:defRPr sz="2100" b="1">
                 <a:solidFill>
                   <a:srgbClr val="1B5E20"/>
                 </a:solidFill>
@@ -5853,7 +5657,7 @@
               </a:defRPr>
             </a:lvl4pPr>
             <a:lvl5pPr>
-              <a:defRPr sz="2025" b="1">
+              <a:defRPr sz="2100" b="1">
                 <a:solidFill>
                   <a:srgbClr val="1B5E20"/>
                 </a:solidFill>
@@ -5863,7 +5667,7 @@
               </a:defRPr>
             </a:lvl5pPr>
             <a:lvl6pPr>
-              <a:defRPr sz="2025" b="1">
+              <a:defRPr sz="2100" b="1">
                 <a:solidFill>
                   <a:srgbClr val="1B5E20"/>
                 </a:solidFill>
@@ -5873,7 +5677,7 @@
               </a:defRPr>
             </a:lvl6pPr>
             <a:lvl7pPr>
-              <a:defRPr sz="2025" b="1">
+              <a:defRPr sz="2100" b="1">
                 <a:solidFill>
                   <a:srgbClr val="1B5E20"/>
                 </a:solidFill>
@@ -5883,7 +5687,7 @@
               </a:defRPr>
             </a:lvl7pPr>
             <a:lvl8pPr>
-              <a:defRPr sz="2025" b="1">
+              <a:defRPr sz="2100" b="1">
                 <a:solidFill>
                   <a:srgbClr val="1B5E20"/>
                 </a:solidFill>
@@ -5893,7 +5697,7 @@
               </a:defRPr>
             </a:lvl8pPr>
             <a:lvl9pPr>
-              <a:defRPr sz="2025" b="1">
+              <a:defRPr sz="2100" b="1">
                 <a:solidFill>
                   <a:srgbClr val="1B5E20"/>
                 </a:solidFill>
@@ -5905,7 +5709,7 @@
           </a:lstStyle>
           <a:p xmlns:a="http://schemas.openxmlformats.org/drawingml/2006/main">
             <a:pPr>
-              <a:defRPr sz="2025" b="1">
+              <a:defRPr sz="2100" b="1">
                 <a:solidFill>
                   <a:srgbClr val="1B5E20"/>
                 </a:solidFill>
@@ -5915,7 +5719,7 @@
               </a:defRPr>
             </a:pPr>
             <a:r>
-              <a:rPr sz="2025" b="1">
+              <a:rPr sz="2100" b="1">
                 <a:solidFill>
                   <a:srgbClr val="1B5E20"/>
                 </a:solidFill>
@@ -5923,17 +5727,17 @@
                 <a:ea typeface="Inter"/>
                 <a:cs typeface="Inter"/>
               </a:rPr>
-              <a:t>Review measured genes and sources</a:t>
+              <a:t>Review genes and source links</a:t>
             </a:r>
           </a:p>
         </p:txBody>
       </p:sp>
       <p:sp>
         <p:nvSpPr>
-          <p:cNvPr id="12" name="copy-16">
+          <p:cNvPr id="11" name="copy-15">
             <a:extLst xmlns:a="http://schemas.openxmlformats.org/drawingml/2006/main">
               <a:ext uri="{FF2B5EF4-FFF2-40B4-BE49-F238E27FC236}">
-                <a16:creationId xmlns:a16="http://schemas.microsoft.com/office/drawing/2014/main" id="{2CBB3269-618F-48D1-B416-9915F337219B}"/>
+                <a16:creationId xmlns:a16="http://schemas.microsoft.com/office/drawing/2014/main" id="{A6D79F35-18E0-4A61-B354-8D4902DAD702}"/>
               </a:ext>
             </a:extLst>
           </p:cNvPr>
@@ -5944,8 +5748,8 @@
         </p:nvSpPr>
         <p:spPr>
           <a:xfrm xmlns:a="http://schemas.openxmlformats.org/drawingml/2006/main">
-            <a:off x="552450" y="4981575"/>
-            <a:ext cx="4953000" cy="704850"/>
+            <a:off x="552450" y="5181600"/>
+            <a:ext cx="4953000" cy="628650"/>
           </a:xfrm>
           <a:prstGeom xmlns:a="http://schemas.openxmlformats.org/drawingml/2006/main" prst="rect">
             <a:avLst/>
@@ -5961,7 +5765,7 @@
           </a:bodyPr>
           <a:lstStyle xmlns:a="http://schemas.openxmlformats.org/drawingml/2006/main">
             <a:defPPr>
-              <a:defRPr sz="2025" b="0">
+              <a:defRPr sz="2100" b="0">
                 <a:solidFill>
                   <a:srgbClr val="666666"/>
                 </a:solidFill>
@@ -5971,7 +5775,7 @@
               </a:defRPr>
             </a:defPPr>
             <a:lvl1pPr>
-              <a:defRPr sz="2025" b="0">
+              <a:defRPr sz="2100" b="0">
                 <a:solidFill>
                   <a:srgbClr val="666666"/>
                 </a:solidFill>
@@ -5981,7 +5785,7 @@
               </a:defRPr>
             </a:lvl1pPr>
             <a:lvl2pPr>
-              <a:defRPr sz="2025" b="0">
+              <a:defRPr sz="2100" b="0">
                 <a:solidFill>
                   <a:srgbClr val="666666"/>
                 </a:solidFill>
@@ -5991,7 +5795,7 @@
               </a:defRPr>
             </a:lvl2pPr>
             <a:lvl3pPr>
-              <a:defRPr sz="2025" b="0">
+              <a:defRPr sz="2100" b="0">
                 <a:solidFill>
                   <a:srgbClr val="666666"/>
                 </a:solidFill>
@@ -6001,7 +5805,7 @@
               </a:defRPr>
             </a:lvl3pPr>
             <a:lvl4pPr>
-              <a:defRPr sz="2025" b="0">
+              <a:defRPr sz="2100" b="0">
                 <a:solidFill>
                   <a:srgbClr val="666666"/>
                 </a:solidFill>
@@ -6011,7 +5815,7 @@
               </a:defRPr>
             </a:lvl4pPr>
             <a:lvl5pPr>
-              <a:defRPr sz="2025" b="0">
+              <a:defRPr sz="2100" b="0">
                 <a:solidFill>
                   <a:srgbClr val="666666"/>
                 </a:solidFill>
@@ -6021,7 +5825,7 @@
               </a:defRPr>
             </a:lvl5pPr>
             <a:lvl6pPr>
-              <a:defRPr sz="2025" b="0">
+              <a:defRPr sz="2100" b="0">
                 <a:solidFill>
                   <a:srgbClr val="666666"/>
                 </a:solidFill>
@@ -6031,7 +5835,7 @@
               </a:defRPr>
             </a:lvl6pPr>
             <a:lvl7pPr>
-              <a:defRPr sz="2025" b="0">
+              <a:defRPr sz="2100" b="0">
                 <a:solidFill>
                   <a:srgbClr val="666666"/>
                 </a:solidFill>
@@ -6041,7 +5845,7 @@
               </a:defRPr>
             </a:lvl7pPr>
             <a:lvl8pPr>
-              <a:defRPr sz="2025" b="0">
+              <a:defRPr sz="2100" b="0">
                 <a:solidFill>
                   <a:srgbClr val="666666"/>
                 </a:solidFill>
@@ -6051,7 +5855,7 @@
               </a:defRPr>
             </a:lvl8pPr>
             <a:lvl9pPr>
-              <a:defRPr sz="2025" b="0">
+              <a:defRPr sz="2100" b="0">
                 <a:solidFill>
                   <a:srgbClr val="666666"/>
                 </a:solidFill>
@@ -6063,7 +5867,7 @@
           </a:lstStyle>
           <a:p xmlns:a="http://schemas.openxmlformats.org/drawingml/2006/main">
             <a:pPr>
-              <a:defRPr sz="2025" b="0">
+              <a:defRPr sz="2100" b="0">
                 <a:solidFill>
                   <a:srgbClr val="666666"/>
                 </a:solidFill>
@@ -6073,7 +5877,7 @@
               </a:defRPr>
             </a:pPr>
             <a:r>
-              <a:rPr sz="2025" b="0">
+              <a:rPr sz="2100" b="0">
                 <a:solidFill>
                   <a:srgbClr val="666666"/>
                 </a:solidFill>
@@ -6081,17 +5885,17 @@
                 <a:ea typeface="Inter"/>
                 <a:cs typeface="Inter"/>
               </a:rPr>
-              <a:t>Keep decisions in separate notes</a:t>
+              <a:t>Reconstruct past decisions</a:t>
             </a:r>
           </a:p>
         </p:txBody>
       </p:sp>
       <p:sp>
         <p:nvSpPr>
-          <p:cNvPr id="13" name="arrow-17">
+          <p:cNvPr id="12" name="arrow-16">
             <a:extLst xmlns:a="http://schemas.openxmlformats.org/drawingml/2006/main">
               <a:ext uri="{FF2B5EF4-FFF2-40B4-BE49-F238E27FC236}">
-                <a16:creationId xmlns:a16="http://schemas.microsoft.com/office/drawing/2014/main" id="{FA5ACD28-7E5F-4A81-837E-BF4A9851B139}"/>
+                <a16:creationId xmlns:a16="http://schemas.microsoft.com/office/drawing/2014/main" id="{8668A13A-777A-48DB-809C-4DA85F2E4C54}"/>
               </a:ext>
             </a:extLst>
           </p:cNvPr>
@@ -6102,7 +5906,7 @@
         </p:nvSpPr>
         <p:spPr>
           <a:xfrm xmlns:a="http://schemas.openxmlformats.org/drawingml/2006/main">
-            <a:off x="5781675" y="5086350"/>
+            <a:off x="5781675" y="5286375"/>
             <a:ext cx="304800" cy="152400"/>
           </a:xfrm>
           <a:prstGeom xmlns:a="http://schemas.openxmlformats.org/drawingml/2006/main" prst="rightArrow">
@@ -6118,10 +5922,10 @@
       </p:sp>
       <p:sp>
         <p:nvSpPr>
-          <p:cNvPr id="14" name="copy-18">
+          <p:cNvPr id="13" name="copy-17">
             <a:extLst xmlns:a="http://schemas.openxmlformats.org/drawingml/2006/main">
               <a:ext uri="{FF2B5EF4-FFF2-40B4-BE49-F238E27FC236}">
-                <a16:creationId xmlns:a16="http://schemas.microsoft.com/office/drawing/2014/main" id="{333A4147-236C-47EA-9921-142F78CEC4FF}"/>
+                <a16:creationId xmlns:a16="http://schemas.microsoft.com/office/drawing/2014/main" id="{D91EEAAC-18D6-4762-B6CE-D5CF361FEA53}"/>
               </a:ext>
             </a:extLst>
           </p:cNvPr>
@@ -6132,8 +5936,8 @@
         </p:nvSpPr>
         <p:spPr>
           <a:xfrm xmlns:a="http://schemas.openxmlformats.org/drawingml/2006/main">
-            <a:off x="6667500" y="4981575"/>
-            <a:ext cx="4695825" cy="704850"/>
+            <a:off x="6667500" y="5181600"/>
+            <a:ext cx="4695825" cy="685800"/>
           </a:xfrm>
           <a:prstGeom xmlns:a="http://schemas.openxmlformats.org/drawingml/2006/main" prst="rect">
             <a:avLst/>
@@ -6149,7 +5953,7 @@
           </a:bodyPr>
           <a:lstStyle xmlns:a="http://schemas.openxmlformats.org/drawingml/2006/main">
             <a:defPPr>
-              <a:defRPr sz="2025" b="1">
+              <a:defRPr sz="2100" b="1">
                 <a:solidFill>
                   <a:srgbClr val="1B5E20"/>
                 </a:solidFill>
@@ -6159,7 +5963,7 @@
               </a:defRPr>
             </a:defPPr>
             <a:lvl1pPr>
-              <a:defRPr sz="2025" b="1">
+              <a:defRPr sz="2100" b="1">
                 <a:solidFill>
                   <a:srgbClr val="1B5E20"/>
                 </a:solidFill>
@@ -6169,7 +5973,7 @@
               </a:defRPr>
             </a:lvl1pPr>
             <a:lvl2pPr>
-              <a:defRPr sz="2025" b="1">
+              <a:defRPr sz="2100" b="1">
                 <a:solidFill>
                   <a:srgbClr val="1B5E20"/>
                 </a:solidFill>
@@ -6179,7 +5983,7 @@
               </a:defRPr>
             </a:lvl2pPr>
             <a:lvl3pPr>
-              <a:defRPr sz="2025" b="1">
+              <a:defRPr sz="2100" b="1">
                 <a:solidFill>
                   <a:srgbClr val="1B5E20"/>
                 </a:solidFill>
@@ -6189,7 +5993,7 @@
               </a:defRPr>
             </a:lvl3pPr>
             <a:lvl4pPr>
-              <a:defRPr sz="2025" b="1">
+              <a:defRPr sz="2100" b="1">
                 <a:solidFill>
                   <a:srgbClr val="1B5E20"/>
                 </a:solidFill>
@@ -6199,7 +6003,7 @@
               </a:defRPr>
             </a:lvl4pPr>
             <a:lvl5pPr>
-              <a:defRPr sz="2025" b="1">
+              <a:defRPr sz="2100" b="1">
                 <a:solidFill>
                   <a:srgbClr val="1B5E20"/>
                 </a:solidFill>
@@ -6209,7 +6013,7 @@
               </a:defRPr>
             </a:lvl5pPr>
             <a:lvl6pPr>
-              <a:defRPr sz="2025" b="1">
+              <a:defRPr sz="2100" b="1">
                 <a:solidFill>
                   <a:srgbClr val="1B5E20"/>
                 </a:solidFill>
@@ -6219,7 +6023,7 @@
               </a:defRPr>
             </a:lvl6pPr>
             <a:lvl7pPr>
-              <a:defRPr sz="2025" b="1">
+              <a:defRPr sz="2100" b="1">
                 <a:solidFill>
                   <a:srgbClr val="1B5E20"/>
                 </a:solidFill>
@@ -6229,7 +6033,7 @@
               </a:defRPr>
             </a:lvl7pPr>
             <a:lvl8pPr>
-              <a:defRPr sz="2025" b="1">
+              <a:defRPr sz="2100" b="1">
                 <a:solidFill>
                   <a:srgbClr val="1B5E20"/>
                 </a:solidFill>
@@ -6239,7 +6043,7 @@
               </a:defRPr>
             </a:lvl8pPr>
             <a:lvl9pPr>
-              <a:defRPr sz="2025" b="1">
+              <a:defRPr sz="2100" b="1">
                 <a:solidFill>
                   <a:srgbClr val="1B5E20"/>
                 </a:solidFill>
@@ -6251,7 +6055,7 @@
           </a:lstStyle>
           <a:p xmlns:a="http://schemas.openxmlformats.org/drawingml/2006/main">
             <a:pPr>
-              <a:defRPr sz="2025" b="1">
+              <a:defRPr sz="2100" b="1">
                 <a:solidFill>
                   <a:srgbClr val="1B5E20"/>
                 </a:solidFill>
@@ -6261,7 +6065,7 @@
               </a:defRPr>
             </a:pPr>
             <a:r>
-              <a:rPr sz="2025" b="1">
+              <a:rPr sz="2100" b="1">
                 <a:solidFill>
                   <a:srgbClr val="1B5E20"/>
                 </a:solidFill>
@@ -6269,17 +6073,17 @@
                 <a:ea typeface="Inter"/>
                 <a:cs typeface="Inter"/>
               </a:rPr>
-              <a:t>Save and revisit the decision in chat</a:t>
+              <a:t>Ask what you decided and why</a:t>
             </a:r>
           </a:p>
         </p:txBody>
       </p:sp>
       <p:sp>
         <p:nvSpPr>
-          <p:cNvPr id="15" name="copy-19">
+          <p:cNvPr id="14" name="copy-18">
             <a:extLst xmlns:a="http://schemas.openxmlformats.org/drawingml/2006/main">
               <a:ext uri="{FF2B5EF4-FFF2-40B4-BE49-F238E27FC236}">
-                <a16:creationId xmlns:a16="http://schemas.microsoft.com/office/drawing/2014/main" id="{D8BBD288-DFA6-4C43-A745-C15BC8D14278}"/>
+                <a16:creationId xmlns:a16="http://schemas.microsoft.com/office/drawing/2014/main" id="{71C0EE02-649F-4D01-916D-45798F4FD40D}"/>
               </a:ext>
             </a:extLst>
           </p:cNvPr>
@@ -6307,7 +6111,7 @@
           </a:bodyPr>
           <a:lstStyle xmlns:a="http://schemas.openxmlformats.org/drawingml/2006/main">
             <a:defPPr>
-              <a:defRPr sz="2100" b="0">
+              <a:defRPr sz="1950" b="0">
                 <a:solidFill>
                   <a:srgbClr val="111111"/>
                 </a:solidFill>
@@ -6317,7 +6121,7 @@
               </a:defRPr>
             </a:defPPr>
             <a:lvl1pPr>
-              <a:defRPr sz="2100" b="0">
+              <a:defRPr sz="1950" b="0">
                 <a:solidFill>
                   <a:srgbClr val="111111"/>
                 </a:solidFill>
@@ -6327,7 +6131,7 @@
               </a:defRPr>
             </a:lvl1pPr>
             <a:lvl2pPr>
-              <a:defRPr sz="2100" b="0">
+              <a:defRPr sz="1950" b="0">
                 <a:solidFill>
                   <a:srgbClr val="111111"/>
                 </a:solidFill>
@@ -6337,7 +6141,7 @@
               </a:defRPr>
             </a:lvl2pPr>
             <a:lvl3pPr>
-              <a:defRPr sz="2100" b="0">
+              <a:defRPr sz="1950" b="0">
                 <a:solidFill>
                   <a:srgbClr val="111111"/>
                 </a:solidFill>
@@ -6347,7 +6151,7 @@
               </a:defRPr>
             </a:lvl3pPr>
             <a:lvl4pPr>
-              <a:defRPr sz="2100" b="0">
+              <a:defRPr sz="1950" b="0">
                 <a:solidFill>
                   <a:srgbClr val="111111"/>
                 </a:solidFill>
@@ -6357,7 +6161,7 @@
               </a:defRPr>
             </a:lvl4pPr>
             <a:lvl5pPr>
-              <a:defRPr sz="2100" b="0">
+              <a:defRPr sz="1950" b="0">
                 <a:solidFill>
                   <a:srgbClr val="111111"/>
                 </a:solidFill>
@@ -6367,7 +6171,7 @@
               </a:defRPr>
             </a:lvl5pPr>
             <a:lvl6pPr>
-              <a:defRPr sz="2100" b="0">
+              <a:defRPr sz="1950" b="0">
                 <a:solidFill>
                   <a:srgbClr val="111111"/>
                 </a:solidFill>
@@ -6377,7 +6181,7 @@
               </a:defRPr>
             </a:lvl6pPr>
             <a:lvl7pPr>
-              <a:defRPr sz="2100" b="0">
+              <a:defRPr sz="1950" b="0">
                 <a:solidFill>
                   <a:srgbClr val="111111"/>
                 </a:solidFill>
@@ -6387,7 +6191,7 @@
               </a:defRPr>
             </a:lvl7pPr>
             <a:lvl8pPr>
-              <a:defRPr sz="2100" b="0">
+              <a:defRPr sz="1950" b="0">
                 <a:solidFill>
                   <a:srgbClr val="111111"/>
                 </a:solidFill>
@@ -6397,7 +6201,7 @@
               </a:defRPr>
             </a:lvl8pPr>
             <a:lvl9pPr>
-              <a:defRPr sz="2100" b="0">
+              <a:defRPr sz="1950" b="0">
                 <a:solidFill>
                   <a:srgbClr val="111111"/>
                 </a:solidFill>
@@ -6409,7 +6213,7 @@
           </a:lstStyle>
           <a:p xmlns:a="http://schemas.openxmlformats.org/drawingml/2006/main">
             <a:pPr>
-              <a:defRPr sz="2100" b="0">
+              <a:defRPr sz="1950" b="0">
                 <a:solidFill>
                   <a:srgbClr val="111111"/>
                 </a:solidFill>
@@ -6419,7 +6223,7 @@
               </a:defRPr>
             </a:pPr>
             <a:r>
-              <a:rPr sz="2100" b="0">
+              <a:rPr sz="1950" b="0">
                 <a:solidFill>
                   <a:srgbClr val="111111"/>
                 </a:solidFill>
@@ -6427,7 +6231,7 @@
                 <a:ea typeface="Inter"/>
                 <a:cs typeface="Inter"/>
               </a:rPr>
-              <a:t>The researcher decides whether the evidence is enough.</a:t>
+              <a:t>You keep the scientific judgment. The agent coordinates the work.</a:t>
             </a:r>
           </a:p>
         </p:txBody>
@@ -6435,7 +6239,7 @@
     </p:spTree>
     <p:extLst>
       <p:ext uri="{BB962C8B-B14F-4D97-AF65-F5344CB8AC3E}">
-        <p14:creationId xmlns:p14="http://schemas.microsoft.com/office/powerpoint/2010/main" val="2138293464"/>
+        <p14:creationId xmlns:p14="http://schemas.microsoft.com/office/powerpoint/2010/main" val="1469401544"/>
       </p:ext>
     </p:extLst>
   </p:cSld>
@@ -6463,10 +6267,10 @@
       </p:grpSpPr>
       <p:sp>
         <p:nvSpPr>
-          <p:cNvPr id="18" name="copy-20">
+          <p:cNvPr id="17" name="copy-19">
             <a:extLst xmlns:a="http://schemas.openxmlformats.org/drawingml/2006/main">
               <a:ext uri="{FF2B5EF4-FFF2-40B4-BE49-F238E27FC236}">
-                <a16:creationId xmlns:a16="http://schemas.microsoft.com/office/drawing/2014/main" id="{BFBEAA76-542D-4A9C-AF47-5E855FE9F609}"/>
+                <a16:creationId xmlns:a16="http://schemas.microsoft.com/office/drawing/2014/main" id="{B374BC4E-BA18-4630-8329-4AE94CB95A3B}"/>
               </a:ext>
             </a:extLst>
           </p:cNvPr>
@@ -6494,7 +6298,7 @@
           </a:bodyPr>
           <a:lstStyle xmlns:a="http://schemas.openxmlformats.org/drawingml/2006/main">
             <a:defPPr>
-              <a:defRPr sz="3825" b="1">
+              <a:defRPr sz="4275" b="1">
                 <a:solidFill>
                   <a:srgbClr val="111111"/>
                 </a:solidFill>
@@ -6504,7 +6308,7 @@
               </a:defRPr>
             </a:defPPr>
             <a:lvl1pPr>
-              <a:defRPr sz="3825" b="1">
+              <a:defRPr sz="4275" b="1">
                 <a:solidFill>
                   <a:srgbClr val="111111"/>
                 </a:solidFill>
@@ -6514,7 +6318,7 @@
               </a:defRPr>
             </a:lvl1pPr>
             <a:lvl2pPr>
-              <a:defRPr sz="3825" b="1">
+              <a:defRPr sz="4275" b="1">
                 <a:solidFill>
                   <a:srgbClr val="111111"/>
                 </a:solidFill>
@@ -6524,7 +6328,7 @@
               </a:defRPr>
             </a:lvl2pPr>
             <a:lvl3pPr>
-              <a:defRPr sz="3825" b="1">
+              <a:defRPr sz="4275" b="1">
                 <a:solidFill>
                   <a:srgbClr val="111111"/>
                 </a:solidFill>
@@ -6534,7 +6338,7 @@
               </a:defRPr>
             </a:lvl3pPr>
             <a:lvl4pPr>
-              <a:defRPr sz="3825" b="1">
+              <a:defRPr sz="4275" b="1">
                 <a:solidFill>
                   <a:srgbClr val="111111"/>
                 </a:solidFill>
@@ -6544,7 +6348,7 @@
               </a:defRPr>
             </a:lvl4pPr>
             <a:lvl5pPr>
-              <a:defRPr sz="3825" b="1">
+              <a:defRPr sz="4275" b="1">
                 <a:solidFill>
                   <a:srgbClr val="111111"/>
                 </a:solidFill>
@@ -6554,7 +6358,7 @@
               </a:defRPr>
             </a:lvl5pPr>
             <a:lvl6pPr>
-              <a:defRPr sz="3825" b="1">
+              <a:defRPr sz="4275" b="1">
                 <a:solidFill>
                   <a:srgbClr val="111111"/>
                 </a:solidFill>
@@ -6564,7 +6368,7 @@
               </a:defRPr>
             </a:lvl6pPr>
             <a:lvl7pPr>
-              <a:defRPr sz="3825" b="1">
+              <a:defRPr sz="4275" b="1">
                 <a:solidFill>
                   <a:srgbClr val="111111"/>
                 </a:solidFill>
@@ -6574,7 +6378,7 @@
               </a:defRPr>
             </a:lvl7pPr>
             <a:lvl8pPr>
-              <a:defRPr sz="3825" b="1">
+              <a:defRPr sz="4275" b="1">
                 <a:solidFill>
                   <a:srgbClr val="111111"/>
                 </a:solidFill>
@@ -6584,7 +6388,7 @@
               </a:defRPr>
             </a:lvl8pPr>
             <a:lvl9pPr>
-              <a:defRPr sz="3825" b="1">
+              <a:defRPr sz="4275" b="1">
                 <a:solidFill>
                   <a:srgbClr val="111111"/>
                 </a:solidFill>
@@ -6596,7 +6400,7 @@
           </a:lstStyle>
           <a:p xmlns:a="http://schemas.openxmlformats.org/drawingml/2006/main">
             <a:pPr>
-              <a:defRPr sz="3825" b="1">
+              <a:defRPr sz="4275" b="1">
                 <a:solidFill>
                   <a:srgbClr val="111111"/>
                 </a:solidFill>
@@ -6606,7 +6410,7 @@
               </a:defRPr>
             </a:pPr>
             <a:r>
-              <a:rPr sz="3825" b="1">
+              <a:rPr sz="4275" b="1">
                 <a:solidFill>
                   <a:srgbClr val="111111"/>
                 </a:solidFill>
@@ -6614,17 +6418,17 @@
                 <a:ea typeface="Inter"/>
                 <a:cs typeface="Inter"/>
               </a:rPr>
-              <a:t>The agent investigates one cell group</a:t>
+              <a:t>What the agent actually does</a:t>
             </a:r>
           </a:p>
         </p:txBody>
       </p:sp>
       <p:sp>
         <p:nvSpPr>
-          <p:cNvPr id="2" name="copy-21">
+          <p:cNvPr id="2" name="copy-20">
             <a:extLst xmlns:a="http://schemas.openxmlformats.org/drawingml/2006/main">
               <a:ext uri="{FF2B5EF4-FFF2-40B4-BE49-F238E27FC236}">
-                <a16:creationId xmlns:a16="http://schemas.microsoft.com/office/drawing/2014/main" id="{FFA10BB3-2BDE-4E94-A70E-531774834FE9}"/>
+                <a16:creationId xmlns:a16="http://schemas.microsoft.com/office/drawing/2014/main" id="{DFCC718C-3D16-4DFD-840B-960AA8E7D8F9}"/>
               </a:ext>
             </a:extLst>
           </p:cNvPr>
@@ -6635,165 +6439,7 @@
         </p:nvSpPr>
         <p:spPr>
           <a:xfrm xmlns:a="http://schemas.openxmlformats.org/drawingml/2006/main">
-            <a:off x="552450" y="1504950"/>
-            <a:ext cx="11087100" cy="466725"/>
-          </a:xfrm>
-          <a:prstGeom xmlns:a="http://schemas.openxmlformats.org/drawingml/2006/main" prst="rect">
-            <a:avLst/>
-          </a:prstGeom>
-          <a:noFill xmlns:a="http://schemas.openxmlformats.org/drawingml/2006/main"/>
-          <a:ln xmlns:a="http://schemas.openxmlformats.org/drawingml/2006/main" w="0">
-            <a:noFill/>
-          </a:ln>
-        </p:spPr>
-        <p:txBody>
-          <a:bodyPr xmlns:a="http://schemas.openxmlformats.org/drawingml/2006/main" wrap="square" lIns="0" tIns="0" rIns="0" bIns="0">
-            <a:noAutofit/>
-          </a:bodyPr>
-          <a:lstStyle xmlns:a="http://schemas.openxmlformats.org/drawingml/2006/main">
-            <a:defPPr>
-              <a:defRPr sz="1950" b="0">
-                <a:solidFill>
-                  <a:srgbClr val="666666"/>
-                </a:solidFill>
-                <a:latin typeface="Inter"/>
-                <a:ea typeface="Inter"/>
-                <a:cs typeface="Inter"/>
-              </a:defRPr>
-            </a:defPPr>
-            <a:lvl1pPr>
-              <a:defRPr sz="1950" b="0">
-                <a:solidFill>
-                  <a:srgbClr val="666666"/>
-                </a:solidFill>
-                <a:latin typeface="Inter"/>
-                <a:ea typeface="Inter"/>
-                <a:cs typeface="Inter"/>
-              </a:defRPr>
-            </a:lvl1pPr>
-            <a:lvl2pPr>
-              <a:defRPr sz="1950" b="0">
-                <a:solidFill>
-                  <a:srgbClr val="666666"/>
-                </a:solidFill>
-                <a:latin typeface="Inter"/>
-                <a:ea typeface="Inter"/>
-                <a:cs typeface="Inter"/>
-              </a:defRPr>
-            </a:lvl2pPr>
-            <a:lvl3pPr>
-              <a:defRPr sz="1950" b="0">
-                <a:solidFill>
-                  <a:srgbClr val="666666"/>
-                </a:solidFill>
-                <a:latin typeface="Inter"/>
-                <a:ea typeface="Inter"/>
-                <a:cs typeface="Inter"/>
-              </a:defRPr>
-            </a:lvl3pPr>
-            <a:lvl4pPr>
-              <a:defRPr sz="1950" b="0">
-                <a:solidFill>
-                  <a:srgbClr val="666666"/>
-                </a:solidFill>
-                <a:latin typeface="Inter"/>
-                <a:ea typeface="Inter"/>
-                <a:cs typeface="Inter"/>
-              </a:defRPr>
-            </a:lvl4pPr>
-            <a:lvl5pPr>
-              <a:defRPr sz="1950" b="0">
-                <a:solidFill>
-                  <a:srgbClr val="666666"/>
-                </a:solidFill>
-                <a:latin typeface="Inter"/>
-                <a:ea typeface="Inter"/>
-                <a:cs typeface="Inter"/>
-              </a:defRPr>
-            </a:lvl5pPr>
-            <a:lvl6pPr>
-              <a:defRPr sz="1950" b="0">
-                <a:solidFill>
-                  <a:srgbClr val="666666"/>
-                </a:solidFill>
-                <a:latin typeface="Inter"/>
-                <a:ea typeface="Inter"/>
-                <a:cs typeface="Inter"/>
-              </a:defRPr>
-            </a:lvl6pPr>
-            <a:lvl7pPr>
-              <a:defRPr sz="1950" b="0">
-                <a:solidFill>
-                  <a:srgbClr val="666666"/>
-                </a:solidFill>
-                <a:latin typeface="Inter"/>
-                <a:ea typeface="Inter"/>
-                <a:cs typeface="Inter"/>
-              </a:defRPr>
-            </a:lvl7pPr>
-            <a:lvl8pPr>
-              <a:defRPr sz="1950" b="0">
-                <a:solidFill>
-                  <a:srgbClr val="666666"/>
-                </a:solidFill>
-                <a:latin typeface="Inter"/>
-                <a:ea typeface="Inter"/>
-                <a:cs typeface="Inter"/>
-              </a:defRPr>
-            </a:lvl8pPr>
-            <a:lvl9pPr>
-              <a:defRPr sz="1950" b="0">
-                <a:solidFill>
-                  <a:srgbClr val="666666"/>
-                </a:solidFill>
-                <a:latin typeface="Inter"/>
-                <a:ea typeface="Inter"/>
-                <a:cs typeface="Inter"/>
-              </a:defRPr>
-            </a:lvl9pPr>
-          </a:lstStyle>
-          <a:p xmlns:a="http://schemas.openxmlformats.org/drawingml/2006/main">
-            <a:pPr>
-              <a:defRPr sz="1950" b="0">
-                <a:solidFill>
-                  <a:srgbClr val="666666"/>
-                </a:solidFill>
-                <a:latin typeface="Inter"/>
-                <a:ea typeface="Inter"/>
-                <a:cs typeface="Inter"/>
-              </a:defRPr>
-            </a:pPr>
-            <a:r>
-              <a:rPr sz="1950" b="0">
-                <a:solidFill>
-                  <a:srgbClr val="666666"/>
-                </a:solidFill>
-                <a:latin typeface="Inter"/>
-                <a:ea typeface="Inter"/>
-                <a:cs typeface="Inter"/>
-              </a:rPr>
-              <a:t>Actual demo: 388 nuclei in group 6; two genes support a Root hair candidate.</a:t>
-            </a:r>
-          </a:p>
-        </p:txBody>
-      </p:sp>
-      <p:sp>
-        <p:nvSpPr>
-          <p:cNvPr id="3" name="copy-22">
-            <a:extLst xmlns:a="http://schemas.openxmlformats.org/drawingml/2006/main">
-              <a:ext uri="{FF2B5EF4-FFF2-40B4-BE49-F238E27FC236}">
-                <a16:creationId xmlns:a16="http://schemas.microsoft.com/office/drawing/2014/main" id="{77221447-B2F7-4219-A414-1985C53EB959}"/>
-              </a:ext>
-            </a:extLst>
-          </p:cNvPr>
-          <p:cNvSpPr>
-            <a:spLocks xmlns:a="http://schemas.openxmlformats.org/drawingml/2006/main" noGrp="1"/>
-          </p:cNvSpPr>
-          <p:nvPr/>
-        </p:nvSpPr>
-        <p:spPr>
-          <a:xfrm xmlns:a="http://schemas.openxmlformats.org/drawingml/2006/main">
-            <a:off x="552450" y="2628900"/>
+            <a:off x="552450" y="2428875"/>
             <a:ext cx="2714625" cy="428625"/>
           </a:xfrm>
           <a:prstGeom xmlns:a="http://schemas.openxmlformats.org/drawingml/2006/main" prst="rect">
@@ -6937,10 +6583,10 @@
       </p:sp>
       <p:sp>
         <p:nvSpPr>
-          <p:cNvPr id="4" name="copy-23">
+          <p:cNvPr id="3" name="copy-21">
             <a:extLst xmlns:a="http://schemas.openxmlformats.org/drawingml/2006/main">
               <a:ext uri="{FF2B5EF4-FFF2-40B4-BE49-F238E27FC236}">
-                <a16:creationId xmlns:a16="http://schemas.microsoft.com/office/drawing/2014/main" id="{28C885E3-D376-49CB-A534-9C48391FF729}"/>
+                <a16:creationId xmlns:a16="http://schemas.microsoft.com/office/drawing/2014/main" id="{149793C8-AD60-4543-BBA7-6376D46BCE21}"/>
               </a:ext>
             </a:extLst>
           </p:cNvPr>
@@ -6951,7 +6597,7 @@
         </p:nvSpPr>
         <p:spPr>
           <a:xfrm xmlns:a="http://schemas.openxmlformats.org/drawingml/2006/main">
-            <a:off x="552450" y="3286125"/>
+            <a:off x="552450" y="3095625"/>
             <a:ext cx="2714625" cy="1047750"/>
           </a:xfrm>
           <a:prstGeom xmlns:a="http://schemas.openxmlformats.org/drawingml/2006/main" prst="rect">
@@ -6968,7 +6614,7 @@
           </a:bodyPr>
           <a:lstStyle xmlns:a="http://schemas.openxmlformats.org/drawingml/2006/main">
             <a:defPPr>
-              <a:defRPr sz="2400" b="1">
+              <a:defRPr sz="2550" b="1">
                 <a:solidFill>
                   <a:srgbClr val="111111"/>
                 </a:solidFill>
@@ -6978,7 +6624,7 @@
               </a:defRPr>
             </a:defPPr>
             <a:lvl1pPr>
-              <a:defRPr sz="2400" b="1">
+              <a:defRPr sz="2550" b="1">
                 <a:solidFill>
                   <a:srgbClr val="111111"/>
                 </a:solidFill>
@@ -6988,7 +6634,7 @@
               </a:defRPr>
             </a:lvl1pPr>
             <a:lvl2pPr>
-              <a:defRPr sz="2400" b="1">
+              <a:defRPr sz="2550" b="1">
                 <a:solidFill>
                   <a:srgbClr val="111111"/>
                 </a:solidFill>
@@ -6998,7 +6644,7 @@
               </a:defRPr>
             </a:lvl2pPr>
             <a:lvl3pPr>
-              <a:defRPr sz="2400" b="1">
+              <a:defRPr sz="2550" b="1">
                 <a:solidFill>
                   <a:srgbClr val="111111"/>
                 </a:solidFill>
@@ -7008,7 +6654,7 @@
               </a:defRPr>
             </a:lvl3pPr>
             <a:lvl4pPr>
-              <a:defRPr sz="2400" b="1">
+              <a:defRPr sz="2550" b="1">
                 <a:solidFill>
                   <a:srgbClr val="111111"/>
                 </a:solidFill>
@@ -7018,7 +6664,7 @@
               </a:defRPr>
             </a:lvl4pPr>
             <a:lvl5pPr>
-              <a:defRPr sz="2400" b="1">
+              <a:defRPr sz="2550" b="1">
                 <a:solidFill>
                   <a:srgbClr val="111111"/>
                 </a:solidFill>
@@ -7028,7 +6674,7 @@
               </a:defRPr>
             </a:lvl5pPr>
             <a:lvl6pPr>
-              <a:defRPr sz="2400" b="1">
+              <a:defRPr sz="2550" b="1">
                 <a:solidFill>
                   <a:srgbClr val="111111"/>
                 </a:solidFill>
@@ -7038,7 +6684,7 @@
               </a:defRPr>
             </a:lvl6pPr>
             <a:lvl7pPr>
-              <a:defRPr sz="2400" b="1">
+              <a:defRPr sz="2550" b="1">
                 <a:solidFill>
                   <a:srgbClr val="111111"/>
                 </a:solidFill>
@@ -7048,7 +6694,7 @@
               </a:defRPr>
             </a:lvl7pPr>
             <a:lvl8pPr>
-              <a:defRPr sz="2400" b="1">
+              <a:defRPr sz="2550" b="1">
                 <a:solidFill>
                   <a:srgbClr val="111111"/>
                 </a:solidFill>
@@ -7058,7 +6704,7 @@
               </a:defRPr>
             </a:lvl8pPr>
             <a:lvl9pPr>
-              <a:defRPr sz="2400" b="1">
+              <a:defRPr sz="2550" b="1">
                 <a:solidFill>
                   <a:srgbClr val="111111"/>
                 </a:solidFill>
@@ -7070,7 +6716,7 @@
           </a:lstStyle>
           <a:p xmlns:a="http://schemas.openxmlformats.org/drawingml/2006/main">
             <a:pPr>
-              <a:defRPr sz="2400" b="1">
+              <a:defRPr sz="2550" b="1">
                 <a:solidFill>
                   <a:srgbClr val="111111"/>
                 </a:solidFill>
@@ -7080,7 +6726,7 @@
               </a:defRPr>
             </a:pPr>
             <a:r>
-              <a:rPr sz="2400" b="1">
+              <a:rPr sz="2550" b="1">
                 <a:solidFill>
                   <a:srgbClr val="111111"/>
                 </a:solidFill>
@@ -7088,12 +6734,12 @@
                 <a:ea typeface="Inter"/>
                 <a:cs typeface="Inter"/>
               </a:rPr>
-              <a:t>“Could these be</a:t>
+              <a:t>“Which cells</a:t>
             </a:r>
           </a:p>
           <a:p xmlns:a="http://schemas.openxmlformats.org/drawingml/2006/main">
             <a:pPr>
-              <a:defRPr sz="2400" b="1">
+              <a:defRPr sz="2550" b="1">
                 <a:solidFill>
                   <a:srgbClr val="111111"/>
                 </a:solidFill>
@@ -7103,7 +6749,7 @@
               </a:defRPr>
             </a:pPr>
             <a:r>
-              <a:rPr sz="2400" b="1">
+              <a:rPr sz="2550" b="1">
                 <a:solidFill>
                   <a:srgbClr val="111111"/>
                 </a:solidFill>
@@ -7111,17 +6757,17 @@
                 <a:ea typeface="Inter"/>
                 <a:cs typeface="Inter"/>
               </a:rPr>
-              <a:t>root-hair cells?”</a:t>
+              <a:t>are these?”</a:t>
             </a:r>
           </a:p>
         </p:txBody>
       </p:sp>
       <p:sp>
         <p:nvSpPr>
-          <p:cNvPr id="5" name="arrow-24">
+          <p:cNvPr id="4" name="arrow-22">
             <a:extLst xmlns:a="http://schemas.openxmlformats.org/drawingml/2006/main">
               <a:ext uri="{FF2B5EF4-FFF2-40B4-BE49-F238E27FC236}">
-                <a16:creationId xmlns:a16="http://schemas.microsoft.com/office/drawing/2014/main" id="{0CE8535E-E2C5-4510-9E28-7D7C630F2015}"/>
+                <a16:creationId xmlns:a16="http://schemas.microsoft.com/office/drawing/2014/main" id="{DD93AF22-BF1E-4ECB-8ACF-B94553A539AC}"/>
               </a:ext>
             </a:extLst>
           </p:cNvPr>
@@ -7132,7 +6778,7 @@
         </p:nvSpPr>
         <p:spPr>
           <a:xfrm xmlns:a="http://schemas.openxmlformats.org/drawingml/2006/main">
-            <a:off x="3057525" y="3895725"/>
+            <a:off x="3057525" y="3705225"/>
             <a:ext cx="361950" cy="152400"/>
           </a:xfrm>
           <a:prstGeom xmlns:a="http://schemas.openxmlformats.org/drawingml/2006/main" prst="rightArrow">
@@ -7148,10 +6794,10 @@
       </p:sp>
       <p:sp>
         <p:nvSpPr>
-          <p:cNvPr id="6" name="block-25">
+          <p:cNvPr id="5" name="block-23">
             <a:extLst xmlns:a="http://schemas.openxmlformats.org/drawingml/2006/main">
               <a:ext uri="{FF2B5EF4-FFF2-40B4-BE49-F238E27FC236}">
-                <a16:creationId xmlns:a16="http://schemas.microsoft.com/office/drawing/2014/main" id="{B3934760-426C-4887-BCAD-9C2AE14F6999}"/>
+                <a16:creationId xmlns:a16="http://schemas.microsoft.com/office/drawing/2014/main" id="{C6453E33-9D11-417E-A683-4682ED99F972}"/>
               </a:ext>
             </a:extLst>
           </p:cNvPr>
@@ -7162,7 +6808,7 @@
         </p:nvSpPr>
         <p:spPr>
           <a:xfrm xmlns:a="http://schemas.openxmlformats.org/drawingml/2006/main">
-            <a:off x="3714750" y="2324100"/>
+            <a:off x="3714750" y="2133600"/>
             <a:ext cx="4762500" cy="3476625"/>
           </a:xfrm>
           <a:prstGeom xmlns:a="http://schemas.openxmlformats.org/drawingml/2006/main" prst="rect">
@@ -7178,10 +6824,10 @@
       </p:sp>
       <p:sp>
         <p:nvSpPr>
-          <p:cNvPr id="7" name="copy-26">
+          <p:cNvPr id="6" name="copy-24">
             <a:extLst xmlns:a="http://schemas.openxmlformats.org/drawingml/2006/main">
               <a:ext uri="{FF2B5EF4-FFF2-40B4-BE49-F238E27FC236}">
-                <a16:creationId xmlns:a16="http://schemas.microsoft.com/office/drawing/2014/main" id="{BCA520AA-4DF4-4381-B8D8-F8E0EEE84D4E}"/>
+                <a16:creationId xmlns:a16="http://schemas.microsoft.com/office/drawing/2014/main" id="{FE7CA30B-2B73-4F84-925C-53823FA3C756}"/>
               </a:ext>
             </a:extLst>
           </p:cNvPr>
@@ -7192,7 +6838,7 @@
         </p:nvSpPr>
         <p:spPr>
           <a:xfrm xmlns:a="http://schemas.openxmlformats.org/drawingml/2006/main">
-            <a:off x="4000500" y="2552700"/>
+            <a:off x="4000500" y="2362200"/>
             <a:ext cx="4191000" cy="523875"/>
           </a:xfrm>
           <a:prstGeom xmlns:a="http://schemas.openxmlformats.org/drawingml/2006/main" prst="rect">
@@ -7336,10 +6982,10 @@
       </p:sp>
       <p:sp>
         <p:nvSpPr>
-          <p:cNvPr id="8" name="copy-27">
+          <p:cNvPr id="7" name="copy-25">
             <a:extLst xmlns:a="http://schemas.openxmlformats.org/drawingml/2006/main">
               <a:ext uri="{FF2B5EF4-FFF2-40B4-BE49-F238E27FC236}">
-                <a16:creationId xmlns:a16="http://schemas.microsoft.com/office/drawing/2014/main" id="{A6D9B3FE-6455-4384-86A5-6E464A346A6D}"/>
+                <a16:creationId xmlns:a16="http://schemas.microsoft.com/office/drawing/2014/main" id="{666F5245-859C-42FE-B619-2159436BCD59}"/>
               </a:ext>
             </a:extLst>
           </p:cNvPr>
@@ -7350,7 +6996,7 @@
         </p:nvSpPr>
         <p:spPr>
           <a:xfrm xmlns:a="http://schemas.openxmlformats.org/drawingml/2006/main">
-            <a:off x="4000500" y="3343275"/>
+            <a:off x="4000500" y="3152775"/>
             <a:ext cx="4191000" cy="352425"/>
           </a:xfrm>
           <a:prstGeom xmlns:a="http://schemas.openxmlformats.org/drawingml/2006/main" prst="rect">
@@ -7367,7 +7013,7 @@
           </a:bodyPr>
           <a:lstStyle xmlns:a="http://schemas.openxmlformats.org/drawingml/2006/main">
             <a:defPPr>
-              <a:defRPr sz="1800" b="1">
+              <a:defRPr sz="1875" b="1">
                 <a:solidFill>
                   <a:srgbClr val="FFFFFF"/>
                 </a:solidFill>
@@ -7377,7 +7023,7 @@
               </a:defRPr>
             </a:defPPr>
             <a:lvl1pPr>
-              <a:defRPr sz="1800" b="1">
+              <a:defRPr sz="1875" b="1">
                 <a:solidFill>
                   <a:srgbClr val="FFFFFF"/>
                 </a:solidFill>
@@ -7387,7 +7033,7 @@
               </a:defRPr>
             </a:lvl1pPr>
             <a:lvl2pPr>
-              <a:defRPr sz="1800" b="1">
+              <a:defRPr sz="1875" b="1">
                 <a:solidFill>
                   <a:srgbClr val="FFFFFF"/>
                 </a:solidFill>
@@ -7397,7 +7043,7 @@
               </a:defRPr>
             </a:lvl2pPr>
             <a:lvl3pPr>
-              <a:defRPr sz="1800" b="1">
+              <a:defRPr sz="1875" b="1">
                 <a:solidFill>
                   <a:srgbClr val="FFFFFF"/>
                 </a:solidFill>
@@ -7407,7 +7053,7 @@
               </a:defRPr>
             </a:lvl3pPr>
             <a:lvl4pPr>
-              <a:defRPr sz="1800" b="1">
+              <a:defRPr sz="1875" b="1">
                 <a:solidFill>
                   <a:srgbClr val="FFFFFF"/>
                 </a:solidFill>
@@ -7417,7 +7063,7 @@
               </a:defRPr>
             </a:lvl4pPr>
             <a:lvl5pPr>
-              <a:defRPr sz="1800" b="1">
+              <a:defRPr sz="1875" b="1">
                 <a:solidFill>
                   <a:srgbClr val="FFFFFF"/>
                 </a:solidFill>
@@ -7427,7 +7073,7 @@
               </a:defRPr>
             </a:lvl5pPr>
             <a:lvl6pPr>
-              <a:defRPr sz="1800" b="1">
+              <a:defRPr sz="1875" b="1">
                 <a:solidFill>
                   <a:srgbClr val="FFFFFF"/>
                 </a:solidFill>
@@ -7437,7 +7083,7 @@
               </a:defRPr>
             </a:lvl6pPr>
             <a:lvl7pPr>
-              <a:defRPr sz="1800" b="1">
+              <a:defRPr sz="1875" b="1">
                 <a:solidFill>
                   <a:srgbClr val="FFFFFF"/>
                 </a:solidFill>
@@ -7447,7 +7093,7 @@
               </a:defRPr>
             </a:lvl7pPr>
             <a:lvl8pPr>
-              <a:defRPr sz="1800" b="1">
+              <a:defRPr sz="1875" b="1">
                 <a:solidFill>
                   <a:srgbClr val="FFFFFF"/>
                 </a:solidFill>
@@ -7457,7 +7103,7 @@
               </a:defRPr>
             </a:lvl8pPr>
             <a:lvl9pPr>
-              <a:defRPr sz="1800" b="1">
+              <a:defRPr sz="1875" b="1">
                 <a:solidFill>
                   <a:srgbClr val="FFFFFF"/>
                 </a:solidFill>
@@ -7469,7 +7115,7 @@
           </a:lstStyle>
           <a:p xmlns:a="http://schemas.openxmlformats.org/drawingml/2006/main">
             <a:pPr>
-              <a:defRPr sz="1800" b="1">
+              <a:defRPr sz="1875" b="1">
                 <a:solidFill>
                   <a:srgbClr val="FFFFFF"/>
                 </a:solidFill>
@@ -7479,7 +7125,7 @@
               </a:defRPr>
             </a:pPr>
             <a:r>
-              <a:rPr sz="1800" b="1">
+              <a:rPr sz="1875" b="1">
                 <a:solidFill>
                   <a:srgbClr val="FFFFFF"/>
                 </a:solidFill>
@@ -7487,17 +7133,17 @@
                 <a:ea typeface="Inter"/>
                 <a:cs typeface="Inter"/>
               </a:rPr>
-              <a:t>Checks published marker genes</a:t>
+              <a:t>Checks published markers</a:t>
             </a:r>
           </a:p>
         </p:txBody>
       </p:sp>
       <p:sp>
         <p:nvSpPr>
-          <p:cNvPr id="9" name="copy-28">
+          <p:cNvPr id="8" name="copy-26">
             <a:extLst xmlns:a="http://schemas.openxmlformats.org/drawingml/2006/main">
               <a:ext uri="{FF2B5EF4-FFF2-40B4-BE49-F238E27FC236}">
-                <a16:creationId xmlns:a16="http://schemas.microsoft.com/office/drawing/2014/main" id="{2712A84A-4191-4C0C-B04B-C74AFA9BFC86}"/>
+                <a16:creationId xmlns:a16="http://schemas.microsoft.com/office/drawing/2014/main" id="{0C0B7B26-3B4B-450E-BBBD-A782513622BD}"/>
               </a:ext>
             </a:extLst>
           </p:cNvPr>
@@ -7508,7 +7154,7 @@
         </p:nvSpPr>
         <p:spPr>
           <a:xfrm xmlns:a="http://schemas.openxmlformats.org/drawingml/2006/main">
-            <a:off x="4000500" y="3705225"/>
+            <a:off x="4000500" y="3514725"/>
             <a:ext cx="4191000" cy="266700"/>
           </a:xfrm>
           <a:prstGeom xmlns:a="http://schemas.openxmlformats.org/drawingml/2006/main" prst="rect">
@@ -7645,17 +7291,17 @@
                 <a:ea typeface="Inter"/>
                 <a:cs typeface="Inter"/>
               </a:rPr>
-              <a:t>Zetaris reference retrieval</a:t>
+              <a:t>Zetaris</a:t>
             </a:r>
           </a:p>
         </p:txBody>
       </p:sp>
       <p:sp>
         <p:nvSpPr>
-          <p:cNvPr id="10" name="copy-29">
+          <p:cNvPr id="9" name="copy-27">
             <a:extLst xmlns:a="http://schemas.openxmlformats.org/drawingml/2006/main">
               <a:ext uri="{FF2B5EF4-FFF2-40B4-BE49-F238E27FC236}">
-                <a16:creationId xmlns:a16="http://schemas.microsoft.com/office/drawing/2014/main" id="{62681BC6-E941-49E8-9170-FC986A105CCA}"/>
+                <a16:creationId xmlns:a16="http://schemas.microsoft.com/office/drawing/2014/main" id="{CED8882E-8BA3-46A6-AF3D-E00F637376F7}"/>
               </a:ext>
             </a:extLst>
           </p:cNvPr>
@@ -7666,7 +7312,7 @@
         </p:nvSpPr>
         <p:spPr>
           <a:xfrm xmlns:a="http://schemas.openxmlformats.org/drawingml/2006/main">
-            <a:off x="4000500" y="4105275"/>
+            <a:off x="4000500" y="3914775"/>
             <a:ext cx="4191000" cy="352425"/>
           </a:xfrm>
           <a:prstGeom xmlns:a="http://schemas.openxmlformats.org/drawingml/2006/main" prst="rect">
@@ -7683,7 +7329,7 @@
           </a:bodyPr>
           <a:lstStyle xmlns:a="http://schemas.openxmlformats.org/drawingml/2006/main">
             <a:defPPr>
-              <a:defRPr sz="1800" b="1">
+              <a:defRPr sz="1875" b="1">
                 <a:solidFill>
                   <a:srgbClr val="FFFFFF"/>
                 </a:solidFill>
@@ -7693,7 +7339,7 @@
               </a:defRPr>
             </a:defPPr>
             <a:lvl1pPr>
-              <a:defRPr sz="1800" b="1">
+              <a:defRPr sz="1875" b="1">
                 <a:solidFill>
                   <a:srgbClr val="FFFFFF"/>
                 </a:solidFill>
@@ -7703,7 +7349,7 @@
               </a:defRPr>
             </a:lvl1pPr>
             <a:lvl2pPr>
-              <a:defRPr sz="1800" b="1">
+              <a:defRPr sz="1875" b="1">
                 <a:solidFill>
                   <a:srgbClr val="FFFFFF"/>
                 </a:solidFill>
@@ -7713,7 +7359,7 @@
               </a:defRPr>
             </a:lvl2pPr>
             <a:lvl3pPr>
-              <a:defRPr sz="1800" b="1">
+              <a:defRPr sz="1875" b="1">
                 <a:solidFill>
                   <a:srgbClr val="FFFFFF"/>
                 </a:solidFill>
@@ -7723,7 +7369,7 @@
               </a:defRPr>
             </a:lvl3pPr>
             <a:lvl4pPr>
-              <a:defRPr sz="1800" b="1">
+              <a:defRPr sz="1875" b="1">
                 <a:solidFill>
                   <a:srgbClr val="FFFFFF"/>
                 </a:solidFill>
@@ -7733,7 +7379,7 @@
               </a:defRPr>
             </a:lvl4pPr>
             <a:lvl5pPr>
-              <a:defRPr sz="1800" b="1">
+              <a:defRPr sz="1875" b="1">
                 <a:solidFill>
                   <a:srgbClr val="FFFFFF"/>
                 </a:solidFill>
@@ -7743,7 +7389,7 @@
               </a:defRPr>
             </a:lvl5pPr>
             <a:lvl6pPr>
-              <a:defRPr sz="1800" b="1">
+              <a:defRPr sz="1875" b="1">
                 <a:solidFill>
                   <a:srgbClr val="FFFFFF"/>
                 </a:solidFill>
@@ -7753,7 +7399,7 @@
               </a:defRPr>
             </a:lvl6pPr>
             <a:lvl7pPr>
-              <a:defRPr sz="1800" b="1">
+              <a:defRPr sz="1875" b="1">
                 <a:solidFill>
                   <a:srgbClr val="FFFFFF"/>
                 </a:solidFill>
@@ -7763,7 +7409,7 @@
               </a:defRPr>
             </a:lvl7pPr>
             <a:lvl8pPr>
-              <a:defRPr sz="1800" b="1">
+              <a:defRPr sz="1875" b="1">
                 <a:solidFill>
                   <a:srgbClr val="FFFFFF"/>
                 </a:solidFill>
@@ -7773,7 +7419,7 @@
               </a:defRPr>
             </a:lvl8pPr>
             <a:lvl9pPr>
-              <a:defRPr sz="1800" b="1">
+              <a:defRPr sz="1875" b="1">
                 <a:solidFill>
                   <a:srgbClr val="FFFFFF"/>
                 </a:solidFill>
@@ -7785,7 +7431,7 @@
           </a:lstStyle>
           <a:p xmlns:a="http://schemas.openxmlformats.org/drawingml/2006/main">
             <a:pPr>
-              <a:defRPr sz="1800" b="1">
+              <a:defRPr sz="1875" b="1">
                 <a:solidFill>
                   <a:srgbClr val="FFFFFF"/>
                 </a:solidFill>
@@ -7795,7 +7441,7 @@
               </a:defRPr>
             </a:pPr>
             <a:r>
-              <a:rPr sz="1800" b="1">
+              <a:rPr sz="1875" b="1">
                 <a:solidFill>
                   <a:srgbClr val="FFFFFF"/>
                 </a:solidFill>
@@ -7803,17 +7449,17 @@
                 <a:ea typeface="Inter"/>
                 <a:cs typeface="Inter"/>
               </a:rPr>
-              <a:t>Measures activity of those genes</a:t>
+              <a:t>Measures gene expression</a:t>
             </a:r>
           </a:p>
         </p:txBody>
       </p:sp>
       <p:sp>
         <p:nvSpPr>
-          <p:cNvPr id="11" name="copy-30">
+          <p:cNvPr id="10" name="copy-28">
             <a:extLst xmlns:a="http://schemas.openxmlformats.org/drawingml/2006/main">
               <a:ext uri="{FF2B5EF4-FFF2-40B4-BE49-F238E27FC236}">
-                <a16:creationId xmlns:a16="http://schemas.microsoft.com/office/drawing/2014/main" id="{5C398793-78F7-4028-AB8D-05A9541AA2B6}"/>
+                <a16:creationId xmlns:a16="http://schemas.microsoft.com/office/drawing/2014/main" id="{6488416E-FB4F-43F9-AE42-CF4695E7FAF9}"/>
               </a:ext>
             </a:extLst>
           </p:cNvPr>
@@ -7824,7 +7470,7 @@
         </p:nvSpPr>
         <p:spPr>
           <a:xfrm xmlns:a="http://schemas.openxmlformats.org/drawingml/2006/main">
-            <a:off x="4000500" y="4467225"/>
+            <a:off x="4000500" y="4276725"/>
             <a:ext cx="4191000" cy="266700"/>
           </a:xfrm>
           <a:prstGeom xmlns:a="http://schemas.openxmlformats.org/drawingml/2006/main" prst="rect">
@@ -7968,10 +7614,10 @@
       </p:sp>
       <p:sp>
         <p:nvSpPr>
-          <p:cNvPr id="12" name="copy-31">
+          <p:cNvPr id="11" name="copy-29">
             <a:extLst xmlns:a="http://schemas.openxmlformats.org/drawingml/2006/main">
               <a:ext uri="{FF2B5EF4-FFF2-40B4-BE49-F238E27FC236}">
-                <a16:creationId xmlns:a16="http://schemas.microsoft.com/office/drawing/2014/main" id="{C0AC56A2-87FE-4426-88AC-890A4C74E001}"/>
+                <a16:creationId xmlns:a16="http://schemas.microsoft.com/office/drawing/2014/main" id="{94430AA9-54F6-425A-9535-EB0A2F31DFB5}"/>
               </a:ext>
             </a:extLst>
           </p:cNvPr>
@@ -7982,7 +7628,7 @@
         </p:nvSpPr>
         <p:spPr>
           <a:xfrm xmlns:a="http://schemas.openxmlformats.org/drawingml/2006/main">
-            <a:off x="4000500" y="4867275"/>
+            <a:off x="4000500" y="4676775"/>
             <a:ext cx="4191000" cy="352425"/>
           </a:xfrm>
           <a:prstGeom xmlns:a="http://schemas.openxmlformats.org/drawingml/2006/main" prst="rect">
@@ -7999,7 +7645,7 @@
           </a:bodyPr>
           <a:lstStyle xmlns:a="http://schemas.openxmlformats.org/drawingml/2006/main">
             <a:defPPr>
-              <a:defRPr sz="1800" b="1">
+              <a:defRPr sz="1875" b="1">
                 <a:solidFill>
                   <a:srgbClr val="FFFFFF"/>
                 </a:solidFill>
@@ -8009,7 +7655,7 @@
               </a:defRPr>
             </a:defPPr>
             <a:lvl1pPr>
-              <a:defRPr sz="1800" b="1">
+              <a:defRPr sz="1875" b="1">
                 <a:solidFill>
                   <a:srgbClr val="FFFFFF"/>
                 </a:solidFill>
@@ -8019,7 +7665,7 @@
               </a:defRPr>
             </a:lvl1pPr>
             <a:lvl2pPr>
-              <a:defRPr sz="1800" b="1">
+              <a:defRPr sz="1875" b="1">
                 <a:solidFill>
                   <a:srgbClr val="FFFFFF"/>
                 </a:solidFill>
@@ -8029,7 +7675,7 @@
               </a:defRPr>
             </a:lvl2pPr>
             <a:lvl3pPr>
-              <a:defRPr sz="1800" b="1">
+              <a:defRPr sz="1875" b="1">
                 <a:solidFill>
                   <a:srgbClr val="FFFFFF"/>
                 </a:solidFill>
@@ -8039,7 +7685,7 @@
               </a:defRPr>
             </a:lvl3pPr>
             <a:lvl4pPr>
-              <a:defRPr sz="1800" b="1">
+              <a:defRPr sz="1875" b="1">
                 <a:solidFill>
                   <a:srgbClr val="FFFFFF"/>
                 </a:solidFill>
@@ -8049,7 +7695,7 @@
               </a:defRPr>
             </a:lvl4pPr>
             <a:lvl5pPr>
-              <a:defRPr sz="1800" b="1">
+              <a:defRPr sz="1875" b="1">
                 <a:solidFill>
                   <a:srgbClr val="FFFFFF"/>
                 </a:solidFill>
@@ -8059,7 +7705,7 @@
               </a:defRPr>
             </a:lvl5pPr>
             <a:lvl6pPr>
-              <a:defRPr sz="1800" b="1">
+              <a:defRPr sz="1875" b="1">
                 <a:solidFill>
                   <a:srgbClr val="FFFFFF"/>
                 </a:solidFill>
@@ -8069,7 +7715,7 @@
               </a:defRPr>
             </a:lvl6pPr>
             <a:lvl7pPr>
-              <a:defRPr sz="1800" b="1">
+              <a:defRPr sz="1875" b="1">
                 <a:solidFill>
                   <a:srgbClr val="FFFFFF"/>
                 </a:solidFill>
@@ -8079,7 +7725,7 @@
               </a:defRPr>
             </a:lvl7pPr>
             <a:lvl8pPr>
-              <a:defRPr sz="1800" b="1">
+              <a:defRPr sz="1875" b="1">
                 <a:solidFill>
                   <a:srgbClr val="FFFFFF"/>
                 </a:solidFill>
@@ -8089,7 +7735,7 @@
               </a:defRPr>
             </a:lvl8pPr>
             <a:lvl9pPr>
-              <a:defRPr sz="1800" b="1">
+              <a:defRPr sz="1875" b="1">
                 <a:solidFill>
                   <a:srgbClr val="FFFFFF"/>
                 </a:solidFill>
@@ -8101,7 +7747,7 @@
           </a:lstStyle>
           <a:p xmlns:a="http://schemas.openxmlformats.org/drawingml/2006/main">
             <a:pPr>
-              <a:defRPr sz="1800" b="1">
+              <a:defRPr sz="1875" b="1">
                 <a:solidFill>
                   <a:srgbClr val="FFFFFF"/>
                 </a:solidFill>
@@ -8111,7 +7757,7 @@
               </a:defRPr>
             </a:pPr>
             <a:r>
-              <a:rPr sz="1800" b="1">
+              <a:rPr sz="1875" b="1">
                 <a:solidFill>
                   <a:srgbClr val="FFFFFF"/>
                 </a:solidFill>
@@ -8119,17 +7765,17 @@
                 <a:ea typeface="Inter"/>
                 <a:cs typeface="Inter"/>
               </a:rPr>
-              <a:t>Recalls the saved review and why</a:t>
+              <a:t>Recalls your reviewed decisions</a:t>
             </a:r>
           </a:p>
         </p:txBody>
       </p:sp>
       <p:sp>
         <p:nvSpPr>
-          <p:cNvPr id="13" name="copy-32">
+          <p:cNvPr id="12" name="copy-30">
             <a:extLst xmlns:a="http://schemas.openxmlformats.org/drawingml/2006/main">
               <a:ext uri="{FF2B5EF4-FFF2-40B4-BE49-F238E27FC236}">
-                <a16:creationId xmlns:a16="http://schemas.microsoft.com/office/drawing/2014/main" id="{BC661AF2-9BE6-40F3-AE42-F12BFBCDD8C7}"/>
+                <a16:creationId xmlns:a16="http://schemas.microsoft.com/office/drawing/2014/main" id="{9CAC7BDB-0147-4BD3-96A6-4449412F0320}"/>
               </a:ext>
             </a:extLst>
           </p:cNvPr>
@@ -8140,7 +7786,7 @@
         </p:nvSpPr>
         <p:spPr>
           <a:xfrm xmlns:a="http://schemas.openxmlformats.org/drawingml/2006/main">
-            <a:off x="4000500" y="5229225"/>
+            <a:off x="4000500" y="5038725"/>
             <a:ext cx="4191000" cy="266700"/>
           </a:xfrm>
           <a:prstGeom xmlns:a="http://schemas.openxmlformats.org/drawingml/2006/main" prst="rect">
@@ -8284,10 +7930,10 @@
       </p:sp>
       <p:sp>
         <p:nvSpPr>
-          <p:cNvPr id="14" name="arrow-33">
+          <p:cNvPr id="13" name="arrow-31">
             <a:extLst xmlns:a="http://schemas.openxmlformats.org/drawingml/2006/main">
               <a:ext uri="{FF2B5EF4-FFF2-40B4-BE49-F238E27FC236}">
-                <a16:creationId xmlns:a16="http://schemas.microsoft.com/office/drawing/2014/main" id="{345E5CEE-935B-41F2-A7C4-5DBBE91766CB}"/>
+                <a16:creationId xmlns:a16="http://schemas.microsoft.com/office/drawing/2014/main" id="{A446DA27-0513-444B-BD85-03C652A8959C}"/>
               </a:ext>
             </a:extLst>
           </p:cNvPr>
@@ -8298,7 +7944,7 @@
         </p:nvSpPr>
         <p:spPr>
           <a:xfrm xmlns:a="http://schemas.openxmlformats.org/drawingml/2006/main">
-            <a:off x="8724900" y="3895725"/>
+            <a:off x="8724900" y="3705225"/>
             <a:ext cx="361950" cy="152400"/>
           </a:xfrm>
           <a:prstGeom xmlns:a="http://schemas.openxmlformats.org/drawingml/2006/main" prst="rightArrow">
@@ -8314,10 +7960,10 @@
       </p:sp>
       <p:sp>
         <p:nvSpPr>
-          <p:cNvPr id="15" name="copy-34">
+          <p:cNvPr id="14" name="copy-32">
             <a:extLst xmlns:a="http://schemas.openxmlformats.org/drawingml/2006/main">
               <a:ext uri="{FF2B5EF4-FFF2-40B4-BE49-F238E27FC236}">
-                <a16:creationId xmlns:a16="http://schemas.microsoft.com/office/drawing/2014/main" id="{1D7F0C62-DBAA-47B8-BE1C-C361BE76A845}"/>
+                <a16:creationId xmlns:a16="http://schemas.microsoft.com/office/drawing/2014/main" id="{7A8EA216-7165-44E3-80C8-CC98AD033E1F}"/>
               </a:ext>
             </a:extLst>
           </p:cNvPr>
@@ -8328,7 +7974,7 @@
         </p:nvSpPr>
         <p:spPr>
           <a:xfrm xmlns:a="http://schemas.openxmlformats.org/drawingml/2006/main">
-            <a:off x="9372600" y="2628900"/>
+            <a:off x="9372600" y="2428875"/>
             <a:ext cx="2381250" cy="428625"/>
           </a:xfrm>
           <a:prstGeom xmlns:a="http://schemas.openxmlformats.org/drawingml/2006/main" prst="rect">
@@ -8465,17 +8111,17 @@
                 <a:ea typeface="Inter"/>
                 <a:cs typeface="Inter"/>
               </a:rPr>
-              <a:t>You see</a:t>
+              <a:t>You receive</a:t>
             </a:r>
           </a:p>
         </p:txBody>
       </p:sp>
       <p:sp>
         <p:nvSpPr>
-          <p:cNvPr id="16" name="copy-35">
+          <p:cNvPr id="15" name="copy-33">
             <a:extLst xmlns:a="http://schemas.openxmlformats.org/drawingml/2006/main">
               <a:ext uri="{FF2B5EF4-FFF2-40B4-BE49-F238E27FC236}">
-                <a16:creationId xmlns:a16="http://schemas.microsoft.com/office/drawing/2014/main" id="{2F47BDCF-BC8C-4798-82C4-581688653804}"/>
+                <a16:creationId xmlns:a16="http://schemas.microsoft.com/office/drawing/2014/main" id="{C110C285-2917-4A64-84DA-C450DC72E081}"/>
               </a:ext>
             </a:extLst>
           </p:cNvPr>
@@ -8486,7 +8132,7 @@
         </p:nvSpPr>
         <p:spPr>
           <a:xfrm xmlns:a="http://schemas.openxmlformats.org/drawingml/2006/main">
-            <a:off x="9372600" y="3286125"/>
+            <a:off x="9372600" y="3095625"/>
             <a:ext cx="2381250" cy="1381125"/>
           </a:xfrm>
           <a:prstGeom xmlns:a="http://schemas.openxmlformats.org/drawingml/2006/main" prst="rect">
@@ -8503,7 +8149,7 @@
           </a:bodyPr>
           <a:lstStyle xmlns:a="http://schemas.openxmlformats.org/drawingml/2006/main">
             <a:defPPr>
-              <a:defRPr sz="1875" b="0">
+              <a:defRPr sz="2025" b="0">
                 <a:solidFill>
                   <a:srgbClr val="111111"/>
                 </a:solidFill>
@@ -8513,7 +8159,7 @@
               </a:defRPr>
             </a:defPPr>
             <a:lvl1pPr>
-              <a:defRPr sz="1875" b="0">
+              <a:defRPr sz="2025" b="0">
                 <a:solidFill>
                   <a:srgbClr val="111111"/>
                 </a:solidFill>
@@ -8523,7 +8169,7 @@
               </a:defRPr>
             </a:lvl1pPr>
             <a:lvl2pPr>
-              <a:defRPr sz="1875" b="0">
+              <a:defRPr sz="2025" b="0">
                 <a:solidFill>
                   <a:srgbClr val="111111"/>
                 </a:solidFill>
@@ -8533,7 +8179,7 @@
               </a:defRPr>
             </a:lvl2pPr>
             <a:lvl3pPr>
-              <a:defRPr sz="1875" b="0">
+              <a:defRPr sz="2025" b="0">
                 <a:solidFill>
                   <a:srgbClr val="111111"/>
                 </a:solidFill>
@@ -8543,7 +8189,7 @@
               </a:defRPr>
             </a:lvl3pPr>
             <a:lvl4pPr>
-              <a:defRPr sz="1875" b="0">
+              <a:defRPr sz="2025" b="0">
                 <a:solidFill>
                   <a:srgbClr val="111111"/>
                 </a:solidFill>
@@ -8553,7 +8199,7 @@
               </a:defRPr>
             </a:lvl4pPr>
             <a:lvl5pPr>
-              <a:defRPr sz="1875" b="0">
+              <a:defRPr sz="2025" b="0">
                 <a:solidFill>
                   <a:srgbClr val="111111"/>
                 </a:solidFill>
@@ -8563,7 +8209,7 @@
               </a:defRPr>
             </a:lvl5pPr>
             <a:lvl6pPr>
-              <a:defRPr sz="1875" b="0">
+              <a:defRPr sz="2025" b="0">
                 <a:solidFill>
                   <a:srgbClr val="111111"/>
                 </a:solidFill>
@@ -8573,7 +8219,7 @@
               </a:defRPr>
             </a:lvl6pPr>
             <a:lvl7pPr>
-              <a:defRPr sz="1875" b="0">
+              <a:defRPr sz="2025" b="0">
                 <a:solidFill>
                   <a:srgbClr val="111111"/>
                 </a:solidFill>
@@ -8583,7 +8229,7 @@
               </a:defRPr>
             </a:lvl7pPr>
             <a:lvl8pPr>
-              <a:defRPr sz="1875" b="0">
+              <a:defRPr sz="2025" b="0">
                 <a:solidFill>
                   <a:srgbClr val="111111"/>
                 </a:solidFill>
@@ -8593,7 +8239,7 @@
               </a:defRPr>
             </a:lvl8pPr>
             <a:lvl9pPr>
-              <a:defRPr sz="1875" b="0">
+              <a:defRPr sz="2025" b="0">
                 <a:solidFill>
                   <a:srgbClr val="111111"/>
                 </a:solidFill>
@@ -8605,7 +8251,7 @@
           </a:lstStyle>
           <a:p xmlns:a="http://schemas.openxmlformats.org/drawingml/2006/main">
             <a:pPr>
-              <a:defRPr sz="1875" b="0">
+              <a:defRPr sz="2025" b="0">
                 <a:solidFill>
                   <a:srgbClr val="111111"/>
                 </a:solidFill>
@@ -8615,7 +8261,7 @@
               </a:defRPr>
             </a:pPr>
             <a:r>
-              <a:rPr sz="1875" b="0">
+              <a:rPr sz="2025" b="0">
                 <a:solidFill>
                   <a:srgbClr val="111111"/>
                 </a:solidFill>
@@ -8623,12 +8269,12 @@
                 <a:ea typeface="Inter"/>
                 <a:cs typeface="Inter"/>
               </a:rPr>
-              <a:t>Root hair candidate</a:t>
+              <a:t>Cell map</a:t>
             </a:r>
           </a:p>
           <a:p xmlns:a="http://schemas.openxmlformats.org/drawingml/2006/main">
             <a:pPr>
-              <a:defRPr sz="1875" b="0">
+              <a:defRPr sz="2025" b="0">
                 <a:solidFill>
                   <a:srgbClr val="111111"/>
                 </a:solidFill>
@@ -8638,7 +8284,7 @@
               </a:defRPr>
             </a:pPr>
             <a:r>
-              <a:rPr sz="1875" b="0">
+              <a:rPr sz="2025" b="0">
                 <a:solidFill>
                   <a:srgbClr val="111111"/>
                 </a:solidFill>
@@ -8646,12 +8292,12 @@
                 <a:ea typeface="Inter"/>
                 <a:cs typeface="Inter"/>
               </a:rPr>
-              <a:t>2 supporting genes</a:t>
+              <a:t>Supporting genes</a:t>
             </a:r>
           </a:p>
           <a:p xmlns:a="http://schemas.openxmlformats.org/drawingml/2006/main">
             <a:pPr>
-              <a:defRPr sz="1875" b="0">
+              <a:defRPr sz="2025" b="0">
                 <a:solidFill>
                   <a:srgbClr val="111111"/>
                 </a:solidFill>
@@ -8661,7 +8307,7 @@
               </a:defRPr>
             </a:pPr>
             <a:r>
-              <a:rPr sz="1875" b="0">
+              <a:rPr sz="2025" b="0">
                 <a:solidFill>
                   <a:srgbClr val="111111"/>
                 </a:solidFill>
@@ -8669,17 +8315,17 @@
                 <a:ea typeface="Inter"/>
                 <a:cs typeface="Inter"/>
               </a:rPr>
-              <a:t>Links to the evidence</a:t>
+              <a:t>Source links</a:t>
             </a:r>
           </a:p>
         </p:txBody>
       </p:sp>
       <p:sp>
         <p:nvSpPr>
-          <p:cNvPr id="17" name="copy-36">
+          <p:cNvPr id="16" name="copy-34">
             <a:extLst xmlns:a="http://schemas.openxmlformats.org/drawingml/2006/main">
               <a:ext uri="{FF2B5EF4-FFF2-40B4-BE49-F238E27FC236}">
-                <a16:creationId xmlns:a16="http://schemas.microsoft.com/office/drawing/2014/main" id="{6652F4D3-E1ED-49CF-AE12-E9F5EEC731C4}"/>
+                <a16:creationId xmlns:a16="http://schemas.microsoft.com/office/drawing/2014/main" id="{C302DCCD-D9EF-4D59-9B71-7A8CC8BA2BB4}"/>
               </a:ext>
             </a:extLst>
           </p:cNvPr>
@@ -8690,7 +8336,7 @@
         </p:nvSpPr>
         <p:spPr>
           <a:xfrm xmlns:a="http://schemas.openxmlformats.org/drawingml/2006/main">
-            <a:off x="552450" y="6238875"/>
+            <a:off x="552450" y="6172200"/>
             <a:ext cx="11087100" cy="409575"/>
           </a:xfrm>
           <a:prstGeom xmlns:a="http://schemas.openxmlformats.org/drawingml/2006/main" prst="rect">
@@ -8707,7 +8353,7 @@
           </a:bodyPr>
           <a:lstStyle xmlns:a="http://schemas.openxmlformats.org/drawingml/2006/main">
             <a:defPPr>
-              <a:defRPr sz="1950" b="0">
+              <a:defRPr sz="2100" b="0">
                 <a:solidFill>
                   <a:srgbClr val="111111"/>
                 </a:solidFill>
@@ -8717,7 +8363,7 @@
               </a:defRPr>
             </a:defPPr>
             <a:lvl1pPr>
-              <a:defRPr sz="1950" b="0">
+              <a:defRPr sz="2100" b="0">
                 <a:solidFill>
                   <a:srgbClr val="111111"/>
                 </a:solidFill>
@@ -8727,7 +8373,7 @@
               </a:defRPr>
             </a:lvl1pPr>
             <a:lvl2pPr>
-              <a:defRPr sz="1950" b="0">
+              <a:defRPr sz="2100" b="0">
                 <a:solidFill>
                   <a:srgbClr val="111111"/>
                 </a:solidFill>
@@ -8737,7 +8383,7 @@
               </a:defRPr>
             </a:lvl2pPr>
             <a:lvl3pPr>
-              <a:defRPr sz="1950" b="0">
+              <a:defRPr sz="2100" b="0">
                 <a:solidFill>
                   <a:srgbClr val="111111"/>
                 </a:solidFill>
@@ -8747,7 +8393,7 @@
               </a:defRPr>
             </a:lvl3pPr>
             <a:lvl4pPr>
-              <a:defRPr sz="1950" b="0">
+              <a:defRPr sz="2100" b="0">
                 <a:solidFill>
                   <a:srgbClr val="111111"/>
                 </a:solidFill>
@@ -8757,7 +8403,7 @@
               </a:defRPr>
             </a:lvl4pPr>
             <a:lvl5pPr>
-              <a:defRPr sz="1950" b="0">
+              <a:defRPr sz="2100" b="0">
                 <a:solidFill>
                   <a:srgbClr val="111111"/>
                 </a:solidFill>
@@ -8767,7 +8413,7 @@
               </a:defRPr>
             </a:lvl5pPr>
             <a:lvl6pPr>
-              <a:defRPr sz="1950" b="0">
+              <a:defRPr sz="2100" b="0">
                 <a:solidFill>
                   <a:srgbClr val="111111"/>
                 </a:solidFill>
@@ -8777,7 +8423,7 @@
               </a:defRPr>
             </a:lvl6pPr>
             <a:lvl7pPr>
-              <a:defRPr sz="1950" b="0">
+              <a:defRPr sz="2100" b="0">
                 <a:solidFill>
                   <a:srgbClr val="111111"/>
                 </a:solidFill>
@@ -8787,7 +8433,7 @@
               </a:defRPr>
             </a:lvl7pPr>
             <a:lvl8pPr>
-              <a:defRPr sz="1950" b="0">
+              <a:defRPr sz="2100" b="0">
                 <a:solidFill>
                   <a:srgbClr val="111111"/>
                 </a:solidFill>
@@ -8797,7 +8443,7 @@
               </a:defRPr>
             </a:lvl8pPr>
             <a:lvl9pPr>
-              <a:defRPr sz="1950" b="0">
+              <a:defRPr sz="2100" b="0">
                 <a:solidFill>
                   <a:srgbClr val="111111"/>
                 </a:solidFill>
@@ -8809,7 +8455,7 @@
           </a:lstStyle>
           <a:p xmlns:a="http://schemas.openxmlformats.org/drawingml/2006/main">
             <a:pPr>
-              <a:defRPr sz="1950" b="0">
+              <a:defRPr sz="2100" b="0">
                 <a:solidFill>
                   <a:srgbClr val="111111"/>
                 </a:solidFill>
@@ -8819,7 +8465,7 @@
               </a:defRPr>
             </a:pPr>
             <a:r>
-              <a:rPr sz="1950" b="0">
+              <a:rPr sz="2100" b="0">
                 <a:solidFill>
                   <a:srgbClr val="111111"/>
                 </a:solidFill>
@@ -8827,7 +8473,7 @@
                 <a:ea typeface="Inter"/>
                 <a:cs typeface="Inter"/>
               </a:rPr>
-              <a:t>Annotation suggests the identity. The journal keeps your judgment.</a:t>
+              <a:t>You review the evidence and save your decision.</a:t>
             </a:r>
           </a:p>
         </p:txBody>
@@ -8835,7 +8481,7 @@
     </p:spTree>
     <p:extLst>
       <p:ext uri="{BB962C8B-B14F-4D97-AF65-F5344CB8AC3E}">
-        <p14:creationId xmlns:p14="http://schemas.microsoft.com/office/powerpoint/2010/main" val="1611020421"/>
+        <p14:creationId xmlns:p14="http://schemas.microsoft.com/office/powerpoint/2010/main" val="1020874434"/>
       </p:ext>
     </p:extLst>
   </p:cSld>
@@ -8863,10 +8509,10 @@
       </p:grpSpPr>
       <p:sp>
         <p:nvSpPr>
-          <p:cNvPr id="14" name="copy-37">
+          <p:cNvPr id="12" name="copy-35">
             <a:extLst xmlns:a="http://schemas.openxmlformats.org/drawingml/2006/main">
               <a:ext uri="{FF2B5EF4-FFF2-40B4-BE49-F238E27FC236}">
-                <a16:creationId xmlns:a16="http://schemas.microsoft.com/office/drawing/2014/main" id="{59BC21FD-FC09-486B-B91E-C6F60C4D5902}"/>
+                <a16:creationId xmlns:a16="http://schemas.microsoft.com/office/drawing/2014/main" id="{94F7065F-F657-4019-92CB-22EF801D5FBB}"/>
               </a:ext>
             </a:extLst>
           </p:cNvPr>
@@ -9021,10 +8667,10 @@
       </p:sp>
       <p:sp>
         <p:nvSpPr>
-          <p:cNvPr id="2" name="copy-38">
+          <p:cNvPr id="2" name="copy-36">
             <a:extLst xmlns:a="http://schemas.openxmlformats.org/drawingml/2006/main">
               <a:ext uri="{FF2B5EF4-FFF2-40B4-BE49-F238E27FC236}">
-                <a16:creationId xmlns:a16="http://schemas.microsoft.com/office/drawing/2014/main" id="{9A4B30CA-426F-4192-8595-4939804FB638}"/>
+                <a16:creationId xmlns:a16="http://schemas.microsoft.com/office/drawing/2014/main" id="{598F4407-745E-448E-9E6C-1C6EAB9E527E}"/>
               </a:ext>
             </a:extLst>
           </p:cNvPr>
@@ -9172,17 +8818,17 @@
                 <a:ea typeface="Inter"/>
                 <a:cs typeface="Inter"/>
               </a:rPr>
-              <a:t>The research journal keeps the decision attached to its evidence.</a:t>
+              <a:t>The agent recalls your latest decision and links to its source.</a:t>
             </a:r>
           </a:p>
         </p:txBody>
       </p:sp>
       <p:sp>
         <p:nvSpPr>
-          <p:cNvPr id="3" name="copy-39">
+          <p:cNvPr id="3" name="copy-37">
             <a:extLst xmlns:a="http://schemas.openxmlformats.org/drawingml/2006/main">
               <a:ext uri="{FF2B5EF4-FFF2-40B4-BE49-F238E27FC236}">
-                <a16:creationId xmlns:a16="http://schemas.microsoft.com/office/drawing/2014/main" id="{356CC0B6-54FC-427D-B643-83F5BE140E4C}"/>
+                <a16:creationId xmlns:a16="http://schemas.microsoft.com/office/drawing/2014/main" id="{160B9BA7-06BF-4AF7-8FFB-BED151A722AF}"/>
               </a:ext>
             </a:extLst>
           </p:cNvPr>
@@ -9193,7 +8839,7 @@
         </p:nvSpPr>
         <p:spPr>
           <a:xfrm xmlns:a="http://schemas.openxmlformats.org/drawingml/2006/main">
-            <a:off x="552450" y="2228850"/>
+            <a:off x="552450" y="2286000"/>
             <a:ext cx="11087100" cy="314325"/>
           </a:xfrm>
           <a:prstGeom xmlns:a="http://schemas.openxmlformats.org/drawingml/2006/main" prst="rect">
@@ -9330,17 +8976,17 @@
                 <a:ea typeface="Inter"/>
                 <a:cs typeface="Inter"/>
               </a:rPr>
-              <a:t>Actual agent reply after a demo review</a:t>
+              <a:t>Actual agent reply</a:t>
             </a:r>
           </a:p>
         </p:txBody>
       </p:sp>
       <p:sp>
         <p:nvSpPr>
-          <p:cNvPr id="4" name="copy-40">
+          <p:cNvPr id="4" name="copy-38">
             <a:extLst xmlns:a="http://schemas.openxmlformats.org/drawingml/2006/main">
               <a:ext uri="{FF2B5EF4-FFF2-40B4-BE49-F238E27FC236}">
-                <a16:creationId xmlns:a16="http://schemas.microsoft.com/office/drawing/2014/main" id="{C09246AB-0122-4E1F-B058-930022F718DB}"/>
+                <a16:creationId xmlns:a16="http://schemas.microsoft.com/office/drawing/2014/main" id="{87E76C6C-DBA0-436A-BB0D-0048DA1D766C}"/>
               </a:ext>
             </a:extLst>
           </p:cNvPr>
@@ -9351,8 +8997,8 @@
         </p:nvSpPr>
         <p:spPr>
           <a:xfrm xmlns:a="http://schemas.openxmlformats.org/drawingml/2006/main">
-            <a:off x="552450" y="2667000"/>
-            <a:ext cx="11087100" cy="1028700"/>
+            <a:off x="552450" y="2800350"/>
+            <a:ext cx="11087100" cy="1152525"/>
           </a:xfrm>
           <a:prstGeom xmlns:a="http://schemas.openxmlformats.org/drawingml/2006/main" prst="rect">
             <a:avLst/>
@@ -9368,7 +9014,7 @@
           </a:bodyPr>
           <a:lstStyle xmlns:a="http://schemas.openxmlformats.org/drawingml/2006/main">
             <a:defPPr>
-              <a:defRPr sz="2100" b="0">
+              <a:defRPr sz="2175" b="0">
                 <a:solidFill>
                   <a:srgbClr val="111111"/>
                 </a:solidFill>
@@ -9378,7 +9024,7 @@
               </a:defRPr>
             </a:defPPr>
             <a:lvl1pPr>
-              <a:defRPr sz="2100" b="0">
+              <a:defRPr sz="2175" b="0">
                 <a:solidFill>
                   <a:srgbClr val="111111"/>
                 </a:solidFill>
@@ -9388,7 +9034,7 @@
               </a:defRPr>
             </a:lvl1pPr>
             <a:lvl2pPr>
-              <a:defRPr sz="2100" b="0">
+              <a:defRPr sz="2175" b="0">
                 <a:solidFill>
                   <a:srgbClr val="111111"/>
                 </a:solidFill>
@@ -9398,7 +9044,7 @@
               </a:defRPr>
             </a:lvl2pPr>
             <a:lvl3pPr>
-              <a:defRPr sz="2100" b="0">
+              <a:defRPr sz="2175" b="0">
                 <a:solidFill>
                   <a:srgbClr val="111111"/>
                 </a:solidFill>
@@ -9408,7 +9054,7 @@
               </a:defRPr>
             </a:lvl3pPr>
             <a:lvl4pPr>
-              <a:defRPr sz="2100" b="0">
+              <a:defRPr sz="2175" b="0">
                 <a:solidFill>
                   <a:srgbClr val="111111"/>
                 </a:solidFill>
@@ -9418,7 +9064,7 @@
               </a:defRPr>
             </a:lvl4pPr>
             <a:lvl5pPr>
-              <a:defRPr sz="2100" b="0">
+              <a:defRPr sz="2175" b="0">
                 <a:solidFill>
                   <a:srgbClr val="111111"/>
                 </a:solidFill>
@@ -9428,7 +9074,7 @@
               </a:defRPr>
             </a:lvl5pPr>
             <a:lvl6pPr>
-              <a:defRPr sz="2100" b="0">
+              <a:defRPr sz="2175" b="0">
                 <a:solidFill>
                   <a:srgbClr val="111111"/>
                 </a:solidFill>
@@ -9438,7 +9084,7 @@
               </a:defRPr>
             </a:lvl6pPr>
             <a:lvl7pPr>
-              <a:defRPr sz="2100" b="0">
+              <a:defRPr sz="2175" b="0">
                 <a:solidFill>
                   <a:srgbClr val="111111"/>
                 </a:solidFill>
@@ -9448,7 +9094,7 @@
               </a:defRPr>
             </a:lvl7pPr>
             <a:lvl8pPr>
-              <a:defRPr sz="2100" b="0">
+              <a:defRPr sz="2175" b="0">
                 <a:solidFill>
                   <a:srgbClr val="111111"/>
                 </a:solidFill>
@@ -9458,7 +9104,7 @@
               </a:defRPr>
             </a:lvl8pPr>
             <a:lvl9pPr>
-              <a:defRPr sz="2100" b="0">
+              <a:defRPr sz="2175" b="0">
                 <a:solidFill>
                   <a:srgbClr val="111111"/>
                 </a:solidFill>
@@ -9470,7 +9116,7 @@
           </a:lstStyle>
           <a:p xmlns:a="http://schemas.openxmlformats.org/drawingml/2006/main">
             <a:pPr>
-              <a:defRPr sz="2100" b="0">
+              <a:defRPr sz="2175" b="0">
                 <a:solidFill>
                   <a:srgbClr val="111111"/>
                 </a:solidFill>
@@ -9480,7 +9126,7 @@
               </a:defRPr>
             </a:pPr>
             <a:r>
-              <a:rPr sz="2100" b="0">
+              <a:rPr sz="2175" b="0">
                 <a:solidFill>
                   <a:srgbClr val="111111"/>
                 </a:solidFill>
@@ -9495,10 +9141,10 @@
       </p:sp>
       <p:sp>
         <p:nvSpPr>
-          <p:cNvPr id="5" name="copy-41">
+          <p:cNvPr id="5" name="copy-39">
             <a:extLst xmlns:a="http://schemas.openxmlformats.org/drawingml/2006/main">
               <a:ext uri="{FF2B5EF4-FFF2-40B4-BE49-F238E27FC236}">
-                <a16:creationId xmlns:a16="http://schemas.microsoft.com/office/drawing/2014/main" id="{BBEFB007-4E66-46FA-9A0B-852FD98C7D51}"/>
+                <a16:creationId xmlns:a16="http://schemas.microsoft.com/office/drawing/2014/main" id="{5B53936B-BABA-400B-8123-42992C7EDA8F}"/>
               </a:ext>
             </a:extLst>
           </p:cNvPr>
@@ -9509,7 +9155,7 @@
         </p:nvSpPr>
         <p:spPr>
           <a:xfrm xmlns:a="http://schemas.openxmlformats.org/drawingml/2006/main">
-            <a:off x="552450" y="3667125"/>
+            <a:off x="552450" y="3981450"/>
             <a:ext cx="11087100" cy="352425"/>
           </a:xfrm>
           <a:prstGeom xmlns:a="http://schemas.openxmlformats.org/drawingml/2006/main" prst="rect">
@@ -9645,7 +9291,7 @@
                 <a:latin typeface="Inter"/>
                 <a:ea typeface="Inter"/>
                 <a:cs typeface="Inter"/>
-                <a:hlinkClick xmlns:r="http://schemas.openxmlformats.org/officeDocument/2006/relationships" r:id="Rf1e771b4b3ce47ea"/>
+                <a:hlinkClick xmlns:r="http://schemas.openxmlformats.org/officeDocument/2006/relationships" r:id="Rfa0665f5669b49ba"/>
               </a:rPr>
               <a:t>Open the reply and its saved-review source</a:t>
             </a:r>
@@ -9654,10 +9300,10 @@
       </p:sp>
       <p:sp>
         <p:nvSpPr>
-          <p:cNvPr id="6" name="copy-42">
+          <p:cNvPr id="6" name="copy-40">
             <a:extLst xmlns:a="http://schemas.openxmlformats.org/drawingml/2006/main">
               <a:ext uri="{FF2B5EF4-FFF2-40B4-BE49-F238E27FC236}">
-                <a16:creationId xmlns:a16="http://schemas.microsoft.com/office/drawing/2014/main" id="{B36CECFB-8100-4EA5-86D5-C16744B9BA47}"/>
+                <a16:creationId xmlns:a16="http://schemas.microsoft.com/office/drawing/2014/main" id="{27DF9C1C-EE4C-4ECE-94E6-72193D9666D0}"/>
               </a:ext>
             </a:extLst>
           </p:cNvPr>
@@ -9668,7 +9314,7 @@
         </p:nvSpPr>
         <p:spPr>
           <a:xfrm xmlns:a="http://schemas.openxmlformats.org/drawingml/2006/main">
-            <a:off x="552450" y="4295775"/>
+            <a:off x="552450" y="4533900"/>
             <a:ext cx="4953000" cy="361950"/>
           </a:xfrm>
           <a:prstGeom xmlns:a="http://schemas.openxmlformats.org/drawingml/2006/main" prst="rect">
@@ -9812,10 +9458,10 @@
       </p:sp>
       <p:sp>
         <p:nvSpPr>
-          <p:cNvPr id="7" name="copy-43">
+          <p:cNvPr id="7" name="copy-41">
             <a:extLst xmlns:a="http://schemas.openxmlformats.org/drawingml/2006/main">
               <a:ext uri="{FF2B5EF4-FFF2-40B4-BE49-F238E27FC236}">
-                <a16:creationId xmlns:a16="http://schemas.microsoft.com/office/drawing/2014/main" id="{F846373C-D9B5-4F3D-B363-54E355A9CC65}"/>
+                <a16:creationId xmlns:a16="http://schemas.microsoft.com/office/drawing/2014/main" id="{CDE0BCC8-35B1-4360-80CA-53FA194DC67E}"/>
               </a:ext>
             </a:extLst>
           </p:cNvPr>
@@ -9826,8 +9472,8 @@
         </p:nvSpPr>
         <p:spPr>
           <a:xfrm xmlns:a="http://schemas.openxmlformats.org/drawingml/2006/main">
-            <a:off x="552450" y="4705350"/>
-            <a:ext cx="4953000" cy="666750"/>
+            <a:off x="552450" y="5010150"/>
+            <a:ext cx="4953000" cy="704850"/>
           </a:xfrm>
           <a:prstGeom xmlns:a="http://schemas.openxmlformats.org/drawingml/2006/main" prst="rect">
             <a:avLst/>
@@ -9843,7 +9489,7 @@
           </a:bodyPr>
           <a:lstStyle xmlns:a="http://schemas.openxmlformats.org/drawingml/2006/main">
             <a:defPPr>
-              <a:defRPr sz="3600" b="1">
+              <a:defRPr sz="3825" b="1">
                 <a:solidFill>
                   <a:srgbClr val="111111"/>
                 </a:solidFill>
@@ -9853,7 +9499,7 @@
               </a:defRPr>
             </a:defPPr>
             <a:lvl1pPr>
-              <a:defRPr sz="3600" b="1">
+              <a:defRPr sz="3825" b="1">
                 <a:solidFill>
                   <a:srgbClr val="111111"/>
                 </a:solidFill>
@@ -9863,7 +9509,7 @@
               </a:defRPr>
             </a:lvl1pPr>
             <a:lvl2pPr>
-              <a:defRPr sz="3600" b="1">
+              <a:defRPr sz="3825" b="1">
                 <a:solidFill>
                   <a:srgbClr val="111111"/>
                 </a:solidFill>
@@ -9873,7 +9519,7 @@
               </a:defRPr>
             </a:lvl2pPr>
             <a:lvl3pPr>
-              <a:defRPr sz="3600" b="1">
+              <a:defRPr sz="3825" b="1">
                 <a:solidFill>
                   <a:srgbClr val="111111"/>
                 </a:solidFill>
@@ -9883,7 +9529,7 @@
               </a:defRPr>
             </a:lvl3pPr>
             <a:lvl4pPr>
-              <a:defRPr sz="3600" b="1">
+              <a:defRPr sz="3825" b="1">
                 <a:solidFill>
                   <a:srgbClr val="111111"/>
                 </a:solidFill>
@@ -9893,7 +9539,7 @@
               </a:defRPr>
             </a:lvl4pPr>
             <a:lvl5pPr>
-              <a:defRPr sz="3600" b="1">
+              <a:defRPr sz="3825" b="1">
                 <a:solidFill>
                   <a:srgbClr val="111111"/>
                 </a:solidFill>
@@ -9903,7 +9549,7 @@
               </a:defRPr>
             </a:lvl5pPr>
             <a:lvl6pPr>
-              <a:defRPr sz="3600" b="1">
+              <a:defRPr sz="3825" b="1">
                 <a:solidFill>
                   <a:srgbClr val="111111"/>
                 </a:solidFill>
@@ -9913,7 +9559,7 @@
               </a:defRPr>
             </a:lvl6pPr>
             <a:lvl7pPr>
-              <a:defRPr sz="3600" b="1">
+              <a:defRPr sz="3825" b="1">
                 <a:solidFill>
                   <a:srgbClr val="111111"/>
                 </a:solidFill>
@@ -9923,7 +9569,7 @@
               </a:defRPr>
             </a:lvl7pPr>
             <a:lvl8pPr>
-              <a:defRPr sz="3600" b="1">
+              <a:defRPr sz="3825" b="1">
                 <a:solidFill>
                   <a:srgbClr val="111111"/>
                 </a:solidFill>
@@ -9933,7 +9579,7 @@
               </a:defRPr>
             </a:lvl8pPr>
             <a:lvl9pPr>
-              <a:defRPr sz="3600" b="1">
+              <a:defRPr sz="3825" b="1">
                 <a:solidFill>
                   <a:srgbClr val="111111"/>
                 </a:solidFill>
@@ -9945,7 +9591,7 @@
           </a:lstStyle>
           <a:p xmlns:a="http://schemas.openxmlformats.org/drawingml/2006/main">
             <a:pPr>
-              <a:defRPr sz="3600" b="1">
+              <a:defRPr sz="3825" b="1">
                 <a:solidFill>
                   <a:srgbClr val="111111"/>
                 </a:solidFill>
@@ -9955,7 +9601,7 @@
               </a:defRPr>
             </a:pPr>
             <a:r>
-              <a:rPr sz="3600" b="1">
+              <a:rPr sz="3825" b="1">
                 <a:solidFill>
                   <a:srgbClr val="111111"/>
                 </a:solidFill>
@@ -9970,10 +9616,10 @@
       </p:sp>
       <p:sp>
         <p:nvSpPr>
-          <p:cNvPr id="8" name="copy-44">
+          <p:cNvPr id="8" name="copy-42">
             <a:extLst xmlns:a="http://schemas.openxmlformats.org/drawingml/2006/main">
               <a:ext uri="{FF2B5EF4-FFF2-40B4-BE49-F238E27FC236}">
-                <a16:creationId xmlns:a16="http://schemas.microsoft.com/office/drawing/2014/main" id="{2B3F87F0-8E1A-4A85-BA93-279E1B702CDD}"/>
+                <a16:creationId xmlns:a16="http://schemas.microsoft.com/office/drawing/2014/main" id="{B41745BD-65FF-4650-961A-5DBBD7BA1586}"/>
               </a:ext>
             </a:extLst>
           </p:cNvPr>
@@ -9984,7 +9630,7 @@
         </p:nvSpPr>
         <p:spPr>
           <a:xfrm xmlns:a="http://schemas.openxmlformats.org/drawingml/2006/main">
-            <a:off x="6686550" y="4295775"/>
+            <a:off x="6686550" y="4533900"/>
             <a:ext cx="4953000" cy="361950"/>
           </a:xfrm>
           <a:prstGeom xmlns:a="http://schemas.openxmlformats.org/drawingml/2006/main" prst="rect">
@@ -10128,10 +9774,10 @@
       </p:sp>
       <p:sp>
         <p:nvSpPr>
-          <p:cNvPr id="9" name="copy-45">
+          <p:cNvPr id="9" name="copy-43">
             <a:extLst xmlns:a="http://schemas.openxmlformats.org/drawingml/2006/main">
               <a:ext uri="{FF2B5EF4-FFF2-40B4-BE49-F238E27FC236}">
-                <a16:creationId xmlns:a16="http://schemas.microsoft.com/office/drawing/2014/main" id="{F18924CB-ACD7-44D2-9DE1-07754BFBD1A1}"/>
+                <a16:creationId xmlns:a16="http://schemas.microsoft.com/office/drawing/2014/main" id="{A2CCE58B-76BD-4677-8A44-4FA49F17B209}"/>
               </a:ext>
             </a:extLst>
           </p:cNvPr>
@@ -10142,8 +9788,8 @@
         </p:nvSpPr>
         <p:spPr>
           <a:xfrm xmlns:a="http://schemas.openxmlformats.org/drawingml/2006/main">
-            <a:off x="6686550" y="4705350"/>
-            <a:ext cx="4953000" cy="666750"/>
+            <a:off x="6686550" y="5010150"/>
+            <a:ext cx="4953000" cy="704850"/>
           </a:xfrm>
           <a:prstGeom xmlns:a="http://schemas.openxmlformats.org/drawingml/2006/main" prst="rect">
             <a:avLst/>
@@ -10159,7 +9805,7 @@
           </a:bodyPr>
           <a:lstStyle xmlns:a="http://schemas.openxmlformats.org/drawingml/2006/main">
             <a:defPPr>
-              <a:defRPr sz="3600" b="1">
+              <a:defRPr sz="3825" b="1">
                 <a:solidFill>
                   <a:srgbClr val="1B5E20"/>
                 </a:solidFill>
@@ -10169,7 +9815,7 @@
               </a:defRPr>
             </a:defPPr>
             <a:lvl1pPr>
-              <a:defRPr sz="3600" b="1">
+              <a:defRPr sz="3825" b="1">
                 <a:solidFill>
                   <a:srgbClr val="1B5E20"/>
                 </a:solidFill>
@@ -10179,7 +9825,7 @@
               </a:defRPr>
             </a:lvl1pPr>
             <a:lvl2pPr>
-              <a:defRPr sz="3600" b="1">
+              <a:defRPr sz="3825" b="1">
                 <a:solidFill>
                   <a:srgbClr val="1B5E20"/>
                 </a:solidFill>
@@ -10189,7 +9835,7 @@
               </a:defRPr>
             </a:lvl2pPr>
             <a:lvl3pPr>
-              <a:defRPr sz="3600" b="1">
+              <a:defRPr sz="3825" b="1">
                 <a:solidFill>
                   <a:srgbClr val="1B5E20"/>
                 </a:solidFill>
@@ -10199,7 +9845,7 @@
               </a:defRPr>
             </a:lvl3pPr>
             <a:lvl4pPr>
-              <a:defRPr sz="3600" b="1">
+              <a:defRPr sz="3825" b="1">
                 <a:solidFill>
                   <a:srgbClr val="1B5E20"/>
                 </a:solidFill>
@@ -10209,7 +9855,7 @@
               </a:defRPr>
             </a:lvl4pPr>
             <a:lvl5pPr>
-              <a:defRPr sz="3600" b="1">
+              <a:defRPr sz="3825" b="1">
                 <a:solidFill>
                   <a:srgbClr val="1B5E20"/>
                 </a:solidFill>
@@ -10219,7 +9865,7 @@
               </a:defRPr>
             </a:lvl5pPr>
             <a:lvl6pPr>
-              <a:defRPr sz="3600" b="1">
+              <a:defRPr sz="3825" b="1">
                 <a:solidFill>
                   <a:srgbClr val="1B5E20"/>
                 </a:solidFill>
@@ -10229,7 +9875,7 @@
               </a:defRPr>
             </a:lvl6pPr>
             <a:lvl7pPr>
-              <a:defRPr sz="3600" b="1">
+              <a:defRPr sz="3825" b="1">
                 <a:solidFill>
                   <a:srgbClr val="1B5E20"/>
                 </a:solidFill>
@@ -10239,7 +9885,7 @@
               </a:defRPr>
             </a:lvl7pPr>
             <a:lvl8pPr>
-              <a:defRPr sz="3600" b="1">
+              <a:defRPr sz="3825" b="1">
                 <a:solidFill>
                   <a:srgbClr val="1B5E20"/>
                 </a:solidFill>
@@ -10249,7 +9895,7 @@
               </a:defRPr>
             </a:lvl8pPr>
             <a:lvl9pPr>
-              <a:defRPr sz="3600" b="1">
+              <a:defRPr sz="3825" b="1">
                 <a:solidFill>
                   <a:srgbClr val="1B5E20"/>
                 </a:solidFill>
@@ -10261,7 +9907,7 @@
           </a:lstStyle>
           <a:p xmlns:a="http://schemas.openxmlformats.org/drawingml/2006/main">
             <a:pPr>
-              <a:defRPr sz="3600" b="1">
+              <a:defRPr sz="3825" b="1">
                 <a:solidFill>
                   <a:srgbClr val="1B5E20"/>
                 </a:solidFill>
@@ -10271,7 +9917,7 @@
               </a:defRPr>
             </a:pPr>
             <a:r>
-              <a:rPr sz="3600" b="1">
+              <a:rPr sz="3825" b="1">
                 <a:solidFill>
                   <a:srgbClr val="1B5E20"/>
                 </a:solidFill>
@@ -10286,10 +9932,10 @@
       </p:sp>
       <p:sp>
         <p:nvSpPr>
-          <p:cNvPr id="10" name="copy-46">
+          <p:cNvPr id="10" name="copy-44">
             <a:extLst xmlns:a="http://schemas.openxmlformats.org/drawingml/2006/main">
               <a:ext uri="{FF2B5EF4-FFF2-40B4-BE49-F238E27FC236}">
-                <a16:creationId xmlns:a16="http://schemas.microsoft.com/office/drawing/2014/main" id="{35C8FD8B-860F-4403-9048-EFEE4B90AAF1}"/>
+                <a16:creationId xmlns:a16="http://schemas.microsoft.com/office/drawing/2014/main" id="{1279840C-05BF-4C01-A80C-800150690D77}"/>
               </a:ext>
             </a:extLst>
           </p:cNvPr>
@@ -10300,8 +9946,166 @@
         </p:nvSpPr>
         <p:spPr>
           <a:xfrm xmlns:a="http://schemas.openxmlformats.org/drawingml/2006/main">
-            <a:off x="552450" y="5619750"/>
-            <a:ext cx="11087100" cy="342900"/>
+            <a:off x="552450" y="6210300"/>
+            <a:ext cx="5905500" cy="447675"/>
+          </a:xfrm>
+          <a:prstGeom xmlns:a="http://schemas.openxmlformats.org/drawingml/2006/main" prst="rect">
+            <a:avLst/>
+          </a:prstGeom>
+          <a:noFill xmlns:a="http://schemas.openxmlformats.org/drawingml/2006/main"/>
+          <a:ln xmlns:a="http://schemas.openxmlformats.org/drawingml/2006/main" w="0">
+            <a:noFill/>
+          </a:ln>
+        </p:spPr>
+        <p:txBody>
+          <a:bodyPr xmlns:a="http://schemas.openxmlformats.org/drawingml/2006/main" wrap="square" lIns="0" tIns="0" rIns="0" bIns="0">
+            <a:noAutofit/>
+          </a:bodyPr>
+          <a:lstStyle xmlns:a="http://schemas.openxmlformats.org/drawingml/2006/main">
+            <a:defPPr>
+              <a:defRPr sz="2400" b="1">
+                <a:solidFill>
+                  <a:srgbClr val="1B5E20"/>
+                </a:solidFill>
+                <a:latin typeface="Inter"/>
+                <a:ea typeface="Inter"/>
+                <a:cs typeface="Inter"/>
+              </a:defRPr>
+            </a:defPPr>
+            <a:lvl1pPr>
+              <a:defRPr sz="2400" b="1">
+                <a:solidFill>
+                  <a:srgbClr val="1B5E20"/>
+                </a:solidFill>
+                <a:latin typeface="Inter"/>
+                <a:ea typeface="Inter"/>
+                <a:cs typeface="Inter"/>
+              </a:defRPr>
+            </a:lvl1pPr>
+            <a:lvl2pPr>
+              <a:defRPr sz="2400" b="1">
+                <a:solidFill>
+                  <a:srgbClr val="1B5E20"/>
+                </a:solidFill>
+                <a:latin typeface="Inter"/>
+                <a:ea typeface="Inter"/>
+                <a:cs typeface="Inter"/>
+              </a:defRPr>
+            </a:lvl2pPr>
+            <a:lvl3pPr>
+              <a:defRPr sz="2400" b="1">
+                <a:solidFill>
+                  <a:srgbClr val="1B5E20"/>
+                </a:solidFill>
+                <a:latin typeface="Inter"/>
+                <a:ea typeface="Inter"/>
+                <a:cs typeface="Inter"/>
+              </a:defRPr>
+            </a:lvl3pPr>
+            <a:lvl4pPr>
+              <a:defRPr sz="2400" b="1">
+                <a:solidFill>
+                  <a:srgbClr val="1B5E20"/>
+                </a:solidFill>
+                <a:latin typeface="Inter"/>
+                <a:ea typeface="Inter"/>
+                <a:cs typeface="Inter"/>
+              </a:defRPr>
+            </a:lvl4pPr>
+            <a:lvl5pPr>
+              <a:defRPr sz="2400" b="1">
+                <a:solidFill>
+                  <a:srgbClr val="1B5E20"/>
+                </a:solidFill>
+                <a:latin typeface="Inter"/>
+                <a:ea typeface="Inter"/>
+                <a:cs typeface="Inter"/>
+              </a:defRPr>
+            </a:lvl5pPr>
+            <a:lvl6pPr>
+              <a:defRPr sz="2400" b="1">
+                <a:solidFill>
+                  <a:srgbClr val="1B5E20"/>
+                </a:solidFill>
+                <a:latin typeface="Inter"/>
+                <a:ea typeface="Inter"/>
+                <a:cs typeface="Inter"/>
+              </a:defRPr>
+            </a:lvl6pPr>
+            <a:lvl7pPr>
+              <a:defRPr sz="2400" b="1">
+                <a:solidFill>
+                  <a:srgbClr val="1B5E20"/>
+                </a:solidFill>
+                <a:latin typeface="Inter"/>
+                <a:ea typeface="Inter"/>
+                <a:cs typeface="Inter"/>
+              </a:defRPr>
+            </a:lvl7pPr>
+            <a:lvl8pPr>
+              <a:defRPr sz="2400" b="1">
+                <a:solidFill>
+                  <a:srgbClr val="1B5E20"/>
+                </a:solidFill>
+                <a:latin typeface="Inter"/>
+                <a:ea typeface="Inter"/>
+                <a:cs typeface="Inter"/>
+              </a:defRPr>
+            </a:lvl8pPr>
+            <a:lvl9pPr>
+              <a:defRPr sz="2400" b="1">
+                <a:solidFill>
+                  <a:srgbClr val="1B5E20"/>
+                </a:solidFill>
+                <a:latin typeface="Inter"/>
+                <a:ea typeface="Inter"/>
+                <a:cs typeface="Inter"/>
+              </a:defRPr>
+            </a:lvl9pPr>
+          </a:lstStyle>
+          <a:p xmlns:a="http://schemas.openxmlformats.org/drawingml/2006/main">
+            <a:pPr>
+              <a:defRPr sz="2400" b="1">
+                <a:solidFill>
+                  <a:srgbClr val="1B5E20"/>
+                </a:solidFill>
+                <a:latin typeface="Inter"/>
+                <a:ea typeface="Inter"/>
+                <a:cs typeface="Inter"/>
+              </a:defRPr>
+            </a:pPr>
+            <a:r>
+              <a:rPr sz="2400" b="1">
+                <a:solidFill>
+                  <a:srgbClr val="1B5E20"/>
+                </a:solidFill>
+                <a:latin typeface="Inter"/>
+                <a:ea typeface="Inter"/>
+                <a:cs typeface="Inter"/>
+              </a:rPr>
+              <a:t>celloras.com</a:t>
+            </a:r>
+          </a:p>
+        </p:txBody>
+      </p:sp>
+      <p:sp>
+        <p:nvSpPr>
+          <p:cNvPr id="11" name="copy-45">
+            <a:extLst xmlns:a="http://schemas.openxmlformats.org/drawingml/2006/main">
+              <a:ext uri="{FF2B5EF4-FFF2-40B4-BE49-F238E27FC236}">
+                <a16:creationId xmlns:a16="http://schemas.microsoft.com/office/drawing/2014/main" id="{4DAF4A1B-3F59-4C08-9524-78564A9980F0}"/>
+              </a:ext>
+            </a:extLst>
+          </p:cNvPr>
+          <p:cNvSpPr>
+            <a:spLocks xmlns:a="http://schemas.openxmlformats.org/drawingml/2006/main" noGrp="1"/>
+          </p:cNvSpPr>
+          <p:nvPr/>
+        </p:nvSpPr>
+        <p:spPr>
+          <a:xfrm xmlns:a="http://schemas.openxmlformats.org/drawingml/2006/main">
+            <a:off x="8410575" y="6248400"/>
+            <a:ext cx="3267075" cy="361950"/>
           </a:xfrm>
           <a:prstGeom xmlns:a="http://schemas.openxmlformats.org/drawingml/2006/main" prst="rect">
             <a:avLst/>
@@ -10319,7 +10123,7 @@
             <a:defPPr>
               <a:defRPr sz="1725" b="0">
                 <a:solidFill>
-                  <a:srgbClr val="666666"/>
+                  <a:srgbClr val="1B5E20"/>
                 </a:solidFill>
                 <a:latin typeface="Inter"/>
                 <a:ea typeface="Inter"/>
@@ -10329,7 +10133,7 @@
             <a:lvl1pPr>
               <a:defRPr sz="1725" b="0">
                 <a:solidFill>
-                  <a:srgbClr val="666666"/>
+                  <a:srgbClr val="1B5E20"/>
                 </a:solidFill>
                 <a:latin typeface="Inter"/>
                 <a:ea typeface="Inter"/>
@@ -10339,7 +10143,7 @@
             <a:lvl2pPr>
               <a:defRPr sz="1725" b="0">
                 <a:solidFill>
-                  <a:srgbClr val="666666"/>
+                  <a:srgbClr val="1B5E20"/>
                 </a:solidFill>
                 <a:latin typeface="Inter"/>
                 <a:ea typeface="Inter"/>
@@ -10349,7 +10153,7 @@
             <a:lvl3pPr>
               <a:defRPr sz="1725" b="0">
                 <a:solidFill>
-                  <a:srgbClr val="666666"/>
+                  <a:srgbClr val="1B5E20"/>
                 </a:solidFill>
                 <a:latin typeface="Inter"/>
                 <a:ea typeface="Inter"/>
@@ -10359,7 +10163,7 @@
             <a:lvl4pPr>
               <a:defRPr sz="1725" b="0">
                 <a:solidFill>
-                  <a:srgbClr val="666666"/>
+                  <a:srgbClr val="1B5E20"/>
                 </a:solidFill>
                 <a:latin typeface="Inter"/>
                 <a:ea typeface="Inter"/>
@@ -10369,7 +10173,7 @@
             <a:lvl5pPr>
               <a:defRPr sz="1725" b="0">
                 <a:solidFill>
-                  <a:srgbClr val="666666"/>
+                  <a:srgbClr val="1B5E20"/>
                 </a:solidFill>
                 <a:latin typeface="Inter"/>
                 <a:ea typeface="Inter"/>
@@ -10379,7 +10183,7 @@
             <a:lvl6pPr>
               <a:defRPr sz="1725" b="0">
                 <a:solidFill>
-                  <a:srgbClr val="666666"/>
+                  <a:srgbClr val="1B5E20"/>
                 </a:solidFill>
                 <a:latin typeface="Inter"/>
                 <a:ea typeface="Inter"/>
@@ -10389,7 +10193,7 @@
             <a:lvl7pPr>
               <a:defRPr sz="1725" b="0">
                 <a:solidFill>
-                  <a:srgbClr val="666666"/>
+                  <a:srgbClr val="1B5E20"/>
                 </a:solidFill>
                 <a:latin typeface="Inter"/>
                 <a:ea typeface="Inter"/>
@@ -10399,7 +10203,7 @@
             <a:lvl8pPr>
               <a:defRPr sz="1725" b="0">
                 <a:solidFill>
-                  <a:srgbClr val="666666"/>
+                  <a:srgbClr val="1B5E20"/>
                 </a:solidFill>
                 <a:latin typeface="Inter"/>
                 <a:ea typeface="Inter"/>
@@ -10409,7 +10213,7 @@
             <a:lvl9pPr>
               <a:defRPr sz="1725" b="0">
                 <a:solidFill>
-                  <a:srgbClr val="666666"/>
+                  <a:srgbClr val="1B5E20"/>
                 </a:solidFill>
                 <a:latin typeface="Inter"/>
                 <a:ea typeface="Inter"/>
@@ -10421,7 +10225,7 @@
             <a:pPr>
               <a:defRPr sz="1725" b="0">
                 <a:solidFill>
-                  <a:srgbClr val="666666"/>
+                  <a:srgbClr val="1B5E20"/>
                 </a:solidFill>
                 <a:latin typeface="Inter"/>
                 <a:ea typeface="Inter"/>
@@ -10431,487 +10235,12 @@
             <a:r>
               <a:rPr sz="1725" b="0">
                 <a:solidFill>
-                  <a:srgbClr val="666666"/>
-                </a:solidFill>
-                <a:latin typeface="Inter"/>
-                <a:ea typeface="Inter"/>
-                <a:cs typeface="Inter"/>
-              </a:rPr>
-              <a:t>Global single-cell sequencing: $3.46B forecast for 2030.</a:t>
-            </a:r>
-          </a:p>
-        </p:txBody>
-      </p:sp>
-      <p:sp>
-        <p:nvSpPr>
-          <p:cNvPr id="11" name="copy-47">
-            <a:extLst xmlns:a="http://schemas.openxmlformats.org/drawingml/2006/main">
-              <a:ext uri="{FF2B5EF4-FFF2-40B4-BE49-F238E27FC236}">
-                <a16:creationId xmlns:a16="http://schemas.microsoft.com/office/drawing/2014/main" id="{D71282D1-8748-4BBC-89A6-C9795DD63CC8}"/>
-              </a:ext>
-            </a:extLst>
-          </p:cNvPr>
-          <p:cNvSpPr>
-            <a:spLocks xmlns:a="http://schemas.openxmlformats.org/drawingml/2006/main" noGrp="1"/>
-          </p:cNvSpPr>
-          <p:nvPr/>
-        </p:nvSpPr>
-        <p:spPr>
-          <a:xfrm xmlns:a="http://schemas.openxmlformats.org/drawingml/2006/main">
-            <a:off x="552450" y="5981700"/>
-            <a:ext cx="11087100" cy="285750"/>
-          </a:xfrm>
-          <a:prstGeom xmlns:a="http://schemas.openxmlformats.org/drawingml/2006/main" prst="rect">
-            <a:avLst/>
-          </a:prstGeom>
-          <a:noFill xmlns:a="http://schemas.openxmlformats.org/drawingml/2006/main"/>
-          <a:ln xmlns:a="http://schemas.openxmlformats.org/drawingml/2006/main" w="0">
-            <a:noFill/>
-          </a:ln>
-        </p:spPr>
-        <p:txBody>
-          <a:bodyPr xmlns:a="http://schemas.openxmlformats.org/drawingml/2006/main" wrap="square" lIns="0" tIns="0" rIns="0" bIns="0">
-            <a:noAutofit/>
-          </a:bodyPr>
-          <a:lstStyle xmlns:a="http://schemas.openxmlformats.org/drawingml/2006/main">
-            <a:defPPr>
-              <a:defRPr sz="1350" b="0">
-                <a:solidFill>
-                  <a:srgbClr val="666666"/>
-                </a:solidFill>
-                <a:latin typeface="Inter"/>
-                <a:ea typeface="Inter"/>
-                <a:cs typeface="Inter"/>
-              </a:defRPr>
-            </a:defPPr>
-            <a:lvl1pPr>
-              <a:defRPr sz="1350" b="0">
-                <a:solidFill>
-                  <a:srgbClr val="666666"/>
-                </a:solidFill>
-                <a:latin typeface="Inter"/>
-                <a:ea typeface="Inter"/>
-                <a:cs typeface="Inter"/>
-              </a:defRPr>
-            </a:lvl1pPr>
-            <a:lvl2pPr>
-              <a:defRPr sz="1350" b="0">
-                <a:solidFill>
-                  <a:srgbClr val="666666"/>
-                </a:solidFill>
-                <a:latin typeface="Inter"/>
-                <a:ea typeface="Inter"/>
-                <a:cs typeface="Inter"/>
-              </a:defRPr>
-            </a:lvl2pPr>
-            <a:lvl3pPr>
-              <a:defRPr sz="1350" b="0">
-                <a:solidFill>
-                  <a:srgbClr val="666666"/>
-                </a:solidFill>
-                <a:latin typeface="Inter"/>
-                <a:ea typeface="Inter"/>
-                <a:cs typeface="Inter"/>
-              </a:defRPr>
-            </a:lvl3pPr>
-            <a:lvl4pPr>
-              <a:defRPr sz="1350" b="0">
-                <a:solidFill>
-                  <a:srgbClr val="666666"/>
-                </a:solidFill>
-                <a:latin typeface="Inter"/>
-                <a:ea typeface="Inter"/>
-                <a:cs typeface="Inter"/>
-              </a:defRPr>
-            </a:lvl4pPr>
-            <a:lvl5pPr>
-              <a:defRPr sz="1350" b="0">
-                <a:solidFill>
-                  <a:srgbClr val="666666"/>
-                </a:solidFill>
-                <a:latin typeface="Inter"/>
-                <a:ea typeface="Inter"/>
-                <a:cs typeface="Inter"/>
-              </a:defRPr>
-            </a:lvl5pPr>
-            <a:lvl6pPr>
-              <a:defRPr sz="1350" b="0">
-                <a:solidFill>
-                  <a:srgbClr val="666666"/>
-                </a:solidFill>
-                <a:latin typeface="Inter"/>
-                <a:ea typeface="Inter"/>
-                <a:cs typeface="Inter"/>
-              </a:defRPr>
-            </a:lvl6pPr>
-            <a:lvl7pPr>
-              <a:defRPr sz="1350" b="0">
-                <a:solidFill>
-                  <a:srgbClr val="666666"/>
-                </a:solidFill>
-                <a:latin typeface="Inter"/>
-                <a:ea typeface="Inter"/>
-                <a:cs typeface="Inter"/>
-              </a:defRPr>
-            </a:lvl7pPr>
-            <a:lvl8pPr>
-              <a:defRPr sz="1350" b="0">
-                <a:solidFill>
-                  <a:srgbClr val="666666"/>
-                </a:solidFill>
-                <a:latin typeface="Inter"/>
-                <a:ea typeface="Inter"/>
-                <a:cs typeface="Inter"/>
-              </a:defRPr>
-            </a:lvl8pPr>
-            <a:lvl9pPr>
-              <a:defRPr sz="1350" b="0">
-                <a:solidFill>
-                  <a:srgbClr val="666666"/>
-                </a:solidFill>
-                <a:latin typeface="Inter"/>
-                <a:ea typeface="Inter"/>
-                <a:cs typeface="Inter"/>
-              </a:defRPr>
-            </a:lvl9pPr>
-          </a:lstStyle>
-          <a:p xmlns:a="http://schemas.openxmlformats.org/drawingml/2006/main">
-            <a:pPr>
-              <a:defRPr sz="1350" b="0">
-                <a:solidFill>
-                  <a:srgbClr val="666666"/>
-                </a:solidFill>
-                <a:latin typeface="Inter"/>
-                <a:ea typeface="Inter"/>
-                <a:cs typeface="Inter"/>
-              </a:defRPr>
-            </a:pPr>
-            <a:r>
-              <a:rPr sz="1350" b="0">
-                <a:solidFill>
-                  <a:srgbClr val="666666"/>
-                </a:solidFill>
-                <a:latin typeface="Inter"/>
-                <a:ea typeface="Inter"/>
-                <a:cs typeface="Inter"/>
-                <a:hlinkClick xmlns:r="http://schemas.openxmlformats.org/officeDocument/2006/relationships" r:id="R11dc5293d2a74003"/>
-              </a:rPr>
-              <a:t>MarketsandMarkets (2025); includes equipment, consumables and services.</a:t>
-            </a:r>
-          </a:p>
-        </p:txBody>
-      </p:sp>
-      <p:sp>
-        <p:nvSpPr>
-          <p:cNvPr id="12" name="copy-48">
-            <a:extLst xmlns:a="http://schemas.openxmlformats.org/drawingml/2006/main">
-              <a:ext uri="{FF2B5EF4-FFF2-40B4-BE49-F238E27FC236}">
-                <a16:creationId xmlns:a16="http://schemas.microsoft.com/office/drawing/2014/main" id="{62202090-525C-4B96-8843-CF1D7D8E9AD3}"/>
-              </a:ext>
-            </a:extLst>
-          </p:cNvPr>
-          <p:cNvSpPr>
-            <a:spLocks xmlns:a="http://schemas.openxmlformats.org/drawingml/2006/main" noGrp="1"/>
-          </p:cNvSpPr>
-          <p:nvPr/>
-        </p:nvSpPr>
-        <p:spPr>
-          <a:xfrm xmlns:a="http://schemas.openxmlformats.org/drawingml/2006/main">
-            <a:off x="552450" y="6372225"/>
-            <a:ext cx="5905500" cy="381000"/>
-          </a:xfrm>
-          <a:prstGeom xmlns:a="http://schemas.openxmlformats.org/drawingml/2006/main" prst="rect">
-            <a:avLst/>
-          </a:prstGeom>
-          <a:noFill xmlns:a="http://schemas.openxmlformats.org/drawingml/2006/main"/>
-          <a:ln xmlns:a="http://schemas.openxmlformats.org/drawingml/2006/main" w="0">
-            <a:noFill/>
-          </a:ln>
-        </p:spPr>
-        <p:txBody>
-          <a:bodyPr xmlns:a="http://schemas.openxmlformats.org/drawingml/2006/main" wrap="square" lIns="0" tIns="0" rIns="0" bIns="0">
-            <a:noAutofit/>
-          </a:bodyPr>
-          <a:lstStyle xmlns:a="http://schemas.openxmlformats.org/drawingml/2006/main">
-            <a:defPPr>
-              <a:defRPr sz="2025" b="1">
-                <a:solidFill>
-                  <a:srgbClr val="1B5E20"/>
-                </a:solidFill>
-                <a:latin typeface="Inter"/>
-                <a:ea typeface="Inter"/>
-                <a:cs typeface="Inter"/>
-              </a:defRPr>
-            </a:defPPr>
-            <a:lvl1pPr>
-              <a:defRPr sz="2025" b="1">
-                <a:solidFill>
-                  <a:srgbClr val="1B5E20"/>
-                </a:solidFill>
-                <a:latin typeface="Inter"/>
-                <a:ea typeface="Inter"/>
-                <a:cs typeface="Inter"/>
-              </a:defRPr>
-            </a:lvl1pPr>
-            <a:lvl2pPr>
-              <a:defRPr sz="2025" b="1">
-                <a:solidFill>
-                  <a:srgbClr val="1B5E20"/>
-                </a:solidFill>
-                <a:latin typeface="Inter"/>
-                <a:ea typeface="Inter"/>
-                <a:cs typeface="Inter"/>
-              </a:defRPr>
-            </a:lvl2pPr>
-            <a:lvl3pPr>
-              <a:defRPr sz="2025" b="1">
-                <a:solidFill>
-                  <a:srgbClr val="1B5E20"/>
-                </a:solidFill>
-                <a:latin typeface="Inter"/>
-                <a:ea typeface="Inter"/>
-                <a:cs typeface="Inter"/>
-              </a:defRPr>
-            </a:lvl3pPr>
-            <a:lvl4pPr>
-              <a:defRPr sz="2025" b="1">
-                <a:solidFill>
-                  <a:srgbClr val="1B5E20"/>
-                </a:solidFill>
-                <a:latin typeface="Inter"/>
-                <a:ea typeface="Inter"/>
-                <a:cs typeface="Inter"/>
-              </a:defRPr>
-            </a:lvl4pPr>
-            <a:lvl5pPr>
-              <a:defRPr sz="2025" b="1">
-                <a:solidFill>
-                  <a:srgbClr val="1B5E20"/>
-                </a:solidFill>
-                <a:latin typeface="Inter"/>
-                <a:ea typeface="Inter"/>
-                <a:cs typeface="Inter"/>
-              </a:defRPr>
-            </a:lvl5pPr>
-            <a:lvl6pPr>
-              <a:defRPr sz="2025" b="1">
-                <a:solidFill>
-                  <a:srgbClr val="1B5E20"/>
-                </a:solidFill>
-                <a:latin typeface="Inter"/>
-                <a:ea typeface="Inter"/>
-                <a:cs typeface="Inter"/>
-              </a:defRPr>
-            </a:lvl6pPr>
-            <a:lvl7pPr>
-              <a:defRPr sz="2025" b="1">
-                <a:solidFill>
-                  <a:srgbClr val="1B5E20"/>
-                </a:solidFill>
-                <a:latin typeface="Inter"/>
-                <a:ea typeface="Inter"/>
-                <a:cs typeface="Inter"/>
-              </a:defRPr>
-            </a:lvl7pPr>
-            <a:lvl8pPr>
-              <a:defRPr sz="2025" b="1">
-                <a:solidFill>
-                  <a:srgbClr val="1B5E20"/>
-                </a:solidFill>
-                <a:latin typeface="Inter"/>
-                <a:ea typeface="Inter"/>
-                <a:cs typeface="Inter"/>
-              </a:defRPr>
-            </a:lvl8pPr>
-            <a:lvl9pPr>
-              <a:defRPr sz="2025" b="1">
-                <a:solidFill>
-                  <a:srgbClr val="1B5E20"/>
-                </a:solidFill>
-                <a:latin typeface="Inter"/>
-                <a:ea typeface="Inter"/>
-                <a:cs typeface="Inter"/>
-              </a:defRPr>
-            </a:lvl9pPr>
-          </a:lstStyle>
-          <a:p xmlns:a="http://schemas.openxmlformats.org/drawingml/2006/main">
-            <a:pPr>
-              <a:defRPr sz="2025" b="1">
-                <a:solidFill>
-                  <a:srgbClr val="1B5E20"/>
-                </a:solidFill>
-                <a:latin typeface="Inter"/>
-                <a:ea typeface="Inter"/>
-                <a:cs typeface="Inter"/>
-              </a:defRPr>
-            </a:pPr>
-            <a:r>
-              <a:rPr sz="2025" b="1">
-                <a:solidFill>
-                  <a:srgbClr val="1B5E20"/>
-                </a:solidFill>
-                <a:latin typeface="Inter"/>
-                <a:ea typeface="Inter"/>
-                <a:cs typeface="Inter"/>
-              </a:rPr>
-              <a:t>celloras.com</a:t>
-            </a:r>
-          </a:p>
-        </p:txBody>
-      </p:sp>
-      <p:sp>
-        <p:nvSpPr>
-          <p:cNvPr id="13" name="copy-49">
-            <a:extLst xmlns:a="http://schemas.openxmlformats.org/drawingml/2006/main">
-              <a:ext uri="{FF2B5EF4-FFF2-40B4-BE49-F238E27FC236}">
-                <a16:creationId xmlns:a16="http://schemas.microsoft.com/office/drawing/2014/main" id="{086091EC-ACCD-4DDA-A92E-0F5F058D5F14}"/>
-              </a:ext>
-            </a:extLst>
-          </p:cNvPr>
-          <p:cNvSpPr>
-            <a:spLocks xmlns:a="http://schemas.openxmlformats.org/drawingml/2006/main" noGrp="1"/>
-          </p:cNvSpPr>
-          <p:nvPr/>
-        </p:nvSpPr>
-        <p:spPr>
-          <a:xfrm xmlns:a="http://schemas.openxmlformats.org/drawingml/2006/main">
-            <a:off x="8410575" y="6391275"/>
-            <a:ext cx="3267075" cy="304800"/>
-          </a:xfrm>
-          <a:prstGeom xmlns:a="http://schemas.openxmlformats.org/drawingml/2006/main" prst="rect">
-            <a:avLst/>
-          </a:prstGeom>
-          <a:noFill xmlns:a="http://schemas.openxmlformats.org/drawingml/2006/main"/>
-          <a:ln xmlns:a="http://schemas.openxmlformats.org/drawingml/2006/main" w="0">
-            <a:noFill/>
-          </a:ln>
-        </p:spPr>
-        <p:txBody>
-          <a:bodyPr xmlns:a="http://schemas.openxmlformats.org/drawingml/2006/main" wrap="square" lIns="0" tIns="0" rIns="0" bIns="0">
-            <a:noAutofit/>
-          </a:bodyPr>
-          <a:lstStyle xmlns:a="http://schemas.openxmlformats.org/drawingml/2006/main">
-            <a:defPPr>
-              <a:defRPr sz="1650" b="0">
-                <a:solidFill>
-                  <a:srgbClr val="1B5E20"/>
-                </a:solidFill>
-                <a:latin typeface="Inter"/>
-                <a:ea typeface="Inter"/>
-                <a:cs typeface="Inter"/>
-              </a:defRPr>
-            </a:defPPr>
-            <a:lvl1pPr>
-              <a:defRPr sz="1650" b="0">
-                <a:solidFill>
-                  <a:srgbClr val="1B5E20"/>
-                </a:solidFill>
-                <a:latin typeface="Inter"/>
-                <a:ea typeface="Inter"/>
-                <a:cs typeface="Inter"/>
-              </a:defRPr>
-            </a:lvl1pPr>
-            <a:lvl2pPr>
-              <a:defRPr sz="1650" b="0">
-                <a:solidFill>
-                  <a:srgbClr val="1B5E20"/>
-                </a:solidFill>
-                <a:latin typeface="Inter"/>
-                <a:ea typeface="Inter"/>
-                <a:cs typeface="Inter"/>
-              </a:defRPr>
-            </a:lvl2pPr>
-            <a:lvl3pPr>
-              <a:defRPr sz="1650" b="0">
-                <a:solidFill>
-                  <a:srgbClr val="1B5E20"/>
-                </a:solidFill>
-                <a:latin typeface="Inter"/>
-                <a:ea typeface="Inter"/>
-                <a:cs typeface="Inter"/>
-              </a:defRPr>
-            </a:lvl3pPr>
-            <a:lvl4pPr>
-              <a:defRPr sz="1650" b="0">
-                <a:solidFill>
-                  <a:srgbClr val="1B5E20"/>
-                </a:solidFill>
-                <a:latin typeface="Inter"/>
-                <a:ea typeface="Inter"/>
-                <a:cs typeface="Inter"/>
-              </a:defRPr>
-            </a:lvl4pPr>
-            <a:lvl5pPr>
-              <a:defRPr sz="1650" b="0">
-                <a:solidFill>
-                  <a:srgbClr val="1B5E20"/>
-                </a:solidFill>
-                <a:latin typeface="Inter"/>
-                <a:ea typeface="Inter"/>
-                <a:cs typeface="Inter"/>
-              </a:defRPr>
-            </a:lvl5pPr>
-            <a:lvl6pPr>
-              <a:defRPr sz="1650" b="0">
-                <a:solidFill>
-                  <a:srgbClr val="1B5E20"/>
-                </a:solidFill>
-                <a:latin typeface="Inter"/>
-                <a:ea typeface="Inter"/>
-                <a:cs typeface="Inter"/>
-              </a:defRPr>
-            </a:lvl6pPr>
-            <a:lvl7pPr>
-              <a:defRPr sz="1650" b="0">
-                <a:solidFill>
-                  <a:srgbClr val="1B5E20"/>
-                </a:solidFill>
-                <a:latin typeface="Inter"/>
-                <a:ea typeface="Inter"/>
-                <a:cs typeface="Inter"/>
-              </a:defRPr>
-            </a:lvl7pPr>
-            <a:lvl8pPr>
-              <a:defRPr sz="1650" b="0">
-                <a:solidFill>
-                  <a:srgbClr val="1B5E20"/>
-                </a:solidFill>
-                <a:latin typeface="Inter"/>
-                <a:ea typeface="Inter"/>
-                <a:cs typeface="Inter"/>
-              </a:defRPr>
-            </a:lvl8pPr>
-            <a:lvl9pPr>
-              <a:defRPr sz="1650" b="0">
-                <a:solidFill>
-                  <a:srgbClr val="1B5E20"/>
-                </a:solidFill>
-                <a:latin typeface="Inter"/>
-                <a:ea typeface="Inter"/>
-                <a:cs typeface="Inter"/>
-              </a:defRPr>
-            </a:lvl9pPr>
-          </a:lstStyle>
-          <a:p xmlns:a="http://schemas.openxmlformats.org/drawingml/2006/main">
-            <a:pPr>
-              <a:defRPr sz="1650" b="0">
-                <a:solidFill>
-                  <a:srgbClr val="1B5E20"/>
-                </a:solidFill>
-                <a:latin typeface="Inter"/>
-                <a:ea typeface="Inter"/>
-                <a:cs typeface="Inter"/>
-              </a:defRPr>
-            </a:pPr>
-            <a:r>
-              <a:rPr sz="1650" b="0">
-                <a:solidFill>
-                  <a:srgbClr val="1B5E20"/>
-                </a:solidFill>
-                <a:latin typeface="Inter"/>
-                <a:ea typeface="Inter"/>
-                <a:cs typeface="Inter"/>
-                <a:hlinkClick xmlns:r="http://schemas.openxmlformats.org/officeDocument/2006/relationships" r:id="Rd7964e1745644503"/>
+                  <a:srgbClr val="1B5E20"/>
+                </a:solidFill>
+                <a:latin typeface="Inter"/>
+                <a:ea typeface="Inter"/>
+                <a:cs typeface="Inter"/>
+                <a:hlinkClick xmlns:r="http://schemas.openxmlformats.org/officeDocument/2006/relationships" r:id="R1756bb5969b54154"/>
               </a:rPr>
               <a:t>Public code and demo</a:t>
             </a:r>
@@ -10921,7 +10250,7 @@
     </p:spTree>
     <p:extLst>
       <p:ext uri="{BB962C8B-B14F-4D97-AF65-F5344CB8AC3E}">
-        <p14:creationId xmlns:p14="http://schemas.microsoft.com/office/powerpoint/2010/main" val="1580949889"/>
+        <p14:creationId xmlns:p14="http://schemas.microsoft.com/office/powerpoint/2010/main" val="517376490"/>
       </p:ext>
     </p:extLst>
   </p:cSld>

</xml_diff>

<commit_message>
docs: add technical deck and real agent conversation
</commit_message>
<xml_diff>
--- a/docs/pitchdeck/Celloras-Pitch-Deck.pptx
+++ b/docs/pitchdeck/Celloras-Pitch-Deck.pptx
@@ -2,16 +2,16 @@
 <file path=ppt/presentation.xml><?xml version="1.0" encoding="utf-8"?>
 <p:presentation xmlns:p="http://schemas.openxmlformats.org/presentationml/2006/main">
   <p:sldMasterIdLst>
-    <p:sldMasterId xmlns:r="http://schemas.openxmlformats.org/officeDocument/2006/relationships" id="2147483648" r:id="Rf01c0c7f6c8e465b"/>
+    <p:sldMasterId xmlns:r="http://schemas.openxmlformats.org/officeDocument/2006/relationships" id="2147483648" r:id="R1e3212cb8dbd4548"/>
   </p:sldMasterIdLst>
   <p:notesMasterIdLst>
-    <p:notesMasterId xmlns:r="http://schemas.openxmlformats.org/officeDocument/2006/relationships" r:id="Re7dd0c5dfb6f4cf9"/>
+    <p:notesMasterId xmlns:r="http://schemas.openxmlformats.org/officeDocument/2006/relationships" r:id="Rf174ab2454804922"/>
   </p:notesMasterIdLst>
   <p:sldIdLst>
-    <p:sldId xmlns:r="http://schemas.openxmlformats.org/officeDocument/2006/relationships" id="256" r:id="R27762b7e274644a4"/>
-    <p:sldId xmlns:r="http://schemas.openxmlformats.org/officeDocument/2006/relationships" id="257" r:id="R030c148ef8224740"/>
-    <p:sldId xmlns:r="http://schemas.openxmlformats.org/officeDocument/2006/relationships" id="258" r:id="R3c591484595b41f9"/>
-    <p:sldId xmlns:r="http://schemas.openxmlformats.org/officeDocument/2006/relationships" id="259" r:id="R85fc30fc9b8e4283"/>
+    <p:sldId xmlns:r="http://schemas.openxmlformats.org/officeDocument/2006/relationships" id="256" r:id="R51b2747cadef4b1a"/>
+    <p:sldId xmlns:r="http://schemas.openxmlformats.org/officeDocument/2006/relationships" id="257" r:id="Ra05314c194b841cb"/>
+    <p:sldId xmlns:r="http://schemas.openxmlformats.org/officeDocument/2006/relationships" id="258" r:id="R4ae28b9bdbdc4800"/>
+    <p:sldId xmlns:r="http://schemas.openxmlformats.org/officeDocument/2006/relationships" id="259" r:id="R26833f2fcdb54a53"/>
   </p:sldIdLst>
   <p:sldSz cx="12192000" cy="6858000"/>
   <p:notesSz cx="6858000" cy="9144000"/>
@@ -630,7 +630,7 @@
           <a:lstStyle xmlns:a="http://schemas.openxmlformats.org/drawingml/2006/main"/>
           <a:p xmlns:a="http://schemas.openxmlformats.org/drawingml/2006/main">
             <a:r>
-              <a:t>The server-side OpenShell/Codex agent chooses scientific tools in response to the request. Zetaris supplies a checked, versioned marker reference. Numerical tools measure expression; the language model explains their outputs. The official Meterless H-MEM Engine recalls explicit project-owned reviews and their sources when relevant. Next.js and Keycloak provide the interface, with owned state in PostgreSQL. The agent suggests; the researcher reviews.</a:t>
+              <a:t>Actual agent conversation captured on 26 October 2026. The agent was asked to show the saved soybean-root annotation card and briefly explain it. It returned the real existing card and its computed map. The agent runs scientific tools, proposes interpretations, explains supporting evidence and uncertainty, and can recall reviewed decisions. The user can challenge and correct its conclusions. The deterministic annotation engine computes provisional candidates, and the language model interprets their outputs. This screenshot is a cropped viewport from the actual reply; no text or scientific result was fabricated. The first slide remains unchanged at the user’s request.</a:t>
             </a:r>
           </a:p>
           <a:p xmlns:a="http://schemas.openxmlformats.org/drawingml/2006/main">
@@ -656,6 +656,11 @@
           <a:p xmlns:a="http://schemas.openxmlformats.org/drawingml/2006/main">
             <a:r>
               <a:t>https://github.com/mpckkk/2026_GenAI/tree/celloras.com</a:t>
+            </a:r>
+          </a:p>
+          <a:p xmlns:a="http://schemas.openxmlformats.org/drawingml/2006/main">
+            <a:r>
+              <a:t>https://celloras.com/app/projects/786e3d61-c1b5-4255-aae3-0d3d58f69320?chatBefore=14#turn-7d65780e-45ae-42c3-9ee3-0f2b112d767a</a:t>
             </a:r>
           </a:p>
         </p:txBody>
@@ -802,7 +807,7 @@
           <p:cNvPr id="3" name="Title">
             <a:extLst xmlns:a="http://schemas.openxmlformats.org/drawingml/2006/main">
               <a:ext uri="{FF2B5EF4-FFF2-40B4-BE49-F238E27FC236}">
-                <a16:creationId xmlns:a16="http://schemas.microsoft.com/office/drawing/2014/main" id="{2DAE4D72-EF44-4731-B97B-3FC34AB9513B}"/>
+                <a16:creationId xmlns:a16="http://schemas.microsoft.com/office/drawing/2014/main" id="{F1504595-B0B9-4DA1-BF58-AA083A3A724F}"/>
               </a:ext>
             </a:extLst>
           </p:cNvPr>
@@ -1031,7 +1036,7 @@
           <p:cNvPr id="2" name="Subtitle">
             <a:extLst xmlns:a="http://schemas.openxmlformats.org/drawingml/2006/main">
               <a:ext uri="{FF2B5EF4-FFF2-40B4-BE49-F238E27FC236}">
-                <a16:creationId xmlns:a16="http://schemas.microsoft.com/office/drawing/2014/main" id="{EDB53ED1-99B0-41F3-93D4-A9389883B976}"/>
+                <a16:creationId xmlns:a16="http://schemas.microsoft.com/office/drawing/2014/main" id="{BF43D9D0-A923-4D11-8B0B-52F545E61AE9}"/>
               </a:ext>
             </a:extLst>
           </p:cNvPr>
@@ -1277,7 +1282,7 @@
           <p:cNvPr id="2" name="Section title">
             <a:extLst xmlns:a="http://schemas.openxmlformats.org/drawingml/2006/main">
               <a:ext uri="{FF2B5EF4-FFF2-40B4-BE49-F238E27FC236}">
-                <a16:creationId xmlns:a16="http://schemas.microsoft.com/office/drawing/2014/main" id="{AB9E905B-F24D-4715-A84D-FB0F708E4DAF}"/>
+                <a16:creationId xmlns:a16="http://schemas.microsoft.com/office/drawing/2014/main" id="{94042BED-2661-41D9-A300-4A856D954BD0}"/>
               </a:ext>
             </a:extLst>
           </p:cNvPr>
@@ -1523,7 +1528,7 @@
           <p:cNvPr id="3" name="Title">
             <a:extLst xmlns:a="http://schemas.openxmlformats.org/drawingml/2006/main">
               <a:ext uri="{FF2B5EF4-FFF2-40B4-BE49-F238E27FC236}">
-                <a16:creationId xmlns:a16="http://schemas.microsoft.com/office/drawing/2014/main" id="{E81B89D6-CF33-47DD-813D-30CBC67D27A5}"/>
+                <a16:creationId xmlns:a16="http://schemas.microsoft.com/office/drawing/2014/main" id="{DF3AE89B-6BE4-46B7-8EF9-3D274905E810}"/>
               </a:ext>
             </a:extLst>
           </p:cNvPr>
@@ -1752,7 +1757,7 @@
           <p:cNvPr id="2" name="Body">
             <a:extLst xmlns:a="http://schemas.openxmlformats.org/drawingml/2006/main">
               <a:ext uri="{FF2B5EF4-FFF2-40B4-BE49-F238E27FC236}">
-                <a16:creationId xmlns:a16="http://schemas.microsoft.com/office/drawing/2014/main" id="{2C4DBCA8-C899-4D82-AAC0-6736A200687D}"/>
+                <a16:creationId xmlns:a16="http://schemas.microsoft.com/office/drawing/2014/main" id="{AB8505C3-CE89-4CB0-8543-48C07A468865}"/>
               </a:ext>
             </a:extLst>
           </p:cNvPr>
@@ -1998,7 +2003,7 @@
           <p:cNvPr id="4" name="Title">
             <a:extLst xmlns:a="http://schemas.openxmlformats.org/drawingml/2006/main">
               <a:ext uri="{FF2B5EF4-FFF2-40B4-BE49-F238E27FC236}">
-                <a16:creationId xmlns:a16="http://schemas.microsoft.com/office/drawing/2014/main" id="{F8FDB0F8-7F2A-41A7-9DB0-3FFED603FB15}"/>
+                <a16:creationId xmlns:a16="http://schemas.microsoft.com/office/drawing/2014/main" id="{A1F63039-FE2D-4F78-9369-6EA86A628FAB}"/>
               </a:ext>
             </a:extLst>
           </p:cNvPr>
@@ -2227,7 +2232,7 @@
           <p:cNvPr id="2" name="Left column">
             <a:extLst xmlns:a="http://schemas.openxmlformats.org/drawingml/2006/main">
               <a:ext uri="{FF2B5EF4-FFF2-40B4-BE49-F238E27FC236}">
-                <a16:creationId xmlns:a16="http://schemas.microsoft.com/office/drawing/2014/main" id="{7351A9A7-6F74-45E3-9D52-48F4D1EB85D1}"/>
+                <a16:creationId xmlns:a16="http://schemas.microsoft.com/office/drawing/2014/main" id="{F26444C8-46EA-4CB1-9142-5EFB384330A3}"/>
               </a:ext>
             </a:extLst>
           </p:cNvPr>
@@ -2456,7 +2461,7 @@
           <p:cNvPr id="3" name="Right column">
             <a:extLst xmlns:a="http://schemas.openxmlformats.org/drawingml/2006/main">
               <a:ext uri="{FF2B5EF4-FFF2-40B4-BE49-F238E27FC236}">
-                <a16:creationId xmlns:a16="http://schemas.microsoft.com/office/drawing/2014/main" id="{ECAFF073-3A46-495F-AC35-BF8E73CA9FB1}"/>
+                <a16:creationId xmlns:a16="http://schemas.microsoft.com/office/drawing/2014/main" id="{EEF4B11F-6941-466A-9D23-5AFA811CE3F3}"/>
               </a:ext>
             </a:extLst>
           </p:cNvPr>
@@ -2702,7 +2707,7 @@
           <p:cNvPr id="3" name="Title">
             <a:extLst xmlns:a="http://schemas.openxmlformats.org/drawingml/2006/main">
               <a:ext uri="{FF2B5EF4-FFF2-40B4-BE49-F238E27FC236}">
-                <a16:creationId xmlns:a16="http://schemas.microsoft.com/office/drawing/2014/main" id="{2477923A-FA80-4433-9E28-7B7EA773F02B}"/>
+                <a16:creationId xmlns:a16="http://schemas.microsoft.com/office/drawing/2014/main" id="{E9B646DB-779F-41C1-9B53-3CAFE0842FA5}"/>
               </a:ext>
             </a:extLst>
           </p:cNvPr>
@@ -2931,7 +2936,7 @@
           <p:cNvPr id="2" name="Left column">
             <a:extLst xmlns:a="http://schemas.openxmlformats.org/drawingml/2006/main">
               <a:ext uri="{FF2B5EF4-FFF2-40B4-BE49-F238E27FC236}">
-                <a16:creationId xmlns:a16="http://schemas.microsoft.com/office/drawing/2014/main" id="{EE95067B-90C7-4B54-AC19-FA7E89BC5AAA}"/>
+                <a16:creationId xmlns:a16="http://schemas.microsoft.com/office/drawing/2014/main" id="{FF075C1A-995E-48A0-A3E6-591738B9B986}"/>
               </a:ext>
             </a:extLst>
           </p:cNvPr>
@@ -3198,12 +3203,12 @@
   </p:cSld>
   <p:clrMap bg1="lt1" tx1="dk1" bg2="lt2" tx2="dk2" accent1="accent1" accent2="accent2" accent3="accent3" accent4="accent4" accent5="accent5" accent6="accent6" hlink="hlink" folHlink="folHlink"/>
   <p:sldLayoutIdLst>
-    <p:sldLayoutId xmlns:r="http://schemas.openxmlformats.org/officeDocument/2006/relationships" id="2147483649" r:id="R0812fa30cc854044"/>
-    <p:sldLayoutId xmlns:r="http://schemas.openxmlformats.org/officeDocument/2006/relationships" id="2147483650" r:id="R746a05c2710d420a"/>
-    <p:sldLayoutId xmlns:r="http://schemas.openxmlformats.org/officeDocument/2006/relationships" id="2147483651" r:id="Rbce4f0254afd4cc5"/>
-    <p:sldLayoutId xmlns:r="http://schemas.openxmlformats.org/officeDocument/2006/relationships" id="2147483652" r:id="Rcba66cff563b48bf"/>
-    <p:sldLayoutId xmlns:r="http://schemas.openxmlformats.org/officeDocument/2006/relationships" id="2147483653" r:id="R80a323677048472c"/>
-    <p:sldLayoutId xmlns:r="http://schemas.openxmlformats.org/officeDocument/2006/relationships" id="2147483654" r:id="R6b11bad04f254895"/>
+    <p:sldLayoutId xmlns:r="http://schemas.openxmlformats.org/officeDocument/2006/relationships" id="2147483649" r:id="Rafaf0e16b9c044da"/>
+    <p:sldLayoutId xmlns:r="http://schemas.openxmlformats.org/officeDocument/2006/relationships" id="2147483650" r:id="R357b7122a915407c"/>
+    <p:sldLayoutId xmlns:r="http://schemas.openxmlformats.org/officeDocument/2006/relationships" id="2147483651" r:id="Rc2b8566c2afb4590"/>
+    <p:sldLayoutId xmlns:r="http://schemas.openxmlformats.org/officeDocument/2006/relationships" id="2147483652" r:id="Rf86fdaa9ab2e4f85"/>
+    <p:sldLayoutId xmlns:r="http://schemas.openxmlformats.org/officeDocument/2006/relationships" id="2147483653" r:id="Rcd029132289b4327"/>
+    <p:sldLayoutId xmlns:r="http://schemas.openxmlformats.org/officeDocument/2006/relationships" id="2147483654" r:id="Rd21f8457c8fe43be"/>
   </p:sldLayoutIdLst>
   <p:txStyles>
     <p:titleStyle>
@@ -3754,7 +3759,7 @@
           <p:cNvPr id="7" name="">
             <a:extLst xmlns:a="http://schemas.openxmlformats.org/drawingml/2006/main">
               <a:ext uri="{FF2B5EF4-FFF2-40B4-BE49-F238E27FC236}">
-                <a16:creationId xmlns:a16="http://schemas.microsoft.com/office/drawing/2014/main" id="{092F30EF-C8EC-45AC-B500-C42783DF5073}"/>
+                <a16:creationId xmlns:a16="http://schemas.microsoft.com/office/drawing/2014/main" id="{C16CF773-BA8A-414D-A49E-B44FB46CCEA3}"/>
               </a:ext>
             </a:extLst>
           </p:cNvPr>
@@ -3764,7 +3769,7 @@
           <p:nvPr/>
         </p:nvPicPr>
         <p:blipFill>
-          <a:blip xmlns:r="http://schemas.openxmlformats.org/officeDocument/2006/relationships" xmlns:a="http://schemas.openxmlformats.org/drawingml/2006/main" r:embed="R2ce9d418df2442eb"/>
+          <a:blip xmlns:r="http://schemas.openxmlformats.org/officeDocument/2006/relationships" xmlns:a="http://schemas.openxmlformats.org/drawingml/2006/main" r:embed="R9ac60e956fa34c4e"/>
           <a:srcRect xmlns:a="http://schemas.openxmlformats.org/drawingml/2006/main" l="10800" t="30500" r="5500" b="33000"/>
           <a:stretch xmlns:a="http://schemas.openxmlformats.org/drawingml/2006/main"/>
         </p:blipFill>
@@ -3783,7 +3788,7 @@
           <p:cNvPr id="2" name="copy-1">
             <a:extLst xmlns:a="http://schemas.openxmlformats.org/drawingml/2006/main">
               <a:ext uri="{FF2B5EF4-FFF2-40B4-BE49-F238E27FC236}">
-                <a16:creationId xmlns:a16="http://schemas.microsoft.com/office/drawing/2014/main" id="{B1D3EEB9-F985-48B3-A48B-FDD55370B6AC}"/>
+                <a16:creationId xmlns:a16="http://schemas.microsoft.com/office/drawing/2014/main" id="{72A00DE8-40B9-4AED-A5CE-1E3C7B2450C4}"/>
               </a:ext>
             </a:extLst>
           </p:cNvPr>
@@ -3964,7 +3969,7 @@
           <p:cNvPr id="3" name="copy-2">
             <a:extLst xmlns:a="http://schemas.openxmlformats.org/drawingml/2006/main">
               <a:ext uri="{FF2B5EF4-FFF2-40B4-BE49-F238E27FC236}">
-                <a16:creationId xmlns:a16="http://schemas.microsoft.com/office/drawing/2014/main" id="{2FA4018D-A03B-4F0D-AB64-EDFABBD4D57B}"/>
+                <a16:creationId xmlns:a16="http://schemas.microsoft.com/office/drawing/2014/main" id="{3D731661-C47B-49A6-A661-D5B79BDB634D}"/>
               </a:ext>
             </a:extLst>
           </p:cNvPr>
@@ -4145,7 +4150,7 @@
           <p:cNvPr id="4" name="copy-3">
             <a:extLst xmlns:a="http://schemas.openxmlformats.org/drawingml/2006/main">
               <a:ext uri="{FF2B5EF4-FFF2-40B4-BE49-F238E27FC236}">
-                <a16:creationId xmlns:a16="http://schemas.microsoft.com/office/drawing/2014/main" id="{29CEDBC9-16CB-4E5D-81F1-E83FF64C913E}"/>
+                <a16:creationId xmlns:a16="http://schemas.microsoft.com/office/drawing/2014/main" id="{6CC34A40-9817-4EFE-B256-98DA937C0085}"/>
               </a:ext>
             </a:extLst>
           </p:cNvPr>
@@ -4326,7 +4331,7 @@
           <p:cNvPr id="5" name="">
             <a:extLst xmlns:a="http://schemas.openxmlformats.org/drawingml/2006/main">
               <a:ext uri="{FF2B5EF4-FFF2-40B4-BE49-F238E27FC236}">
-                <a16:creationId xmlns:a16="http://schemas.microsoft.com/office/drawing/2014/main" id="{C3BD8244-1780-4051-B8B2-8DF7CD03DB24}"/>
+                <a16:creationId xmlns:a16="http://schemas.microsoft.com/office/drawing/2014/main" id="{70B26B9E-CC34-42D0-9BA2-092B40ACC1A5}"/>
               </a:ext>
             </a:extLst>
           </p:cNvPr>
@@ -4336,7 +4341,7 @@
           <p:nvPr/>
         </p:nvPicPr>
         <p:blipFill>
-          <a:blip xmlns:r="http://schemas.openxmlformats.org/officeDocument/2006/relationships" xmlns:a="http://schemas.openxmlformats.org/drawingml/2006/main" r:embed="R83f27ba48a7543cb"/>
+          <a:blip xmlns:r="http://schemas.openxmlformats.org/officeDocument/2006/relationships" xmlns:a="http://schemas.openxmlformats.org/drawingml/2006/main" r:embed="Ra08d66ed146a4f9f"/>
           <a:stretch xmlns:a="http://schemas.openxmlformats.org/drawingml/2006/main"/>
         </p:blipFill>
         <p:spPr>
@@ -4354,7 +4359,7 @@
           <p:cNvPr id="6" name="copy-4">
             <a:extLst xmlns:a="http://schemas.openxmlformats.org/drawingml/2006/main">
               <a:ext uri="{FF2B5EF4-FFF2-40B4-BE49-F238E27FC236}">
-                <a16:creationId xmlns:a16="http://schemas.microsoft.com/office/drawing/2014/main" id="{AF882377-1657-4AD4-B56E-AE2FCE3251DC}"/>
+                <a16:creationId xmlns:a16="http://schemas.microsoft.com/office/drawing/2014/main" id="{B5E8C1B3-B543-4F7A-9089-57E0470A3F50}"/>
               </a:ext>
             </a:extLst>
           </p:cNvPr>
@@ -4510,7 +4515,7 @@
     </p:spTree>
     <p:extLst>
       <p:ext uri="{BB962C8B-B14F-4D97-AF65-F5344CB8AC3E}">
-        <p14:creationId xmlns:p14="http://schemas.microsoft.com/office/powerpoint/2010/main" val="183982470"/>
+        <p14:creationId xmlns:p14="http://schemas.microsoft.com/office/powerpoint/2010/main" val="1189907914"/>
       </p:ext>
     </p:extLst>
   </p:cSld>
@@ -4541,7 +4546,7 @@
           <p:cNvPr id="15" name="copy-5">
             <a:extLst xmlns:a="http://schemas.openxmlformats.org/drawingml/2006/main">
               <a:ext uri="{FF2B5EF4-FFF2-40B4-BE49-F238E27FC236}">
-                <a16:creationId xmlns:a16="http://schemas.microsoft.com/office/drawing/2014/main" id="{43081E3E-C828-4D47-B8F1-0BC65D249233}"/>
+                <a16:creationId xmlns:a16="http://schemas.microsoft.com/office/drawing/2014/main" id="{14AE84D1-8202-4583-924E-578205701819}"/>
               </a:ext>
             </a:extLst>
           </p:cNvPr>
@@ -4699,7 +4704,7 @@
           <p:cNvPr id="2" name="block-6">
             <a:extLst xmlns:a="http://schemas.openxmlformats.org/drawingml/2006/main">
               <a:ext uri="{FF2B5EF4-FFF2-40B4-BE49-F238E27FC236}">
-                <a16:creationId xmlns:a16="http://schemas.microsoft.com/office/drawing/2014/main" id="{B2EFCFB6-C220-4A63-885E-A87398A740F5}"/>
+                <a16:creationId xmlns:a16="http://schemas.microsoft.com/office/drawing/2014/main" id="{868B5FE6-EC1F-4746-8690-03A8E261861B}"/>
               </a:ext>
             </a:extLst>
           </p:cNvPr>
@@ -4729,7 +4734,7 @@
           <p:cNvPr id="3" name="copy-7">
             <a:extLst xmlns:a="http://schemas.openxmlformats.org/drawingml/2006/main">
               <a:ext uri="{FF2B5EF4-FFF2-40B4-BE49-F238E27FC236}">
-                <a16:creationId xmlns:a16="http://schemas.microsoft.com/office/drawing/2014/main" id="{64739AF2-975F-44CA-B6B9-D5FE10CAA122}"/>
+                <a16:creationId xmlns:a16="http://schemas.microsoft.com/office/drawing/2014/main" id="{0066291E-1512-41C5-B058-57C9571DA1B8}"/>
               </a:ext>
             </a:extLst>
           </p:cNvPr>
@@ -4887,7 +4892,7 @@
           <p:cNvPr id="4" name="copy-8">
             <a:extLst xmlns:a="http://schemas.openxmlformats.org/drawingml/2006/main">
               <a:ext uri="{FF2B5EF4-FFF2-40B4-BE49-F238E27FC236}">
-                <a16:creationId xmlns:a16="http://schemas.microsoft.com/office/drawing/2014/main" id="{2E0ABB6F-5947-4DCD-82E8-0F591079A85E}"/>
+                <a16:creationId xmlns:a16="http://schemas.microsoft.com/office/drawing/2014/main" id="{76ED4202-8A68-47D0-AC99-9179D2CC7FC7}"/>
               </a:ext>
             </a:extLst>
           </p:cNvPr>
@@ -5045,7 +5050,7 @@
           <p:cNvPr id="5" name="copy-9">
             <a:extLst xmlns:a="http://schemas.openxmlformats.org/drawingml/2006/main">
               <a:ext uri="{FF2B5EF4-FFF2-40B4-BE49-F238E27FC236}">
-                <a16:creationId xmlns:a16="http://schemas.microsoft.com/office/drawing/2014/main" id="{EF387A8D-02E0-410E-99EE-96EDD35AD89A}"/>
+                <a16:creationId xmlns:a16="http://schemas.microsoft.com/office/drawing/2014/main" id="{2DAFF41F-FBC9-4AFE-BFFA-7EE77149428C}"/>
               </a:ext>
             </a:extLst>
           </p:cNvPr>
@@ -5203,7 +5208,7 @@
           <p:cNvPr id="6" name="arrow-10">
             <a:extLst xmlns:a="http://schemas.openxmlformats.org/drawingml/2006/main">
               <a:ext uri="{FF2B5EF4-FFF2-40B4-BE49-F238E27FC236}">
-                <a16:creationId xmlns:a16="http://schemas.microsoft.com/office/drawing/2014/main" id="{332E2F28-8D2D-44D9-81EF-7F8B5A925026}"/>
+                <a16:creationId xmlns:a16="http://schemas.microsoft.com/office/drawing/2014/main" id="{B6E2B588-18D3-44A5-9C75-F12D068FC528}"/>
               </a:ext>
             </a:extLst>
           </p:cNvPr>
@@ -5233,7 +5238,7 @@
           <p:cNvPr id="7" name="copy-11">
             <a:extLst xmlns:a="http://schemas.openxmlformats.org/drawingml/2006/main">
               <a:ext uri="{FF2B5EF4-FFF2-40B4-BE49-F238E27FC236}">
-                <a16:creationId xmlns:a16="http://schemas.microsoft.com/office/drawing/2014/main" id="{AA9E3AEE-7E3E-40E8-A452-3E06D68F31BC}"/>
+                <a16:creationId xmlns:a16="http://schemas.microsoft.com/office/drawing/2014/main" id="{63A12B7F-AE25-47F0-9472-521F8C15403D}"/>
               </a:ext>
             </a:extLst>
           </p:cNvPr>
@@ -5391,7 +5396,7 @@
           <p:cNvPr id="8" name="copy-12">
             <a:extLst xmlns:a="http://schemas.openxmlformats.org/drawingml/2006/main">
               <a:ext uri="{FF2B5EF4-FFF2-40B4-BE49-F238E27FC236}">
-                <a16:creationId xmlns:a16="http://schemas.microsoft.com/office/drawing/2014/main" id="{024FD050-9023-4C98-BC9D-AE8AF93014D3}"/>
+                <a16:creationId xmlns:a16="http://schemas.microsoft.com/office/drawing/2014/main" id="{7B8ABC3C-58EA-4224-82EA-B6D853F8A28B}"/>
               </a:ext>
             </a:extLst>
           </p:cNvPr>
@@ -5549,7 +5554,7 @@
           <p:cNvPr id="9" name="arrow-13">
             <a:extLst xmlns:a="http://schemas.openxmlformats.org/drawingml/2006/main">
               <a:ext uri="{FF2B5EF4-FFF2-40B4-BE49-F238E27FC236}">
-                <a16:creationId xmlns:a16="http://schemas.microsoft.com/office/drawing/2014/main" id="{72562C67-A842-441F-8385-D049189E4FFE}"/>
+                <a16:creationId xmlns:a16="http://schemas.microsoft.com/office/drawing/2014/main" id="{5A3AA364-CFCC-4824-BAEA-981114F512C7}"/>
               </a:ext>
             </a:extLst>
           </p:cNvPr>
@@ -5579,7 +5584,7 @@
           <p:cNvPr id="10" name="copy-14">
             <a:extLst xmlns:a="http://schemas.openxmlformats.org/drawingml/2006/main">
               <a:ext uri="{FF2B5EF4-FFF2-40B4-BE49-F238E27FC236}">
-                <a16:creationId xmlns:a16="http://schemas.microsoft.com/office/drawing/2014/main" id="{8DCBF99D-013F-4F36-B0D8-C966E62DE0F8}"/>
+                <a16:creationId xmlns:a16="http://schemas.microsoft.com/office/drawing/2014/main" id="{ADB3F97D-0D80-478C-9281-232A6FD3B60E}"/>
               </a:ext>
             </a:extLst>
           </p:cNvPr>
@@ -5737,7 +5742,7 @@
           <p:cNvPr id="11" name="copy-15">
             <a:extLst xmlns:a="http://schemas.openxmlformats.org/drawingml/2006/main">
               <a:ext uri="{FF2B5EF4-FFF2-40B4-BE49-F238E27FC236}">
-                <a16:creationId xmlns:a16="http://schemas.microsoft.com/office/drawing/2014/main" id="{A6D79F35-18E0-4A61-B354-8D4902DAD702}"/>
+                <a16:creationId xmlns:a16="http://schemas.microsoft.com/office/drawing/2014/main" id="{10521183-B27F-4009-83CE-062CAEB0FDBE}"/>
               </a:ext>
             </a:extLst>
           </p:cNvPr>
@@ -5895,7 +5900,7 @@
           <p:cNvPr id="12" name="arrow-16">
             <a:extLst xmlns:a="http://schemas.openxmlformats.org/drawingml/2006/main">
               <a:ext uri="{FF2B5EF4-FFF2-40B4-BE49-F238E27FC236}">
-                <a16:creationId xmlns:a16="http://schemas.microsoft.com/office/drawing/2014/main" id="{8668A13A-777A-48DB-809C-4DA85F2E4C54}"/>
+                <a16:creationId xmlns:a16="http://schemas.microsoft.com/office/drawing/2014/main" id="{CA5B85FA-CC83-4083-AB4D-29BFB851277D}"/>
               </a:ext>
             </a:extLst>
           </p:cNvPr>
@@ -5925,7 +5930,7 @@
           <p:cNvPr id="13" name="copy-17">
             <a:extLst xmlns:a="http://schemas.openxmlformats.org/drawingml/2006/main">
               <a:ext uri="{FF2B5EF4-FFF2-40B4-BE49-F238E27FC236}">
-                <a16:creationId xmlns:a16="http://schemas.microsoft.com/office/drawing/2014/main" id="{D91EEAAC-18D6-4762-B6CE-D5CF361FEA53}"/>
+                <a16:creationId xmlns:a16="http://schemas.microsoft.com/office/drawing/2014/main" id="{7E67CAF6-07CC-4BB5-8F6D-082554FD714D}"/>
               </a:ext>
             </a:extLst>
           </p:cNvPr>
@@ -6083,7 +6088,7 @@
           <p:cNvPr id="14" name="copy-18">
             <a:extLst xmlns:a="http://schemas.openxmlformats.org/drawingml/2006/main">
               <a:ext uri="{FF2B5EF4-FFF2-40B4-BE49-F238E27FC236}">
-                <a16:creationId xmlns:a16="http://schemas.microsoft.com/office/drawing/2014/main" id="{71C0EE02-649F-4D01-916D-45798F4FD40D}"/>
+                <a16:creationId xmlns:a16="http://schemas.microsoft.com/office/drawing/2014/main" id="{6D278628-5085-429A-A936-9E1DBFD9BA36}"/>
               </a:ext>
             </a:extLst>
           </p:cNvPr>
@@ -6231,7 +6236,7 @@
                 <a:ea typeface="Inter"/>
                 <a:cs typeface="Inter"/>
               </a:rPr>
-              <a:t>You keep the scientific judgment. The agent coordinates the work.</a:t>
+              <a:t>The agent analyses and recommends. You review and correct the results.</a:t>
             </a:r>
           </a:p>
         </p:txBody>
@@ -6239,7 +6244,7 @@
     </p:spTree>
     <p:extLst>
       <p:ext uri="{BB962C8B-B14F-4D97-AF65-F5344CB8AC3E}">
-        <p14:creationId xmlns:p14="http://schemas.microsoft.com/office/powerpoint/2010/main" val="1469401544"/>
+        <p14:creationId xmlns:p14="http://schemas.microsoft.com/office/powerpoint/2010/main" val="1982614496"/>
       </p:ext>
     </p:extLst>
   </p:cSld>
@@ -6267,10 +6272,10 @@
       </p:grpSpPr>
       <p:sp>
         <p:nvSpPr>
-          <p:cNvPr id="17" name="copy-19">
+          <p:cNvPr id="12" name="copy-19">
             <a:extLst xmlns:a="http://schemas.openxmlformats.org/drawingml/2006/main">
               <a:ext uri="{FF2B5EF4-FFF2-40B4-BE49-F238E27FC236}">
-                <a16:creationId xmlns:a16="http://schemas.microsoft.com/office/drawing/2014/main" id="{B374BC4E-BA18-4630-8329-4AE94CB95A3B}"/>
+                <a16:creationId xmlns:a16="http://schemas.microsoft.com/office/drawing/2014/main" id="{42C955C0-4E8C-4468-8FA1-E63258015598}"/>
               </a:ext>
             </a:extLst>
           </p:cNvPr>
@@ -6428,7 +6433,7 @@
           <p:cNvPr id="2" name="copy-20">
             <a:extLst xmlns:a="http://schemas.openxmlformats.org/drawingml/2006/main">
               <a:ext uri="{FF2B5EF4-FFF2-40B4-BE49-F238E27FC236}">
-                <a16:creationId xmlns:a16="http://schemas.microsoft.com/office/drawing/2014/main" id="{DFCC718C-3D16-4DFD-840B-960AA8E7D8F9}"/>
+                <a16:creationId xmlns:a16="http://schemas.microsoft.com/office/drawing/2014/main" id="{D1CD4261-52E6-4B08-8B56-E9023EED6417}"/>
               </a:ext>
             </a:extLst>
           </p:cNvPr>
@@ -6439,8 +6444,8 @@
         </p:nvSpPr>
         <p:spPr>
           <a:xfrm xmlns:a="http://schemas.openxmlformats.org/drawingml/2006/main">
-            <a:off x="552450" y="2428875"/>
-            <a:ext cx="2714625" cy="428625"/>
+            <a:off x="552450" y="2124075"/>
+            <a:ext cx="5238750" cy="619125"/>
           </a:xfrm>
           <a:prstGeom xmlns:a="http://schemas.openxmlformats.org/drawingml/2006/main" prst="rect">
             <a:avLst/>
@@ -6456,9 +6461,9 @@
           </a:bodyPr>
           <a:lstStyle xmlns:a="http://schemas.openxmlformats.org/drawingml/2006/main">
             <a:defPPr>
-              <a:defRPr sz="2100" b="1">
-                <a:solidFill>
-                  <a:srgbClr val="1B5E20"/>
+              <a:defRPr sz="2025" b="1">
+                <a:solidFill>
+                  <a:srgbClr val="111111"/>
                 </a:solidFill>
                 <a:latin typeface="Inter"/>
                 <a:ea typeface="Inter"/>
@@ -6466,9 +6471,9 @@
               </a:defRPr>
             </a:defPPr>
             <a:lvl1pPr>
-              <a:defRPr sz="2100" b="1">
-                <a:solidFill>
-                  <a:srgbClr val="1B5E20"/>
+              <a:defRPr sz="2025" b="1">
+                <a:solidFill>
+                  <a:srgbClr val="111111"/>
                 </a:solidFill>
                 <a:latin typeface="Inter"/>
                 <a:ea typeface="Inter"/>
@@ -6476,9 +6481,9 @@
               </a:defRPr>
             </a:lvl1pPr>
             <a:lvl2pPr>
-              <a:defRPr sz="2100" b="1">
-                <a:solidFill>
-                  <a:srgbClr val="1B5E20"/>
+              <a:defRPr sz="2025" b="1">
+                <a:solidFill>
+                  <a:srgbClr val="111111"/>
                 </a:solidFill>
                 <a:latin typeface="Inter"/>
                 <a:ea typeface="Inter"/>
@@ -6486,9 +6491,9 @@
               </a:defRPr>
             </a:lvl2pPr>
             <a:lvl3pPr>
-              <a:defRPr sz="2100" b="1">
-                <a:solidFill>
-                  <a:srgbClr val="1B5E20"/>
+              <a:defRPr sz="2025" b="1">
+                <a:solidFill>
+                  <a:srgbClr val="111111"/>
                 </a:solidFill>
                 <a:latin typeface="Inter"/>
                 <a:ea typeface="Inter"/>
@@ -6496,9 +6501,9 @@
               </a:defRPr>
             </a:lvl3pPr>
             <a:lvl4pPr>
-              <a:defRPr sz="2100" b="1">
-                <a:solidFill>
-                  <a:srgbClr val="1B5E20"/>
+              <a:defRPr sz="2025" b="1">
+                <a:solidFill>
+                  <a:srgbClr val="111111"/>
                 </a:solidFill>
                 <a:latin typeface="Inter"/>
                 <a:ea typeface="Inter"/>
@@ -6506,9 +6511,9 @@
               </a:defRPr>
             </a:lvl4pPr>
             <a:lvl5pPr>
-              <a:defRPr sz="2100" b="1">
-                <a:solidFill>
-                  <a:srgbClr val="1B5E20"/>
+              <a:defRPr sz="2025" b="1">
+                <a:solidFill>
+                  <a:srgbClr val="111111"/>
                 </a:solidFill>
                 <a:latin typeface="Inter"/>
                 <a:ea typeface="Inter"/>
@@ -6516,9 +6521,9 @@
               </a:defRPr>
             </a:lvl5pPr>
             <a:lvl6pPr>
-              <a:defRPr sz="2100" b="1">
-                <a:solidFill>
-                  <a:srgbClr val="1B5E20"/>
+              <a:defRPr sz="2025" b="1">
+                <a:solidFill>
+                  <a:srgbClr val="111111"/>
                 </a:solidFill>
                 <a:latin typeface="Inter"/>
                 <a:ea typeface="Inter"/>
@@ -6526,9 +6531,9 @@
               </a:defRPr>
             </a:lvl6pPr>
             <a:lvl7pPr>
-              <a:defRPr sz="2100" b="1">
-                <a:solidFill>
-                  <a:srgbClr val="1B5E20"/>
+              <a:defRPr sz="2025" b="1">
+                <a:solidFill>
+                  <a:srgbClr val="111111"/>
                 </a:solidFill>
                 <a:latin typeface="Inter"/>
                 <a:ea typeface="Inter"/>
@@ -6536,9 +6541,9 @@
               </a:defRPr>
             </a:lvl7pPr>
             <a:lvl8pPr>
-              <a:defRPr sz="2100" b="1">
-                <a:solidFill>
-                  <a:srgbClr val="1B5E20"/>
+              <a:defRPr sz="2025" b="1">
+                <a:solidFill>
+                  <a:srgbClr val="111111"/>
                 </a:solidFill>
                 <a:latin typeface="Inter"/>
                 <a:ea typeface="Inter"/>
@@ -6546,9 +6551,9 @@
               </a:defRPr>
             </a:lvl8pPr>
             <a:lvl9pPr>
-              <a:defRPr sz="2100" b="1">
-                <a:solidFill>
-                  <a:srgbClr val="1B5E20"/>
+              <a:defRPr sz="2025" b="1">
+                <a:solidFill>
+                  <a:srgbClr val="111111"/>
                 </a:solidFill>
                 <a:latin typeface="Inter"/>
                 <a:ea typeface="Inter"/>
@@ -6558,9 +6563,9 @@
           </a:lstStyle>
           <a:p xmlns:a="http://schemas.openxmlformats.org/drawingml/2006/main">
             <a:pPr>
-              <a:defRPr sz="2100" b="1">
-                <a:solidFill>
-                  <a:srgbClr val="1B5E20"/>
+              <a:defRPr sz="2025" b="1">
+                <a:solidFill>
+                  <a:srgbClr val="111111"/>
                 </a:solidFill>
                 <a:latin typeface="Inter"/>
                 <a:ea typeface="Inter"/>
@@ -6568,15 +6573,15 @@
               </a:defRPr>
             </a:pPr>
             <a:r>
-              <a:rPr sz="2100" b="1">
-                <a:solidFill>
-                  <a:srgbClr val="1B5E20"/>
+              <a:rPr sz="2025" b="1">
+                <a:solidFill>
+                  <a:srgbClr val="111111"/>
                 </a:solidFill>
                 <a:latin typeface="Inter"/>
                 <a:ea typeface="Inter"/>
                 <a:cs typeface="Inter"/>
               </a:rPr>
-              <a:t>You ask</a:t>
+              <a:t>Checks marker references</a:t>
             </a:r>
           </a:p>
         </p:txBody>
@@ -6586,7 +6591,7 @@
           <p:cNvPr id="3" name="copy-21">
             <a:extLst xmlns:a="http://schemas.openxmlformats.org/drawingml/2006/main">
               <a:ext uri="{FF2B5EF4-FFF2-40B4-BE49-F238E27FC236}">
-                <a16:creationId xmlns:a16="http://schemas.microsoft.com/office/drawing/2014/main" id="{149793C8-AD60-4543-BBA7-6376D46BCE21}"/>
+                <a16:creationId xmlns:a16="http://schemas.microsoft.com/office/drawing/2014/main" id="{C5F4DCDB-9C37-4E72-8633-518137CBD7DC}"/>
               </a:ext>
             </a:extLst>
           </p:cNvPr>
@@ -6597,8 +6602,8 @@
         </p:nvSpPr>
         <p:spPr>
           <a:xfrm xmlns:a="http://schemas.openxmlformats.org/drawingml/2006/main">
-            <a:off x="552450" y="3095625"/>
-            <a:ext cx="2714625" cy="1047750"/>
+            <a:off x="552450" y="2495550"/>
+            <a:ext cx="5238750" cy="285750"/>
           </a:xfrm>
           <a:prstGeom xmlns:a="http://schemas.openxmlformats.org/drawingml/2006/main" prst="rect">
             <a:avLst/>
@@ -6614,9 +6619,9 @@
           </a:bodyPr>
           <a:lstStyle xmlns:a="http://schemas.openxmlformats.org/drawingml/2006/main">
             <a:defPPr>
-              <a:defRPr sz="2550" b="1">
-                <a:solidFill>
-                  <a:srgbClr val="111111"/>
+              <a:defRPr sz="1500" b="0">
+                <a:solidFill>
+                  <a:srgbClr val="666666"/>
                 </a:solidFill>
                 <a:latin typeface="Inter"/>
                 <a:ea typeface="Inter"/>
@@ -6624,9 +6629,9 @@
               </a:defRPr>
             </a:defPPr>
             <a:lvl1pPr>
-              <a:defRPr sz="2550" b="1">
-                <a:solidFill>
-                  <a:srgbClr val="111111"/>
+              <a:defRPr sz="1500" b="0">
+                <a:solidFill>
+                  <a:srgbClr val="666666"/>
                 </a:solidFill>
                 <a:latin typeface="Inter"/>
                 <a:ea typeface="Inter"/>
@@ -6634,9 +6639,9 @@
               </a:defRPr>
             </a:lvl1pPr>
             <a:lvl2pPr>
-              <a:defRPr sz="2550" b="1">
-                <a:solidFill>
-                  <a:srgbClr val="111111"/>
+              <a:defRPr sz="1500" b="0">
+                <a:solidFill>
+                  <a:srgbClr val="666666"/>
                 </a:solidFill>
                 <a:latin typeface="Inter"/>
                 <a:ea typeface="Inter"/>
@@ -6644,9 +6649,9 @@
               </a:defRPr>
             </a:lvl2pPr>
             <a:lvl3pPr>
-              <a:defRPr sz="2550" b="1">
-                <a:solidFill>
-                  <a:srgbClr val="111111"/>
+              <a:defRPr sz="1500" b="0">
+                <a:solidFill>
+                  <a:srgbClr val="666666"/>
                 </a:solidFill>
                 <a:latin typeface="Inter"/>
                 <a:ea typeface="Inter"/>
@@ -6654,9 +6659,9 @@
               </a:defRPr>
             </a:lvl3pPr>
             <a:lvl4pPr>
-              <a:defRPr sz="2550" b="1">
-                <a:solidFill>
-                  <a:srgbClr val="111111"/>
+              <a:defRPr sz="1500" b="0">
+                <a:solidFill>
+                  <a:srgbClr val="666666"/>
                 </a:solidFill>
                 <a:latin typeface="Inter"/>
                 <a:ea typeface="Inter"/>
@@ -6664,9 +6669,9 @@
               </a:defRPr>
             </a:lvl4pPr>
             <a:lvl5pPr>
-              <a:defRPr sz="2550" b="1">
-                <a:solidFill>
-                  <a:srgbClr val="111111"/>
+              <a:defRPr sz="1500" b="0">
+                <a:solidFill>
+                  <a:srgbClr val="666666"/>
                 </a:solidFill>
                 <a:latin typeface="Inter"/>
                 <a:ea typeface="Inter"/>
@@ -6674,9 +6679,9 @@
               </a:defRPr>
             </a:lvl5pPr>
             <a:lvl6pPr>
-              <a:defRPr sz="2550" b="1">
-                <a:solidFill>
-                  <a:srgbClr val="111111"/>
+              <a:defRPr sz="1500" b="0">
+                <a:solidFill>
+                  <a:srgbClr val="666666"/>
                 </a:solidFill>
                 <a:latin typeface="Inter"/>
                 <a:ea typeface="Inter"/>
@@ -6684,9 +6689,9 @@
               </a:defRPr>
             </a:lvl6pPr>
             <a:lvl7pPr>
-              <a:defRPr sz="2550" b="1">
-                <a:solidFill>
-                  <a:srgbClr val="111111"/>
+              <a:defRPr sz="1500" b="0">
+                <a:solidFill>
+                  <a:srgbClr val="666666"/>
                 </a:solidFill>
                 <a:latin typeface="Inter"/>
                 <a:ea typeface="Inter"/>
@@ -6694,9 +6699,9 @@
               </a:defRPr>
             </a:lvl7pPr>
             <a:lvl8pPr>
-              <a:defRPr sz="2550" b="1">
-                <a:solidFill>
-                  <a:srgbClr val="111111"/>
+              <a:defRPr sz="1500" b="0">
+                <a:solidFill>
+                  <a:srgbClr val="666666"/>
                 </a:solidFill>
                 <a:latin typeface="Inter"/>
                 <a:ea typeface="Inter"/>
@@ -6704,9 +6709,9 @@
               </a:defRPr>
             </a:lvl8pPr>
             <a:lvl9pPr>
-              <a:defRPr sz="2550" b="1">
-                <a:solidFill>
-                  <a:srgbClr val="111111"/>
+              <a:defRPr sz="1500" b="0">
+                <a:solidFill>
+                  <a:srgbClr val="666666"/>
                 </a:solidFill>
                 <a:latin typeface="Inter"/>
                 <a:ea typeface="Inter"/>
@@ -6716,9 +6721,9 @@
           </a:lstStyle>
           <a:p xmlns:a="http://schemas.openxmlformats.org/drawingml/2006/main">
             <a:pPr>
-              <a:defRPr sz="2550" b="1">
-                <a:solidFill>
-                  <a:srgbClr val="111111"/>
+              <a:defRPr sz="1500" b="0">
+                <a:solidFill>
+                  <a:srgbClr val="666666"/>
                 </a:solidFill>
                 <a:latin typeface="Inter"/>
                 <a:ea typeface="Inter"/>
@@ -6726,48 +6731,25 @@
               </a:defRPr>
             </a:pPr>
             <a:r>
-              <a:rPr sz="2550" b="1">
-                <a:solidFill>
-                  <a:srgbClr val="111111"/>
+              <a:rPr sz="1500" b="0">
+                <a:solidFill>
+                  <a:srgbClr val="666666"/>
                 </a:solidFill>
                 <a:latin typeface="Inter"/>
                 <a:ea typeface="Inter"/>
                 <a:cs typeface="Inter"/>
               </a:rPr>
-              <a:t>“Which cells</a:t>
-            </a:r>
-          </a:p>
-          <a:p xmlns:a="http://schemas.openxmlformats.org/drawingml/2006/main">
-            <a:pPr>
-              <a:defRPr sz="2550" b="1">
-                <a:solidFill>
-                  <a:srgbClr val="111111"/>
-                </a:solidFill>
-                <a:latin typeface="Inter"/>
-                <a:ea typeface="Inter"/>
-                <a:cs typeface="Inter"/>
-              </a:defRPr>
-            </a:pPr>
-            <a:r>
-              <a:rPr sz="2550" b="1">
-                <a:solidFill>
-                  <a:srgbClr val="111111"/>
-                </a:solidFill>
-                <a:latin typeface="Inter"/>
-                <a:ea typeface="Inter"/>
-                <a:cs typeface="Inter"/>
-              </a:rPr>
-              <a:t>are these?”</a:t>
+              <a:t>Zetaris</a:t>
             </a:r>
           </a:p>
         </p:txBody>
       </p:sp>
       <p:sp>
         <p:nvSpPr>
-          <p:cNvPr id="4" name="arrow-22">
+          <p:cNvPr id="4" name="copy-22">
             <a:extLst xmlns:a="http://schemas.openxmlformats.org/drawingml/2006/main">
               <a:ext uri="{FF2B5EF4-FFF2-40B4-BE49-F238E27FC236}">
-                <a16:creationId xmlns:a16="http://schemas.microsoft.com/office/drawing/2014/main" id="{DD93AF22-BF1E-4ECB-8ACF-B94553A539AC}"/>
+                <a16:creationId xmlns:a16="http://schemas.microsoft.com/office/drawing/2014/main" id="{506E5637-ED0D-4736-9345-0125E4C9E0B5}"/>
               </a:ext>
             </a:extLst>
           </p:cNvPr>
@@ -6778,68 +6760,8 @@
         </p:nvSpPr>
         <p:spPr>
           <a:xfrm xmlns:a="http://schemas.openxmlformats.org/drawingml/2006/main">
-            <a:off x="3057525" y="3705225"/>
-            <a:ext cx="361950" cy="152400"/>
-          </a:xfrm>
-          <a:prstGeom xmlns:a="http://schemas.openxmlformats.org/drawingml/2006/main" prst="rightArrow">
-            <a:avLst/>
-          </a:prstGeom>
-          <a:solidFill xmlns:a="http://schemas.openxmlformats.org/drawingml/2006/main">
-            <a:srgbClr val="1B5E20"/>
-          </a:solidFill>
-          <a:ln xmlns:a="http://schemas.openxmlformats.org/drawingml/2006/main" w="0">
-            <a:noFill/>
-          </a:ln>
-        </p:spPr>
-      </p:sp>
-      <p:sp>
-        <p:nvSpPr>
-          <p:cNvPr id="5" name="block-23">
-            <a:extLst xmlns:a="http://schemas.openxmlformats.org/drawingml/2006/main">
-              <a:ext uri="{FF2B5EF4-FFF2-40B4-BE49-F238E27FC236}">
-                <a16:creationId xmlns:a16="http://schemas.microsoft.com/office/drawing/2014/main" id="{C6453E33-9D11-417E-A683-4682ED99F972}"/>
-              </a:ext>
-            </a:extLst>
-          </p:cNvPr>
-          <p:cNvSpPr>
-            <a:spLocks xmlns:a="http://schemas.openxmlformats.org/drawingml/2006/main" noGrp="1"/>
-          </p:cNvSpPr>
-          <p:nvPr/>
-        </p:nvSpPr>
-        <p:spPr>
-          <a:xfrm xmlns:a="http://schemas.openxmlformats.org/drawingml/2006/main">
-            <a:off x="3714750" y="2133600"/>
-            <a:ext cx="4762500" cy="3476625"/>
-          </a:xfrm>
-          <a:prstGeom xmlns:a="http://schemas.openxmlformats.org/drawingml/2006/main" prst="rect">
-            <a:avLst/>
-          </a:prstGeom>
-          <a:solidFill xmlns:a="http://schemas.openxmlformats.org/drawingml/2006/main">
-            <a:srgbClr val="111111"/>
-          </a:solidFill>
-          <a:ln xmlns:a="http://schemas.openxmlformats.org/drawingml/2006/main" w="0">
-            <a:noFill/>
-          </a:ln>
-        </p:spPr>
-      </p:sp>
-      <p:sp>
-        <p:nvSpPr>
-          <p:cNvPr id="6" name="copy-24">
-            <a:extLst xmlns:a="http://schemas.openxmlformats.org/drawingml/2006/main">
-              <a:ext uri="{FF2B5EF4-FFF2-40B4-BE49-F238E27FC236}">
-                <a16:creationId xmlns:a16="http://schemas.microsoft.com/office/drawing/2014/main" id="{FE7CA30B-2B73-4F84-925C-53823FA3C756}"/>
-              </a:ext>
-            </a:extLst>
-          </p:cNvPr>
-          <p:cNvSpPr>
-            <a:spLocks xmlns:a="http://schemas.openxmlformats.org/drawingml/2006/main" noGrp="1"/>
-          </p:cNvSpPr>
-          <p:nvPr/>
-        </p:nvSpPr>
-        <p:spPr>
-          <a:xfrm xmlns:a="http://schemas.openxmlformats.org/drawingml/2006/main">
-            <a:off x="4000500" y="2362200"/>
-            <a:ext cx="4191000" cy="523875"/>
+            <a:off x="552450" y="2971800"/>
+            <a:ext cx="5238750" cy="619125"/>
           </a:xfrm>
           <a:prstGeom xmlns:a="http://schemas.openxmlformats.org/drawingml/2006/main" prst="rect">
             <a:avLst/>
@@ -6855,9 +6777,9 @@
           </a:bodyPr>
           <a:lstStyle xmlns:a="http://schemas.openxmlformats.org/drawingml/2006/main">
             <a:defPPr>
-              <a:defRPr sz="2775" b="1">
-                <a:solidFill>
-                  <a:srgbClr val="FFFFFF"/>
+              <a:defRPr sz="2025" b="1">
+                <a:solidFill>
+                  <a:srgbClr val="111111"/>
                 </a:solidFill>
                 <a:latin typeface="Inter"/>
                 <a:ea typeface="Inter"/>
@@ -6865,9 +6787,9 @@
               </a:defRPr>
             </a:defPPr>
             <a:lvl1pPr>
-              <a:defRPr sz="2775" b="1">
-                <a:solidFill>
-                  <a:srgbClr val="FFFFFF"/>
+              <a:defRPr sz="2025" b="1">
+                <a:solidFill>
+                  <a:srgbClr val="111111"/>
                 </a:solidFill>
                 <a:latin typeface="Inter"/>
                 <a:ea typeface="Inter"/>
@@ -6875,9 +6797,9 @@
               </a:defRPr>
             </a:lvl1pPr>
             <a:lvl2pPr>
-              <a:defRPr sz="2775" b="1">
-                <a:solidFill>
-                  <a:srgbClr val="FFFFFF"/>
+              <a:defRPr sz="2025" b="1">
+                <a:solidFill>
+                  <a:srgbClr val="111111"/>
                 </a:solidFill>
                 <a:latin typeface="Inter"/>
                 <a:ea typeface="Inter"/>
@@ -6885,9 +6807,9 @@
               </a:defRPr>
             </a:lvl2pPr>
             <a:lvl3pPr>
-              <a:defRPr sz="2775" b="1">
-                <a:solidFill>
-                  <a:srgbClr val="FFFFFF"/>
+              <a:defRPr sz="2025" b="1">
+                <a:solidFill>
+                  <a:srgbClr val="111111"/>
                 </a:solidFill>
                 <a:latin typeface="Inter"/>
                 <a:ea typeface="Inter"/>
@@ -6895,9 +6817,9 @@
               </a:defRPr>
             </a:lvl3pPr>
             <a:lvl4pPr>
-              <a:defRPr sz="2775" b="1">
-                <a:solidFill>
-                  <a:srgbClr val="FFFFFF"/>
+              <a:defRPr sz="2025" b="1">
+                <a:solidFill>
+                  <a:srgbClr val="111111"/>
                 </a:solidFill>
                 <a:latin typeface="Inter"/>
                 <a:ea typeface="Inter"/>
@@ -6905,9 +6827,9 @@
               </a:defRPr>
             </a:lvl4pPr>
             <a:lvl5pPr>
-              <a:defRPr sz="2775" b="1">
-                <a:solidFill>
-                  <a:srgbClr val="FFFFFF"/>
+              <a:defRPr sz="2025" b="1">
+                <a:solidFill>
+                  <a:srgbClr val="111111"/>
                 </a:solidFill>
                 <a:latin typeface="Inter"/>
                 <a:ea typeface="Inter"/>
@@ -6915,9 +6837,9 @@
               </a:defRPr>
             </a:lvl5pPr>
             <a:lvl6pPr>
-              <a:defRPr sz="2775" b="1">
-                <a:solidFill>
-                  <a:srgbClr val="FFFFFF"/>
+              <a:defRPr sz="2025" b="1">
+                <a:solidFill>
+                  <a:srgbClr val="111111"/>
                 </a:solidFill>
                 <a:latin typeface="Inter"/>
                 <a:ea typeface="Inter"/>
@@ -6925,9 +6847,9 @@
               </a:defRPr>
             </a:lvl6pPr>
             <a:lvl7pPr>
-              <a:defRPr sz="2775" b="1">
-                <a:solidFill>
-                  <a:srgbClr val="FFFFFF"/>
+              <a:defRPr sz="2025" b="1">
+                <a:solidFill>
+                  <a:srgbClr val="111111"/>
                 </a:solidFill>
                 <a:latin typeface="Inter"/>
                 <a:ea typeface="Inter"/>
@@ -6935,9 +6857,9 @@
               </a:defRPr>
             </a:lvl7pPr>
             <a:lvl8pPr>
-              <a:defRPr sz="2775" b="1">
-                <a:solidFill>
-                  <a:srgbClr val="FFFFFF"/>
+              <a:defRPr sz="2025" b="1">
+                <a:solidFill>
+                  <a:srgbClr val="111111"/>
                 </a:solidFill>
                 <a:latin typeface="Inter"/>
                 <a:ea typeface="Inter"/>
@@ -6945,9 +6867,9 @@
               </a:defRPr>
             </a:lvl8pPr>
             <a:lvl9pPr>
-              <a:defRPr sz="2775" b="1">
-                <a:solidFill>
-                  <a:srgbClr val="FFFFFF"/>
+              <a:defRPr sz="2025" b="1">
+                <a:solidFill>
+                  <a:srgbClr val="111111"/>
                 </a:solidFill>
                 <a:latin typeface="Inter"/>
                 <a:ea typeface="Inter"/>
@@ -6957,9 +6879,9 @@
           </a:lstStyle>
           <a:p xmlns:a="http://schemas.openxmlformats.org/drawingml/2006/main">
             <a:pPr>
-              <a:defRPr sz="2775" b="1">
-                <a:solidFill>
-                  <a:srgbClr val="FFFFFF"/>
+              <a:defRPr sz="2025" b="1">
+                <a:solidFill>
+                  <a:srgbClr val="111111"/>
                 </a:solidFill>
                 <a:latin typeface="Inter"/>
                 <a:ea typeface="Inter"/>
@@ -6967,25 +6889,25 @@
               </a:defRPr>
             </a:pPr>
             <a:r>
-              <a:rPr sz="2775" b="1">
-                <a:solidFill>
-                  <a:srgbClr val="FFFFFF"/>
+              <a:rPr sz="2025" b="1">
+                <a:solidFill>
+                  <a:srgbClr val="111111"/>
                 </a:solidFill>
                 <a:latin typeface="Inter"/>
                 <a:ea typeface="Inter"/>
                 <a:cs typeface="Inter"/>
               </a:rPr>
-              <a:t>Celloras agent</a:t>
+              <a:t>Measures gene activity</a:t>
             </a:r>
           </a:p>
         </p:txBody>
       </p:sp>
       <p:sp>
         <p:nvSpPr>
-          <p:cNvPr id="7" name="copy-25">
+          <p:cNvPr id="5" name="copy-23">
             <a:extLst xmlns:a="http://schemas.openxmlformats.org/drawingml/2006/main">
               <a:ext uri="{FF2B5EF4-FFF2-40B4-BE49-F238E27FC236}">
-                <a16:creationId xmlns:a16="http://schemas.microsoft.com/office/drawing/2014/main" id="{666F5245-859C-42FE-B619-2159436BCD59}"/>
+                <a16:creationId xmlns:a16="http://schemas.microsoft.com/office/drawing/2014/main" id="{660F8F19-EC55-4D8B-8B30-8C65C17BE87A}"/>
               </a:ext>
             </a:extLst>
           </p:cNvPr>
@@ -6996,8 +6918,8 @@
         </p:nvSpPr>
         <p:spPr>
           <a:xfrm xmlns:a="http://schemas.openxmlformats.org/drawingml/2006/main">
-            <a:off x="4000500" y="3152775"/>
-            <a:ext cx="4191000" cy="352425"/>
+            <a:off x="552450" y="3343275"/>
+            <a:ext cx="5238750" cy="285750"/>
           </a:xfrm>
           <a:prstGeom xmlns:a="http://schemas.openxmlformats.org/drawingml/2006/main" prst="rect">
             <a:avLst/>
@@ -7013,9 +6935,9 @@
           </a:bodyPr>
           <a:lstStyle xmlns:a="http://schemas.openxmlformats.org/drawingml/2006/main">
             <a:defPPr>
-              <a:defRPr sz="1875" b="1">
-                <a:solidFill>
-                  <a:srgbClr val="FFFFFF"/>
+              <a:defRPr sz="1500" b="0">
+                <a:solidFill>
+                  <a:srgbClr val="666666"/>
                 </a:solidFill>
                 <a:latin typeface="Inter"/>
                 <a:ea typeface="Inter"/>
@@ -7023,9 +6945,9 @@
               </a:defRPr>
             </a:defPPr>
             <a:lvl1pPr>
-              <a:defRPr sz="1875" b="1">
-                <a:solidFill>
-                  <a:srgbClr val="FFFFFF"/>
+              <a:defRPr sz="1500" b="0">
+                <a:solidFill>
+                  <a:srgbClr val="666666"/>
                 </a:solidFill>
                 <a:latin typeface="Inter"/>
                 <a:ea typeface="Inter"/>
@@ -7033,9 +6955,9 @@
               </a:defRPr>
             </a:lvl1pPr>
             <a:lvl2pPr>
-              <a:defRPr sz="1875" b="1">
-                <a:solidFill>
-                  <a:srgbClr val="FFFFFF"/>
+              <a:defRPr sz="1500" b="0">
+                <a:solidFill>
+                  <a:srgbClr val="666666"/>
                 </a:solidFill>
                 <a:latin typeface="Inter"/>
                 <a:ea typeface="Inter"/>
@@ -7043,9 +6965,9 @@
               </a:defRPr>
             </a:lvl2pPr>
             <a:lvl3pPr>
-              <a:defRPr sz="1875" b="1">
-                <a:solidFill>
-                  <a:srgbClr val="FFFFFF"/>
+              <a:defRPr sz="1500" b="0">
+                <a:solidFill>
+                  <a:srgbClr val="666666"/>
                 </a:solidFill>
                 <a:latin typeface="Inter"/>
                 <a:ea typeface="Inter"/>
@@ -7053,9 +6975,9 @@
               </a:defRPr>
             </a:lvl3pPr>
             <a:lvl4pPr>
-              <a:defRPr sz="1875" b="1">
-                <a:solidFill>
-                  <a:srgbClr val="FFFFFF"/>
+              <a:defRPr sz="1500" b="0">
+                <a:solidFill>
+                  <a:srgbClr val="666666"/>
                 </a:solidFill>
                 <a:latin typeface="Inter"/>
                 <a:ea typeface="Inter"/>
@@ -7063,9 +6985,9 @@
               </a:defRPr>
             </a:lvl4pPr>
             <a:lvl5pPr>
-              <a:defRPr sz="1875" b="1">
-                <a:solidFill>
-                  <a:srgbClr val="FFFFFF"/>
+              <a:defRPr sz="1500" b="0">
+                <a:solidFill>
+                  <a:srgbClr val="666666"/>
                 </a:solidFill>
                 <a:latin typeface="Inter"/>
                 <a:ea typeface="Inter"/>
@@ -7073,9 +6995,9 @@
               </a:defRPr>
             </a:lvl5pPr>
             <a:lvl6pPr>
-              <a:defRPr sz="1875" b="1">
-                <a:solidFill>
-                  <a:srgbClr val="FFFFFF"/>
+              <a:defRPr sz="1500" b="0">
+                <a:solidFill>
+                  <a:srgbClr val="666666"/>
                 </a:solidFill>
                 <a:latin typeface="Inter"/>
                 <a:ea typeface="Inter"/>
@@ -7083,9 +7005,9 @@
               </a:defRPr>
             </a:lvl6pPr>
             <a:lvl7pPr>
-              <a:defRPr sz="1875" b="1">
-                <a:solidFill>
-                  <a:srgbClr val="FFFFFF"/>
+              <a:defRPr sz="1500" b="0">
+                <a:solidFill>
+                  <a:srgbClr val="666666"/>
                 </a:solidFill>
                 <a:latin typeface="Inter"/>
                 <a:ea typeface="Inter"/>
@@ -7093,9 +7015,9 @@
               </a:defRPr>
             </a:lvl7pPr>
             <a:lvl8pPr>
-              <a:defRPr sz="1875" b="1">
-                <a:solidFill>
-                  <a:srgbClr val="FFFFFF"/>
+              <a:defRPr sz="1500" b="0">
+                <a:solidFill>
+                  <a:srgbClr val="666666"/>
                 </a:solidFill>
                 <a:latin typeface="Inter"/>
                 <a:ea typeface="Inter"/>
@@ -7103,9 +7025,9 @@
               </a:defRPr>
             </a:lvl8pPr>
             <a:lvl9pPr>
-              <a:defRPr sz="1875" b="1">
-                <a:solidFill>
-                  <a:srgbClr val="FFFFFF"/>
+              <a:defRPr sz="1500" b="0">
+                <a:solidFill>
+                  <a:srgbClr val="666666"/>
                 </a:solidFill>
                 <a:latin typeface="Inter"/>
                 <a:ea typeface="Inter"/>
@@ -7115,9 +7037,9 @@
           </a:lstStyle>
           <a:p xmlns:a="http://schemas.openxmlformats.org/drawingml/2006/main">
             <a:pPr>
-              <a:defRPr sz="1875" b="1">
-                <a:solidFill>
-                  <a:srgbClr val="FFFFFF"/>
+              <a:defRPr sz="1500" b="0">
+                <a:solidFill>
+                  <a:srgbClr val="666666"/>
                 </a:solidFill>
                 <a:latin typeface="Inter"/>
                 <a:ea typeface="Inter"/>
@@ -7125,25 +7047,25 @@
               </a:defRPr>
             </a:pPr>
             <a:r>
-              <a:rPr sz="1875" b="1">
-                <a:solidFill>
-                  <a:srgbClr val="FFFFFF"/>
+              <a:rPr sz="1500" b="0">
+                <a:solidFill>
+                  <a:srgbClr val="666666"/>
                 </a:solidFill>
                 <a:latin typeface="Inter"/>
                 <a:ea typeface="Inter"/>
                 <a:cs typeface="Inter"/>
               </a:rPr>
-              <a:t>Checks published markers</a:t>
+              <a:t>Scientific analysis tools</a:t>
             </a:r>
           </a:p>
         </p:txBody>
       </p:sp>
       <p:sp>
         <p:nvSpPr>
-          <p:cNvPr id="8" name="copy-26">
+          <p:cNvPr id="6" name="copy-24">
             <a:extLst xmlns:a="http://schemas.openxmlformats.org/drawingml/2006/main">
               <a:ext uri="{FF2B5EF4-FFF2-40B4-BE49-F238E27FC236}">
-                <a16:creationId xmlns:a16="http://schemas.microsoft.com/office/drawing/2014/main" id="{0C0B7B26-3B4B-450E-BBBD-A782513622BD}"/>
+                <a16:creationId xmlns:a16="http://schemas.microsoft.com/office/drawing/2014/main" id="{56D6EC85-3A55-4114-AD42-B87D5688BE32}"/>
               </a:ext>
             </a:extLst>
           </p:cNvPr>
@@ -7154,8 +7076,8 @@
         </p:nvSpPr>
         <p:spPr>
           <a:xfrm xmlns:a="http://schemas.openxmlformats.org/drawingml/2006/main">
-            <a:off x="4000500" y="3514725"/>
-            <a:ext cx="4191000" cy="266700"/>
+            <a:off x="552450" y="3819525"/>
+            <a:ext cx="5238750" cy="619125"/>
           </a:xfrm>
           <a:prstGeom xmlns:a="http://schemas.openxmlformats.org/drawingml/2006/main" prst="rect">
             <a:avLst/>
@@ -7171,9 +7093,9 @@
           </a:bodyPr>
           <a:lstStyle xmlns:a="http://schemas.openxmlformats.org/drawingml/2006/main">
             <a:defPPr>
-              <a:defRPr sz="1425" b="0">
-                <a:solidFill>
-                  <a:srgbClr val="BAD4B1"/>
+              <a:defRPr sz="2025" b="1">
+                <a:solidFill>
+                  <a:srgbClr val="1B5E20"/>
                 </a:solidFill>
                 <a:latin typeface="Inter"/>
                 <a:ea typeface="Inter"/>
@@ -7181,9 +7103,9 @@
               </a:defRPr>
             </a:defPPr>
             <a:lvl1pPr>
-              <a:defRPr sz="1425" b="0">
-                <a:solidFill>
-                  <a:srgbClr val="BAD4B1"/>
+              <a:defRPr sz="2025" b="1">
+                <a:solidFill>
+                  <a:srgbClr val="1B5E20"/>
                 </a:solidFill>
                 <a:latin typeface="Inter"/>
                 <a:ea typeface="Inter"/>
@@ -7191,9 +7113,9 @@
               </a:defRPr>
             </a:lvl1pPr>
             <a:lvl2pPr>
-              <a:defRPr sz="1425" b="0">
-                <a:solidFill>
-                  <a:srgbClr val="BAD4B1"/>
+              <a:defRPr sz="2025" b="1">
+                <a:solidFill>
+                  <a:srgbClr val="1B5E20"/>
                 </a:solidFill>
                 <a:latin typeface="Inter"/>
                 <a:ea typeface="Inter"/>
@@ -7201,9 +7123,9 @@
               </a:defRPr>
             </a:lvl2pPr>
             <a:lvl3pPr>
-              <a:defRPr sz="1425" b="0">
-                <a:solidFill>
-                  <a:srgbClr val="BAD4B1"/>
+              <a:defRPr sz="2025" b="1">
+                <a:solidFill>
+                  <a:srgbClr val="1B5E20"/>
                 </a:solidFill>
                 <a:latin typeface="Inter"/>
                 <a:ea typeface="Inter"/>
@@ -7211,9 +7133,9 @@
               </a:defRPr>
             </a:lvl3pPr>
             <a:lvl4pPr>
-              <a:defRPr sz="1425" b="0">
-                <a:solidFill>
-                  <a:srgbClr val="BAD4B1"/>
+              <a:defRPr sz="2025" b="1">
+                <a:solidFill>
+                  <a:srgbClr val="1B5E20"/>
                 </a:solidFill>
                 <a:latin typeface="Inter"/>
                 <a:ea typeface="Inter"/>
@@ -7221,9 +7143,9 @@
               </a:defRPr>
             </a:lvl4pPr>
             <a:lvl5pPr>
-              <a:defRPr sz="1425" b="0">
-                <a:solidFill>
-                  <a:srgbClr val="BAD4B1"/>
+              <a:defRPr sz="2025" b="1">
+                <a:solidFill>
+                  <a:srgbClr val="1B5E20"/>
                 </a:solidFill>
                 <a:latin typeface="Inter"/>
                 <a:ea typeface="Inter"/>
@@ -7231,9 +7153,9 @@
               </a:defRPr>
             </a:lvl5pPr>
             <a:lvl6pPr>
-              <a:defRPr sz="1425" b="0">
-                <a:solidFill>
-                  <a:srgbClr val="BAD4B1"/>
+              <a:defRPr sz="2025" b="1">
+                <a:solidFill>
+                  <a:srgbClr val="1B5E20"/>
                 </a:solidFill>
                 <a:latin typeface="Inter"/>
                 <a:ea typeface="Inter"/>
@@ -7241,9 +7163,9 @@
               </a:defRPr>
             </a:lvl6pPr>
             <a:lvl7pPr>
-              <a:defRPr sz="1425" b="0">
-                <a:solidFill>
-                  <a:srgbClr val="BAD4B1"/>
+              <a:defRPr sz="2025" b="1">
+                <a:solidFill>
+                  <a:srgbClr val="1B5E20"/>
                 </a:solidFill>
                 <a:latin typeface="Inter"/>
                 <a:ea typeface="Inter"/>
@@ -7251,9 +7173,9 @@
               </a:defRPr>
             </a:lvl7pPr>
             <a:lvl8pPr>
-              <a:defRPr sz="1425" b="0">
-                <a:solidFill>
-                  <a:srgbClr val="BAD4B1"/>
+              <a:defRPr sz="2025" b="1">
+                <a:solidFill>
+                  <a:srgbClr val="1B5E20"/>
                 </a:solidFill>
                 <a:latin typeface="Inter"/>
                 <a:ea typeface="Inter"/>
@@ -7261,9 +7183,9 @@
               </a:defRPr>
             </a:lvl8pPr>
             <a:lvl9pPr>
-              <a:defRPr sz="1425" b="0">
-                <a:solidFill>
-                  <a:srgbClr val="BAD4B1"/>
+              <a:defRPr sz="2025" b="1">
+                <a:solidFill>
+                  <a:srgbClr val="1B5E20"/>
                 </a:solidFill>
                 <a:latin typeface="Inter"/>
                 <a:ea typeface="Inter"/>
@@ -7273,9 +7195,9 @@
           </a:lstStyle>
           <a:p xmlns:a="http://schemas.openxmlformats.org/drawingml/2006/main">
             <a:pPr>
-              <a:defRPr sz="1425" b="0">
-                <a:solidFill>
-                  <a:srgbClr val="BAD4B1"/>
+              <a:defRPr sz="2025" b="1">
+                <a:solidFill>
+                  <a:srgbClr val="1B5E20"/>
                 </a:solidFill>
                 <a:latin typeface="Inter"/>
                 <a:ea typeface="Inter"/>
@@ -7283,25 +7205,25 @@
               </a:defRPr>
             </a:pPr>
             <a:r>
-              <a:rPr sz="1425" b="0">
-                <a:solidFill>
-                  <a:srgbClr val="BAD4B1"/>
+              <a:rPr sz="2025" b="1">
+                <a:solidFill>
+                  <a:srgbClr val="1B5E20"/>
                 </a:solidFill>
                 <a:latin typeface="Inter"/>
                 <a:ea typeface="Inter"/>
                 <a:cs typeface="Inter"/>
               </a:rPr>
-              <a:t>Zetaris</a:t>
+              <a:t>Proposes cell types and explains why</a:t>
             </a:r>
           </a:p>
         </p:txBody>
       </p:sp>
       <p:sp>
         <p:nvSpPr>
-          <p:cNvPr id="9" name="copy-27">
+          <p:cNvPr id="7" name="copy-25">
             <a:extLst xmlns:a="http://schemas.openxmlformats.org/drawingml/2006/main">
               <a:ext uri="{FF2B5EF4-FFF2-40B4-BE49-F238E27FC236}">
-                <a16:creationId xmlns:a16="http://schemas.microsoft.com/office/drawing/2014/main" id="{CED8882E-8BA3-46A6-AF3D-E00F637376F7}"/>
+                <a16:creationId xmlns:a16="http://schemas.microsoft.com/office/drawing/2014/main" id="{818A7045-458B-4749-AA64-F7FD6DBC01BA}"/>
               </a:ext>
             </a:extLst>
           </p:cNvPr>
@@ -7312,8 +7234,8 @@
         </p:nvSpPr>
         <p:spPr>
           <a:xfrm xmlns:a="http://schemas.openxmlformats.org/drawingml/2006/main">
-            <a:off x="4000500" y="3914775"/>
-            <a:ext cx="4191000" cy="352425"/>
+            <a:off x="552450" y="4191000"/>
+            <a:ext cx="5238750" cy="285750"/>
           </a:xfrm>
           <a:prstGeom xmlns:a="http://schemas.openxmlformats.org/drawingml/2006/main" prst="rect">
             <a:avLst/>
@@ -7329,9 +7251,9 @@
           </a:bodyPr>
           <a:lstStyle xmlns:a="http://schemas.openxmlformats.org/drawingml/2006/main">
             <a:defPPr>
-              <a:defRPr sz="1875" b="1">
-                <a:solidFill>
-                  <a:srgbClr val="FFFFFF"/>
+              <a:defRPr sz="1500" b="0">
+                <a:solidFill>
+                  <a:srgbClr val="666666"/>
                 </a:solidFill>
                 <a:latin typeface="Inter"/>
                 <a:ea typeface="Inter"/>
@@ -7339,9 +7261,9 @@
               </a:defRPr>
             </a:defPPr>
             <a:lvl1pPr>
-              <a:defRPr sz="1875" b="1">
-                <a:solidFill>
-                  <a:srgbClr val="FFFFFF"/>
+              <a:defRPr sz="1500" b="0">
+                <a:solidFill>
+                  <a:srgbClr val="666666"/>
                 </a:solidFill>
                 <a:latin typeface="Inter"/>
                 <a:ea typeface="Inter"/>
@@ -7349,9 +7271,9 @@
               </a:defRPr>
             </a:lvl1pPr>
             <a:lvl2pPr>
-              <a:defRPr sz="1875" b="1">
-                <a:solidFill>
-                  <a:srgbClr val="FFFFFF"/>
+              <a:defRPr sz="1500" b="0">
+                <a:solidFill>
+                  <a:srgbClr val="666666"/>
                 </a:solidFill>
                 <a:latin typeface="Inter"/>
                 <a:ea typeface="Inter"/>
@@ -7359,9 +7281,9 @@
               </a:defRPr>
             </a:lvl2pPr>
             <a:lvl3pPr>
-              <a:defRPr sz="1875" b="1">
-                <a:solidFill>
-                  <a:srgbClr val="FFFFFF"/>
+              <a:defRPr sz="1500" b="0">
+                <a:solidFill>
+                  <a:srgbClr val="666666"/>
                 </a:solidFill>
                 <a:latin typeface="Inter"/>
                 <a:ea typeface="Inter"/>
@@ -7369,9 +7291,9 @@
               </a:defRPr>
             </a:lvl3pPr>
             <a:lvl4pPr>
-              <a:defRPr sz="1875" b="1">
-                <a:solidFill>
-                  <a:srgbClr val="FFFFFF"/>
+              <a:defRPr sz="1500" b="0">
+                <a:solidFill>
+                  <a:srgbClr val="666666"/>
                 </a:solidFill>
                 <a:latin typeface="Inter"/>
                 <a:ea typeface="Inter"/>
@@ -7379,9 +7301,9 @@
               </a:defRPr>
             </a:lvl4pPr>
             <a:lvl5pPr>
-              <a:defRPr sz="1875" b="1">
-                <a:solidFill>
-                  <a:srgbClr val="FFFFFF"/>
+              <a:defRPr sz="1500" b="0">
+                <a:solidFill>
+                  <a:srgbClr val="666666"/>
                 </a:solidFill>
                 <a:latin typeface="Inter"/>
                 <a:ea typeface="Inter"/>
@@ -7389,9 +7311,9 @@
               </a:defRPr>
             </a:lvl5pPr>
             <a:lvl6pPr>
-              <a:defRPr sz="1875" b="1">
-                <a:solidFill>
-                  <a:srgbClr val="FFFFFF"/>
+              <a:defRPr sz="1500" b="0">
+                <a:solidFill>
+                  <a:srgbClr val="666666"/>
                 </a:solidFill>
                 <a:latin typeface="Inter"/>
                 <a:ea typeface="Inter"/>
@@ -7399,9 +7321,9 @@
               </a:defRPr>
             </a:lvl6pPr>
             <a:lvl7pPr>
-              <a:defRPr sz="1875" b="1">
-                <a:solidFill>
-                  <a:srgbClr val="FFFFFF"/>
+              <a:defRPr sz="1500" b="0">
+                <a:solidFill>
+                  <a:srgbClr val="666666"/>
                 </a:solidFill>
                 <a:latin typeface="Inter"/>
                 <a:ea typeface="Inter"/>
@@ -7409,9 +7331,9 @@
               </a:defRPr>
             </a:lvl7pPr>
             <a:lvl8pPr>
-              <a:defRPr sz="1875" b="1">
-                <a:solidFill>
-                  <a:srgbClr val="FFFFFF"/>
+              <a:defRPr sz="1500" b="0">
+                <a:solidFill>
+                  <a:srgbClr val="666666"/>
                 </a:solidFill>
                 <a:latin typeface="Inter"/>
                 <a:ea typeface="Inter"/>
@@ -7419,9 +7341,9 @@
               </a:defRPr>
             </a:lvl8pPr>
             <a:lvl9pPr>
-              <a:defRPr sz="1875" b="1">
-                <a:solidFill>
-                  <a:srgbClr val="FFFFFF"/>
+              <a:defRPr sz="1500" b="0">
+                <a:solidFill>
+                  <a:srgbClr val="666666"/>
                 </a:solidFill>
                 <a:latin typeface="Inter"/>
                 <a:ea typeface="Inter"/>
@@ -7431,9 +7353,9 @@
           </a:lstStyle>
           <a:p xmlns:a="http://schemas.openxmlformats.org/drawingml/2006/main">
             <a:pPr>
-              <a:defRPr sz="1875" b="1">
-                <a:solidFill>
-                  <a:srgbClr val="FFFFFF"/>
+              <a:defRPr sz="1500" b="0">
+                <a:solidFill>
+                  <a:srgbClr val="666666"/>
                 </a:solidFill>
                 <a:latin typeface="Inter"/>
                 <a:ea typeface="Inter"/>
@@ -7441,25 +7363,25 @@
               </a:defRPr>
             </a:pPr>
             <a:r>
-              <a:rPr sz="1875" b="1">
-                <a:solidFill>
-                  <a:srgbClr val="FFFFFF"/>
+              <a:rPr sz="1500" b="0">
+                <a:solidFill>
+                  <a:srgbClr val="666666"/>
                 </a:solidFill>
                 <a:latin typeface="Inter"/>
                 <a:ea typeface="Inter"/>
                 <a:cs typeface="Inter"/>
               </a:rPr>
-              <a:t>Measures gene expression</a:t>
+              <a:t>Evidence and uncertainty</a:t>
             </a:r>
           </a:p>
         </p:txBody>
       </p:sp>
       <p:sp>
         <p:nvSpPr>
-          <p:cNvPr id="10" name="copy-28">
+          <p:cNvPr id="8" name="copy-26">
             <a:extLst xmlns:a="http://schemas.openxmlformats.org/drawingml/2006/main">
               <a:ext uri="{FF2B5EF4-FFF2-40B4-BE49-F238E27FC236}">
-                <a16:creationId xmlns:a16="http://schemas.microsoft.com/office/drawing/2014/main" id="{6488416E-FB4F-43F9-AE42-CF4695E7FAF9}"/>
+                <a16:creationId xmlns:a16="http://schemas.microsoft.com/office/drawing/2014/main" id="{926D42C5-1E78-4B89-B101-22B9CC3BBC25}"/>
               </a:ext>
             </a:extLst>
           </p:cNvPr>
@@ -7470,8 +7392,8 @@
         </p:nvSpPr>
         <p:spPr>
           <a:xfrm xmlns:a="http://schemas.openxmlformats.org/drawingml/2006/main">
-            <a:off x="4000500" y="4276725"/>
-            <a:ext cx="4191000" cy="266700"/>
+            <a:off x="552450" y="4667250"/>
+            <a:ext cx="5238750" cy="619125"/>
           </a:xfrm>
           <a:prstGeom xmlns:a="http://schemas.openxmlformats.org/drawingml/2006/main" prst="rect">
             <a:avLst/>
@@ -7487,9 +7409,9 @@
           </a:bodyPr>
           <a:lstStyle xmlns:a="http://schemas.openxmlformats.org/drawingml/2006/main">
             <a:defPPr>
-              <a:defRPr sz="1425" b="0">
-                <a:solidFill>
-                  <a:srgbClr val="BAD4B1"/>
+              <a:defRPr sz="2025" b="1">
+                <a:solidFill>
+                  <a:srgbClr val="111111"/>
                 </a:solidFill>
                 <a:latin typeface="Inter"/>
                 <a:ea typeface="Inter"/>
@@ -7497,9 +7419,9 @@
               </a:defRPr>
             </a:defPPr>
             <a:lvl1pPr>
-              <a:defRPr sz="1425" b="0">
-                <a:solidFill>
-                  <a:srgbClr val="BAD4B1"/>
+              <a:defRPr sz="2025" b="1">
+                <a:solidFill>
+                  <a:srgbClr val="111111"/>
                 </a:solidFill>
                 <a:latin typeface="Inter"/>
                 <a:ea typeface="Inter"/>
@@ -7507,9 +7429,9 @@
               </a:defRPr>
             </a:lvl1pPr>
             <a:lvl2pPr>
-              <a:defRPr sz="1425" b="0">
-                <a:solidFill>
-                  <a:srgbClr val="BAD4B1"/>
+              <a:defRPr sz="2025" b="1">
+                <a:solidFill>
+                  <a:srgbClr val="111111"/>
                 </a:solidFill>
                 <a:latin typeface="Inter"/>
                 <a:ea typeface="Inter"/>
@@ -7517,9 +7439,9 @@
               </a:defRPr>
             </a:lvl2pPr>
             <a:lvl3pPr>
-              <a:defRPr sz="1425" b="0">
-                <a:solidFill>
-                  <a:srgbClr val="BAD4B1"/>
+              <a:defRPr sz="2025" b="1">
+                <a:solidFill>
+                  <a:srgbClr val="111111"/>
                 </a:solidFill>
                 <a:latin typeface="Inter"/>
                 <a:ea typeface="Inter"/>
@@ -7527,9 +7449,9 @@
               </a:defRPr>
             </a:lvl3pPr>
             <a:lvl4pPr>
-              <a:defRPr sz="1425" b="0">
-                <a:solidFill>
-                  <a:srgbClr val="BAD4B1"/>
+              <a:defRPr sz="2025" b="1">
+                <a:solidFill>
+                  <a:srgbClr val="111111"/>
                 </a:solidFill>
                 <a:latin typeface="Inter"/>
                 <a:ea typeface="Inter"/>
@@ -7537,9 +7459,9 @@
               </a:defRPr>
             </a:lvl4pPr>
             <a:lvl5pPr>
-              <a:defRPr sz="1425" b="0">
-                <a:solidFill>
-                  <a:srgbClr val="BAD4B1"/>
+              <a:defRPr sz="2025" b="1">
+                <a:solidFill>
+                  <a:srgbClr val="111111"/>
                 </a:solidFill>
                 <a:latin typeface="Inter"/>
                 <a:ea typeface="Inter"/>
@@ -7547,9 +7469,9 @@
               </a:defRPr>
             </a:lvl5pPr>
             <a:lvl6pPr>
-              <a:defRPr sz="1425" b="0">
-                <a:solidFill>
-                  <a:srgbClr val="BAD4B1"/>
+              <a:defRPr sz="2025" b="1">
+                <a:solidFill>
+                  <a:srgbClr val="111111"/>
                 </a:solidFill>
                 <a:latin typeface="Inter"/>
                 <a:ea typeface="Inter"/>
@@ -7557,9 +7479,9 @@
               </a:defRPr>
             </a:lvl6pPr>
             <a:lvl7pPr>
-              <a:defRPr sz="1425" b="0">
-                <a:solidFill>
-                  <a:srgbClr val="BAD4B1"/>
+              <a:defRPr sz="2025" b="1">
+                <a:solidFill>
+                  <a:srgbClr val="111111"/>
                 </a:solidFill>
                 <a:latin typeface="Inter"/>
                 <a:ea typeface="Inter"/>
@@ -7567,9 +7489,9 @@
               </a:defRPr>
             </a:lvl7pPr>
             <a:lvl8pPr>
-              <a:defRPr sz="1425" b="0">
-                <a:solidFill>
-                  <a:srgbClr val="BAD4B1"/>
+              <a:defRPr sz="2025" b="1">
+                <a:solidFill>
+                  <a:srgbClr val="111111"/>
                 </a:solidFill>
                 <a:latin typeface="Inter"/>
                 <a:ea typeface="Inter"/>
@@ -7577,9 +7499,9 @@
               </a:defRPr>
             </a:lvl8pPr>
             <a:lvl9pPr>
-              <a:defRPr sz="1425" b="0">
-                <a:solidFill>
-                  <a:srgbClr val="BAD4B1"/>
+              <a:defRPr sz="2025" b="1">
+                <a:solidFill>
+                  <a:srgbClr val="111111"/>
                 </a:solidFill>
                 <a:latin typeface="Inter"/>
                 <a:ea typeface="Inter"/>
@@ -7589,9 +7511,9 @@
           </a:lstStyle>
           <a:p xmlns:a="http://schemas.openxmlformats.org/drawingml/2006/main">
             <a:pPr>
-              <a:defRPr sz="1425" b="0">
-                <a:solidFill>
-                  <a:srgbClr val="BAD4B1"/>
+              <a:defRPr sz="2025" b="1">
+                <a:solidFill>
+                  <a:srgbClr val="111111"/>
                 </a:solidFill>
                 <a:latin typeface="Inter"/>
                 <a:ea typeface="Inter"/>
@@ -7599,25 +7521,25 @@
               </a:defRPr>
             </a:pPr>
             <a:r>
-              <a:rPr sz="1425" b="0">
-                <a:solidFill>
-                  <a:srgbClr val="BAD4B1"/>
+              <a:rPr sz="2025" b="1">
+                <a:solidFill>
+                  <a:srgbClr val="111111"/>
                 </a:solidFill>
                 <a:latin typeface="Inter"/>
                 <a:ea typeface="Inter"/>
                 <a:cs typeface="Inter"/>
               </a:rPr>
-              <a:t>Scientific analysis tools</a:t>
+              <a:t>Recalls your reviewed decisions</a:t>
             </a:r>
           </a:p>
         </p:txBody>
       </p:sp>
       <p:sp>
         <p:nvSpPr>
-          <p:cNvPr id="11" name="copy-29">
+          <p:cNvPr id="9" name="copy-27">
             <a:extLst xmlns:a="http://schemas.openxmlformats.org/drawingml/2006/main">
               <a:ext uri="{FF2B5EF4-FFF2-40B4-BE49-F238E27FC236}">
-                <a16:creationId xmlns:a16="http://schemas.microsoft.com/office/drawing/2014/main" id="{94430AA9-54F6-425A-9535-EB0A2F31DFB5}"/>
+                <a16:creationId xmlns:a16="http://schemas.microsoft.com/office/drawing/2014/main" id="{4D2EFADE-92D5-4559-B167-1544FBDDF871}"/>
               </a:ext>
             </a:extLst>
           </p:cNvPr>
@@ -7628,8 +7550,8 @@
         </p:nvSpPr>
         <p:spPr>
           <a:xfrm xmlns:a="http://schemas.openxmlformats.org/drawingml/2006/main">
-            <a:off x="4000500" y="4676775"/>
-            <a:ext cx="4191000" cy="352425"/>
+            <a:off x="552450" y="5038725"/>
+            <a:ext cx="5238750" cy="285750"/>
           </a:xfrm>
           <a:prstGeom xmlns:a="http://schemas.openxmlformats.org/drawingml/2006/main" prst="rect">
             <a:avLst/>
@@ -7645,9 +7567,9 @@
           </a:bodyPr>
           <a:lstStyle xmlns:a="http://schemas.openxmlformats.org/drawingml/2006/main">
             <a:defPPr>
-              <a:defRPr sz="1875" b="1">
-                <a:solidFill>
-                  <a:srgbClr val="FFFFFF"/>
+              <a:defRPr sz="1500" b="0">
+                <a:solidFill>
+                  <a:srgbClr val="666666"/>
                 </a:solidFill>
                 <a:latin typeface="Inter"/>
                 <a:ea typeface="Inter"/>
@@ -7655,9 +7577,9 @@
               </a:defRPr>
             </a:defPPr>
             <a:lvl1pPr>
-              <a:defRPr sz="1875" b="1">
-                <a:solidFill>
-                  <a:srgbClr val="FFFFFF"/>
+              <a:defRPr sz="1500" b="0">
+                <a:solidFill>
+                  <a:srgbClr val="666666"/>
                 </a:solidFill>
                 <a:latin typeface="Inter"/>
                 <a:ea typeface="Inter"/>
@@ -7665,9 +7587,9 @@
               </a:defRPr>
             </a:lvl1pPr>
             <a:lvl2pPr>
-              <a:defRPr sz="1875" b="1">
-                <a:solidFill>
-                  <a:srgbClr val="FFFFFF"/>
+              <a:defRPr sz="1500" b="0">
+                <a:solidFill>
+                  <a:srgbClr val="666666"/>
                 </a:solidFill>
                 <a:latin typeface="Inter"/>
                 <a:ea typeface="Inter"/>
@@ -7675,9 +7597,9 @@
               </a:defRPr>
             </a:lvl2pPr>
             <a:lvl3pPr>
-              <a:defRPr sz="1875" b="1">
-                <a:solidFill>
-                  <a:srgbClr val="FFFFFF"/>
+              <a:defRPr sz="1500" b="0">
+                <a:solidFill>
+                  <a:srgbClr val="666666"/>
                 </a:solidFill>
                 <a:latin typeface="Inter"/>
                 <a:ea typeface="Inter"/>
@@ -7685,9 +7607,9 @@
               </a:defRPr>
             </a:lvl3pPr>
             <a:lvl4pPr>
-              <a:defRPr sz="1875" b="1">
-                <a:solidFill>
-                  <a:srgbClr val="FFFFFF"/>
+              <a:defRPr sz="1500" b="0">
+                <a:solidFill>
+                  <a:srgbClr val="666666"/>
                 </a:solidFill>
                 <a:latin typeface="Inter"/>
                 <a:ea typeface="Inter"/>
@@ -7695,9 +7617,9 @@
               </a:defRPr>
             </a:lvl4pPr>
             <a:lvl5pPr>
-              <a:defRPr sz="1875" b="1">
-                <a:solidFill>
-                  <a:srgbClr val="FFFFFF"/>
+              <a:defRPr sz="1500" b="0">
+                <a:solidFill>
+                  <a:srgbClr val="666666"/>
                 </a:solidFill>
                 <a:latin typeface="Inter"/>
                 <a:ea typeface="Inter"/>
@@ -7705,9 +7627,9 @@
               </a:defRPr>
             </a:lvl5pPr>
             <a:lvl6pPr>
-              <a:defRPr sz="1875" b="1">
-                <a:solidFill>
-                  <a:srgbClr val="FFFFFF"/>
+              <a:defRPr sz="1500" b="0">
+                <a:solidFill>
+                  <a:srgbClr val="666666"/>
                 </a:solidFill>
                 <a:latin typeface="Inter"/>
                 <a:ea typeface="Inter"/>
@@ -7715,9 +7637,9 @@
               </a:defRPr>
             </a:lvl6pPr>
             <a:lvl7pPr>
-              <a:defRPr sz="1875" b="1">
-                <a:solidFill>
-                  <a:srgbClr val="FFFFFF"/>
+              <a:defRPr sz="1500" b="0">
+                <a:solidFill>
+                  <a:srgbClr val="666666"/>
                 </a:solidFill>
                 <a:latin typeface="Inter"/>
                 <a:ea typeface="Inter"/>
@@ -7725,9 +7647,9 @@
               </a:defRPr>
             </a:lvl7pPr>
             <a:lvl8pPr>
-              <a:defRPr sz="1875" b="1">
-                <a:solidFill>
-                  <a:srgbClr val="FFFFFF"/>
+              <a:defRPr sz="1500" b="0">
+                <a:solidFill>
+                  <a:srgbClr val="666666"/>
                 </a:solidFill>
                 <a:latin typeface="Inter"/>
                 <a:ea typeface="Inter"/>
@@ -7735,9 +7657,9 @@
               </a:defRPr>
             </a:lvl8pPr>
             <a:lvl9pPr>
-              <a:defRPr sz="1875" b="1">
-                <a:solidFill>
-                  <a:srgbClr val="FFFFFF"/>
+              <a:defRPr sz="1500" b="0">
+                <a:solidFill>
+                  <a:srgbClr val="666666"/>
                 </a:solidFill>
                 <a:latin typeface="Inter"/>
                 <a:ea typeface="Inter"/>
@@ -7747,9 +7669,9 @@
           </a:lstStyle>
           <a:p xmlns:a="http://schemas.openxmlformats.org/drawingml/2006/main">
             <a:pPr>
-              <a:defRPr sz="1875" b="1">
-                <a:solidFill>
-                  <a:srgbClr val="FFFFFF"/>
+              <a:defRPr sz="1500" b="0">
+                <a:solidFill>
+                  <a:srgbClr val="666666"/>
                 </a:solidFill>
                 <a:latin typeface="Inter"/>
                 <a:ea typeface="Inter"/>
@@ -7757,25 +7679,54 @@
               </a:defRPr>
             </a:pPr>
             <a:r>
-              <a:rPr sz="1875" b="1">
-                <a:solidFill>
-                  <a:srgbClr val="FFFFFF"/>
+              <a:rPr sz="1500" b="0">
+                <a:solidFill>
+                  <a:srgbClr val="666666"/>
                 </a:solidFill>
                 <a:latin typeface="Inter"/>
                 <a:ea typeface="Inter"/>
                 <a:cs typeface="Inter"/>
               </a:rPr>
-              <a:t>Recalls your reviewed decisions</a:t>
+              <a:t>Meterless H-MEM</a:t>
             </a:r>
           </a:p>
         </p:txBody>
       </p:sp>
+      <p:pic>
+        <p:nvPicPr>
+          <p:cNvPr id="10" name="">
+            <a:extLst xmlns:a="http://schemas.openxmlformats.org/drawingml/2006/main">
+              <a:ext uri="{FF2B5EF4-FFF2-40B4-BE49-F238E27FC236}">
+                <a16:creationId xmlns:a16="http://schemas.microsoft.com/office/drawing/2014/main" id="{1C446386-CBD6-41DE-A339-9C5A98DED70D}"/>
+              </a:ext>
+            </a:extLst>
+          </p:cNvPr>
+          <p:cNvPicPr>
+            <a:picLocks xmlns:a="http://schemas.openxmlformats.org/drawingml/2006/main" noChangeAspect="1"/>
+          </p:cNvPicPr>
+          <p:nvPr/>
+        </p:nvPicPr>
+        <p:blipFill>
+          <a:blip xmlns:r="http://schemas.openxmlformats.org/officeDocument/2006/relationships" xmlns:a="http://schemas.openxmlformats.org/drawingml/2006/main" r:embed="Reb45694bf6fa4de5"/>
+          <a:srcRect xmlns:a="http://schemas.openxmlformats.org/drawingml/2006/main" l="0" t="0" r="0" b="16000"/>
+          <a:stretch xmlns:a="http://schemas.openxmlformats.org/drawingml/2006/main"/>
+        </p:blipFill>
+        <p:spPr>
+          <a:xfrm xmlns:a="http://schemas.openxmlformats.org/drawingml/2006/main">
+            <a:off x="7524750" y="1600200"/>
+            <a:ext cx="3524250" cy="4381500"/>
+          </a:xfrm>
+          <a:prstGeom xmlns:a="http://schemas.openxmlformats.org/drawingml/2006/main" prst="rect">
+            <a:avLst/>
+          </a:prstGeom>
+        </p:spPr>
+      </p:pic>
       <p:sp>
         <p:nvSpPr>
-          <p:cNvPr id="12" name="copy-30">
+          <p:cNvPr id="11" name="copy-28">
             <a:extLst xmlns:a="http://schemas.openxmlformats.org/drawingml/2006/main">
               <a:ext uri="{FF2B5EF4-FFF2-40B4-BE49-F238E27FC236}">
-                <a16:creationId xmlns:a16="http://schemas.microsoft.com/office/drawing/2014/main" id="{9CAC7BDB-0147-4BD3-96A6-4449412F0320}"/>
+                <a16:creationId xmlns:a16="http://schemas.microsoft.com/office/drawing/2014/main" id="{8298FF19-DF9A-433C-A19C-F4013C828F7E}"/>
               </a:ext>
             </a:extLst>
           </p:cNvPr>
@@ -7786,557 +7737,7 @@
         </p:nvSpPr>
         <p:spPr>
           <a:xfrm xmlns:a="http://schemas.openxmlformats.org/drawingml/2006/main">
-            <a:off x="4000500" y="5038725"/>
-            <a:ext cx="4191000" cy="266700"/>
-          </a:xfrm>
-          <a:prstGeom xmlns:a="http://schemas.openxmlformats.org/drawingml/2006/main" prst="rect">
-            <a:avLst/>
-          </a:prstGeom>
-          <a:noFill xmlns:a="http://schemas.openxmlformats.org/drawingml/2006/main"/>
-          <a:ln xmlns:a="http://schemas.openxmlformats.org/drawingml/2006/main" w="0">
-            <a:noFill/>
-          </a:ln>
-        </p:spPr>
-        <p:txBody>
-          <a:bodyPr xmlns:a="http://schemas.openxmlformats.org/drawingml/2006/main" wrap="square" lIns="0" tIns="0" rIns="0" bIns="0">
-            <a:noAutofit/>
-          </a:bodyPr>
-          <a:lstStyle xmlns:a="http://schemas.openxmlformats.org/drawingml/2006/main">
-            <a:defPPr>
-              <a:defRPr sz="1425" b="0">
-                <a:solidFill>
-                  <a:srgbClr val="BAD4B1"/>
-                </a:solidFill>
-                <a:latin typeface="Inter"/>
-                <a:ea typeface="Inter"/>
-                <a:cs typeface="Inter"/>
-              </a:defRPr>
-            </a:defPPr>
-            <a:lvl1pPr>
-              <a:defRPr sz="1425" b="0">
-                <a:solidFill>
-                  <a:srgbClr val="BAD4B1"/>
-                </a:solidFill>
-                <a:latin typeface="Inter"/>
-                <a:ea typeface="Inter"/>
-                <a:cs typeface="Inter"/>
-              </a:defRPr>
-            </a:lvl1pPr>
-            <a:lvl2pPr>
-              <a:defRPr sz="1425" b="0">
-                <a:solidFill>
-                  <a:srgbClr val="BAD4B1"/>
-                </a:solidFill>
-                <a:latin typeface="Inter"/>
-                <a:ea typeface="Inter"/>
-                <a:cs typeface="Inter"/>
-              </a:defRPr>
-            </a:lvl2pPr>
-            <a:lvl3pPr>
-              <a:defRPr sz="1425" b="0">
-                <a:solidFill>
-                  <a:srgbClr val="BAD4B1"/>
-                </a:solidFill>
-                <a:latin typeface="Inter"/>
-                <a:ea typeface="Inter"/>
-                <a:cs typeface="Inter"/>
-              </a:defRPr>
-            </a:lvl3pPr>
-            <a:lvl4pPr>
-              <a:defRPr sz="1425" b="0">
-                <a:solidFill>
-                  <a:srgbClr val="BAD4B1"/>
-                </a:solidFill>
-                <a:latin typeface="Inter"/>
-                <a:ea typeface="Inter"/>
-                <a:cs typeface="Inter"/>
-              </a:defRPr>
-            </a:lvl4pPr>
-            <a:lvl5pPr>
-              <a:defRPr sz="1425" b="0">
-                <a:solidFill>
-                  <a:srgbClr val="BAD4B1"/>
-                </a:solidFill>
-                <a:latin typeface="Inter"/>
-                <a:ea typeface="Inter"/>
-                <a:cs typeface="Inter"/>
-              </a:defRPr>
-            </a:lvl5pPr>
-            <a:lvl6pPr>
-              <a:defRPr sz="1425" b="0">
-                <a:solidFill>
-                  <a:srgbClr val="BAD4B1"/>
-                </a:solidFill>
-                <a:latin typeface="Inter"/>
-                <a:ea typeface="Inter"/>
-                <a:cs typeface="Inter"/>
-              </a:defRPr>
-            </a:lvl6pPr>
-            <a:lvl7pPr>
-              <a:defRPr sz="1425" b="0">
-                <a:solidFill>
-                  <a:srgbClr val="BAD4B1"/>
-                </a:solidFill>
-                <a:latin typeface="Inter"/>
-                <a:ea typeface="Inter"/>
-                <a:cs typeface="Inter"/>
-              </a:defRPr>
-            </a:lvl7pPr>
-            <a:lvl8pPr>
-              <a:defRPr sz="1425" b="0">
-                <a:solidFill>
-                  <a:srgbClr val="BAD4B1"/>
-                </a:solidFill>
-                <a:latin typeface="Inter"/>
-                <a:ea typeface="Inter"/>
-                <a:cs typeface="Inter"/>
-              </a:defRPr>
-            </a:lvl8pPr>
-            <a:lvl9pPr>
-              <a:defRPr sz="1425" b="0">
-                <a:solidFill>
-                  <a:srgbClr val="BAD4B1"/>
-                </a:solidFill>
-                <a:latin typeface="Inter"/>
-                <a:ea typeface="Inter"/>
-                <a:cs typeface="Inter"/>
-              </a:defRPr>
-            </a:lvl9pPr>
-          </a:lstStyle>
-          <a:p xmlns:a="http://schemas.openxmlformats.org/drawingml/2006/main">
-            <a:pPr>
-              <a:defRPr sz="1425" b="0">
-                <a:solidFill>
-                  <a:srgbClr val="BAD4B1"/>
-                </a:solidFill>
-                <a:latin typeface="Inter"/>
-                <a:ea typeface="Inter"/>
-                <a:cs typeface="Inter"/>
-              </a:defRPr>
-            </a:pPr>
-            <a:r>
-              <a:rPr sz="1425" b="0">
-                <a:solidFill>
-                  <a:srgbClr val="BAD4B1"/>
-                </a:solidFill>
-                <a:latin typeface="Inter"/>
-                <a:ea typeface="Inter"/>
-                <a:cs typeface="Inter"/>
-              </a:rPr>
-              <a:t>Meterless H-MEM</a:t>
-            </a:r>
-          </a:p>
-        </p:txBody>
-      </p:sp>
-      <p:sp>
-        <p:nvSpPr>
-          <p:cNvPr id="13" name="arrow-31">
-            <a:extLst xmlns:a="http://schemas.openxmlformats.org/drawingml/2006/main">
-              <a:ext uri="{FF2B5EF4-FFF2-40B4-BE49-F238E27FC236}">
-                <a16:creationId xmlns:a16="http://schemas.microsoft.com/office/drawing/2014/main" id="{A446DA27-0513-444B-BD85-03C652A8959C}"/>
-              </a:ext>
-            </a:extLst>
-          </p:cNvPr>
-          <p:cNvSpPr>
-            <a:spLocks xmlns:a="http://schemas.openxmlformats.org/drawingml/2006/main" noGrp="1"/>
-          </p:cNvSpPr>
-          <p:nvPr/>
-        </p:nvSpPr>
-        <p:spPr>
-          <a:xfrm xmlns:a="http://schemas.openxmlformats.org/drawingml/2006/main">
-            <a:off x="8724900" y="3705225"/>
-            <a:ext cx="361950" cy="152400"/>
-          </a:xfrm>
-          <a:prstGeom xmlns:a="http://schemas.openxmlformats.org/drawingml/2006/main" prst="rightArrow">
-            <a:avLst/>
-          </a:prstGeom>
-          <a:solidFill xmlns:a="http://schemas.openxmlformats.org/drawingml/2006/main">
-            <a:srgbClr val="1B5E20"/>
-          </a:solidFill>
-          <a:ln xmlns:a="http://schemas.openxmlformats.org/drawingml/2006/main" w="0">
-            <a:noFill/>
-          </a:ln>
-        </p:spPr>
-      </p:sp>
-      <p:sp>
-        <p:nvSpPr>
-          <p:cNvPr id="14" name="copy-32">
-            <a:extLst xmlns:a="http://schemas.openxmlformats.org/drawingml/2006/main">
-              <a:ext uri="{FF2B5EF4-FFF2-40B4-BE49-F238E27FC236}">
-                <a16:creationId xmlns:a16="http://schemas.microsoft.com/office/drawing/2014/main" id="{7A8EA216-7165-44E3-80C8-CC98AD033E1F}"/>
-              </a:ext>
-            </a:extLst>
-          </p:cNvPr>
-          <p:cNvSpPr>
-            <a:spLocks xmlns:a="http://schemas.openxmlformats.org/drawingml/2006/main" noGrp="1"/>
-          </p:cNvSpPr>
-          <p:nvPr/>
-        </p:nvSpPr>
-        <p:spPr>
-          <a:xfrm xmlns:a="http://schemas.openxmlformats.org/drawingml/2006/main">
-            <a:off x="9372600" y="2428875"/>
-            <a:ext cx="2381250" cy="428625"/>
-          </a:xfrm>
-          <a:prstGeom xmlns:a="http://schemas.openxmlformats.org/drawingml/2006/main" prst="rect">
-            <a:avLst/>
-          </a:prstGeom>
-          <a:noFill xmlns:a="http://schemas.openxmlformats.org/drawingml/2006/main"/>
-          <a:ln xmlns:a="http://schemas.openxmlformats.org/drawingml/2006/main" w="0">
-            <a:noFill/>
-          </a:ln>
-        </p:spPr>
-        <p:txBody>
-          <a:bodyPr xmlns:a="http://schemas.openxmlformats.org/drawingml/2006/main" wrap="square" lIns="0" tIns="0" rIns="0" bIns="0">
-            <a:noAutofit/>
-          </a:bodyPr>
-          <a:lstStyle xmlns:a="http://schemas.openxmlformats.org/drawingml/2006/main">
-            <a:defPPr>
-              <a:defRPr sz="2100" b="1">
-                <a:solidFill>
-                  <a:srgbClr val="1B5E20"/>
-                </a:solidFill>
-                <a:latin typeface="Inter"/>
-                <a:ea typeface="Inter"/>
-                <a:cs typeface="Inter"/>
-              </a:defRPr>
-            </a:defPPr>
-            <a:lvl1pPr>
-              <a:defRPr sz="2100" b="1">
-                <a:solidFill>
-                  <a:srgbClr val="1B5E20"/>
-                </a:solidFill>
-                <a:latin typeface="Inter"/>
-                <a:ea typeface="Inter"/>
-                <a:cs typeface="Inter"/>
-              </a:defRPr>
-            </a:lvl1pPr>
-            <a:lvl2pPr>
-              <a:defRPr sz="2100" b="1">
-                <a:solidFill>
-                  <a:srgbClr val="1B5E20"/>
-                </a:solidFill>
-                <a:latin typeface="Inter"/>
-                <a:ea typeface="Inter"/>
-                <a:cs typeface="Inter"/>
-              </a:defRPr>
-            </a:lvl2pPr>
-            <a:lvl3pPr>
-              <a:defRPr sz="2100" b="1">
-                <a:solidFill>
-                  <a:srgbClr val="1B5E20"/>
-                </a:solidFill>
-                <a:latin typeface="Inter"/>
-                <a:ea typeface="Inter"/>
-                <a:cs typeface="Inter"/>
-              </a:defRPr>
-            </a:lvl3pPr>
-            <a:lvl4pPr>
-              <a:defRPr sz="2100" b="1">
-                <a:solidFill>
-                  <a:srgbClr val="1B5E20"/>
-                </a:solidFill>
-                <a:latin typeface="Inter"/>
-                <a:ea typeface="Inter"/>
-                <a:cs typeface="Inter"/>
-              </a:defRPr>
-            </a:lvl4pPr>
-            <a:lvl5pPr>
-              <a:defRPr sz="2100" b="1">
-                <a:solidFill>
-                  <a:srgbClr val="1B5E20"/>
-                </a:solidFill>
-                <a:latin typeface="Inter"/>
-                <a:ea typeface="Inter"/>
-                <a:cs typeface="Inter"/>
-              </a:defRPr>
-            </a:lvl5pPr>
-            <a:lvl6pPr>
-              <a:defRPr sz="2100" b="1">
-                <a:solidFill>
-                  <a:srgbClr val="1B5E20"/>
-                </a:solidFill>
-                <a:latin typeface="Inter"/>
-                <a:ea typeface="Inter"/>
-                <a:cs typeface="Inter"/>
-              </a:defRPr>
-            </a:lvl6pPr>
-            <a:lvl7pPr>
-              <a:defRPr sz="2100" b="1">
-                <a:solidFill>
-                  <a:srgbClr val="1B5E20"/>
-                </a:solidFill>
-                <a:latin typeface="Inter"/>
-                <a:ea typeface="Inter"/>
-                <a:cs typeface="Inter"/>
-              </a:defRPr>
-            </a:lvl7pPr>
-            <a:lvl8pPr>
-              <a:defRPr sz="2100" b="1">
-                <a:solidFill>
-                  <a:srgbClr val="1B5E20"/>
-                </a:solidFill>
-                <a:latin typeface="Inter"/>
-                <a:ea typeface="Inter"/>
-                <a:cs typeface="Inter"/>
-              </a:defRPr>
-            </a:lvl8pPr>
-            <a:lvl9pPr>
-              <a:defRPr sz="2100" b="1">
-                <a:solidFill>
-                  <a:srgbClr val="1B5E20"/>
-                </a:solidFill>
-                <a:latin typeface="Inter"/>
-                <a:ea typeface="Inter"/>
-                <a:cs typeface="Inter"/>
-              </a:defRPr>
-            </a:lvl9pPr>
-          </a:lstStyle>
-          <a:p xmlns:a="http://schemas.openxmlformats.org/drawingml/2006/main">
-            <a:pPr>
-              <a:defRPr sz="2100" b="1">
-                <a:solidFill>
-                  <a:srgbClr val="1B5E20"/>
-                </a:solidFill>
-                <a:latin typeface="Inter"/>
-                <a:ea typeface="Inter"/>
-                <a:cs typeface="Inter"/>
-              </a:defRPr>
-            </a:pPr>
-            <a:r>
-              <a:rPr sz="2100" b="1">
-                <a:solidFill>
-                  <a:srgbClr val="1B5E20"/>
-                </a:solidFill>
-                <a:latin typeface="Inter"/>
-                <a:ea typeface="Inter"/>
-                <a:cs typeface="Inter"/>
-              </a:rPr>
-              <a:t>You receive</a:t>
-            </a:r>
-          </a:p>
-        </p:txBody>
-      </p:sp>
-      <p:sp>
-        <p:nvSpPr>
-          <p:cNvPr id="15" name="copy-33">
-            <a:extLst xmlns:a="http://schemas.openxmlformats.org/drawingml/2006/main">
-              <a:ext uri="{FF2B5EF4-FFF2-40B4-BE49-F238E27FC236}">
-                <a16:creationId xmlns:a16="http://schemas.microsoft.com/office/drawing/2014/main" id="{C110C285-2917-4A64-84DA-C450DC72E081}"/>
-              </a:ext>
-            </a:extLst>
-          </p:cNvPr>
-          <p:cNvSpPr>
-            <a:spLocks xmlns:a="http://schemas.openxmlformats.org/drawingml/2006/main" noGrp="1"/>
-          </p:cNvSpPr>
-          <p:nvPr/>
-        </p:nvSpPr>
-        <p:spPr>
-          <a:xfrm xmlns:a="http://schemas.openxmlformats.org/drawingml/2006/main">
-            <a:off x="9372600" y="3095625"/>
-            <a:ext cx="2381250" cy="1381125"/>
-          </a:xfrm>
-          <a:prstGeom xmlns:a="http://schemas.openxmlformats.org/drawingml/2006/main" prst="rect">
-            <a:avLst/>
-          </a:prstGeom>
-          <a:noFill xmlns:a="http://schemas.openxmlformats.org/drawingml/2006/main"/>
-          <a:ln xmlns:a="http://schemas.openxmlformats.org/drawingml/2006/main" w="0">
-            <a:noFill/>
-          </a:ln>
-        </p:spPr>
-        <p:txBody>
-          <a:bodyPr xmlns:a="http://schemas.openxmlformats.org/drawingml/2006/main" wrap="square" lIns="0" tIns="0" rIns="0" bIns="0">
-            <a:noAutofit/>
-          </a:bodyPr>
-          <a:lstStyle xmlns:a="http://schemas.openxmlformats.org/drawingml/2006/main">
-            <a:defPPr>
-              <a:defRPr sz="2025" b="0">
-                <a:solidFill>
-                  <a:srgbClr val="111111"/>
-                </a:solidFill>
-                <a:latin typeface="Inter"/>
-                <a:ea typeface="Inter"/>
-                <a:cs typeface="Inter"/>
-              </a:defRPr>
-            </a:defPPr>
-            <a:lvl1pPr>
-              <a:defRPr sz="2025" b="0">
-                <a:solidFill>
-                  <a:srgbClr val="111111"/>
-                </a:solidFill>
-                <a:latin typeface="Inter"/>
-                <a:ea typeface="Inter"/>
-                <a:cs typeface="Inter"/>
-              </a:defRPr>
-            </a:lvl1pPr>
-            <a:lvl2pPr>
-              <a:defRPr sz="2025" b="0">
-                <a:solidFill>
-                  <a:srgbClr val="111111"/>
-                </a:solidFill>
-                <a:latin typeface="Inter"/>
-                <a:ea typeface="Inter"/>
-                <a:cs typeface="Inter"/>
-              </a:defRPr>
-            </a:lvl2pPr>
-            <a:lvl3pPr>
-              <a:defRPr sz="2025" b="0">
-                <a:solidFill>
-                  <a:srgbClr val="111111"/>
-                </a:solidFill>
-                <a:latin typeface="Inter"/>
-                <a:ea typeface="Inter"/>
-                <a:cs typeface="Inter"/>
-              </a:defRPr>
-            </a:lvl3pPr>
-            <a:lvl4pPr>
-              <a:defRPr sz="2025" b="0">
-                <a:solidFill>
-                  <a:srgbClr val="111111"/>
-                </a:solidFill>
-                <a:latin typeface="Inter"/>
-                <a:ea typeface="Inter"/>
-                <a:cs typeface="Inter"/>
-              </a:defRPr>
-            </a:lvl4pPr>
-            <a:lvl5pPr>
-              <a:defRPr sz="2025" b="0">
-                <a:solidFill>
-                  <a:srgbClr val="111111"/>
-                </a:solidFill>
-                <a:latin typeface="Inter"/>
-                <a:ea typeface="Inter"/>
-                <a:cs typeface="Inter"/>
-              </a:defRPr>
-            </a:lvl5pPr>
-            <a:lvl6pPr>
-              <a:defRPr sz="2025" b="0">
-                <a:solidFill>
-                  <a:srgbClr val="111111"/>
-                </a:solidFill>
-                <a:latin typeface="Inter"/>
-                <a:ea typeface="Inter"/>
-                <a:cs typeface="Inter"/>
-              </a:defRPr>
-            </a:lvl6pPr>
-            <a:lvl7pPr>
-              <a:defRPr sz="2025" b="0">
-                <a:solidFill>
-                  <a:srgbClr val="111111"/>
-                </a:solidFill>
-                <a:latin typeface="Inter"/>
-                <a:ea typeface="Inter"/>
-                <a:cs typeface="Inter"/>
-              </a:defRPr>
-            </a:lvl7pPr>
-            <a:lvl8pPr>
-              <a:defRPr sz="2025" b="0">
-                <a:solidFill>
-                  <a:srgbClr val="111111"/>
-                </a:solidFill>
-                <a:latin typeface="Inter"/>
-                <a:ea typeface="Inter"/>
-                <a:cs typeface="Inter"/>
-              </a:defRPr>
-            </a:lvl8pPr>
-            <a:lvl9pPr>
-              <a:defRPr sz="2025" b="0">
-                <a:solidFill>
-                  <a:srgbClr val="111111"/>
-                </a:solidFill>
-                <a:latin typeface="Inter"/>
-                <a:ea typeface="Inter"/>
-                <a:cs typeface="Inter"/>
-              </a:defRPr>
-            </a:lvl9pPr>
-          </a:lstStyle>
-          <a:p xmlns:a="http://schemas.openxmlformats.org/drawingml/2006/main">
-            <a:pPr>
-              <a:defRPr sz="2025" b="0">
-                <a:solidFill>
-                  <a:srgbClr val="111111"/>
-                </a:solidFill>
-                <a:latin typeface="Inter"/>
-                <a:ea typeface="Inter"/>
-                <a:cs typeface="Inter"/>
-              </a:defRPr>
-            </a:pPr>
-            <a:r>
-              <a:rPr sz="2025" b="0">
-                <a:solidFill>
-                  <a:srgbClr val="111111"/>
-                </a:solidFill>
-                <a:latin typeface="Inter"/>
-                <a:ea typeface="Inter"/>
-                <a:cs typeface="Inter"/>
-              </a:rPr>
-              <a:t>Cell map</a:t>
-            </a:r>
-          </a:p>
-          <a:p xmlns:a="http://schemas.openxmlformats.org/drawingml/2006/main">
-            <a:pPr>
-              <a:defRPr sz="2025" b="0">
-                <a:solidFill>
-                  <a:srgbClr val="111111"/>
-                </a:solidFill>
-                <a:latin typeface="Inter"/>
-                <a:ea typeface="Inter"/>
-                <a:cs typeface="Inter"/>
-              </a:defRPr>
-            </a:pPr>
-            <a:r>
-              <a:rPr sz="2025" b="0">
-                <a:solidFill>
-                  <a:srgbClr val="111111"/>
-                </a:solidFill>
-                <a:latin typeface="Inter"/>
-                <a:ea typeface="Inter"/>
-                <a:cs typeface="Inter"/>
-              </a:rPr>
-              <a:t>Supporting genes</a:t>
-            </a:r>
-          </a:p>
-          <a:p xmlns:a="http://schemas.openxmlformats.org/drawingml/2006/main">
-            <a:pPr>
-              <a:defRPr sz="2025" b="0">
-                <a:solidFill>
-                  <a:srgbClr val="111111"/>
-                </a:solidFill>
-                <a:latin typeface="Inter"/>
-                <a:ea typeface="Inter"/>
-                <a:cs typeface="Inter"/>
-              </a:defRPr>
-            </a:pPr>
-            <a:r>
-              <a:rPr sz="2025" b="0">
-                <a:solidFill>
-                  <a:srgbClr val="111111"/>
-                </a:solidFill>
-                <a:latin typeface="Inter"/>
-                <a:ea typeface="Inter"/>
-                <a:cs typeface="Inter"/>
-              </a:rPr>
-              <a:t>Source links</a:t>
-            </a:r>
-          </a:p>
-        </p:txBody>
-      </p:sp>
-      <p:sp>
-        <p:nvSpPr>
-          <p:cNvPr id="16" name="copy-34">
-            <a:extLst xmlns:a="http://schemas.openxmlformats.org/drawingml/2006/main">
-              <a:ext uri="{FF2B5EF4-FFF2-40B4-BE49-F238E27FC236}">
-                <a16:creationId xmlns:a16="http://schemas.microsoft.com/office/drawing/2014/main" id="{C302DCCD-D9EF-4D59-9B71-7A8CC8BA2BB4}"/>
-              </a:ext>
-            </a:extLst>
-          </p:cNvPr>
-          <p:cNvSpPr>
-            <a:spLocks xmlns:a="http://schemas.openxmlformats.org/drawingml/2006/main" noGrp="1"/>
-          </p:cNvSpPr>
-          <p:nvPr/>
-        </p:nvSpPr>
-        <p:spPr>
-          <a:xfrm xmlns:a="http://schemas.openxmlformats.org/drawingml/2006/main">
-            <a:off x="552450" y="6172200"/>
+            <a:off x="552450" y="6191250"/>
             <a:ext cx="11087100" cy="409575"/>
           </a:xfrm>
           <a:prstGeom xmlns:a="http://schemas.openxmlformats.org/drawingml/2006/main" prst="rect">
@@ -8353,7 +7754,7 @@
           </a:bodyPr>
           <a:lstStyle xmlns:a="http://schemas.openxmlformats.org/drawingml/2006/main">
             <a:defPPr>
-              <a:defRPr sz="2100" b="0">
+              <a:defRPr sz="1875" b="0">
                 <a:solidFill>
                   <a:srgbClr val="111111"/>
                 </a:solidFill>
@@ -8363,7 +7764,7 @@
               </a:defRPr>
             </a:defPPr>
             <a:lvl1pPr>
-              <a:defRPr sz="2100" b="0">
+              <a:defRPr sz="1875" b="0">
                 <a:solidFill>
                   <a:srgbClr val="111111"/>
                 </a:solidFill>
@@ -8373,7 +7774,7 @@
               </a:defRPr>
             </a:lvl1pPr>
             <a:lvl2pPr>
-              <a:defRPr sz="2100" b="0">
+              <a:defRPr sz="1875" b="0">
                 <a:solidFill>
                   <a:srgbClr val="111111"/>
                 </a:solidFill>
@@ -8383,7 +7784,7 @@
               </a:defRPr>
             </a:lvl2pPr>
             <a:lvl3pPr>
-              <a:defRPr sz="2100" b="0">
+              <a:defRPr sz="1875" b="0">
                 <a:solidFill>
                   <a:srgbClr val="111111"/>
                 </a:solidFill>
@@ -8393,7 +7794,7 @@
               </a:defRPr>
             </a:lvl3pPr>
             <a:lvl4pPr>
-              <a:defRPr sz="2100" b="0">
+              <a:defRPr sz="1875" b="0">
                 <a:solidFill>
                   <a:srgbClr val="111111"/>
                 </a:solidFill>
@@ -8403,7 +7804,7 @@
               </a:defRPr>
             </a:lvl4pPr>
             <a:lvl5pPr>
-              <a:defRPr sz="2100" b="0">
+              <a:defRPr sz="1875" b="0">
                 <a:solidFill>
                   <a:srgbClr val="111111"/>
                 </a:solidFill>
@@ -8413,7 +7814,7 @@
               </a:defRPr>
             </a:lvl5pPr>
             <a:lvl6pPr>
-              <a:defRPr sz="2100" b="0">
+              <a:defRPr sz="1875" b="0">
                 <a:solidFill>
                   <a:srgbClr val="111111"/>
                 </a:solidFill>
@@ -8423,7 +7824,7 @@
               </a:defRPr>
             </a:lvl6pPr>
             <a:lvl7pPr>
-              <a:defRPr sz="2100" b="0">
+              <a:defRPr sz="1875" b="0">
                 <a:solidFill>
                   <a:srgbClr val="111111"/>
                 </a:solidFill>
@@ -8433,7 +7834,7 @@
               </a:defRPr>
             </a:lvl7pPr>
             <a:lvl8pPr>
-              <a:defRPr sz="2100" b="0">
+              <a:defRPr sz="1875" b="0">
                 <a:solidFill>
                   <a:srgbClr val="111111"/>
                 </a:solidFill>
@@ -8443,7 +7844,7 @@
               </a:defRPr>
             </a:lvl8pPr>
             <a:lvl9pPr>
-              <a:defRPr sz="2100" b="0">
+              <a:defRPr sz="1875" b="0">
                 <a:solidFill>
                   <a:srgbClr val="111111"/>
                 </a:solidFill>
@@ -8455,7 +7856,7 @@
           </a:lstStyle>
           <a:p xmlns:a="http://schemas.openxmlformats.org/drawingml/2006/main">
             <a:pPr>
-              <a:defRPr sz="2100" b="0">
+              <a:defRPr sz="1875" b="0">
                 <a:solidFill>
                   <a:srgbClr val="111111"/>
                 </a:solidFill>
@@ -8465,7 +7866,7 @@
               </a:defRPr>
             </a:pPr>
             <a:r>
-              <a:rPr sz="2100" b="0">
+              <a:rPr sz="1875" b="0">
                 <a:solidFill>
                   <a:srgbClr val="111111"/>
                 </a:solidFill>
@@ -8473,7 +7874,7 @@
                 <a:ea typeface="Inter"/>
                 <a:cs typeface="Inter"/>
               </a:rPr>
-              <a:t>You review the evidence and save your decision.</a:t>
+              <a:t>A real conversation. An interactive cell map. Evidence you can inspect.</a:t>
             </a:r>
           </a:p>
         </p:txBody>
@@ -8481,7 +7882,7 @@
     </p:spTree>
     <p:extLst>
       <p:ext uri="{BB962C8B-B14F-4D97-AF65-F5344CB8AC3E}">
-        <p14:creationId xmlns:p14="http://schemas.microsoft.com/office/powerpoint/2010/main" val="1020874434"/>
+        <p14:creationId xmlns:p14="http://schemas.microsoft.com/office/powerpoint/2010/main" val="2048545940"/>
       </p:ext>
     </p:extLst>
   </p:cSld>
@@ -8509,10 +7910,10 @@
       </p:grpSpPr>
       <p:sp>
         <p:nvSpPr>
-          <p:cNvPr id="12" name="copy-35">
+          <p:cNvPr id="12" name="copy-29">
             <a:extLst xmlns:a="http://schemas.openxmlformats.org/drawingml/2006/main">
               <a:ext uri="{FF2B5EF4-FFF2-40B4-BE49-F238E27FC236}">
-                <a16:creationId xmlns:a16="http://schemas.microsoft.com/office/drawing/2014/main" id="{94F7065F-F657-4019-92CB-22EF801D5FBB}"/>
+                <a16:creationId xmlns:a16="http://schemas.microsoft.com/office/drawing/2014/main" id="{EA1216F5-2BBD-4016-A6F4-4736A555E20D}"/>
               </a:ext>
             </a:extLst>
           </p:cNvPr>
@@ -8667,10 +8068,10 @@
       </p:sp>
       <p:sp>
         <p:nvSpPr>
-          <p:cNvPr id="2" name="copy-36">
+          <p:cNvPr id="2" name="copy-30">
             <a:extLst xmlns:a="http://schemas.openxmlformats.org/drawingml/2006/main">
               <a:ext uri="{FF2B5EF4-FFF2-40B4-BE49-F238E27FC236}">
-                <a16:creationId xmlns:a16="http://schemas.microsoft.com/office/drawing/2014/main" id="{598F4407-745E-448E-9E6C-1C6EAB9E527E}"/>
+                <a16:creationId xmlns:a16="http://schemas.microsoft.com/office/drawing/2014/main" id="{EE012C56-DDF4-49F4-99DB-3D7E9B560894}"/>
               </a:ext>
             </a:extLst>
           </p:cNvPr>
@@ -8825,10 +8226,10 @@
       </p:sp>
       <p:sp>
         <p:nvSpPr>
-          <p:cNvPr id="3" name="copy-37">
+          <p:cNvPr id="3" name="copy-31">
             <a:extLst xmlns:a="http://schemas.openxmlformats.org/drawingml/2006/main">
               <a:ext uri="{FF2B5EF4-FFF2-40B4-BE49-F238E27FC236}">
-                <a16:creationId xmlns:a16="http://schemas.microsoft.com/office/drawing/2014/main" id="{160B9BA7-06BF-4AF7-8FFB-BED151A722AF}"/>
+                <a16:creationId xmlns:a16="http://schemas.microsoft.com/office/drawing/2014/main" id="{72A66FBE-BD5D-4CB3-BB16-919D16320E81}"/>
               </a:ext>
             </a:extLst>
           </p:cNvPr>
@@ -8983,10 +8384,10 @@
       </p:sp>
       <p:sp>
         <p:nvSpPr>
-          <p:cNvPr id="4" name="copy-38">
+          <p:cNvPr id="4" name="copy-32">
             <a:extLst xmlns:a="http://schemas.openxmlformats.org/drawingml/2006/main">
               <a:ext uri="{FF2B5EF4-FFF2-40B4-BE49-F238E27FC236}">
-                <a16:creationId xmlns:a16="http://schemas.microsoft.com/office/drawing/2014/main" id="{87E76C6C-DBA0-436A-BB0D-0048DA1D766C}"/>
+                <a16:creationId xmlns:a16="http://schemas.microsoft.com/office/drawing/2014/main" id="{30F25A33-A237-4F1D-987C-D5918DCDA639}"/>
               </a:ext>
             </a:extLst>
           </p:cNvPr>
@@ -9141,10 +8542,10 @@
       </p:sp>
       <p:sp>
         <p:nvSpPr>
-          <p:cNvPr id="5" name="copy-39">
+          <p:cNvPr id="5" name="copy-33">
             <a:extLst xmlns:a="http://schemas.openxmlformats.org/drawingml/2006/main">
               <a:ext uri="{FF2B5EF4-FFF2-40B4-BE49-F238E27FC236}">
-                <a16:creationId xmlns:a16="http://schemas.microsoft.com/office/drawing/2014/main" id="{5B53936B-BABA-400B-8123-42992C7EDA8F}"/>
+                <a16:creationId xmlns:a16="http://schemas.microsoft.com/office/drawing/2014/main" id="{DE2514A3-6C78-4722-84C3-411FAED3C56B}"/>
               </a:ext>
             </a:extLst>
           </p:cNvPr>
@@ -9291,7 +8692,7 @@
                 <a:latin typeface="Inter"/>
                 <a:ea typeface="Inter"/>
                 <a:cs typeface="Inter"/>
-                <a:hlinkClick xmlns:r="http://schemas.openxmlformats.org/officeDocument/2006/relationships" r:id="Rfa0665f5669b49ba"/>
+                <a:hlinkClick xmlns:r="http://schemas.openxmlformats.org/officeDocument/2006/relationships" r:id="Rc58b7f6b1a664d83"/>
               </a:rPr>
               <a:t>Open the reply and its saved-review source</a:t>
             </a:r>
@@ -9300,10 +8701,10 @@
       </p:sp>
       <p:sp>
         <p:nvSpPr>
-          <p:cNvPr id="6" name="copy-40">
+          <p:cNvPr id="6" name="copy-34">
             <a:extLst xmlns:a="http://schemas.openxmlformats.org/drawingml/2006/main">
               <a:ext uri="{FF2B5EF4-FFF2-40B4-BE49-F238E27FC236}">
-                <a16:creationId xmlns:a16="http://schemas.microsoft.com/office/drawing/2014/main" id="{27DF9C1C-EE4C-4ECE-94E6-72193D9666D0}"/>
+                <a16:creationId xmlns:a16="http://schemas.microsoft.com/office/drawing/2014/main" id="{5E27BE3D-36C0-4BFE-BE08-B50CB73662D9}"/>
               </a:ext>
             </a:extLst>
           </p:cNvPr>
@@ -9458,10 +8859,10 @@
       </p:sp>
       <p:sp>
         <p:nvSpPr>
-          <p:cNvPr id="7" name="copy-41">
+          <p:cNvPr id="7" name="copy-35">
             <a:extLst xmlns:a="http://schemas.openxmlformats.org/drawingml/2006/main">
               <a:ext uri="{FF2B5EF4-FFF2-40B4-BE49-F238E27FC236}">
-                <a16:creationId xmlns:a16="http://schemas.microsoft.com/office/drawing/2014/main" id="{CDE0BCC8-35B1-4360-80CA-53FA194DC67E}"/>
+                <a16:creationId xmlns:a16="http://schemas.microsoft.com/office/drawing/2014/main" id="{B1A9E5BC-C6D9-4462-9E69-4BBB434E34EE}"/>
               </a:ext>
             </a:extLst>
           </p:cNvPr>
@@ -9616,10 +9017,10 @@
       </p:sp>
       <p:sp>
         <p:nvSpPr>
-          <p:cNvPr id="8" name="copy-42">
+          <p:cNvPr id="8" name="copy-36">
             <a:extLst xmlns:a="http://schemas.openxmlformats.org/drawingml/2006/main">
               <a:ext uri="{FF2B5EF4-FFF2-40B4-BE49-F238E27FC236}">
-                <a16:creationId xmlns:a16="http://schemas.microsoft.com/office/drawing/2014/main" id="{B41745BD-65FF-4650-961A-5DBBD7BA1586}"/>
+                <a16:creationId xmlns:a16="http://schemas.microsoft.com/office/drawing/2014/main" id="{7A263E40-A1B1-451E-AAE5-19708DC72A82}"/>
               </a:ext>
             </a:extLst>
           </p:cNvPr>
@@ -9774,10 +9175,10 @@
       </p:sp>
       <p:sp>
         <p:nvSpPr>
-          <p:cNvPr id="9" name="copy-43">
+          <p:cNvPr id="9" name="copy-37">
             <a:extLst xmlns:a="http://schemas.openxmlformats.org/drawingml/2006/main">
               <a:ext uri="{FF2B5EF4-FFF2-40B4-BE49-F238E27FC236}">
-                <a16:creationId xmlns:a16="http://schemas.microsoft.com/office/drawing/2014/main" id="{A2CCE58B-76BD-4677-8A44-4FA49F17B209}"/>
+                <a16:creationId xmlns:a16="http://schemas.microsoft.com/office/drawing/2014/main" id="{E97F4015-72BA-4AFF-8437-A3BDEB8A5727}"/>
               </a:ext>
             </a:extLst>
           </p:cNvPr>
@@ -9932,10 +9333,10 @@
       </p:sp>
       <p:sp>
         <p:nvSpPr>
-          <p:cNvPr id="10" name="copy-44">
+          <p:cNvPr id="10" name="copy-38">
             <a:extLst xmlns:a="http://schemas.openxmlformats.org/drawingml/2006/main">
               <a:ext uri="{FF2B5EF4-FFF2-40B4-BE49-F238E27FC236}">
-                <a16:creationId xmlns:a16="http://schemas.microsoft.com/office/drawing/2014/main" id="{1279840C-05BF-4C01-A80C-800150690D77}"/>
+                <a16:creationId xmlns:a16="http://schemas.microsoft.com/office/drawing/2014/main" id="{804D8650-EEB5-4317-BE83-51AE0A94ECAA}"/>
               </a:ext>
             </a:extLst>
           </p:cNvPr>
@@ -10090,10 +9491,10 @@
       </p:sp>
       <p:sp>
         <p:nvSpPr>
-          <p:cNvPr id="11" name="copy-45">
+          <p:cNvPr id="11" name="copy-39">
             <a:extLst xmlns:a="http://schemas.openxmlformats.org/drawingml/2006/main">
               <a:ext uri="{FF2B5EF4-FFF2-40B4-BE49-F238E27FC236}">
-                <a16:creationId xmlns:a16="http://schemas.microsoft.com/office/drawing/2014/main" id="{4DAF4A1B-3F59-4C08-9524-78564A9980F0}"/>
+                <a16:creationId xmlns:a16="http://schemas.microsoft.com/office/drawing/2014/main" id="{DB4B11AC-ECD0-4AB3-937A-41F797412BC8}"/>
               </a:ext>
             </a:extLst>
           </p:cNvPr>
@@ -10240,7 +9641,7 @@
                 <a:latin typeface="Inter"/>
                 <a:ea typeface="Inter"/>
                 <a:cs typeface="Inter"/>
-                <a:hlinkClick xmlns:r="http://schemas.openxmlformats.org/officeDocument/2006/relationships" r:id="R1756bb5969b54154"/>
+                <a:hlinkClick xmlns:r="http://schemas.openxmlformats.org/officeDocument/2006/relationships" r:id="Rea64fd9f8c124620"/>
               </a:rPr>
               <a:t>Public code and demo</a:t>
             </a:r>
@@ -10250,7 +9651,7 @@
     </p:spTree>
     <p:extLst>
       <p:ext uri="{BB962C8B-B14F-4D97-AF65-F5344CB8AC3E}">
-        <p14:creationId xmlns:p14="http://schemas.microsoft.com/office/powerpoint/2010/main" val="517376490"/>
+        <p14:creationId xmlns:p14="http://schemas.microsoft.com/office/powerpoint/2010/main" val="1897894905"/>
       </p:ext>
     </p:extLst>
   </p:cSld>

</xml_diff>